<commit_message>
feat: Add python_2 presentation slide no.11
</commit_message>
<xml_diff>
--- a/python_2/presentation_python_2.pptx
+++ b/python_2/presentation_python_2.pptx
@@ -5,7 +5,7 @@
     <p:sldMasterId id="2147483648" r:id="rId1"/>
   </p:sldMasterIdLst>
   <p:notesMasterIdLst>
-    <p:notesMasterId r:id="rId41"/>
+    <p:notesMasterId r:id="rId42"/>
   </p:notesMasterIdLst>
   <p:sldIdLst>
     <p:sldId id="256" r:id="rId2"/>
@@ -18,35 +18,36 @@
     <p:sldId id="302" r:id="rId9"/>
     <p:sldId id="303" r:id="rId10"/>
     <p:sldId id="304" r:id="rId11"/>
-    <p:sldId id="297" r:id="rId12"/>
-    <p:sldId id="294" r:id="rId13"/>
-    <p:sldId id="259" r:id="rId14"/>
-    <p:sldId id="263" r:id="rId15"/>
-    <p:sldId id="260" r:id="rId16"/>
-    <p:sldId id="261" r:id="rId17"/>
-    <p:sldId id="264" r:id="rId18"/>
-    <p:sldId id="265" r:id="rId19"/>
-    <p:sldId id="266" r:id="rId20"/>
-    <p:sldId id="268" r:id="rId21"/>
-    <p:sldId id="269" r:id="rId22"/>
-    <p:sldId id="271" r:id="rId23"/>
-    <p:sldId id="272" r:id="rId24"/>
-    <p:sldId id="273" r:id="rId25"/>
-    <p:sldId id="274" r:id="rId26"/>
-    <p:sldId id="275" r:id="rId27"/>
-    <p:sldId id="276" r:id="rId28"/>
-    <p:sldId id="277" r:id="rId29"/>
-    <p:sldId id="278" r:id="rId30"/>
-    <p:sldId id="282" r:id="rId31"/>
-    <p:sldId id="283" r:id="rId32"/>
-    <p:sldId id="280" r:id="rId33"/>
-    <p:sldId id="279" r:id="rId34"/>
-    <p:sldId id="288" r:id="rId35"/>
-    <p:sldId id="289" r:id="rId36"/>
-    <p:sldId id="292" r:id="rId37"/>
-    <p:sldId id="291" r:id="rId38"/>
-    <p:sldId id="281" r:id="rId39"/>
-    <p:sldId id="290" r:id="rId40"/>
+    <p:sldId id="305" r:id="rId12"/>
+    <p:sldId id="297" r:id="rId13"/>
+    <p:sldId id="294" r:id="rId14"/>
+    <p:sldId id="259" r:id="rId15"/>
+    <p:sldId id="263" r:id="rId16"/>
+    <p:sldId id="260" r:id="rId17"/>
+    <p:sldId id="261" r:id="rId18"/>
+    <p:sldId id="264" r:id="rId19"/>
+    <p:sldId id="265" r:id="rId20"/>
+    <p:sldId id="266" r:id="rId21"/>
+    <p:sldId id="268" r:id="rId22"/>
+    <p:sldId id="269" r:id="rId23"/>
+    <p:sldId id="271" r:id="rId24"/>
+    <p:sldId id="272" r:id="rId25"/>
+    <p:sldId id="273" r:id="rId26"/>
+    <p:sldId id="274" r:id="rId27"/>
+    <p:sldId id="275" r:id="rId28"/>
+    <p:sldId id="276" r:id="rId29"/>
+    <p:sldId id="277" r:id="rId30"/>
+    <p:sldId id="278" r:id="rId31"/>
+    <p:sldId id="282" r:id="rId32"/>
+    <p:sldId id="283" r:id="rId33"/>
+    <p:sldId id="280" r:id="rId34"/>
+    <p:sldId id="279" r:id="rId35"/>
+    <p:sldId id="288" r:id="rId36"/>
+    <p:sldId id="289" r:id="rId37"/>
+    <p:sldId id="292" r:id="rId38"/>
+    <p:sldId id="291" r:id="rId39"/>
+    <p:sldId id="281" r:id="rId40"/>
+    <p:sldId id="290" r:id="rId41"/>
   </p:sldIdLst>
   <p:sldSz cx="12192000" cy="6858000"/>
   <p:notesSz cx="6858000" cy="9144000"/>
@@ -4721,7 +4722,7 @@
               <a:rPr lang="en-US" dirty="0">
                 <a:latin typeface="Arial Rounded MT Bold" panose="020F0704030504030204" pitchFamily="34" charset="0"/>
               </a:rPr>
-              <a:t> (1/2)</a:t>
+              <a:t> (2/2)</a:t>
             </a:r>
             <a:endParaRPr lang="fr-CA" dirty="0">
               <a:latin typeface="Arial Rounded MT Bold" panose="020F0704030504030204" pitchFamily="34" charset="0"/>
@@ -6655,6 +6656,810 @@
     <p:bg>
       <p:bgPr>
         <a:solidFill>
+          <a:schemeClr val="accent6">
+            <a:lumMod val="20000"/>
+            <a:lumOff val="80000"/>
+          </a:schemeClr>
+        </a:solidFill>
+        <a:effectLst/>
+      </p:bgPr>
+    </p:bg>
+    <p:spTree>
+      <p:nvGrpSpPr>
+        <p:cNvPr id="1" name="">
+          <a:extLst>
+            <a:ext uri="{FF2B5EF4-FFF2-40B4-BE49-F238E27FC236}">
+              <a16:creationId xmlns:a16="http://schemas.microsoft.com/office/drawing/2014/main" id="{8D06BF4E-BBD2-F9E1-3E81-966407441DFF}"/>
+            </a:ext>
+          </a:extLst>
+        </p:cNvPr>
+        <p:cNvGrpSpPr/>
+        <p:nvPr/>
+      </p:nvGrpSpPr>
+      <p:grpSpPr>
+        <a:xfrm>
+          <a:off x="0" y="0"/>
+          <a:ext cx="0" cy="0"/>
+          <a:chOff x="0" y="0"/>
+          <a:chExt cx="0" cy="0"/>
+        </a:xfrm>
+      </p:grpSpPr>
+      <p:sp>
+        <p:nvSpPr>
+          <p:cNvPr id="2" name="Title 1">
+            <a:extLst>
+              <a:ext uri="{FF2B5EF4-FFF2-40B4-BE49-F238E27FC236}">
+                <a16:creationId xmlns:a16="http://schemas.microsoft.com/office/drawing/2014/main" id="{AFFB914A-2C50-CA49-E38B-A080F05C7693}"/>
+              </a:ext>
+            </a:extLst>
+          </p:cNvPr>
+          <p:cNvSpPr>
+            <a:spLocks noGrp="1"/>
+          </p:cNvSpPr>
+          <p:nvPr>
+            <p:ph type="title"/>
+          </p:nvPr>
+        </p:nvSpPr>
+        <p:spPr/>
+        <p:txBody>
+          <a:bodyPr/>
+          <a:lstStyle/>
+          <a:p>
+            <a:r>
+              <a:rPr lang="en-US" dirty="0">
+                <a:latin typeface="Arial Rounded MT Bold" panose="020F0704030504030204" pitchFamily="34" charset="0"/>
+              </a:rPr>
+              <a:t>XR6 – </a:t>
+            </a:r>
+            <a:r>
+              <a:rPr lang="fr-CA" dirty="0">
+                <a:latin typeface="Arial Rounded MT Bold" panose="020F0704030504030204" pitchFamily="34" charset="0"/>
+              </a:rPr>
+              <a:t>Vecteur direction</a:t>
+            </a:r>
+          </a:p>
+        </p:txBody>
+      </p:sp>
+      <mc:AlternateContent xmlns:mc="http://schemas.openxmlformats.org/markup-compatibility/2006">
+        <mc:Choice xmlns:a14="http://schemas.microsoft.com/office/drawing/2010/main" Requires="a14">
+          <p:sp>
+            <p:nvSpPr>
+              <p:cNvPr id="3" name="Content Placeholder 2">
+                <a:extLst>
+                  <a:ext uri="{FF2B5EF4-FFF2-40B4-BE49-F238E27FC236}">
+                    <a16:creationId xmlns:a16="http://schemas.microsoft.com/office/drawing/2014/main" id="{B05F3990-4E4A-E9D2-9105-6733A061A3E1}"/>
+                  </a:ext>
+                </a:extLst>
+              </p:cNvPr>
+              <p:cNvSpPr>
+                <a:spLocks noGrp="1"/>
+              </p:cNvSpPr>
+              <p:nvPr>
+                <p:ph idx="1"/>
+              </p:nvPr>
+            </p:nvSpPr>
+            <p:spPr/>
+            <p:txBody>
+              <a:bodyPr>
+                <a:normAutofit lnSpcReduction="10000"/>
+              </a:bodyPr>
+              <a:lstStyle/>
+              <a:p>
+                <a:pPr marL="342900" indent="-342900" algn="just">
+                  <a:lnSpc>
+                    <a:spcPct val="150000"/>
+                  </a:lnSpc>
+                  <a:buAutoNum type="arabicPeriod"/>
+                </a:pPr>
+                <a:r>
+                  <a:rPr lang="fr-CA" sz="1800" dirty="0">
+                    <a:latin typeface="Consolas" panose="020B0609020204030204" pitchFamily="49" charset="0"/>
+                  </a:rPr>
+                  <a:t>Créez une classe-exception nommée </a:t>
+                </a:r>
+                <a:r>
+                  <a:rPr lang="fr-CA" sz="1800" b="1" dirty="0" err="1">
+                    <a:latin typeface="Consolas" panose="020B0609020204030204" pitchFamily="49" charset="0"/>
+                  </a:rPr>
+                  <a:t>NullNormError</a:t>
+                </a:r>
+                <a:r>
+                  <a:rPr lang="fr-CA" sz="1800" dirty="0">
+                    <a:latin typeface="Consolas" panose="020B0609020204030204" pitchFamily="49" charset="0"/>
+                  </a:rPr>
+                  <a:t>.</a:t>
+                </a:r>
+              </a:p>
+              <a:p>
+                <a:pPr marL="342900" indent="-342900" algn="just">
+                  <a:lnSpc>
+                    <a:spcPct val="150000"/>
+                  </a:lnSpc>
+                  <a:buAutoNum type="arabicPeriod"/>
+                </a:pPr>
+                <a:r>
+                  <a:rPr lang="fr-CA" sz="1800" dirty="0">
+                    <a:latin typeface="Consolas" panose="020B0609020204030204" pitchFamily="49" charset="0"/>
+                  </a:rPr>
+                  <a:t>Ajoutez une méthode nommée </a:t>
+                </a:r>
+                <a:r>
+                  <a:rPr lang="fr-CA" sz="1800" b="1" dirty="0" err="1">
+                    <a:latin typeface="Consolas" panose="020B0609020204030204" pitchFamily="49" charset="0"/>
+                  </a:rPr>
+                  <a:t>calculer_vecteur_direction</a:t>
+                </a:r>
+                <a:r>
+                  <a:rPr lang="fr-CA" sz="1800" b="1" dirty="0">
+                    <a:latin typeface="Consolas" panose="020B0609020204030204" pitchFamily="49" charset="0"/>
+                  </a:rPr>
+                  <a:t>()</a:t>
+                </a:r>
+                <a:r>
+                  <a:rPr lang="fr-CA" sz="1800" dirty="0">
+                    <a:latin typeface="Consolas" panose="020B0609020204030204" pitchFamily="49" charset="0"/>
+                  </a:rPr>
+                  <a:t> à la classe Vecteur qui retourne un nouveau vecteur unitaire (</a:t>
+                </a:r>
+                <a14:m>
+                  <m:oMath xmlns:m="http://schemas.openxmlformats.org/officeDocument/2006/math">
+                    <m:acc>
+                      <m:accPr>
+                        <m:chr m:val="̂"/>
+                        <m:ctrlPr>
+                          <a:rPr lang="fr-CA" sz="1800" i="1">
+                            <a:latin typeface="Cambria Math" panose="02040503050406030204" pitchFamily="18" charset="0"/>
+                          </a:rPr>
+                        </m:ctrlPr>
+                      </m:accPr>
+                      <m:e>
+                        <m:r>
+                          <a:rPr lang="fr-CA" sz="1800" i="1">
+                            <a:latin typeface="Cambria Math" panose="02040503050406030204" pitchFamily="18" charset="0"/>
+                          </a:rPr>
+                          <m:t>𝑣</m:t>
+                        </m:r>
+                      </m:e>
+                    </m:acc>
+                  </m:oMath>
+                </a14:m>
+                <a:r>
+                  <a:rPr lang="fr-CA" sz="1800" dirty="0">
+                    <a:latin typeface="Consolas" panose="020B0609020204030204" pitchFamily="49" charset="0"/>
+                  </a:rPr>
+                  <a:t>) dans la direction de ce dernier.</a:t>
+                </a:r>
+              </a:p>
+              <a:p>
+                <a:pPr marL="800100" lvl="1" indent="-342900" algn="just">
+                  <a:lnSpc>
+                    <a:spcPct val="150000"/>
+                  </a:lnSpc>
+                  <a:buAutoNum type="arabicPeriod"/>
+                </a:pPr>
+                <a:r>
+                  <a:rPr lang="fr-CA" sz="1400" dirty="0">
+                    <a:latin typeface="Consolas" panose="020B0609020204030204" pitchFamily="49" charset="0"/>
+                  </a:rPr>
+                  <a:t>Levez une erreur de type </a:t>
+                </a:r>
+                <a:r>
+                  <a:rPr lang="fr-CA" sz="1400" b="1" dirty="0" err="1">
+                    <a:latin typeface="Consolas" panose="020B0609020204030204" pitchFamily="49" charset="0"/>
+                  </a:rPr>
+                  <a:t>NullNormError</a:t>
+                </a:r>
+                <a:r>
+                  <a:rPr lang="fr-CA" sz="1400" dirty="0">
+                    <a:latin typeface="Consolas" panose="020B0609020204030204" pitchFamily="49" charset="0"/>
+                  </a:rPr>
+                  <a:t> si la norme du vecteur est nulle.</a:t>
+                </a:r>
+              </a:p>
+              <a:p>
+                <a:pPr marL="800100" lvl="1" indent="-342900" algn="just">
+                  <a:lnSpc>
+                    <a:spcPct val="150000"/>
+                  </a:lnSpc>
+                  <a:buAutoNum type="arabicPeriod"/>
+                </a:pPr>
+                <a:r>
+                  <a:rPr lang="fr-CA" sz="1400" dirty="0">
+                    <a:latin typeface="Consolas" panose="020B0609020204030204" pitchFamily="49" charset="0"/>
+                  </a:rPr>
+                  <a:t>Utilisez la fonction </a:t>
+                </a:r>
+                <a:r>
+                  <a:rPr lang="fr-CA" sz="1400" b="1" dirty="0">
+                    <a:latin typeface="Consolas" panose="020B0609020204030204" pitchFamily="49" charset="0"/>
+                  </a:rPr>
+                  <a:t>approx</a:t>
+                </a:r>
+                <a:r>
+                  <a:rPr lang="fr-CA" sz="1400" dirty="0">
+                    <a:latin typeface="Consolas" panose="020B0609020204030204" pitchFamily="49" charset="0"/>
+                  </a:rPr>
+                  <a:t> de </a:t>
+                </a:r>
+                <a:r>
+                  <a:rPr lang="fr-CA" sz="1400" b="1" dirty="0" err="1">
+                    <a:latin typeface="Consolas" panose="020B0609020204030204" pitchFamily="49" charset="0"/>
+                  </a:rPr>
+                  <a:t>pytest</a:t>
+                </a:r>
+                <a:r>
+                  <a:rPr lang="fr-CA" sz="1400" dirty="0">
+                    <a:latin typeface="Consolas" panose="020B0609020204030204" pitchFamily="49" charset="0"/>
+                  </a:rPr>
+                  <a:t> pour le test d'égalité de manière que l'erreur soit levée lorsque </a:t>
+                </a:r>
+                <a14:m>
+                  <m:oMath xmlns:m="http://schemas.openxmlformats.org/officeDocument/2006/math">
+                    <m:d>
+                      <m:dPr>
+                        <m:begChr m:val="‖"/>
+                        <m:endChr m:val="‖"/>
+                        <m:ctrlPr>
+                          <a:rPr lang="fr-CA" sz="1400" i="1">
+                            <a:latin typeface="Cambria Math" panose="02040503050406030204" pitchFamily="18" charset="0"/>
+                          </a:rPr>
+                        </m:ctrlPr>
+                      </m:dPr>
+                      <m:e>
+                        <m:acc>
+                          <m:accPr>
+                            <m:chr m:val="⃗"/>
+                            <m:ctrlPr>
+                              <a:rPr lang="fr-CA" sz="1400" i="1">
+                                <a:latin typeface="Cambria Math" panose="02040503050406030204" pitchFamily="18" charset="0"/>
+                              </a:rPr>
+                            </m:ctrlPr>
+                          </m:accPr>
+                          <m:e>
+                            <m:r>
+                              <a:rPr lang="fr-CA" sz="1400" i="1">
+                                <a:latin typeface="Cambria Math" panose="02040503050406030204" pitchFamily="18" charset="0"/>
+                              </a:rPr>
+                              <m:t>𝑣</m:t>
+                            </m:r>
+                          </m:e>
+                        </m:acc>
+                      </m:e>
+                    </m:d>
+                    <m:r>
+                      <a:rPr lang="en-CA" sz="1400" b="0" i="0" smtClean="0">
+                        <a:latin typeface="Cambria Math" panose="02040503050406030204" pitchFamily="18" charset="0"/>
+                      </a:rPr>
+                      <m:t>&lt;</m:t>
+                    </m:r>
+                    <m:sSup>
+                      <m:sSupPr>
+                        <m:ctrlPr>
+                          <a:rPr lang="en-CA" sz="1400" b="0" i="0" smtClean="0">
+                            <a:latin typeface="Cambria Math" panose="02040503050406030204" pitchFamily="18" charset="0"/>
+                          </a:rPr>
+                        </m:ctrlPr>
+                      </m:sSupPr>
+                      <m:e>
+                        <m:r>
+                          <a:rPr lang="en-CA" sz="1400" b="0" i="0" smtClean="0">
+                            <a:latin typeface="Cambria Math" panose="02040503050406030204" pitchFamily="18" charset="0"/>
+                          </a:rPr>
+                          <m:t>10</m:t>
+                        </m:r>
+                      </m:e>
+                      <m:sup>
+                        <m:r>
+                          <a:rPr lang="en-CA" sz="1400" b="0" i="0" smtClean="0">
+                            <a:latin typeface="Cambria Math" panose="02040503050406030204" pitchFamily="18" charset="0"/>
+                          </a:rPr>
+                          <m:t>−12</m:t>
+                        </m:r>
+                      </m:sup>
+                    </m:sSup>
+                  </m:oMath>
+                </a14:m>
+                <a:r>
+                  <a:rPr lang="fr-CA" sz="1400" dirty="0">
+                    <a:latin typeface="Consolas" panose="020B0609020204030204" pitchFamily="49" charset="0"/>
+                  </a:rPr>
+                  <a:t>, qui est la tolérance par défaut de </a:t>
+                </a:r>
+                <a:r>
+                  <a:rPr lang="fr-CA" sz="1400" b="1" dirty="0">
+                    <a:latin typeface="Consolas" panose="020B0609020204030204" pitchFamily="49" charset="0"/>
+                  </a:rPr>
+                  <a:t>approx()</a:t>
+                </a:r>
+                <a:r>
+                  <a:rPr lang="fr-CA" sz="1400" dirty="0">
+                    <a:latin typeface="Consolas" panose="020B0609020204030204" pitchFamily="49" charset="0"/>
+                  </a:rPr>
+                  <a:t>.</a:t>
+                </a:r>
+              </a:p>
+              <a:p>
+                <a:pPr marL="0" indent="0" algn="just">
+                  <a:lnSpc>
+                    <a:spcPct val="100000"/>
+                  </a:lnSpc>
+                  <a:buNone/>
+                </a:pPr>
+                <a:endParaRPr lang="fr-CA" sz="1800" dirty="0">
+                  <a:latin typeface="Consolas" panose="020B0609020204030204" pitchFamily="49" charset="0"/>
+                </a:endParaRPr>
+              </a:p>
+              <a:p>
+                <a:pPr marL="0" indent="0" algn="just">
+                  <a:lnSpc>
+                    <a:spcPct val="100000"/>
+                  </a:lnSpc>
+                  <a:buNone/>
+                </a:pPr>
+                <a:r>
+                  <a:rPr lang="fr-CA" sz="1800" dirty="0">
+                    <a:latin typeface="Consolas" panose="020B0609020204030204" pitchFamily="49" charset="0"/>
+                  </a:rPr>
+                  <a:t>Le vecteur direction se calcule comme suit:</a:t>
+                </a:r>
+              </a:p>
+              <a:p>
+                <a:pPr marL="0" indent="0" algn="just">
+                  <a:lnSpc>
+                    <a:spcPct val="100000"/>
+                  </a:lnSpc>
+                  <a:buNone/>
+                </a:pPr>
+                <a:endParaRPr lang="fr-CA" sz="1800" dirty="0">
+                  <a:latin typeface="Consolas" panose="020B0609020204030204" pitchFamily="49" charset="0"/>
+                </a:endParaRPr>
+              </a:p>
+              <a:p>
+                <a:pPr marL="0" indent="0" algn="just">
+                  <a:lnSpc>
+                    <a:spcPct val="100000"/>
+                  </a:lnSpc>
+                  <a:buNone/>
+                </a:pPr>
+                <a14:m>
+                  <m:oMathPara xmlns:m="http://schemas.openxmlformats.org/officeDocument/2006/math">
+                    <m:oMathParaPr>
+                      <m:jc m:val="centerGroup"/>
+                    </m:oMathParaPr>
+                    <m:oMath xmlns:m="http://schemas.openxmlformats.org/officeDocument/2006/math">
+                      <m:acc>
+                        <m:accPr>
+                          <m:chr m:val="̂"/>
+                          <m:ctrlPr>
+                            <a:rPr lang="fr-CA" sz="1800" b="0" i="1" smtClean="0">
+                              <a:latin typeface="Cambria Math" panose="02040503050406030204" pitchFamily="18" charset="0"/>
+                            </a:rPr>
+                          </m:ctrlPr>
+                        </m:accPr>
+                        <m:e>
+                          <m:r>
+                            <a:rPr lang="fr-CA" sz="1800" b="0" i="1" smtClean="0">
+                              <a:latin typeface="Cambria Math" panose="02040503050406030204" pitchFamily="18" charset="0"/>
+                            </a:rPr>
+                            <m:t>𝑣</m:t>
+                          </m:r>
+                        </m:e>
+                      </m:acc>
+                      <m:r>
+                        <a:rPr lang="fr-CA" sz="1800" b="0" i="1" smtClean="0">
+                          <a:latin typeface="Cambria Math" panose="02040503050406030204" pitchFamily="18" charset="0"/>
+                        </a:rPr>
+                        <m:t>=</m:t>
+                      </m:r>
+                      <m:f>
+                        <m:fPr>
+                          <m:ctrlPr>
+                            <a:rPr lang="fr-CA" sz="1800" b="0" i="1" smtClean="0">
+                              <a:latin typeface="Cambria Math" panose="02040503050406030204" pitchFamily="18" charset="0"/>
+                            </a:rPr>
+                          </m:ctrlPr>
+                        </m:fPr>
+                        <m:num>
+                          <m:acc>
+                            <m:accPr>
+                              <m:chr m:val="⃗"/>
+                              <m:ctrlPr>
+                                <a:rPr lang="fr-CA" sz="1800" b="0" i="1" smtClean="0">
+                                  <a:latin typeface="Cambria Math" panose="02040503050406030204" pitchFamily="18" charset="0"/>
+                                </a:rPr>
+                              </m:ctrlPr>
+                            </m:accPr>
+                            <m:e>
+                              <m:r>
+                                <a:rPr lang="fr-CA" sz="1800" i="1">
+                                  <a:latin typeface="Cambria Math" panose="02040503050406030204" pitchFamily="18" charset="0"/>
+                                </a:rPr>
+                                <m:t>𝑣</m:t>
+                              </m:r>
+                            </m:e>
+                          </m:acc>
+                        </m:num>
+                        <m:den>
+                          <m:d>
+                            <m:dPr>
+                              <m:begChr m:val="‖"/>
+                              <m:endChr m:val="‖"/>
+                              <m:ctrlPr>
+                                <a:rPr lang="fr-CA" sz="1800" b="0" i="1" smtClean="0">
+                                  <a:latin typeface="Cambria Math" panose="02040503050406030204" pitchFamily="18" charset="0"/>
+                                </a:rPr>
+                              </m:ctrlPr>
+                            </m:dPr>
+                            <m:e>
+                              <m:acc>
+                                <m:accPr>
+                                  <m:chr m:val="⃗"/>
+                                  <m:ctrlPr>
+                                    <a:rPr lang="fr-CA" sz="1800" i="1">
+                                      <a:latin typeface="Cambria Math" panose="02040503050406030204" pitchFamily="18" charset="0"/>
+                                    </a:rPr>
+                                  </m:ctrlPr>
+                                </m:accPr>
+                                <m:e>
+                                  <m:r>
+                                    <a:rPr lang="fr-CA" sz="1800" i="1">
+                                      <a:latin typeface="Cambria Math" panose="02040503050406030204" pitchFamily="18" charset="0"/>
+                                    </a:rPr>
+                                    <m:t>𝑣</m:t>
+                                  </m:r>
+                                </m:e>
+                              </m:acc>
+                            </m:e>
+                          </m:d>
+                        </m:den>
+                      </m:f>
+                      <m:r>
+                        <a:rPr lang="fr-CA" sz="1800" b="0" i="1" smtClean="0">
+                          <a:latin typeface="Cambria Math" panose="02040503050406030204" pitchFamily="18" charset="0"/>
+                        </a:rPr>
+                        <m:t>=</m:t>
+                      </m:r>
+                      <m:d>
+                        <m:dPr>
+                          <m:begChr m:val="⟨"/>
+                          <m:endChr m:val="⟩"/>
+                          <m:ctrlPr>
+                            <a:rPr lang="fr-CA" sz="1800" b="0" i="1" smtClean="0">
+                              <a:latin typeface="Cambria Math" panose="02040503050406030204" pitchFamily="18" charset="0"/>
+                            </a:rPr>
+                          </m:ctrlPr>
+                        </m:dPr>
+                        <m:e>
+                          <m:f>
+                            <m:fPr>
+                              <m:ctrlPr>
+                                <a:rPr lang="fr-CA" sz="1800" b="0" i="1" smtClean="0">
+                                  <a:latin typeface="Cambria Math" panose="02040503050406030204" pitchFamily="18" charset="0"/>
+                                </a:rPr>
+                              </m:ctrlPr>
+                            </m:fPr>
+                            <m:num>
+                              <m:sSub>
+                                <m:sSubPr>
+                                  <m:ctrlPr>
+                                    <a:rPr lang="fr-CA" sz="1800" b="0" i="1" smtClean="0">
+                                      <a:latin typeface="Cambria Math" panose="02040503050406030204" pitchFamily="18" charset="0"/>
+                                    </a:rPr>
+                                  </m:ctrlPr>
+                                </m:sSubPr>
+                                <m:e>
+                                  <m:r>
+                                    <a:rPr lang="fr-CA" sz="1800" b="0" i="1" smtClean="0">
+                                      <a:latin typeface="Cambria Math" panose="02040503050406030204" pitchFamily="18" charset="0"/>
+                                    </a:rPr>
+                                    <m:t>𝑣</m:t>
+                                  </m:r>
+                                </m:e>
+                                <m:sub>
+                                  <m:r>
+                                    <a:rPr lang="fr-CA" sz="1800" b="0" i="1" smtClean="0">
+                                      <a:latin typeface="Cambria Math" panose="02040503050406030204" pitchFamily="18" charset="0"/>
+                                    </a:rPr>
+                                    <m:t>𝑥</m:t>
+                                  </m:r>
+                                </m:sub>
+                              </m:sSub>
+                            </m:num>
+                            <m:den>
+                              <m:d>
+                                <m:dPr>
+                                  <m:begChr m:val="‖"/>
+                                  <m:endChr m:val="‖"/>
+                                  <m:ctrlPr>
+                                    <a:rPr lang="fr-CA" sz="1800" i="1">
+                                      <a:latin typeface="Cambria Math" panose="02040503050406030204" pitchFamily="18" charset="0"/>
+                                    </a:rPr>
+                                  </m:ctrlPr>
+                                </m:dPr>
+                                <m:e>
+                                  <m:acc>
+                                    <m:accPr>
+                                      <m:chr m:val="⃗"/>
+                                      <m:ctrlPr>
+                                        <a:rPr lang="fr-CA" sz="1800" i="1">
+                                          <a:latin typeface="Cambria Math" panose="02040503050406030204" pitchFamily="18" charset="0"/>
+                                        </a:rPr>
+                                      </m:ctrlPr>
+                                    </m:accPr>
+                                    <m:e>
+                                      <m:r>
+                                        <a:rPr lang="fr-CA" sz="1800" i="1">
+                                          <a:latin typeface="Cambria Math" panose="02040503050406030204" pitchFamily="18" charset="0"/>
+                                        </a:rPr>
+                                        <m:t>𝑣</m:t>
+                                      </m:r>
+                                    </m:e>
+                                  </m:acc>
+                                </m:e>
+                              </m:d>
+                            </m:den>
+                          </m:f>
+                          <m:r>
+                            <a:rPr lang="fr-CA" sz="1800" b="0" i="1" smtClean="0">
+                              <a:latin typeface="Cambria Math" panose="02040503050406030204" pitchFamily="18" charset="0"/>
+                            </a:rPr>
+                            <m:t>,</m:t>
+                          </m:r>
+                          <m:f>
+                            <m:fPr>
+                              <m:ctrlPr>
+                                <a:rPr lang="fr-CA" sz="1800" i="1">
+                                  <a:latin typeface="Cambria Math" panose="02040503050406030204" pitchFamily="18" charset="0"/>
+                                </a:rPr>
+                              </m:ctrlPr>
+                            </m:fPr>
+                            <m:num>
+                              <m:sSub>
+                                <m:sSubPr>
+                                  <m:ctrlPr>
+                                    <a:rPr lang="fr-CA" sz="1800" i="1">
+                                      <a:latin typeface="Cambria Math" panose="02040503050406030204" pitchFamily="18" charset="0"/>
+                                    </a:rPr>
+                                  </m:ctrlPr>
+                                </m:sSubPr>
+                                <m:e>
+                                  <m:r>
+                                    <a:rPr lang="fr-CA" sz="1800" i="1">
+                                      <a:latin typeface="Cambria Math" panose="02040503050406030204" pitchFamily="18" charset="0"/>
+                                    </a:rPr>
+                                    <m:t>𝑣</m:t>
+                                  </m:r>
+                                </m:e>
+                                <m:sub>
+                                  <m:r>
+                                    <a:rPr lang="fr-CA" sz="1800" b="0" i="1" smtClean="0">
+                                      <a:latin typeface="Cambria Math" panose="02040503050406030204" pitchFamily="18" charset="0"/>
+                                    </a:rPr>
+                                    <m:t>𝑦</m:t>
+                                  </m:r>
+                                </m:sub>
+                              </m:sSub>
+                            </m:num>
+                            <m:den>
+                              <m:d>
+                                <m:dPr>
+                                  <m:begChr m:val="‖"/>
+                                  <m:endChr m:val="‖"/>
+                                  <m:ctrlPr>
+                                    <a:rPr lang="fr-CA" sz="1800" i="1">
+                                      <a:latin typeface="Cambria Math" panose="02040503050406030204" pitchFamily="18" charset="0"/>
+                                    </a:rPr>
+                                  </m:ctrlPr>
+                                </m:dPr>
+                                <m:e>
+                                  <m:acc>
+                                    <m:accPr>
+                                      <m:chr m:val="⃗"/>
+                                      <m:ctrlPr>
+                                        <a:rPr lang="fr-CA" sz="1800" i="1">
+                                          <a:latin typeface="Cambria Math" panose="02040503050406030204" pitchFamily="18" charset="0"/>
+                                        </a:rPr>
+                                      </m:ctrlPr>
+                                    </m:accPr>
+                                    <m:e>
+                                      <m:r>
+                                        <a:rPr lang="fr-CA" sz="1800" i="1">
+                                          <a:latin typeface="Cambria Math" panose="02040503050406030204" pitchFamily="18" charset="0"/>
+                                        </a:rPr>
+                                        <m:t>𝑣</m:t>
+                                      </m:r>
+                                    </m:e>
+                                  </m:acc>
+                                </m:e>
+                              </m:d>
+                            </m:den>
+                          </m:f>
+                          <m:r>
+                            <a:rPr lang="fr-CA" sz="1800" b="0" i="1" smtClean="0">
+                              <a:latin typeface="Cambria Math" panose="02040503050406030204" pitchFamily="18" charset="0"/>
+                            </a:rPr>
+                            <m:t>,</m:t>
+                          </m:r>
+                          <m:f>
+                            <m:fPr>
+                              <m:ctrlPr>
+                                <a:rPr lang="fr-CA" sz="1800" i="1">
+                                  <a:latin typeface="Cambria Math" panose="02040503050406030204" pitchFamily="18" charset="0"/>
+                                </a:rPr>
+                              </m:ctrlPr>
+                            </m:fPr>
+                            <m:num>
+                              <m:sSub>
+                                <m:sSubPr>
+                                  <m:ctrlPr>
+                                    <a:rPr lang="fr-CA" sz="1800" i="1">
+                                      <a:latin typeface="Cambria Math" panose="02040503050406030204" pitchFamily="18" charset="0"/>
+                                    </a:rPr>
+                                  </m:ctrlPr>
+                                </m:sSubPr>
+                                <m:e>
+                                  <m:r>
+                                    <a:rPr lang="fr-CA" sz="1800" i="1">
+                                      <a:latin typeface="Cambria Math" panose="02040503050406030204" pitchFamily="18" charset="0"/>
+                                    </a:rPr>
+                                    <m:t>𝑣</m:t>
+                                  </m:r>
+                                </m:e>
+                                <m:sub>
+                                  <m:r>
+                                    <a:rPr lang="fr-CA" sz="1800" b="0" i="1" smtClean="0">
+                                      <a:latin typeface="Cambria Math" panose="02040503050406030204" pitchFamily="18" charset="0"/>
+                                    </a:rPr>
+                                    <m:t>𝑧</m:t>
+                                  </m:r>
+                                </m:sub>
+                              </m:sSub>
+                            </m:num>
+                            <m:den>
+                              <m:d>
+                                <m:dPr>
+                                  <m:begChr m:val="‖"/>
+                                  <m:endChr m:val="‖"/>
+                                  <m:ctrlPr>
+                                    <a:rPr lang="fr-CA" sz="1800" i="1">
+                                      <a:latin typeface="Cambria Math" panose="02040503050406030204" pitchFamily="18" charset="0"/>
+                                    </a:rPr>
+                                  </m:ctrlPr>
+                                </m:dPr>
+                                <m:e>
+                                  <m:acc>
+                                    <m:accPr>
+                                      <m:chr m:val="⃗"/>
+                                      <m:ctrlPr>
+                                        <a:rPr lang="fr-CA" sz="1800" i="1">
+                                          <a:latin typeface="Cambria Math" panose="02040503050406030204" pitchFamily="18" charset="0"/>
+                                        </a:rPr>
+                                      </m:ctrlPr>
+                                    </m:accPr>
+                                    <m:e>
+                                      <m:r>
+                                        <a:rPr lang="fr-CA" sz="1800" i="1">
+                                          <a:latin typeface="Cambria Math" panose="02040503050406030204" pitchFamily="18" charset="0"/>
+                                        </a:rPr>
+                                        <m:t>𝑣</m:t>
+                                      </m:r>
+                                    </m:e>
+                                  </m:acc>
+                                </m:e>
+                              </m:d>
+                            </m:den>
+                          </m:f>
+                        </m:e>
+                      </m:d>
+                    </m:oMath>
+                  </m:oMathPara>
+                </a14:m>
+                <a:endParaRPr lang="fr-CA" sz="1800" dirty="0">
+                  <a:latin typeface="Consolas" panose="020B0609020204030204" pitchFamily="49" charset="0"/>
+                </a:endParaRPr>
+              </a:p>
+              <a:p>
+                <a:pPr marL="0" indent="0" algn="just">
+                  <a:lnSpc>
+                    <a:spcPct val="100000"/>
+                  </a:lnSpc>
+                  <a:buNone/>
+                </a:pPr>
+                <a:endParaRPr lang="fr-CA" sz="1800" dirty="0">
+                  <a:latin typeface="Consolas" panose="020B0609020204030204" pitchFamily="49" charset="0"/>
+                </a:endParaRPr>
+              </a:p>
+            </p:txBody>
+          </p:sp>
+        </mc:Choice>
+        <mc:Fallback>
+          <p:sp>
+            <p:nvSpPr>
+              <p:cNvPr id="3" name="Content Placeholder 2">
+                <a:extLst>
+                  <a:ext uri="{FF2B5EF4-FFF2-40B4-BE49-F238E27FC236}">
+                    <a16:creationId xmlns:a16="http://schemas.microsoft.com/office/drawing/2014/main" id="{B05F3990-4E4A-E9D2-9105-6733A061A3E1}"/>
+                  </a:ext>
+                </a:extLst>
+              </p:cNvPr>
+              <p:cNvSpPr>
+                <a:spLocks noGrp="1" noRot="1" noChangeAspect="1" noMove="1" noResize="1" noEditPoints="1" noAdjustHandles="1" noChangeArrowheads="1" noChangeShapeType="1" noTextEdit="1"/>
+              </p:cNvSpPr>
+              <p:nvPr>
+                <p:ph idx="1"/>
+              </p:nvPr>
+            </p:nvSpPr>
+            <p:spPr>
+              <a:blipFill>
+                <a:blip r:embed="rId2"/>
+                <a:stretch>
+                  <a:fillRect l="-522" r="-464"/>
+                </a:stretch>
+              </a:blipFill>
+            </p:spPr>
+            <p:txBody>
+              <a:bodyPr/>
+              <a:lstStyle/>
+              <a:p>
+                <a:r>
+                  <a:rPr lang="fr-CA">
+                    <a:noFill/>
+                  </a:rPr>
+                  <a:t> </a:t>
+                </a:r>
+              </a:p>
+            </p:txBody>
+          </p:sp>
+        </mc:Fallback>
+      </mc:AlternateContent>
+      <p:sp>
+        <p:nvSpPr>
+          <p:cNvPr id="4" name="Slide Number Placeholder 3">
+            <a:extLst>
+              <a:ext uri="{FF2B5EF4-FFF2-40B4-BE49-F238E27FC236}">
+                <a16:creationId xmlns:a16="http://schemas.microsoft.com/office/drawing/2014/main" id="{FA9069FD-7467-A109-B4AE-393F75C0955C}"/>
+              </a:ext>
+            </a:extLst>
+          </p:cNvPr>
+          <p:cNvSpPr>
+            <a:spLocks noGrp="1"/>
+          </p:cNvSpPr>
+          <p:nvPr>
+            <p:ph type="sldNum" sz="quarter" idx="12"/>
+          </p:nvPr>
+        </p:nvSpPr>
+        <p:spPr/>
+        <p:txBody>
+          <a:bodyPr/>
+          <a:lstStyle/>
+          <a:p>
+            <a:fld id="{846B06B1-1179-491F-A487-8E0C403F7C13}" type="slidenum">
+              <a:rPr lang="fr-CA" smtClean="0"/>
+              <a:t>11</a:t>
+            </a:fld>
+            <a:endParaRPr lang="fr-CA"/>
+          </a:p>
+        </p:txBody>
+      </p:sp>
+    </p:spTree>
+    <p:extLst>
+      <p:ext uri="{BB962C8B-B14F-4D97-AF65-F5344CB8AC3E}">
+        <p14:creationId xmlns:p14="http://schemas.microsoft.com/office/powerpoint/2010/main" val="2262892210"/>
+      </p:ext>
+    </p:extLst>
+  </p:cSld>
+  <p:clrMapOvr>
+    <a:masterClrMapping/>
+  </p:clrMapOvr>
+</p:sld>
+</file>
+
+<file path=ppt/slides/slide12.xml><?xml version="1.0" encoding="utf-8"?>
+<p:sld xmlns:a="http://schemas.openxmlformats.org/drawingml/2006/main" xmlns:r="http://schemas.openxmlformats.org/officeDocument/2006/relationships" xmlns:p="http://schemas.openxmlformats.org/presentationml/2006/main">
+  <p:cSld>
+    <p:bg>
+      <p:bgPr>
+        <a:solidFill>
           <a:srgbClr val="FFFF00"/>
         </a:solidFill>
         <a:effectLst/>
@@ -6739,7 +7544,7 @@
 </p:sld>
 </file>
 
-<file path=ppt/slides/slide12.xml><?xml version="1.0" encoding="utf-8"?>
+<file path=ppt/slides/slide13.xml><?xml version="1.0" encoding="utf-8"?>
 <p:sld xmlns:a="http://schemas.openxmlformats.org/drawingml/2006/main" xmlns:r="http://schemas.openxmlformats.org/officeDocument/2006/relationships" xmlns:p="http://schemas.openxmlformats.org/presentationml/2006/main">
   <p:cSld>
     <p:bg>
@@ -7379,7 +8184,7 @@
           <a:p>
             <a:fld id="{846B06B1-1179-491F-A487-8E0C403F7C13}" type="slidenum">
               <a:rPr lang="fr-CA" smtClean="0"/>
-              <a:t>12</a:t>
+              <a:t>13</a:t>
             </a:fld>
             <a:endParaRPr lang="fr-CA"/>
           </a:p>
@@ -7880,7 +8685,7 @@
 </p:sld>
 </file>
 
-<file path=ppt/slides/slide13.xml><?xml version="1.0" encoding="utf-8"?>
+<file path=ppt/slides/slide14.xml><?xml version="1.0" encoding="utf-8"?>
 <p:sld xmlns:a="http://schemas.openxmlformats.org/drawingml/2006/main" xmlns:r="http://schemas.openxmlformats.org/officeDocument/2006/relationships" xmlns:p="http://schemas.openxmlformats.org/presentationml/2006/main">
   <p:cSld>
     <p:bg>
@@ -8370,7 +9175,7 @@
           <a:p>
             <a:fld id="{846B06B1-1179-491F-A487-8E0C403F7C13}" type="slidenum">
               <a:rPr lang="fr-CA" smtClean="0"/>
-              <a:t>13</a:t>
+              <a:t>14</a:t>
             </a:fld>
             <a:endParaRPr lang="fr-CA"/>
           </a:p>
@@ -8907,7 +9712,7 @@
 </p:sld>
 </file>
 
-<file path=ppt/slides/slide14.xml><?xml version="1.0" encoding="utf-8"?>
+<file path=ppt/slides/slide15.xml><?xml version="1.0" encoding="utf-8"?>
 <p:sld xmlns:a="http://schemas.openxmlformats.org/drawingml/2006/main" xmlns:r="http://schemas.openxmlformats.org/officeDocument/2006/relationships" xmlns:p="http://schemas.openxmlformats.org/presentationml/2006/main">
   <p:cSld>
     <p:bg>
@@ -9289,7 +10094,7 @@
           <a:p>
             <a:fld id="{846B06B1-1179-491F-A487-8E0C403F7C13}" type="slidenum">
               <a:rPr lang="fr-CA" smtClean="0"/>
-              <a:t>14</a:t>
+              <a:t>15</a:t>
             </a:fld>
             <a:endParaRPr lang="fr-CA"/>
           </a:p>
@@ -9668,7 +10473,7 @@
 </p:sld>
 </file>
 
-<file path=ppt/slides/slide15.xml><?xml version="1.0" encoding="utf-8"?>
+<file path=ppt/slides/slide16.xml><?xml version="1.0" encoding="utf-8"?>
 <p:sld xmlns:a="http://schemas.openxmlformats.org/drawingml/2006/main" xmlns:r="http://schemas.openxmlformats.org/officeDocument/2006/relationships" xmlns:p="http://schemas.openxmlformats.org/presentationml/2006/main">
   <p:cSld>
     <p:bg>
@@ -10135,7 +10940,7 @@
           <a:p>
             <a:fld id="{846B06B1-1179-491F-A487-8E0C403F7C13}" type="slidenum">
               <a:rPr lang="fr-CA" smtClean="0"/>
-              <a:t>15</a:t>
+              <a:t>16</a:t>
             </a:fld>
             <a:endParaRPr lang="fr-CA"/>
           </a:p>
@@ -10749,7 +11554,7 @@
 </p:sld>
 </file>
 
-<file path=ppt/slides/slide16.xml><?xml version="1.0" encoding="utf-8"?>
+<file path=ppt/slides/slide17.xml><?xml version="1.0" encoding="utf-8"?>
 <p:sld xmlns:a="http://schemas.openxmlformats.org/drawingml/2006/main" xmlns:r="http://schemas.openxmlformats.org/officeDocument/2006/relationships" xmlns:p="http://schemas.openxmlformats.org/presentationml/2006/main">
   <p:cSld>
     <p:bg>
@@ -11484,7 +12289,7 @@
           <a:p>
             <a:fld id="{846B06B1-1179-491F-A487-8E0C403F7C13}" type="slidenum">
               <a:rPr lang="fr-CA" smtClean="0"/>
-              <a:t>16</a:t>
+              <a:t>17</a:t>
             </a:fld>
             <a:endParaRPr lang="fr-CA"/>
           </a:p>
@@ -11503,7 +12308,7 @@
 </p:sld>
 </file>
 
-<file path=ppt/slides/slide17.xml><?xml version="1.0" encoding="utf-8"?>
+<file path=ppt/slides/slide18.xml><?xml version="1.0" encoding="utf-8"?>
 <p:sld xmlns:a="http://schemas.openxmlformats.org/drawingml/2006/main" xmlns:r="http://schemas.openxmlformats.org/officeDocument/2006/relationships" xmlns:p="http://schemas.openxmlformats.org/presentationml/2006/main">
   <p:cSld>
     <p:bg>
@@ -11611,7 +12416,7 @@
           <a:p>
             <a:fld id="{846B06B1-1179-491F-A487-8E0C403F7C13}" type="slidenum">
               <a:rPr lang="fr-CA" smtClean="0"/>
-              <a:t>17</a:t>
+              <a:t>18</a:t>
             </a:fld>
             <a:endParaRPr lang="fr-CA"/>
           </a:p>
@@ -12254,7 +13059,7 @@
 </p:sld>
 </file>
 
-<file path=ppt/slides/slide18.xml><?xml version="1.0" encoding="utf-8"?>
+<file path=ppt/slides/slide19.xml><?xml version="1.0" encoding="utf-8"?>
 <p:sld xmlns:a="http://schemas.openxmlformats.org/drawingml/2006/main" xmlns:r="http://schemas.openxmlformats.org/officeDocument/2006/relationships" xmlns:p="http://schemas.openxmlformats.org/presentationml/2006/main">
   <p:cSld>
     <p:bg>
@@ -12510,7 +13315,7 @@
           <a:p>
             <a:fld id="{846B06B1-1179-491F-A487-8E0C403F7C13}" type="slidenum">
               <a:rPr lang="fr-CA" smtClean="0"/>
-              <a:t>18</a:t>
+              <a:t>19</a:t>
             </a:fld>
             <a:endParaRPr lang="fr-CA"/>
           </a:p>
@@ -13535,7 +14340,468 @@
 </p:sld>
 </file>
 
-<file path=ppt/slides/slide19.xml><?xml version="1.0" encoding="utf-8"?>
+<file path=ppt/slides/slide2.xml><?xml version="1.0" encoding="utf-8"?>
+<p:sld xmlns:a="http://schemas.openxmlformats.org/drawingml/2006/main" xmlns:r="http://schemas.openxmlformats.org/officeDocument/2006/relationships" xmlns:p="http://schemas.openxmlformats.org/presentationml/2006/main">
+  <p:cSld>
+    <p:bg>
+      <p:bgPr>
+        <a:solidFill>
+          <a:srgbClr val="F5F5F5"/>
+        </a:solidFill>
+        <a:effectLst/>
+      </p:bgPr>
+    </p:bg>
+    <p:spTree>
+      <p:nvGrpSpPr>
+        <p:cNvPr id="1" name="">
+          <a:extLst>
+            <a:ext uri="{FF2B5EF4-FFF2-40B4-BE49-F238E27FC236}">
+              <a16:creationId xmlns:a16="http://schemas.microsoft.com/office/drawing/2014/main" id="{9787BE08-8E87-BDAC-AA37-B1440F99BBB3}"/>
+            </a:ext>
+          </a:extLst>
+        </p:cNvPr>
+        <p:cNvGrpSpPr/>
+        <p:nvPr/>
+      </p:nvGrpSpPr>
+      <p:grpSpPr>
+        <a:xfrm>
+          <a:off x="0" y="0"/>
+          <a:ext cx="0" cy="0"/>
+          <a:chOff x="0" y="0"/>
+          <a:chExt cx="0" cy="0"/>
+        </a:xfrm>
+      </p:grpSpPr>
+      <p:sp>
+        <p:nvSpPr>
+          <p:cNvPr id="2" name="Title 1">
+            <a:extLst>
+              <a:ext uri="{FF2B5EF4-FFF2-40B4-BE49-F238E27FC236}">
+                <a16:creationId xmlns:a16="http://schemas.microsoft.com/office/drawing/2014/main" id="{2539027E-795E-A7E7-3EF9-F5DE694B487D}"/>
+              </a:ext>
+            </a:extLst>
+          </p:cNvPr>
+          <p:cNvSpPr>
+            <a:spLocks noGrp="1"/>
+          </p:cNvSpPr>
+          <p:nvPr>
+            <p:ph type="title"/>
+          </p:nvPr>
+        </p:nvSpPr>
+        <p:spPr/>
+        <p:txBody>
+          <a:bodyPr/>
+          <a:lstStyle/>
+          <a:p>
+            <a:r>
+              <a:rPr lang="en-US" dirty="0">
+                <a:latin typeface="Arial Rounded MT Bold" panose="020F0704030504030204" pitchFamily="34" charset="0"/>
+              </a:rPr>
+              <a:t>Plan</a:t>
+            </a:r>
+            <a:endParaRPr lang="fr-CA" dirty="0">
+              <a:latin typeface="Arial Rounded MT Bold" panose="020F0704030504030204" pitchFamily="34" charset="0"/>
+            </a:endParaRPr>
+          </a:p>
+        </p:txBody>
+      </p:sp>
+      <p:sp>
+        <p:nvSpPr>
+          <p:cNvPr id="3" name="Content Placeholder 2">
+            <a:extLst>
+              <a:ext uri="{FF2B5EF4-FFF2-40B4-BE49-F238E27FC236}">
+                <a16:creationId xmlns:a16="http://schemas.microsoft.com/office/drawing/2014/main" id="{1A2C692D-48DA-2C5B-C433-961FD8C3D9A4}"/>
+              </a:ext>
+            </a:extLst>
+          </p:cNvPr>
+          <p:cNvSpPr>
+            <a:spLocks noGrp="1"/>
+          </p:cNvSpPr>
+          <p:nvPr>
+            <p:ph idx="1"/>
+          </p:nvPr>
+        </p:nvSpPr>
+        <p:spPr/>
+        <p:txBody>
+          <a:bodyPr>
+            <a:normAutofit/>
+          </a:bodyPr>
+          <a:lstStyle/>
+          <a:p>
+            <a:pPr algn="just"/>
+            <a:r>
+              <a:rPr lang="en-US" sz="2000" dirty="0">
+                <a:latin typeface="Consolas" panose="020B0609020204030204" pitchFamily="49" charset="0"/>
+              </a:rPr>
+              <a:t>Notions </a:t>
+            </a:r>
+            <a:r>
+              <a:rPr lang="en-US" sz="2000" dirty="0" err="1">
+                <a:latin typeface="Consolas" panose="020B0609020204030204" pitchFamily="49" charset="0"/>
+              </a:rPr>
+              <a:t>intermédiaires</a:t>
+            </a:r>
+            <a:endParaRPr lang="en-US" sz="2000" dirty="0">
+              <a:latin typeface="Consolas" panose="020B0609020204030204" pitchFamily="49" charset="0"/>
+            </a:endParaRPr>
+          </a:p>
+          <a:p>
+            <a:pPr algn="just"/>
+            <a:r>
+              <a:rPr lang="fr-CA" sz="2000" dirty="0">
+                <a:latin typeface="Consolas" panose="020B0609020204030204" pitchFamily="49" charset="0"/>
+              </a:rPr>
+              <a:t>É</a:t>
+            </a:r>
+            <a:r>
+              <a:rPr lang="en-US" sz="2000" dirty="0" err="1">
+                <a:latin typeface="Consolas" panose="020B0609020204030204" pitchFamily="49" charset="0"/>
+              </a:rPr>
+              <a:t>crire</a:t>
+            </a:r>
+            <a:r>
+              <a:rPr lang="en-US" sz="2000" dirty="0">
+                <a:latin typeface="Consolas" panose="020B0609020204030204" pitchFamily="49" charset="0"/>
+              </a:rPr>
+              <a:t> du</a:t>
+            </a:r>
+            <a:r>
+              <a:rPr lang="fr-CA" sz="2000" dirty="0">
+                <a:latin typeface="Consolas" panose="020B0609020204030204" pitchFamily="49" charset="0"/>
+              </a:rPr>
+              <a:t> "vrai"</a:t>
+            </a:r>
+            <a:r>
+              <a:rPr lang="en-US" sz="2000" i="1" dirty="0">
+                <a:latin typeface="Consolas" panose="020B0609020204030204" pitchFamily="49" charset="0"/>
+              </a:rPr>
+              <a:t> </a:t>
+            </a:r>
+            <a:r>
+              <a:rPr lang="en-US" sz="2000" dirty="0">
+                <a:latin typeface="Consolas" panose="020B0609020204030204" pitchFamily="49" charset="0"/>
+              </a:rPr>
+              <a:t>code</a:t>
+            </a:r>
+          </a:p>
+          <a:p>
+            <a:pPr algn="just"/>
+            <a:r>
+              <a:rPr lang="fr-CA" sz="2000" dirty="0">
+                <a:latin typeface="Consolas" panose="020B0609020204030204" pitchFamily="49" charset="0"/>
+              </a:rPr>
+              <a:t>S'amuser</a:t>
+            </a:r>
+          </a:p>
+        </p:txBody>
+      </p:sp>
+      <p:sp>
+        <p:nvSpPr>
+          <p:cNvPr id="5" name="Slide Number Placeholder 4">
+            <a:extLst>
+              <a:ext uri="{FF2B5EF4-FFF2-40B4-BE49-F238E27FC236}">
+                <a16:creationId xmlns:a16="http://schemas.microsoft.com/office/drawing/2014/main" id="{30A9ACC9-0207-BF8C-83A4-76A47041FF41}"/>
+              </a:ext>
+            </a:extLst>
+          </p:cNvPr>
+          <p:cNvSpPr>
+            <a:spLocks noGrp="1"/>
+          </p:cNvSpPr>
+          <p:nvPr>
+            <p:ph type="sldNum" sz="quarter" idx="12"/>
+          </p:nvPr>
+        </p:nvSpPr>
+        <p:spPr/>
+        <p:txBody>
+          <a:bodyPr/>
+          <a:lstStyle/>
+          <a:p>
+            <a:fld id="{846B06B1-1179-491F-A487-8E0C403F7C13}" type="slidenum">
+              <a:rPr lang="fr-CA" smtClean="0"/>
+              <a:t>2</a:t>
+            </a:fld>
+            <a:endParaRPr lang="fr-CA" dirty="0"/>
+          </a:p>
+        </p:txBody>
+      </p:sp>
+      <p:pic>
+        <p:nvPicPr>
+          <p:cNvPr id="6" name="Picture 2" descr="Generated QR Image">
+            <a:extLst>
+              <a:ext uri="{FF2B5EF4-FFF2-40B4-BE49-F238E27FC236}">
+                <a16:creationId xmlns:a16="http://schemas.microsoft.com/office/drawing/2014/main" id="{55503CE9-4B4C-6B08-7AE7-D706357A15F7}"/>
+              </a:ext>
+            </a:extLst>
+          </p:cNvPr>
+          <p:cNvPicPr>
+            <a:picLocks noChangeAspect="1" noChangeArrowheads="1"/>
+          </p:cNvPicPr>
+          <p:nvPr/>
+        </p:nvPicPr>
+        <p:blipFill>
+          <a:blip r:embed="rId3">
+            <a:extLst>
+              <a:ext uri="{28A0092B-C50C-407E-A947-70E740481C1C}">
+                <a14:useLocalDpi xmlns:a14="http://schemas.microsoft.com/office/drawing/2010/main" val="0"/>
+              </a:ext>
+            </a:extLst>
+          </a:blip>
+          <a:srcRect/>
+          <a:stretch>
+            <a:fillRect/>
+          </a:stretch>
+        </p:blipFill>
+        <p:spPr bwMode="auto">
+          <a:xfrm>
+            <a:off x="6095999" y="1825625"/>
+            <a:ext cx="4105275" cy="4105275"/>
+          </a:xfrm>
+          <a:prstGeom prst="rect">
+            <a:avLst/>
+          </a:prstGeom>
+          <a:noFill/>
+          <a:extLst>
+            <a:ext uri="{909E8E84-426E-40DD-AFC4-6F175D3DCCD1}">
+              <a14:hiddenFill xmlns:a14="http://schemas.microsoft.com/office/drawing/2010/main">
+                <a:solidFill>
+                  <a:srgbClr val="FFFFFF"/>
+                </a:solidFill>
+              </a14:hiddenFill>
+            </a:ext>
+          </a:extLst>
+        </p:spPr>
+      </p:pic>
+    </p:spTree>
+    <p:extLst>
+      <p:ext uri="{BB962C8B-B14F-4D97-AF65-F5344CB8AC3E}">
+        <p14:creationId xmlns:p14="http://schemas.microsoft.com/office/powerpoint/2010/main" val="1707187834"/>
+      </p:ext>
+    </p:extLst>
+  </p:cSld>
+  <p:clrMapOvr>
+    <a:masterClrMapping/>
+  </p:clrMapOvr>
+  <p:timing>
+    <p:tnLst>
+      <p:par>
+        <p:cTn id="1" dur="indefinite" restart="never" nodeType="tmRoot">
+          <p:childTnLst>
+            <p:seq concurrent="1" nextAc="seek">
+              <p:cTn id="2" dur="indefinite" nodeType="mainSeq">
+                <p:childTnLst>
+                  <p:par>
+                    <p:cTn id="3" fill="hold">
+                      <p:stCondLst>
+                        <p:cond delay="indefinite"/>
+                      </p:stCondLst>
+                      <p:childTnLst>
+                        <p:par>
+                          <p:cTn id="4" fill="hold">
+                            <p:stCondLst>
+                              <p:cond delay="0"/>
+                            </p:stCondLst>
+                            <p:childTnLst>
+                              <p:par>
+                                <p:cTn id="5" presetID="10" presetClass="entr" presetSubtype="0" fill="hold" nodeType="clickEffect">
+                                  <p:stCondLst>
+                                    <p:cond delay="0"/>
+                                  </p:stCondLst>
+                                  <p:childTnLst>
+                                    <p:set>
+                                      <p:cBhvr>
+                                        <p:cTn id="6" dur="1" fill="hold">
+                                          <p:stCondLst>
+                                            <p:cond delay="0"/>
+                                          </p:stCondLst>
+                                        </p:cTn>
+                                        <p:tgtEl>
+                                          <p:spTgt spid="3">
+                                            <p:txEl>
+                                              <p:pRg st="0" end="0"/>
+                                            </p:txEl>
+                                          </p:spTgt>
+                                        </p:tgtEl>
+                                        <p:attrNameLst>
+                                          <p:attrName>style.visibility</p:attrName>
+                                        </p:attrNameLst>
+                                      </p:cBhvr>
+                                      <p:to>
+                                        <p:strVal val="visible"/>
+                                      </p:to>
+                                    </p:set>
+                                    <p:animEffect transition="in" filter="fade">
+                                      <p:cBhvr>
+                                        <p:cTn id="7" dur="500"/>
+                                        <p:tgtEl>
+                                          <p:spTgt spid="3">
+                                            <p:txEl>
+                                              <p:pRg st="0" end="0"/>
+                                            </p:txEl>
+                                          </p:spTgt>
+                                        </p:tgtEl>
+                                      </p:cBhvr>
+                                    </p:animEffect>
+                                  </p:childTnLst>
+                                </p:cTn>
+                              </p:par>
+                            </p:childTnLst>
+                          </p:cTn>
+                        </p:par>
+                      </p:childTnLst>
+                    </p:cTn>
+                  </p:par>
+                  <p:par>
+                    <p:cTn id="8" fill="hold">
+                      <p:stCondLst>
+                        <p:cond delay="indefinite"/>
+                      </p:stCondLst>
+                      <p:childTnLst>
+                        <p:par>
+                          <p:cTn id="9" fill="hold">
+                            <p:stCondLst>
+                              <p:cond delay="0"/>
+                            </p:stCondLst>
+                            <p:childTnLst>
+                              <p:par>
+                                <p:cTn id="10" presetID="10" presetClass="entr" presetSubtype="0" fill="hold" nodeType="clickEffect">
+                                  <p:stCondLst>
+                                    <p:cond delay="0"/>
+                                  </p:stCondLst>
+                                  <p:childTnLst>
+                                    <p:set>
+                                      <p:cBhvr>
+                                        <p:cTn id="11" dur="1" fill="hold">
+                                          <p:stCondLst>
+                                            <p:cond delay="0"/>
+                                          </p:stCondLst>
+                                        </p:cTn>
+                                        <p:tgtEl>
+                                          <p:spTgt spid="3">
+                                            <p:txEl>
+                                              <p:pRg st="1" end="1"/>
+                                            </p:txEl>
+                                          </p:spTgt>
+                                        </p:tgtEl>
+                                        <p:attrNameLst>
+                                          <p:attrName>style.visibility</p:attrName>
+                                        </p:attrNameLst>
+                                      </p:cBhvr>
+                                      <p:to>
+                                        <p:strVal val="visible"/>
+                                      </p:to>
+                                    </p:set>
+                                    <p:animEffect transition="in" filter="fade">
+                                      <p:cBhvr>
+                                        <p:cTn id="12" dur="500"/>
+                                        <p:tgtEl>
+                                          <p:spTgt spid="3">
+                                            <p:txEl>
+                                              <p:pRg st="1" end="1"/>
+                                            </p:txEl>
+                                          </p:spTgt>
+                                        </p:tgtEl>
+                                      </p:cBhvr>
+                                    </p:animEffect>
+                                  </p:childTnLst>
+                                </p:cTn>
+                              </p:par>
+                            </p:childTnLst>
+                          </p:cTn>
+                        </p:par>
+                      </p:childTnLst>
+                    </p:cTn>
+                  </p:par>
+                  <p:par>
+                    <p:cTn id="13" fill="hold">
+                      <p:stCondLst>
+                        <p:cond delay="indefinite"/>
+                      </p:stCondLst>
+                      <p:childTnLst>
+                        <p:par>
+                          <p:cTn id="14" fill="hold">
+                            <p:stCondLst>
+                              <p:cond delay="0"/>
+                            </p:stCondLst>
+                            <p:childTnLst>
+                              <p:par>
+                                <p:cTn id="15" presetID="10" presetClass="entr" presetSubtype="0" fill="hold" nodeType="clickEffect">
+                                  <p:stCondLst>
+                                    <p:cond delay="0"/>
+                                  </p:stCondLst>
+                                  <p:childTnLst>
+                                    <p:set>
+                                      <p:cBhvr>
+                                        <p:cTn id="16" dur="1" fill="hold">
+                                          <p:stCondLst>
+                                            <p:cond delay="0"/>
+                                          </p:stCondLst>
+                                        </p:cTn>
+                                        <p:tgtEl>
+                                          <p:spTgt spid="3">
+                                            <p:txEl>
+                                              <p:pRg st="2" end="2"/>
+                                            </p:txEl>
+                                          </p:spTgt>
+                                        </p:tgtEl>
+                                        <p:attrNameLst>
+                                          <p:attrName>style.visibility</p:attrName>
+                                        </p:attrNameLst>
+                                      </p:cBhvr>
+                                      <p:to>
+                                        <p:strVal val="visible"/>
+                                      </p:to>
+                                    </p:set>
+                                    <p:animEffect transition="in" filter="fade">
+                                      <p:cBhvr>
+                                        <p:cTn id="17" dur="500"/>
+                                        <p:tgtEl>
+                                          <p:spTgt spid="3">
+                                            <p:txEl>
+                                              <p:pRg st="2" end="2"/>
+                                            </p:txEl>
+                                          </p:spTgt>
+                                        </p:tgtEl>
+                                      </p:cBhvr>
+                                    </p:animEffect>
+                                  </p:childTnLst>
+                                </p:cTn>
+                              </p:par>
+                            </p:childTnLst>
+                          </p:cTn>
+                        </p:par>
+                      </p:childTnLst>
+                    </p:cTn>
+                  </p:par>
+                </p:childTnLst>
+              </p:cTn>
+              <p:prevCondLst>
+                <p:cond evt="onPrev" delay="0">
+                  <p:tgtEl>
+                    <p:sldTgt/>
+                  </p:tgtEl>
+                </p:cond>
+              </p:prevCondLst>
+              <p:nextCondLst>
+                <p:cond evt="onNext" delay="0">
+                  <p:tgtEl>
+                    <p:sldTgt/>
+                  </p:tgtEl>
+                </p:cond>
+              </p:nextCondLst>
+            </p:seq>
+          </p:childTnLst>
+        </p:cTn>
+      </p:par>
+    </p:tnLst>
+  </p:timing>
+  <p:extLst>
+    <p:ext uri="{6950BFC3-D8DA-4A85-94F7-54DA5524770B}">
+      <p188:commentRel xmlns:p188="http://schemas.microsoft.com/office/powerpoint/2018/8/main" r:id="rId2"/>
+    </p:ext>
+  </p:extLst>
+</p:sld>
+</file>
+
+<file path=ppt/slides/slide20.xml><?xml version="1.0" encoding="utf-8"?>
 <p:sld xmlns:a="http://schemas.openxmlformats.org/drawingml/2006/main" xmlns:r="http://schemas.openxmlformats.org/officeDocument/2006/relationships" xmlns:p="http://schemas.openxmlformats.org/presentationml/2006/main">
   <p:cSld>
     <p:bg>
@@ -13802,7 +15068,7 @@
           <a:p>
             <a:fld id="{846B06B1-1179-491F-A487-8E0C403F7C13}" type="slidenum">
               <a:rPr lang="fr-CA" smtClean="0"/>
-              <a:t>19</a:t>
+              <a:t>20</a:t>
             </a:fld>
             <a:endParaRPr lang="fr-CA"/>
           </a:p>
@@ -14326,468 +15592,7 @@
 </p:sld>
 </file>
 
-<file path=ppt/slides/slide2.xml><?xml version="1.0" encoding="utf-8"?>
-<p:sld xmlns:a="http://schemas.openxmlformats.org/drawingml/2006/main" xmlns:r="http://schemas.openxmlformats.org/officeDocument/2006/relationships" xmlns:p="http://schemas.openxmlformats.org/presentationml/2006/main">
-  <p:cSld>
-    <p:bg>
-      <p:bgPr>
-        <a:solidFill>
-          <a:srgbClr val="F5F5F5"/>
-        </a:solidFill>
-        <a:effectLst/>
-      </p:bgPr>
-    </p:bg>
-    <p:spTree>
-      <p:nvGrpSpPr>
-        <p:cNvPr id="1" name="">
-          <a:extLst>
-            <a:ext uri="{FF2B5EF4-FFF2-40B4-BE49-F238E27FC236}">
-              <a16:creationId xmlns:a16="http://schemas.microsoft.com/office/drawing/2014/main" id="{9787BE08-8E87-BDAC-AA37-B1440F99BBB3}"/>
-            </a:ext>
-          </a:extLst>
-        </p:cNvPr>
-        <p:cNvGrpSpPr/>
-        <p:nvPr/>
-      </p:nvGrpSpPr>
-      <p:grpSpPr>
-        <a:xfrm>
-          <a:off x="0" y="0"/>
-          <a:ext cx="0" cy="0"/>
-          <a:chOff x="0" y="0"/>
-          <a:chExt cx="0" cy="0"/>
-        </a:xfrm>
-      </p:grpSpPr>
-      <p:sp>
-        <p:nvSpPr>
-          <p:cNvPr id="2" name="Title 1">
-            <a:extLst>
-              <a:ext uri="{FF2B5EF4-FFF2-40B4-BE49-F238E27FC236}">
-                <a16:creationId xmlns:a16="http://schemas.microsoft.com/office/drawing/2014/main" id="{2539027E-795E-A7E7-3EF9-F5DE694B487D}"/>
-              </a:ext>
-            </a:extLst>
-          </p:cNvPr>
-          <p:cNvSpPr>
-            <a:spLocks noGrp="1"/>
-          </p:cNvSpPr>
-          <p:nvPr>
-            <p:ph type="title"/>
-          </p:nvPr>
-        </p:nvSpPr>
-        <p:spPr/>
-        <p:txBody>
-          <a:bodyPr/>
-          <a:lstStyle/>
-          <a:p>
-            <a:r>
-              <a:rPr lang="en-US" dirty="0">
-                <a:latin typeface="Arial Rounded MT Bold" panose="020F0704030504030204" pitchFamily="34" charset="0"/>
-              </a:rPr>
-              <a:t>Plan</a:t>
-            </a:r>
-            <a:endParaRPr lang="fr-CA" dirty="0">
-              <a:latin typeface="Arial Rounded MT Bold" panose="020F0704030504030204" pitchFamily="34" charset="0"/>
-            </a:endParaRPr>
-          </a:p>
-        </p:txBody>
-      </p:sp>
-      <p:sp>
-        <p:nvSpPr>
-          <p:cNvPr id="3" name="Content Placeholder 2">
-            <a:extLst>
-              <a:ext uri="{FF2B5EF4-FFF2-40B4-BE49-F238E27FC236}">
-                <a16:creationId xmlns:a16="http://schemas.microsoft.com/office/drawing/2014/main" id="{1A2C692D-48DA-2C5B-C433-961FD8C3D9A4}"/>
-              </a:ext>
-            </a:extLst>
-          </p:cNvPr>
-          <p:cNvSpPr>
-            <a:spLocks noGrp="1"/>
-          </p:cNvSpPr>
-          <p:nvPr>
-            <p:ph idx="1"/>
-          </p:nvPr>
-        </p:nvSpPr>
-        <p:spPr/>
-        <p:txBody>
-          <a:bodyPr>
-            <a:normAutofit/>
-          </a:bodyPr>
-          <a:lstStyle/>
-          <a:p>
-            <a:pPr algn="just"/>
-            <a:r>
-              <a:rPr lang="en-US" sz="2000" dirty="0">
-                <a:latin typeface="Consolas" panose="020B0609020204030204" pitchFamily="49" charset="0"/>
-              </a:rPr>
-              <a:t>Notions </a:t>
-            </a:r>
-            <a:r>
-              <a:rPr lang="en-US" sz="2000" dirty="0" err="1">
-                <a:latin typeface="Consolas" panose="020B0609020204030204" pitchFamily="49" charset="0"/>
-              </a:rPr>
-              <a:t>intermédiaires</a:t>
-            </a:r>
-            <a:endParaRPr lang="en-US" sz="2000" dirty="0">
-              <a:latin typeface="Consolas" panose="020B0609020204030204" pitchFamily="49" charset="0"/>
-            </a:endParaRPr>
-          </a:p>
-          <a:p>
-            <a:pPr algn="just"/>
-            <a:r>
-              <a:rPr lang="fr-CA" sz="2000" dirty="0">
-                <a:latin typeface="Consolas" panose="020B0609020204030204" pitchFamily="49" charset="0"/>
-              </a:rPr>
-              <a:t>É</a:t>
-            </a:r>
-            <a:r>
-              <a:rPr lang="en-US" sz="2000" dirty="0" err="1">
-                <a:latin typeface="Consolas" panose="020B0609020204030204" pitchFamily="49" charset="0"/>
-              </a:rPr>
-              <a:t>crire</a:t>
-            </a:r>
-            <a:r>
-              <a:rPr lang="en-US" sz="2000" dirty="0">
-                <a:latin typeface="Consolas" panose="020B0609020204030204" pitchFamily="49" charset="0"/>
-              </a:rPr>
-              <a:t> du</a:t>
-            </a:r>
-            <a:r>
-              <a:rPr lang="fr-CA" sz="2000" dirty="0">
-                <a:latin typeface="Consolas" panose="020B0609020204030204" pitchFamily="49" charset="0"/>
-              </a:rPr>
-              <a:t> "vrai"</a:t>
-            </a:r>
-            <a:r>
-              <a:rPr lang="en-US" sz="2000" i="1" dirty="0">
-                <a:latin typeface="Consolas" panose="020B0609020204030204" pitchFamily="49" charset="0"/>
-              </a:rPr>
-              <a:t> </a:t>
-            </a:r>
-            <a:r>
-              <a:rPr lang="en-US" sz="2000" dirty="0">
-                <a:latin typeface="Consolas" panose="020B0609020204030204" pitchFamily="49" charset="0"/>
-              </a:rPr>
-              <a:t>code</a:t>
-            </a:r>
-          </a:p>
-          <a:p>
-            <a:pPr algn="just"/>
-            <a:r>
-              <a:rPr lang="fr-CA" sz="2000" dirty="0">
-                <a:latin typeface="Consolas" panose="020B0609020204030204" pitchFamily="49" charset="0"/>
-              </a:rPr>
-              <a:t>S'amuser</a:t>
-            </a:r>
-          </a:p>
-        </p:txBody>
-      </p:sp>
-      <p:sp>
-        <p:nvSpPr>
-          <p:cNvPr id="5" name="Slide Number Placeholder 4">
-            <a:extLst>
-              <a:ext uri="{FF2B5EF4-FFF2-40B4-BE49-F238E27FC236}">
-                <a16:creationId xmlns:a16="http://schemas.microsoft.com/office/drawing/2014/main" id="{30A9ACC9-0207-BF8C-83A4-76A47041FF41}"/>
-              </a:ext>
-            </a:extLst>
-          </p:cNvPr>
-          <p:cNvSpPr>
-            <a:spLocks noGrp="1"/>
-          </p:cNvSpPr>
-          <p:nvPr>
-            <p:ph type="sldNum" sz="quarter" idx="12"/>
-          </p:nvPr>
-        </p:nvSpPr>
-        <p:spPr/>
-        <p:txBody>
-          <a:bodyPr/>
-          <a:lstStyle/>
-          <a:p>
-            <a:fld id="{846B06B1-1179-491F-A487-8E0C403F7C13}" type="slidenum">
-              <a:rPr lang="fr-CA" smtClean="0"/>
-              <a:t>2</a:t>
-            </a:fld>
-            <a:endParaRPr lang="fr-CA" dirty="0"/>
-          </a:p>
-        </p:txBody>
-      </p:sp>
-      <p:pic>
-        <p:nvPicPr>
-          <p:cNvPr id="6" name="Picture 2" descr="Generated QR Image">
-            <a:extLst>
-              <a:ext uri="{FF2B5EF4-FFF2-40B4-BE49-F238E27FC236}">
-                <a16:creationId xmlns:a16="http://schemas.microsoft.com/office/drawing/2014/main" id="{55503CE9-4B4C-6B08-7AE7-D706357A15F7}"/>
-              </a:ext>
-            </a:extLst>
-          </p:cNvPr>
-          <p:cNvPicPr>
-            <a:picLocks noChangeAspect="1" noChangeArrowheads="1"/>
-          </p:cNvPicPr>
-          <p:nvPr/>
-        </p:nvPicPr>
-        <p:blipFill>
-          <a:blip r:embed="rId3">
-            <a:extLst>
-              <a:ext uri="{28A0092B-C50C-407E-A947-70E740481C1C}">
-                <a14:useLocalDpi xmlns:a14="http://schemas.microsoft.com/office/drawing/2010/main" val="0"/>
-              </a:ext>
-            </a:extLst>
-          </a:blip>
-          <a:srcRect/>
-          <a:stretch>
-            <a:fillRect/>
-          </a:stretch>
-        </p:blipFill>
-        <p:spPr bwMode="auto">
-          <a:xfrm>
-            <a:off x="6095999" y="1825625"/>
-            <a:ext cx="4105275" cy="4105275"/>
-          </a:xfrm>
-          <a:prstGeom prst="rect">
-            <a:avLst/>
-          </a:prstGeom>
-          <a:noFill/>
-          <a:extLst>
-            <a:ext uri="{909E8E84-426E-40DD-AFC4-6F175D3DCCD1}">
-              <a14:hiddenFill xmlns:a14="http://schemas.microsoft.com/office/drawing/2010/main">
-                <a:solidFill>
-                  <a:srgbClr val="FFFFFF"/>
-                </a:solidFill>
-              </a14:hiddenFill>
-            </a:ext>
-          </a:extLst>
-        </p:spPr>
-      </p:pic>
-    </p:spTree>
-    <p:extLst>
-      <p:ext uri="{BB962C8B-B14F-4D97-AF65-F5344CB8AC3E}">
-        <p14:creationId xmlns:p14="http://schemas.microsoft.com/office/powerpoint/2010/main" val="1707187834"/>
-      </p:ext>
-    </p:extLst>
-  </p:cSld>
-  <p:clrMapOvr>
-    <a:masterClrMapping/>
-  </p:clrMapOvr>
-  <p:timing>
-    <p:tnLst>
-      <p:par>
-        <p:cTn id="1" dur="indefinite" restart="never" nodeType="tmRoot">
-          <p:childTnLst>
-            <p:seq concurrent="1" nextAc="seek">
-              <p:cTn id="2" dur="indefinite" nodeType="mainSeq">
-                <p:childTnLst>
-                  <p:par>
-                    <p:cTn id="3" fill="hold">
-                      <p:stCondLst>
-                        <p:cond delay="indefinite"/>
-                      </p:stCondLst>
-                      <p:childTnLst>
-                        <p:par>
-                          <p:cTn id="4" fill="hold">
-                            <p:stCondLst>
-                              <p:cond delay="0"/>
-                            </p:stCondLst>
-                            <p:childTnLst>
-                              <p:par>
-                                <p:cTn id="5" presetID="10" presetClass="entr" presetSubtype="0" fill="hold" nodeType="clickEffect">
-                                  <p:stCondLst>
-                                    <p:cond delay="0"/>
-                                  </p:stCondLst>
-                                  <p:childTnLst>
-                                    <p:set>
-                                      <p:cBhvr>
-                                        <p:cTn id="6" dur="1" fill="hold">
-                                          <p:stCondLst>
-                                            <p:cond delay="0"/>
-                                          </p:stCondLst>
-                                        </p:cTn>
-                                        <p:tgtEl>
-                                          <p:spTgt spid="3">
-                                            <p:txEl>
-                                              <p:pRg st="0" end="0"/>
-                                            </p:txEl>
-                                          </p:spTgt>
-                                        </p:tgtEl>
-                                        <p:attrNameLst>
-                                          <p:attrName>style.visibility</p:attrName>
-                                        </p:attrNameLst>
-                                      </p:cBhvr>
-                                      <p:to>
-                                        <p:strVal val="visible"/>
-                                      </p:to>
-                                    </p:set>
-                                    <p:animEffect transition="in" filter="fade">
-                                      <p:cBhvr>
-                                        <p:cTn id="7" dur="500"/>
-                                        <p:tgtEl>
-                                          <p:spTgt spid="3">
-                                            <p:txEl>
-                                              <p:pRg st="0" end="0"/>
-                                            </p:txEl>
-                                          </p:spTgt>
-                                        </p:tgtEl>
-                                      </p:cBhvr>
-                                    </p:animEffect>
-                                  </p:childTnLst>
-                                </p:cTn>
-                              </p:par>
-                            </p:childTnLst>
-                          </p:cTn>
-                        </p:par>
-                      </p:childTnLst>
-                    </p:cTn>
-                  </p:par>
-                  <p:par>
-                    <p:cTn id="8" fill="hold">
-                      <p:stCondLst>
-                        <p:cond delay="indefinite"/>
-                      </p:stCondLst>
-                      <p:childTnLst>
-                        <p:par>
-                          <p:cTn id="9" fill="hold">
-                            <p:stCondLst>
-                              <p:cond delay="0"/>
-                            </p:stCondLst>
-                            <p:childTnLst>
-                              <p:par>
-                                <p:cTn id="10" presetID="10" presetClass="entr" presetSubtype="0" fill="hold" nodeType="clickEffect">
-                                  <p:stCondLst>
-                                    <p:cond delay="0"/>
-                                  </p:stCondLst>
-                                  <p:childTnLst>
-                                    <p:set>
-                                      <p:cBhvr>
-                                        <p:cTn id="11" dur="1" fill="hold">
-                                          <p:stCondLst>
-                                            <p:cond delay="0"/>
-                                          </p:stCondLst>
-                                        </p:cTn>
-                                        <p:tgtEl>
-                                          <p:spTgt spid="3">
-                                            <p:txEl>
-                                              <p:pRg st="1" end="1"/>
-                                            </p:txEl>
-                                          </p:spTgt>
-                                        </p:tgtEl>
-                                        <p:attrNameLst>
-                                          <p:attrName>style.visibility</p:attrName>
-                                        </p:attrNameLst>
-                                      </p:cBhvr>
-                                      <p:to>
-                                        <p:strVal val="visible"/>
-                                      </p:to>
-                                    </p:set>
-                                    <p:animEffect transition="in" filter="fade">
-                                      <p:cBhvr>
-                                        <p:cTn id="12" dur="500"/>
-                                        <p:tgtEl>
-                                          <p:spTgt spid="3">
-                                            <p:txEl>
-                                              <p:pRg st="1" end="1"/>
-                                            </p:txEl>
-                                          </p:spTgt>
-                                        </p:tgtEl>
-                                      </p:cBhvr>
-                                    </p:animEffect>
-                                  </p:childTnLst>
-                                </p:cTn>
-                              </p:par>
-                            </p:childTnLst>
-                          </p:cTn>
-                        </p:par>
-                      </p:childTnLst>
-                    </p:cTn>
-                  </p:par>
-                  <p:par>
-                    <p:cTn id="13" fill="hold">
-                      <p:stCondLst>
-                        <p:cond delay="indefinite"/>
-                      </p:stCondLst>
-                      <p:childTnLst>
-                        <p:par>
-                          <p:cTn id="14" fill="hold">
-                            <p:stCondLst>
-                              <p:cond delay="0"/>
-                            </p:stCondLst>
-                            <p:childTnLst>
-                              <p:par>
-                                <p:cTn id="15" presetID="10" presetClass="entr" presetSubtype="0" fill="hold" nodeType="clickEffect">
-                                  <p:stCondLst>
-                                    <p:cond delay="0"/>
-                                  </p:stCondLst>
-                                  <p:childTnLst>
-                                    <p:set>
-                                      <p:cBhvr>
-                                        <p:cTn id="16" dur="1" fill="hold">
-                                          <p:stCondLst>
-                                            <p:cond delay="0"/>
-                                          </p:stCondLst>
-                                        </p:cTn>
-                                        <p:tgtEl>
-                                          <p:spTgt spid="3">
-                                            <p:txEl>
-                                              <p:pRg st="2" end="2"/>
-                                            </p:txEl>
-                                          </p:spTgt>
-                                        </p:tgtEl>
-                                        <p:attrNameLst>
-                                          <p:attrName>style.visibility</p:attrName>
-                                        </p:attrNameLst>
-                                      </p:cBhvr>
-                                      <p:to>
-                                        <p:strVal val="visible"/>
-                                      </p:to>
-                                    </p:set>
-                                    <p:animEffect transition="in" filter="fade">
-                                      <p:cBhvr>
-                                        <p:cTn id="17" dur="500"/>
-                                        <p:tgtEl>
-                                          <p:spTgt spid="3">
-                                            <p:txEl>
-                                              <p:pRg st="2" end="2"/>
-                                            </p:txEl>
-                                          </p:spTgt>
-                                        </p:tgtEl>
-                                      </p:cBhvr>
-                                    </p:animEffect>
-                                  </p:childTnLst>
-                                </p:cTn>
-                              </p:par>
-                            </p:childTnLst>
-                          </p:cTn>
-                        </p:par>
-                      </p:childTnLst>
-                    </p:cTn>
-                  </p:par>
-                </p:childTnLst>
-              </p:cTn>
-              <p:prevCondLst>
-                <p:cond evt="onPrev" delay="0">
-                  <p:tgtEl>
-                    <p:sldTgt/>
-                  </p:tgtEl>
-                </p:cond>
-              </p:prevCondLst>
-              <p:nextCondLst>
-                <p:cond evt="onNext" delay="0">
-                  <p:tgtEl>
-                    <p:sldTgt/>
-                  </p:tgtEl>
-                </p:cond>
-              </p:nextCondLst>
-            </p:seq>
-          </p:childTnLst>
-        </p:cTn>
-      </p:par>
-    </p:tnLst>
-  </p:timing>
-  <p:extLst>
-    <p:ext uri="{6950BFC3-D8DA-4A85-94F7-54DA5524770B}">
-      <p188:commentRel xmlns:p188="http://schemas.microsoft.com/office/powerpoint/2018/8/main" r:id="rId2"/>
-    </p:ext>
-  </p:extLst>
-</p:sld>
-</file>
-
-<file path=ppt/slides/slide20.xml><?xml version="1.0" encoding="utf-8"?>
+<file path=ppt/slides/slide21.xml><?xml version="1.0" encoding="utf-8"?>
 <p:sld xmlns:a="http://schemas.openxmlformats.org/drawingml/2006/main" xmlns:r="http://schemas.openxmlformats.org/officeDocument/2006/relationships" xmlns:p="http://schemas.openxmlformats.org/presentationml/2006/main">
   <p:cSld>
     <p:bg>
@@ -14841,7 +15646,7 @@
           <a:p>
             <a:fld id="{846B06B1-1179-491F-A487-8E0C403F7C13}" type="slidenum">
               <a:rPr lang="fr-CA" smtClean="0"/>
-              <a:t>20</a:t>
+              <a:t>21</a:t>
             </a:fld>
             <a:endParaRPr lang="fr-CA"/>
           </a:p>
@@ -15897,7 +16702,7 @@
 </p:sld>
 </file>
 
-<file path=ppt/slides/slide21.xml><?xml version="1.0" encoding="utf-8"?>
+<file path=ppt/slides/slide22.xml><?xml version="1.0" encoding="utf-8"?>
 <p:sld xmlns:a="http://schemas.openxmlformats.org/drawingml/2006/main" xmlns:r="http://schemas.openxmlformats.org/officeDocument/2006/relationships" xmlns:p="http://schemas.openxmlformats.org/presentationml/2006/main">
   <p:cSld>
     <p:bg>
@@ -16021,7 +16826,7 @@
           <a:p>
             <a:fld id="{846B06B1-1179-491F-A487-8E0C403F7C13}" type="slidenum">
               <a:rPr lang="fr-CA" smtClean="0"/>
-              <a:t>21</a:t>
+              <a:t>22</a:t>
             </a:fld>
             <a:endParaRPr lang="fr-CA"/>
           </a:p>
@@ -17005,7 +17810,7 @@
 </p:sld>
 </file>
 
-<file path=ppt/slides/slide22.xml><?xml version="1.0" encoding="utf-8"?>
+<file path=ppt/slides/slide23.xml><?xml version="1.0" encoding="utf-8"?>
 <p:sld xmlns:a="http://schemas.openxmlformats.org/drawingml/2006/main" xmlns:r="http://schemas.openxmlformats.org/officeDocument/2006/relationships" xmlns:p="http://schemas.openxmlformats.org/presentationml/2006/main">
   <p:cSld>
     <p:bg>
@@ -17106,7 +17911,7 @@
           <a:p>
             <a:fld id="{846B06B1-1179-491F-A487-8E0C403F7C13}" type="slidenum">
               <a:rPr lang="fr-CA" smtClean="0"/>
-              <a:t>22</a:t>
+              <a:t>23</a:t>
             </a:fld>
             <a:endParaRPr lang="fr-CA"/>
           </a:p>
@@ -18079,7 +18884,7 @@
 </p:sld>
 </file>
 
-<file path=ppt/slides/slide23.xml><?xml version="1.0" encoding="utf-8"?>
+<file path=ppt/slides/slide24.xml><?xml version="1.0" encoding="utf-8"?>
 <p:sld xmlns:a="http://schemas.openxmlformats.org/drawingml/2006/main" xmlns:r="http://schemas.openxmlformats.org/officeDocument/2006/relationships" xmlns:p="http://schemas.openxmlformats.org/presentationml/2006/main">
   <p:cSld>
     <p:bg>
@@ -18528,7 +19333,7 @@
           <a:p>
             <a:fld id="{846B06B1-1179-491F-A487-8E0C403F7C13}" type="slidenum">
               <a:rPr lang="fr-CA" smtClean="0"/>
-              <a:t>23</a:t>
+              <a:t>24</a:t>
             </a:fld>
             <a:endParaRPr lang="fr-CA"/>
           </a:p>
@@ -18547,7 +19352,7 @@
 </p:sld>
 </file>
 
-<file path=ppt/slides/slide24.xml><?xml version="1.0" encoding="utf-8"?>
+<file path=ppt/slides/slide25.xml><?xml version="1.0" encoding="utf-8"?>
 <p:sld xmlns:a="http://schemas.openxmlformats.org/drawingml/2006/main" xmlns:r="http://schemas.openxmlformats.org/officeDocument/2006/relationships" xmlns:p="http://schemas.openxmlformats.org/presentationml/2006/main">
   <p:cSld>
     <p:bg>
@@ -19175,7 +19980,7 @@
           <a:p>
             <a:fld id="{846B06B1-1179-491F-A487-8E0C403F7C13}" type="slidenum">
               <a:rPr lang="fr-CA" smtClean="0"/>
-              <a:t>24</a:t>
+              <a:t>25</a:t>
             </a:fld>
             <a:endParaRPr lang="fr-CA"/>
           </a:p>
@@ -20435,7 +21240,7 @@
 </p:sld>
 </file>
 
-<file path=ppt/slides/slide25.xml><?xml version="1.0" encoding="utf-8"?>
+<file path=ppt/slides/slide26.xml><?xml version="1.0" encoding="utf-8"?>
 <p:sld xmlns:a="http://schemas.openxmlformats.org/drawingml/2006/main" xmlns:r="http://schemas.openxmlformats.org/officeDocument/2006/relationships" xmlns:p="http://schemas.openxmlformats.org/presentationml/2006/main">
   <p:cSld>
     <p:bg>
@@ -20876,7 +21681,7 @@
           <a:p>
             <a:fld id="{846B06B1-1179-491F-A487-8E0C403F7C13}" type="slidenum">
               <a:rPr lang="fr-CA" smtClean="0"/>
-              <a:t>25</a:t>
+              <a:t>26</a:t>
             </a:fld>
             <a:endParaRPr lang="fr-CA"/>
           </a:p>
@@ -21508,7 +22313,7 @@
 </p:sld>
 </file>
 
-<file path=ppt/slides/slide26.xml><?xml version="1.0" encoding="utf-8"?>
+<file path=ppt/slides/slide27.xml><?xml version="1.0" encoding="utf-8"?>
 <p:sld xmlns:a="http://schemas.openxmlformats.org/drawingml/2006/main" xmlns:r="http://schemas.openxmlformats.org/officeDocument/2006/relationships" xmlns:p="http://schemas.openxmlformats.org/presentationml/2006/main">
   <p:cSld>
     <p:bg>
@@ -22005,7 +22810,7 @@
           <a:p>
             <a:fld id="{846B06B1-1179-491F-A487-8E0C403F7C13}" type="slidenum">
               <a:rPr lang="fr-CA" smtClean="0"/>
-              <a:t>26</a:t>
+              <a:t>27</a:t>
             </a:fld>
             <a:endParaRPr lang="fr-CA"/>
           </a:p>
@@ -22420,7 +23225,7 @@
 </p:sld>
 </file>
 
-<file path=ppt/slides/slide27.xml><?xml version="1.0" encoding="utf-8"?>
+<file path=ppt/slides/slide28.xml><?xml version="1.0" encoding="utf-8"?>
 <p:sld xmlns:a="http://schemas.openxmlformats.org/drawingml/2006/main" xmlns:r="http://schemas.openxmlformats.org/officeDocument/2006/relationships" xmlns:p="http://schemas.openxmlformats.org/presentationml/2006/main">
   <p:cSld>
     <p:bg>
@@ -22998,7 +23803,7 @@
           <a:p>
             <a:fld id="{846B06B1-1179-491F-A487-8E0C403F7C13}" type="slidenum">
               <a:rPr lang="fr-CA" smtClean="0"/>
-              <a:t>27</a:t>
+              <a:t>28</a:t>
             </a:fld>
             <a:endParaRPr lang="fr-CA"/>
           </a:p>
@@ -23736,7 +24541,7 @@
 </p:sld>
 </file>
 
-<file path=ppt/slides/slide28.xml><?xml version="1.0" encoding="utf-8"?>
+<file path=ppt/slides/slide29.xml><?xml version="1.0" encoding="utf-8"?>
 <p:sld xmlns:a="http://schemas.openxmlformats.org/drawingml/2006/main" xmlns:r="http://schemas.openxmlformats.org/officeDocument/2006/relationships" xmlns:p="http://schemas.openxmlformats.org/presentationml/2006/main">
   <p:cSld>
     <p:bg>
@@ -24254,7 +25059,7 @@
           <a:p>
             <a:fld id="{846B06B1-1179-491F-A487-8E0C403F7C13}" type="slidenum">
               <a:rPr lang="fr-CA" smtClean="0"/>
-              <a:t>28</a:t>
+              <a:t>29</a:t>
             </a:fld>
             <a:endParaRPr lang="fr-CA"/>
           </a:p>
@@ -24968,720 +25773,6 @@
 </p:sld>
 </file>
 
-<file path=ppt/slides/slide29.xml><?xml version="1.0" encoding="utf-8"?>
-<p:sld xmlns:a="http://schemas.openxmlformats.org/drawingml/2006/main" xmlns:r="http://schemas.openxmlformats.org/officeDocument/2006/relationships" xmlns:p="http://schemas.openxmlformats.org/presentationml/2006/main">
-  <p:cSld>
-    <p:bg>
-      <p:bgPr>
-        <a:solidFill>
-          <a:schemeClr val="accent6">
-            <a:lumMod val="20000"/>
-            <a:lumOff val="80000"/>
-          </a:schemeClr>
-        </a:solidFill>
-        <a:effectLst/>
-      </p:bgPr>
-    </p:bg>
-    <p:spTree>
-      <p:nvGrpSpPr>
-        <p:cNvPr id="1" name="">
-          <a:extLst>
-            <a:ext uri="{FF2B5EF4-FFF2-40B4-BE49-F238E27FC236}">
-              <a16:creationId xmlns:a16="http://schemas.microsoft.com/office/drawing/2014/main" id="{12B613ED-4C20-B810-736E-08E5068F9C51}"/>
-            </a:ext>
-          </a:extLst>
-        </p:cNvPr>
-        <p:cNvGrpSpPr/>
-        <p:nvPr/>
-      </p:nvGrpSpPr>
-      <p:grpSpPr>
-        <a:xfrm>
-          <a:off x="0" y="0"/>
-          <a:ext cx="0" cy="0"/>
-          <a:chOff x="0" y="0"/>
-          <a:chExt cx="0" cy="0"/>
-        </a:xfrm>
-      </p:grpSpPr>
-      <p:sp>
-        <p:nvSpPr>
-          <p:cNvPr id="2" name="Title 1">
-            <a:extLst>
-              <a:ext uri="{FF2B5EF4-FFF2-40B4-BE49-F238E27FC236}">
-                <a16:creationId xmlns:a16="http://schemas.microsoft.com/office/drawing/2014/main" id="{01CEAD93-2D28-3BC9-2E9D-896F6B4181BB}"/>
-              </a:ext>
-            </a:extLst>
-          </p:cNvPr>
-          <p:cNvSpPr>
-            <a:spLocks noGrp="1"/>
-          </p:cNvSpPr>
-          <p:nvPr>
-            <p:ph type="title"/>
-          </p:nvPr>
-        </p:nvSpPr>
-        <p:spPr/>
-        <p:txBody>
-          <a:bodyPr/>
-          <a:lstStyle/>
-          <a:p>
-            <a:r>
-              <a:rPr lang="en-US" dirty="0">
-                <a:latin typeface="Arial Rounded MT Bold" panose="020F0704030504030204" pitchFamily="34" charset="0"/>
-              </a:rPr>
-              <a:t>XR6 – Lecture </a:t>
-            </a:r>
-            <a:r>
-              <a:rPr lang="en-US" dirty="0" err="1">
-                <a:latin typeface="Arial Rounded MT Bold" panose="020F0704030504030204" pitchFamily="34" charset="0"/>
-              </a:rPr>
-              <a:t>dirigée</a:t>
-            </a:r>
-            <a:endParaRPr lang="fr-CA" dirty="0">
-              <a:latin typeface="Arial Rounded MT Bold" panose="020F0704030504030204" pitchFamily="34" charset="0"/>
-            </a:endParaRPr>
-          </a:p>
-        </p:txBody>
-      </p:sp>
-      <p:sp>
-        <p:nvSpPr>
-          <p:cNvPr id="3" name="Content Placeholder 2">
-            <a:extLst>
-              <a:ext uri="{FF2B5EF4-FFF2-40B4-BE49-F238E27FC236}">
-                <a16:creationId xmlns:a16="http://schemas.microsoft.com/office/drawing/2014/main" id="{209ABF4A-28F0-C642-B07B-85B4C439D074}"/>
-              </a:ext>
-            </a:extLst>
-          </p:cNvPr>
-          <p:cNvSpPr>
-            <a:spLocks noGrp="1"/>
-          </p:cNvSpPr>
-          <p:nvPr>
-            <p:ph idx="1"/>
-          </p:nvPr>
-        </p:nvSpPr>
-        <p:spPr/>
-        <p:txBody>
-          <a:bodyPr>
-            <a:normAutofit/>
-          </a:bodyPr>
-          <a:lstStyle/>
-          <a:p>
-            <a:pPr marL="0" indent="0" algn="just">
-              <a:lnSpc>
-                <a:spcPct val="100000"/>
-              </a:lnSpc>
-              <a:buNone/>
-            </a:pPr>
-            <a:r>
-              <a:rPr lang="en-US" sz="2000" dirty="0" err="1">
-                <a:latin typeface="Consolas" panose="020B0609020204030204" pitchFamily="49" charset="0"/>
-              </a:rPr>
-              <a:t>Décrivez</a:t>
-            </a:r>
-            <a:r>
-              <a:rPr lang="en-US" sz="2000" dirty="0">
-                <a:latin typeface="Consolas" panose="020B0609020204030204" pitchFamily="49" charset="0"/>
-              </a:rPr>
-              <a:t> la </a:t>
-            </a:r>
-            <a:r>
-              <a:rPr lang="en-US" sz="2000" dirty="0" err="1">
-                <a:latin typeface="Consolas" panose="020B0609020204030204" pitchFamily="49" charset="0"/>
-              </a:rPr>
-              <a:t>fonction</a:t>
-            </a:r>
-            <a:r>
-              <a:rPr lang="en-US" sz="2000" dirty="0">
-                <a:latin typeface="Consolas" panose="020B0609020204030204" pitchFamily="49" charset="0"/>
-              </a:rPr>
-              <a:t> </a:t>
-            </a:r>
-            <a:r>
-              <a:rPr lang="en-US" sz="2000" dirty="0" err="1">
-                <a:latin typeface="Consolas" panose="020B0609020204030204" pitchFamily="49" charset="0"/>
-              </a:rPr>
-              <a:t>suivante</a:t>
-            </a:r>
-            <a:r>
-              <a:rPr lang="en-US" sz="2000" dirty="0">
-                <a:latin typeface="Consolas" panose="020B0609020204030204" pitchFamily="49" charset="0"/>
-              </a:rPr>
-              <a:t> à </a:t>
-            </a:r>
-            <a:r>
-              <a:rPr lang="en-US" sz="2000" dirty="0" err="1">
-                <a:latin typeface="Consolas" panose="020B0609020204030204" pitchFamily="49" charset="0"/>
-              </a:rPr>
-              <a:t>partir</a:t>
-            </a:r>
-            <a:r>
-              <a:rPr lang="en-US" sz="2000" dirty="0">
-                <a:latin typeface="Consolas" panose="020B0609020204030204" pitchFamily="49" charset="0"/>
-              </a:rPr>
-              <a:t> de la documentation: </a:t>
-            </a:r>
-          </a:p>
-          <a:p>
-            <a:pPr marL="0" indent="0" algn="just">
-              <a:lnSpc>
-                <a:spcPct val="100000"/>
-              </a:lnSpc>
-              <a:buNone/>
-            </a:pPr>
-            <a:endParaRPr lang="en-US" sz="100" dirty="0">
-              <a:latin typeface="Consolas" panose="020B0609020204030204" pitchFamily="49" charset="0"/>
-            </a:endParaRPr>
-          </a:p>
-          <a:p>
-            <a:pPr lvl="1" algn="just">
-              <a:lnSpc>
-                <a:spcPct val="150000"/>
-              </a:lnSpc>
-            </a:pPr>
-            <a:r>
-              <a:rPr lang="en-US" sz="1400" dirty="0">
-                <a:latin typeface="Consolas" panose="020B0609020204030204" pitchFamily="49" charset="0"/>
-                <a:hlinkClick r:id="rId2"/>
-              </a:rPr>
-              <a:t>https://docs.python.org/fr/3.14/reference/compound_stmts.html#the-for-statement</a:t>
-            </a:r>
-            <a:endParaRPr lang="en-US" sz="1400" dirty="0">
-              <a:latin typeface="Consolas" panose="020B0609020204030204" pitchFamily="49" charset="0"/>
-            </a:endParaRPr>
-          </a:p>
-          <a:p>
-            <a:pPr lvl="1" algn="just">
-              <a:lnSpc>
-                <a:spcPct val="150000"/>
-              </a:lnSpc>
-            </a:pPr>
-            <a:r>
-              <a:rPr lang="en-US" sz="1400" dirty="0">
-                <a:latin typeface="Consolas" panose="020B0609020204030204" pitchFamily="49" charset="0"/>
-                <a:hlinkClick r:id="rId3"/>
-              </a:rPr>
-              <a:t>https://docs.python.org/fr/3.14/reference/expressions.html#slicings</a:t>
-            </a:r>
-          </a:p>
-          <a:p>
-            <a:pPr lvl="1" algn="just">
-              <a:lnSpc>
-                <a:spcPct val="150000"/>
-              </a:lnSpc>
-            </a:pPr>
-            <a:r>
-              <a:rPr lang="en-US" sz="1400" dirty="0">
-                <a:latin typeface="Consolas" panose="020B0609020204030204" pitchFamily="49" charset="0"/>
-                <a:hlinkClick r:id="rId3"/>
-              </a:rPr>
-              <a:t>https://docs.python.org/fr/3.14/reference/simple_stmts.html#augmented-assignment-statements</a:t>
-            </a:r>
-            <a:endParaRPr lang="en-US" sz="1400" dirty="0">
-              <a:latin typeface="Consolas" panose="020B0609020204030204" pitchFamily="49" charset="0"/>
-            </a:endParaRPr>
-          </a:p>
-          <a:p>
-            <a:pPr lvl="1" algn="just">
-              <a:lnSpc>
-                <a:spcPct val="150000"/>
-              </a:lnSpc>
-            </a:pPr>
-            <a:r>
-              <a:rPr lang="en-US" sz="1400" dirty="0">
-                <a:latin typeface="Consolas" panose="020B0609020204030204" pitchFamily="49" charset="0"/>
-                <a:hlinkClick r:id="rId4"/>
-              </a:rPr>
-              <a:t>https://docs.python.org/fr/3.14/library/stdtypes.html#str</a:t>
-            </a:r>
-            <a:endParaRPr lang="en-US" sz="1400" dirty="0">
-              <a:latin typeface="Consolas" panose="020B0609020204030204" pitchFamily="49" charset="0"/>
-            </a:endParaRPr>
-          </a:p>
-          <a:p>
-            <a:pPr algn="just"/>
-            <a:endParaRPr lang="en-US" sz="2000" dirty="0">
-              <a:latin typeface="Consolas" panose="020B0609020204030204" pitchFamily="49" charset="0"/>
-            </a:endParaRPr>
-          </a:p>
-          <a:p>
-            <a:pPr marL="0" indent="0" algn="just">
-              <a:buNone/>
-            </a:pPr>
-            <a:endParaRPr lang="en-US" sz="2000" dirty="0">
-              <a:latin typeface="Consolas" panose="020B0609020204030204" pitchFamily="49" charset="0"/>
-            </a:endParaRPr>
-          </a:p>
-          <a:p>
-            <a:pPr marL="0" indent="0" algn="just">
-              <a:buNone/>
-            </a:pPr>
-            <a:endParaRPr lang="en-US" sz="2000" dirty="0">
-              <a:latin typeface="Consolas" panose="020B0609020204030204" pitchFamily="49" charset="0"/>
-            </a:endParaRPr>
-          </a:p>
-          <a:p>
-            <a:pPr marL="0" indent="0" algn="just">
-              <a:buNone/>
-            </a:pPr>
-            <a:endParaRPr lang="en-US" sz="2000" dirty="0">
-              <a:latin typeface="Consolas" panose="020B0609020204030204" pitchFamily="49" charset="0"/>
-            </a:endParaRPr>
-          </a:p>
-        </p:txBody>
-      </p:sp>
-      <p:sp>
-        <p:nvSpPr>
-          <p:cNvPr id="4" name="Slide Number Placeholder 3">
-            <a:extLst>
-              <a:ext uri="{FF2B5EF4-FFF2-40B4-BE49-F238E27FC236}">
-                <a16:creationId xmlns:a16="http://schemas.microsoft.com/office/drawing/2014/main" id="{06432649-ACCF-C494-8C4D-BD60A1909A70}"/>
-              </a:ext>
-            </a:extLst>
-          </p:cNvPr>
-          <p:cNvSpPr>
-            <a:spLocks noGrp="1"/>
-          </p:cNvSpPr>
-          <p:nvPr>
-            <p:ph type="sldNum" sz="quarter" idx="12"/>
-          </p:nvPr>
-        </p:nvSpPr>
-        <p:spPr/>
-        <p:txBody>
-          <a:bodyPr/>
-          <a:lstStyle/>
-          <a:p>
-            <a:fld id="{846B06B1-1179-491F-A487-8E0C403F7C13}" type="slidenum">
-              <a:rPr lang="fr-CA" smtClean="0"/>
-              <a:t>29</a:t>
-            </a:fld>
-            <a:endParaRPr lang="fr-CA"/>
-          </a:p>
-        </p:txBody>
-      </p:sp>
-      <p:sp>
-        <p:nvSpPr>
-          <p:cNvPr id="6" name="TextBox 5">
-            <a:extLst>
-              <a:ext uri="{FF2B5EF4-FFF2-40B4-BE49-F238E27FC236}">
-                <a16:creationId xmlns:a16="http://schemas.microsoft.com/office/drawing/2014/main" id="{101C41D6-9989-63BC-E338-ED604AF40B76}"/>
-              </a:ext>
-            </a:extLst>
-          </p:cNvPr>
-          <p:cNvSpPr txBox="1"/>
-          <p:nvPr/>
-        </p:nvSpPr>
-        <p:spPr>
-          <a:xfrm>
-            <a:off x="3538857" y="4422636"/>
-            <a:ext cx="5114285" cy="1754326"/>
-          </a:xfrm>
-          <a:prstGeom prst="rect">
-            <a:avLst/>
-          </a:prstGeom>
-          <a:solidFill>
-            <a:schemeClr val="bg1"/>
-          </a:solidFill>
-          <a:ln w="19050">
-            <a:solidFill>
-              <a:schemeClr val="tx1"/>
-            </a:solidFill>
-          </a:ln>
-        </p:spPr>
-        <p:txBody>
-          <a:bodyPr wrap="square" anchor="ctr">
-            <a:spAutoFit/>
-          </a:bodyPr>
-          <a:lstStyle/>
-          <a:p>
-            <a:pPr algn="just">
-              <a:buNone/>
-            </a:pPr>
-            <a:r>
-              <a:rPr lang="en-CA" b="1" i="0" dirty="0">
-                <a:solidFill>
-                  <a:srgbClr val="008800"/>
-                </a:solidFill>
-                <a:effectLst/>
-                <a:latin typeface="Consolas" panose="020B0609020204030204" pitchFamily="49" charset="0"/>
-              </a:rPr>
-              <a:t>def</a:t>
-            </a:r>
-            <a:r>
-              <a:rPr lang="en-CA" b="0" i="0" dirty="0">
-                <a:solidFill>
-                  <a:srgbClr val="BBBBBB"/>
-                </a:solidFill>
-                <a:effectLst/>
-                <a:latin typeface="Consolas" panose="020B0609020204030204" pitchFamily="49" charset="0"/>
-              </a:rPr>
-              <a:t> </a:t>
-            </a:r>
-            <a:r>
-              <a:rPr lang="en-CA" b="1" i="0" dirty="0" err="1">
-                <a:solidFill>
-                  <a:srgbClr val="0066BB"/>
-                </a:solidFill>
-                <a:effectLst/>
-                <a:latin typeface="Consolas" panose="020B0609020204030204" pitchFamily="49" charset="0"/>
-              </a:rPr>
-              <a:t>souder</a:t>
-            </a:r>
-            <a:r>
-              <a:rPr lang="en-CA" b="0" i="0" dirty="0">
-                <a:solidFill>
-                  <a:srgbClr val="333333"/>
-                </a:solidFill>
-                <a:effectLst/>
-                <a:latin typeface="Consolas" panose="020B0609020204030204" pitchFamily="49" charset="0"/>
-              </a:rPr>
-              <a:t>(*</a:t>
-            </a:r>
-            <a:r>
-              <a:rPr lang="en-CA" b="0" i="0" dirty="0" err="1">
-                <a:solidFill>
-                  <a:srgbClr val="333333"/>
-                </a:solidFill>
-                <a:effectLst/>
-                <a:latin typeface="Consolas" panose="020B0609020204030204" pitchFamily="49" charset="0"/>
-              </a:rPr>
-              <a:t>objets</a:t>
-            </a:r>
-            <a:r>
-              <a:rPr lang="en-CA" b="0" i="0" dirty="0">
-                <a:solidFill>
-                  <a:srgbClr val="333333"/>
-                </a:solidFill>
-                <a:effectLst/>
-                <a:latin typeface="Consolas" panose="020B0609020204030204" pitchFamily="49" charset="0"/>
-              </a:rPr>
-              <a:t>, </a:t>
-            </a:r>
-            <a:r>
-              <a:rPr lang="en-CA" b="0" i="0" dirty="0" err="1">
-                <a:solidFill>
-                  <a:srgbClr val="333333"/>
-                </a:solidFill>
-                <a:effectLst/>
-                <a:latin typeface="Consolas" panose="020B0609020204030204" pitchFamily="49" charset="0"/>
-              </a:rPr>
-              <a:t>sep</a:t>
-            </a:r>
-            <a:r>
-              <a:rPr lang="en-CA" b="0" i="0" dirty="0">
-                <a:solidFill>
-                  <a:srgbClr val="333333"/>
-                </a:solidFill>
-                <a:effectLst/>
-                <a:latin typeface="Consolas" panose="020B0609020204030204" pitchFamily="49" charset="0"/>
-              </a:rPr>
-              <a:t>=' ', end='</a:t>
-            </a:r>
-            <a:r>
-              <a:rPr lang="en-CA" b="1" i="0" dirty="0">
-                <a:solidFill>
-                  <a:srgbClr val="666666"/>
-                </a:solidFill>
-                <a:effectLst/>
-                <a:latin typeface="Consolas" panose="020B0609020204030204" pitchFamily="49" charset="0"/>
-              </a:rPr>
-              <a:t>\n</a:t>
-            </a:r>
-            <a:r>
-              <a:rPr lang="en-CA" b="0" i="0" dirty="0">
-                <a:solidFill>
-                  <a:srgbClr val="333333"/>
-                </a:solidFill>
-                <a:effectLst/>
-                <a:latin typeface="Consolas" panose="020B0609020204030204" pitchFamily="49" charset="0"/>
-              </a:rPr>
-              <a:t>'):</a:t>
-            </a:r>
-          </a:p>
-          <a:p>
-            <a:pPr algn="just">
-              <a:buNone/>
-            </a:pPr>
-            <a:r>
-              <a:rPr lang="en-CA" b="0" i="0" dirty="0">
-                <a:solidFill>
-                  <a:srgbClr val="333333"/>
-                </a:solidFill>
-                <a:effectLst/>
-                <a:latin typeface="Consolas" panose="020B0609020204030204" pitchFamily="49" charset="0"/>
-              </a:rPr>
-              <a:t>  buffer = ''</a:t>
-            </a:r>
-          </a:p>
-          <a:p>
-            <a:pPr algn="just">
-              <a:buNone/>
-            </a:pPr>
-            <a:r>
-              <a:rPr lang="en-CA" b="0" i="0" dirty="0">
-                <a:solidFill>
-                  <a:srgbClr val="333333"/>
-                </a:solidFill>
-                <a:effectLst/>
-                <a:latin typeface="Consolas" panose="020B0609020204030204" pitchFamily="49" charset="0"/>
-              </a:rPr>
-              <a:t>  </a:t>
-            </a:r>
-            <a:r>
-              <a:rPr lang="en-CA" b="1" i="0" dirty="0">
-                <a:solidFill>
-                  <a:srgbClr val="008800"/>
-                </a:solidFill>
-                <a:effectLst/>
-                <a:latin typeface="Consolas" panose="020B0609020204030204" pitchFamily="49" charset="0"/>
-              </a:rPr>
-              <a:t>for</a:t>
-            </a:r>
-            <a:r>
-              <a:rPr lang="en-CA" b="0" i="0" dirty="0">
-                <a:solidFill>
-                  <a:srgbClr val="333333"/>
-                </a:solidFill>
-                <a:effectLst/>
-                <a:latin typeface="Consolas" panose="020B0609020204030204" pitchFamily="49" charset="0"/>
-              </a:rPr>
-              <a:t> obj </a:t>
-            </a:r>
-            <a:r>
-              <a:rPr lang="en-CA" b="1" i="0" dirty="0">
-                <a:solidFill>
-                  <a:srgbClr val="000000"/>
-                </a:solidFill>
-                <a:effectLst/>
-                <a:latin typeface="Consolas" panose="020B0609020204030204" pitchFamily="49" charset="0"/>
-              </a:rPr>
-              <a:t>in</a:t>
-            </a:r>
-            <a:r>
-              <a:rPr lang="en-CA" b="0" i="0" dirty="0">
-                <a:solidFill>
-                  <a:srgbClr val="333333"/>
-                </a:solidFill>
-                <a:effectLst/>
-                <a:latin typeface="Consolas" panose="020B0609020204030204" pitchFamily="49" charset="0"/>
-              </a:rPr>
-              <a:t> </a:t>
-            </a:r>
-            <a:r>
-              <a:rPr lang="en-CA" b="0" i="0" dirty="0" err="1">
-                <a:solidFill>
-                  <a:srgbClr val="333333"/>
-                </a:solidFill>
-                <a:effectLst/>
-                <a:latin typeface="Consolas" panose="020B0609020204030204" pitchFamily="49" charset="0"/>
-              </a:rPr>
-              <a:t>objets</a:t>
-            </a:r>
-            <a:r>
-              <a:rPr lang="en-CA" b="0" i="0" dirty="0">
-                <a:solidFill>
-                  <a:srgbClr val="333333"/>
-                </a:solidFill>
-                <a:effectLst/>
-                <a:latin typeface="Consolas" panose="020B0609020204030204" pitchFamily="49" charset="0"/>
-              </a:rPr>
-              <a:t>[:-</a:t>
-            </a:r>
-            <a:r>
-              <a:rPr lang="en-CA" b="1" i="0" dirty="0">
-                <a:solidFill>
-                  <a:srgbClr val="0000DD"/>
-                </a:solidFill>
-                <a:effectLst/>
-                <a:latin typeface="Consolas" panose="020B0609020204030204" pitchFamily="49" charset="0"/>
-              </a:rPr>
-              <a:t>1</a:t>
-            </a:r>
-            <a:r>
-              <a:rPr lang="en-CA" b="0" i="0" dirty="0">
-                <a:solidFill>
-                  <a:srgbClr val="333333"/>
-                </a:solidFill>
-                <a:effectLst/>
-                <a:latin typeface="Consolas" panose="020B0609020204030204" pitchFamily="49" charset="0"/>
-              </a:rPr>
-              <a:t>]:</a:t>
-            </a:r>
-          </a:p>
-          <a:p>
-            <a:pPr algn="just">
-              <a:buNone/>
-            </a:pPr>
-            <a:r>
-              <a:rPr lang="en-CA" b="0" i="0" dirty="0">
-                <a:solidFill>
-                  <a:srgbClr val="333333"/>
-                </a:solidFill>
-                <a:effectLst/>
-                <a:latin typeface="Consolas" panose="020B0609020204030204" pitchFamily="49" charset="0"/>
-              </a:rPr>
-              <a:t>    buffer += </a:t>
-            </a:r>
-            <a:r>
-              <a:rPr lang="en-CA" b="0" i="0" dirty="0">
-                <a:solidFill>
-                  <a:srgbClr val="007020"/>
-                </a:solidFill>
-                <a:effectLst/>
-                <a:latin typeface="Consolas" panose="020B0609020204030204" pitchFamily="49" charset="0"/>
-              </a:rPr>
-              <a:t>str</a:t>
-            </a:r>
-            <a:r>
-              <a:rPr lang="en-CA" b="0" i="0" dirty="0">
-                <a:solidFill>
-                  <a:srgbClr val="333333"/>
-                </a:solidFill>
-                <a:effectLst/>
-                <a:latin typeface="Consolas" panose="020B0609020204030204" pitchFamily="49" charset="0"/>
-              </a:rPr>
-              <a:t>(obj) + </a:t>
-            </a:r>
-            <a:r>
-              <a:rPr lang="en-CA" b="0" i="0" dirty="0" err="1">
-                <a:solidFill>
-                  <a:srgbClr val="333333"/>
-                </a:solidFill>
-                <a:effectLst/>
-                <a:latin typeface="Consolas" panose="020B0609020204030204" pitchFamily="49" charset="0"/>
-              </a:rPr>
-              <a:t>sep</a:t>
-            </a:r>
-            <a:endParaRPr lang="en-CA" b="0" i="0" dirty="0">
-              <a:solidFill>
-                <a:srgbClr val="333333"/>
-              </a:solidFill>
-              <a:effectLst/>
-              <a:latin typeface="Consolas" panose="020B0609020204030204" pitchFamily="49" charset="0"/>
-            </a:endParaRPr>
-          </a:p>
-          <a:p>
-            <a:pPr algn="just">
-              <a:buNone/>
-            </a:pPr>
-            <a:r>
-              <a:rPr lang="en-CA" b="0" i="0" dirty="0">
-                <a:solidFill>
-                  <a:srgbClr val="333333"/>
-                </a:solidFill>
-                <a:effectLst/>
-                <a:latin typeface="Consolas" panose="020B0609020204030204" pitchFamily="49" charset="0"/>
-              </a:rPr>
-              <a:t>  buffer += </a:t>
-            </a:r>
-            <a:r>
-              <a:rPr lang="en-CA" b="0" i="0" dirty="0">
-                <a:solidFill>
-                  <a:srgbClr val="007020"/>
-                </a:solidFill>
-                <a:effectLst/>
-                <a:latin typeface="Consolas" panose="020B0609020204030204" pitchFamily="49" charset="0"/>
-              </a:rPr>
-              <a:t>str</a:t>
-            </a:r>
-            <a:r>
-              <a:rPr lang="en-CA" b="0" i="0" dirty="0">
-                <a:solidFill>
-                  <a:srgbClr val="333333"/>
-                </a:solidFill>
-                <a:effectLst/>
-                <a:latin typeface="Consolas" panose="020B0609020204030204" pitchFamily="49" charset="0"/>
-              </a:rPr>
-              <a:t>(</a:t>
-            </a:r>
-            <a:r>
-              <a:rPr lang="en-CA" b="0" i="0" dirty="0" err="1">
-                <a:solidFill>
-                  <a:srgbClr val="333333"/>
-                </a:solidFill>
-                <a:effectLst/>
-                <a:latin typeface="Consolas" panose="020B0609020204030204" pitchFamily="49" charset="0"/>
-              </a:rPr>
-              <a:t>objets</a:t>
-            </a:r>
-            <a:r>
-              <a:rPr lang="en-CA" b="0" i="0" dirty="0">
-                <a:solidFill>
-                  <a:srgbClr val="333333"/>
-                </a:solidFill>
-                <a:effectLst/>
-                <a:latin typeface="Consolas" panose="020B0609020204030204" pitchFamily="49" charset="0"/>
-              </a:rPr>
-              <a:t>[-</a:t>
-            </a:r>
-            <a:r>
-              <a:rPr lang="en-CA" b="1" i="0" dirty="0">
-                <a:solidFill>
-                  <a:srgbClr val="0000DD"/>
-                </a:solidFill>
-                <a:effectLst/>
-                <a:latin typeface="Consolas" panose="020B0609020204030204" pitchFamily="49" charset="0"/>
-              </a:rPr>
-              <a:t>1</a:t>
-            </a:r>
-            <a:r>
-              <a:rPr lang="en-CA" b="0" i="0" dirty="0">
-                <a:solidFill>
-                  <a:srgbClr val="333333"/>
-                </a:solidFill>
-                <a:effectLst/>
-                <a:latin typeface="Consolas" panose="020B0609020204030204" pitchFamily="49" charset="0"/>
-              </a:rPr>
-              <a:t>]) + end</a:t>
-            </a:r>
-          </a:p>
-          <a:p>
-            <a:pPr algn="just">
-              <a:buNone/>
-            </a:pPr>
-            <a:r>
-              <a:rPr lang="en-CA" b="0" i="0" dirty="0">
-                <a:solidFill>
-                  <a:srgbClr val="333333"/>
-                </a:solidFill>
-                <a:effectLst/>
-                <a:latin typeface="Consolas" panose="020B0609020204030204" pitchFamily="49" charset="0"/>
-              </a:rPr>
-              <a:t>  </a:t>
-            </a:r>
-            <a:r>
-              <a:rPr lang="en-CA" b="1" i="0" dirty="0">
-                <a:solidFill>
-                  <a:srgbClr val="008800"/>
-                </a:solidFill>
-                <a:effectLst/>
-                <a:latin typeface="Consolas" panose="020B0609020204030204" pitchFamily="49" charset="0"/>
-              </a:rPr>
-              <a:t>return</a:t>
-            </a:r>
-            <a:r>
-              <a:rPr lang="en-CA" b="0" i="0" dirty="0">
-                <a:solidFill>
-                  <a:srgbClr val="333333"/>
-                </a:solidFill>
-                <a:effectLst/>
-                <a:latin typeface="Consolas" panose="020B0609020204030204" pitchFamily="49" charset="0"/>
-              </a:rPr>
-              <a:t> buffer</a:t>
-            </a:r>
-          </a:p>
-        </p:txBody>
-      </p:sp>
-    </p:spTree>
-    <p:extLst>
-      <p:ext uri="{BB962C8B-B14F-4D97-AF65-F5344CB8AC3E}">
-        <p14:creationId xmlns:p14="http://schemas.microsoft.com/office/powerpoint/2010/main" val="2824829369"/>
-      </p:ext>
-    </p:extLst>
-  </p:cSld>
-  <p:clrMapOvr>
-    <a:masterClrMapping/>
-  </p:clrMapOvr>
-</p:sld>
-</file>
-
 <file path=ppt/slides/slide3.xml><?xml version="1.0" encoding="utf-8"?>
 <p:sld xmlns:a="http://schemas.openxmlformats.org/drawingml/2006/main" xmlns:r="http://schemas.openxmlformats.org/officeDocument/2006/relationships" xmlns:p="http://schemas.openxmlformats.org/presentationml/2006/main">
   <p:cSld>
@@ -27068,6 +27159,720 @@
 </file>
 
 <file path=ppt/slides/slide30.xml><?xml version="1.0" encoding="utf-8"?>
+<p:sld xmlns:a="http://schemas.openxmlformats.org/drawingml/2006/main" xmlns:r="http://schemas.openxmlformats.org/officeDocument/2006/relationships" xmlns:p="http://schemas.openxmlformats.org/presentationml/2006/main">
+  <p:cSld>
+    <p:bg>
+      <p:bgPr>
+        <a:solidFill>
+          <a:schemeClr val="accent6">
+            <a:lumMod val="20000"/>
+            <a:lumOff val="80000"/>
+          </a:schemeClr>
+        </a:solidFill>
+        <a:effectLst/>
+      </p:bgPr>
+    </p:bg>
+    <p:spTree>
+      <p:nvGrpSpPr>
+        <p:cNvPr id="1" name="">
+          <a:extLst>
+            <a:ext uri="{FF2B5EF4-FFF2-40B4-BE49-F238E27FC236}">
+              <a16:creationId xmlns:a16="http://schemas.microsoft.com/office/drawing/2014/main" id="{12B613ED-4C20-B810-736E-08E5068F9C51}"/>
+            </a:ext>
+          </a:extLst>
+        </p:cNvPr>
+        <p:cNvGrpSpPr/>
+        <p:nvPr/>
+      </p:nvGrpSpPr>
+      <p:grpSpPr>
+        <a:xfrm>
+          <a:off x="0" y="0"/>
+          <a:ext cx="0" cy="0"/>
+          <a:chOff x="0" y="0"/>
+          <a:chExt cx="0" cy="0"/>
+        </a:xfrm>
+      </p:grpSpPr>
+      <p:sp>
+        <p:nvSpPr>
+          <p:cNvPr id="2" name="Title 1">
+            <a:extLst>
+              <a:ext uri="{FF2B5EF4-FFF2-40B4-BE49-F238E27FC236}">
+                <a16:creationId xmlns:a16="http://schemas.microsoft.com/office/drawing/2014/main" id="{01CEAD93-2D28-3BC9-2E9D-896F6B4181BB}"/>
+              </a:ext>
+            </a:extLst>
+          </p:cNvPr>
+          <p:cNvSpPr>
+            <a:spLocks noGrp="1"/>
+          </p:cNvSpPr>
+          <p:nvPr>
+            <p:ph type="title"/>
+          </p:nvPr>
+        </p:nvSpPr>
+        <p:spPr/>
+        <p:txBody>
+          <a:bodyPr/>
+          <a:lstStyle/>
+          <a:p>
+            <a:r>
+              <a:rPr lang="en-US" dirty="0">
+                <a:latin typeface="Arial Rounded MT Bold" panose="020F0704030504030204" pitchFamily="34" charset="0"/>
+              </a:rPr>
+              <a:t>XR6 – Lecture </a:t>
+            </a:r>
+            <a:r>
+              <a:rPr lang="en-US" dirty="0" err="1">
+                <a:latin typeface="Arial Rounded MT Bold" panose="020F0704030504030204" pitchFamily="34" charset="0"/>
+              </a:rPr>
+              <a:t>dirigée</a:t>
+            </a:r>
+            <a:endParaRPr lang="fr-CA" dirty="0">
+              <a:latin typeface="Arial Rounded MT Bold" panose="020F0704030504030204" pitchFamily="34" charset="0"/>
+            </a:endParaRPr>
+          </a:p>
+        </p:txBody>
+      </p:sp>
+      <p:sp>
+        <p:nvSpPr>
+          <p:cNvPr id="3" name="Content Placeholder 2">
+            <a:extLst>
+              <a:ext uri="{FF2B5EF4-FFF2-40B4-BE49-F238E27FC236}">
+                <a16:creationId xmlns:a16="http://schemas.microsoft.com/office/drawing/2014/main" id="{209ABF4A-28F0-C642-B07B-85B4C439D074}"/>
+              </a:ext>
+            </a:extLst>
+          </p:cNvPr>
+          <p:cNvSpPr>
+            <a:spLocks noGrp="1"/>
+          </p:cNvSpPr>
+          <p:nvPr>
+            <p:ph idx="1"/>
+          </p:nvPr>
+        </p:nvSpPr>
+        <p:spPr/>
+        <p:txBody>
+          <a:bodyPr>
+            <a:normAutofit/>
+          </a:bodyPr>
+          <a:lstStyle/>
+          <a:p>
+            <a:pPr marL="0" indent="0" algn="just">
+              <a:lnSpc>
+                <a:spcPct val="100000"/>
+              </a:lnSpc>
+              <a:buNone/>
+            </a:pPr>
+            <a:r>
+              <a:rPr lang="en-US" sz="2000" dirty="0" err="1">
+                <a:latin typeface="Consolas" panose="020B0609020204030204" pitchFamily="49" charset="0"/>
+              </a:rPr>
+              <a:t>Décrivez</a:t>
+            </a:r>
+            <a:r>
+              <a:rPr lang="en-US" sz="2000" dirty="0">
+                <a:latin typeface="Consolas" panose="020B0609020204030204" pitchFamily="49" charset="0"/>
+              </a:rPr>
+              <a:t> la </a:t>
+            </a:r>
+            <a:r>
+              <a:rPr lang="en-US" sz="2000" dirty="0" err="1">
+                <a:latin typeface="Consolas" panose="020B0609020204030204" pitchFamily="49" charset="0"/>
+              </a:rPr>
+              <a:t>fonction</a:t>
+            </a:r>
+            <a:r>
+              <a:rPr lang="en-US" sz="2000" dirty="0">
+                <a:latin typeface="Consolas" panose="020B0609020204030204" pitchFamily="49" charset="0"/>
+              </a:rPr>
+              <a:t> </a:t>
+            </a:r>
+            <a:r>
+              <a:rPr lang="en-US" sz="2000" dirty="0" err="1">
+                <a:latin typeface="Consolas" panose="020B0609020204030204" pitchFamily="49" charset="0"/>
+              </a:rPr>
+              <a:t>suivante</a:t>
+            </a:r>
+            <a:r>
+              <a:rPr lang="en-US" sz="2000" dirty="0">
+                <a:latin typeface="Consolas" panose="020B0609020204030204" pitchFamily="49" charset="0"/>
+              </a:rPr>
+              <a:t> à </a:t>
+            </a:r>
+            <a:r>
+              <a:rPr lang="en-US" sz="2000" dirty="0" err="1">
+                <a:latin typeface="Consolas" panose="020B0609020204030204" pitchFamily="49" charset="0"/>
+              </a:rPr>
+              <a:t>partir</a:t>
+            </a:r>
+            <a:r>
+              <a:rPr lang="en-US" sz="2000" dirty="0">
+                <a:latin typeface="Consolas" panose="020B0609020204030204" pitchFamily="49" charset="0"/>
+              </a:rPr>
+              <a:t> de la documentation: </a:t>
+            </a:r>
+          </a:p>
+          <a:p>
+            <a:pPr marL="0" indent="0" algn="just">
+              <a:lnSpc>
+                <a:spcPct val="100000"/>
+              </a:lnSpc>
+              <a:buNone/>
+            </a:pPr>
+            <a:endParaRPr lang="en-US" sz="100" dirty="0">
+              <a:latin typeface="Consolas" panose="020B0609020204030204" pitchFamily="49" charset="0"/>
+            </a:endParaRPr>
+          </a:p>
+          <a:p>
+            <a:pPr lvl="1" algn="just">
+              <a:lnSpc>
+                <a:spcPct val="150000"/>
+              </a:lnSpc>
+            </a:pPr>
+            <a:r>
+              <a:rPr lang="en-US" sz="1400" dirty="0">
+                <a:latin typeface="Consolas" panose="020B0609020204030204" pitchFamily="49" charset="0"/>
+                <a:hlinkClick r:id="rId2"/>
+              </a:rPr>
+              <a:t>https://docs.python.org/fr/3.14/reference/compound_stmts.html#the-for-statement</a:t>
+            </a:r>
+            <a:endParaRPr lang="en-US" sz="1400" dirty="0">
+              <a:latin typeface="Consolas" panose="020B0609020204030204" pitchFamily="49" charset="0"/>
+            </a:endParaRPr>
+          </a:p>
+          <a:p>
+            <a:pPr lvl="1" algn="just">
+              <a:lnSpc>
+                <a:spcPct val="150000"/>
+              </a:lnSpc>
+            </a:pPr>
+            <a:r>
+              <a:rPr lang="en-US" sz="1400" dirty="0">
+                <a:latin typeface="Consolas" panose="020B0609020204030204" pitchFamily="49" charset="0"/>
+                <a:hlinkClick r:id="rId3"/>
+              </a:rPr>
+              <a:t>https://docs.python.org/fr/3.14/reference/expressions.html#slicings</a:t>
+            </a:r>
+          </a:p>
+          <a:p>
+            <a:pPr lvl="1" algn="just">
+              <a:lnSpc>
+                <a:spcPct val="150000"/>
+              </a:lnSpc>
+            </a:pPr>
+            <a:r>
+              <a:rPr lang="en-US" sz="1400" dirty="0">
+                <a:latin typeface="Consolas" panose="020B0609020204030204" pitchFamily="49" charset="0"/>
+                <a:hlinkClick r:id="rId3"/>
+              </a:rPr>
+              <a:t>https://docs.python.org/fr/3.14/reference/simple_stmts.html#augmented-assignment-statements</a:t>
+            </a:r>
+            <a:endParaRPr lang="en-US" sz="1400" dirty="0">
+              <a:latin typeface="Consolas" panose="020B0609020204030204" pitchFamily="49" charset="0"/>
+            </a:endParaRPr>
+          </a:p>
+          <a:p>
+            <a:pPr lvl="1" algn="just">
+              <a:lnSpc>
+                <a:spcPct val="150000"/>
+              </a:lnSpc>
+            </a:pPr>
+            <a:r>
+              <a:rPr lang="en-US" sz="1400" dirty="0">
+                <a:latin typeface="Consolas" panose="020B0609020204030204" pitchFamily="49" charset="0"/>
+                <a:hlinkClick r:id="rId4"/>
+              </a:rPr>
+              <a:t>https://docs.python.org/fr/3.14/library/stdtypes.html#str</a:t>
+            </a:r>
+            <a:endParaRPr lang="en-US" sz="1400" dirty="0">
+              <a:latin typeface="Consolas" panose="020B0609020204030204" pitchFamily="49" charset="0"/>
+            </a:endParaRPr>
+          </a:p>
+          <a:p>
+            <a:pPr algn="just"/>
+            <a:endParaRPr lang="en-US" sz="2000" dirty="0">
+              <a:latin typeface="Consolas" panose="020B0609020204030204" pitchFamily="49" charset="0"/>
+            </a:endParaRPr>
+          </a:p>
+          <a:p>
+            <a:pPr marL="0" indent="0" algn="just">
+              <a:buNone/>
+            </a:pPr>
+            <a:endParaRPr lang="en-US" sz="2000" dirty="0">
+              <a:latin typeface="Consolas" panose="020B0609020204030204" pitchFamily="49" charset="0"/>
+            </a:endParaRPr>
+          </a:p>
+          <a:p>
+            <a:pPr marL="0" indent="0" algn="just">
+              <a:buNone/>
+            </a:pPr>
+            <a:endParaRPr lang="en-US" sz="2000" dirty="0">
+              <a:latin typeface="Consolas" panose="020B0609020204030204" pitchFamily="49" charset="0"/>
+            </a:endParaRPr>
+          </a:p>
+          <a:p>
+            <a:pPr marL="0" indent="0" algn="just">
+              <a:buNone/>
+            </a:pPr>
+            <a:endParaRPr lang="en-US" sz="2000" dirty="0">
+              <a:latin typeface="Consolas" panose="020B0609020204030204" pitchFamily="49" charset="0"/>
+            </a:endParaRPr>
+          </a:p>
+        </p:txBody>
+      </p:sp>
+      <p:sp>
+        <p:nvSpPr>
+          <p:cNvPr id="4" name="Slide Number Placeholder 3">
+            <a:extLst>
+              <a:ext uri="{FF2B5EF4-FFF2-40B4-BE49-F238E27FC236}">
+                <a16:creationId xmlns:a16="http://schemas.microsoft.com/office/drawing/2014/main" id="{06432649-ACCF-C494-8C4D-BD60A1909A70}"/>
+              </a:ext>
+            </a:extLst>
+          </p:cNvPr>
+          <p:cNvSpPr>
+            <a:spLocks noGrp="1"/>
+          </p:cNvSpPr>
+          <p:nvPr>
+            <p:ph type="sldNum" sz="quarter" idx="12"/>
+          </p:nvPr>
+        </p:nvSpPr>
+        <p:spPr/>
+        <p:txBody>
+          <a:bodyPr/>
+          <a:lstStyle/>
+          <a:p>
+            <a:fld id="{846B06B1-1179-491F-A487-8E0C403F7C13}" type="slidenum">
+              <a:rPr lang="fr-CA" smtClean="0"/>
+              <a:t>30</a:t>
+            </a:fld>
+            <a:endParaRPr lang="fr-CA"/>
+          </a:p>
+        </p:txBody>
+      </p:sp>
+      <p:sp>
+        <p:nvSpPr>
+          <p:cNvPr id="6" name="TextBox 5">
+            <a:extLst>
+              <a:ext uri="{FF2B5EF4-FFF2-40B4-BE49-F238E27FC236}">
+                <a16:creationId xmlns:a16="http://schemas.microsoft.com/office/drawing/2014/main" id="{101C41D6-9989-63BC-E338-ED604AF40B76}"/>
+              </a:ext>
+            </a:extLst>
+          </p:cNvPr>
+          <p:cNvSpPr txBox="1"/>
+          <p:nvPr/>
+        </p:nvSpPr>
+        <p:spPr>
+          <a:xfrm>
+            <a:off x="3538857" y="4422636"/>
+            <a:ext cx="5114285" cy="1754326"/>
+          </a:xfrm>
+          <a:prstGeom prst="rect">
+            <a:avLst/>
+          </a:prstGeom>
+          <a:solidFill>
+            <a:schemeClr val="bg1"/>
+          </a:solidFill>
+          <a:ln w="19050">
+            <a:solidFill>
+              <a:schemeClr val="tx1"/>
+            </a:solidFill>
+          </a:ln>
+        </p:spPr>
+        <p:txBody>
+          <a:bodyPr wrap="square" anchor="ctr">
+            <a:spAutoFit/>
+          </a:bodyPr>
+          <a:lstStyle/>
+          <a:p>
+            <a:pPr algn="just">
+              <a:buNone/>
+            </a:pPr>
+            <a:r>
+              <a:rPr lang="en-CA" b="1" i="0" dirty="0">
+                <a:solidFill>
+                  <a:srgbClr val="008800"/>
+                </a:solidFill>
+                <a:effectLst/>
+                <a:latin typeface="Consolas" panose="020B0609020204030204" pitchFamily="49" charset="0"/>
+              </a:rPr>
+              <a:t>def</a:t>
+            </a:r>
+            <a:r>
+              <a:rPr lang="en-CA" b="0" i="0" dirty="0">
+                <a:solidFill>
+                  <a:srgbClr val="BBBBBB"/>
+                </a:solidFill>
+                <a:effectLst/>
+                <a:latin typeface="Consolas" panose="020B0609020204030204" pitchFamily="49" charset="0"/>
+              </a:rPr>
+              <a:t> </a:t>
+            </a:r>
+            <a:r>
+              <a:rPr lang="en-CA" b="1" i="0" dirty="0" err="1">
+                <a:solidFill>
+                  <a:srgbClr val="0066BB"/>
+                </a:solidFill>
+                <a:effectLst/>
+                <a:latin typeface="Consolas" panose="020B0609020204030204" pitchFamily="49" charset="0"/>
+              </a:rPr>
+              <a:t>souder</a:t>
+            </a:r>
+            <a:r>
+              <a:rPr lang="en-CA" b="0" i="0" dirty="0">
+                <a:solidFill>
+                  <a:srgbClr val="333333"/>
+                </a:solidFill>
+                <a:effectLst/>
+                <a:latin typeface="Consolas" panose="020B0609020204030204" pitchFamily="49" charset="0"/>
+              </a:rPr>
+              <a:t>(*</a:t>
+            </a:r>
+            <a:r>
+              <a:rPr lang="en-CA" b="0" i="0" dirty="0" err="1">
+                <a:solidFill>
+                  <a:srgbClr val="333333"/>
+                </a:solidFill>
+                <a:effectLst/>
+                <a:latin typeface="Consolas" panose="020B0609020204030204" pitchFamily="49" charset="0"/>
+              </a:rPr>
+              <a:t>objets</a:t>
+            </a:r>
+            <a:r>
+              <a:rPr lang="en-CA" b="0" i="0" dirty="0">
+                <a:solidFill>
+                  <a:srgbClr val="333333"/>
+                </a:solidFill>
+                <a:effectLst/>
+                <a:latin typeface="Consolas" panose="020B0609020204030204" pitchFamily="49" charset="0"/>
+              </a:rPr>
+              <a:t>, </a:t>
+            </a:r>
+            <a:r>
+              <a:rPr lang="en-CA" b="0" i="0" dirty="0" err="1">
+                <a:solidFill>
+                  <a:srgbClr val="333333"/>
+                </a:solidFill>
+                <a:effectLst/>
+                <a:latin typeface="Consolas" panose="020B0609020204030204" pitchFamily="49" charset="0"/>
+              </a:rPr>
+              <a:t>sep</a:t>
+            </a:r>
+            <a:r>
+              <a:rPr lang="en-CA" b="0" i="0" dirty="0">
+                <a:solidFill>
+                  <a:srgbClr val="333333"/>
+                </a:solidFill>
+                <a:effectLst/>
+                <a:latin typeface="Consolas" panose="020B0609020204030204" pitchFamily="49" charset="0"/>
+              </a:rPr>
+              <a:t>=' ', end='</a:t>
+            </a:r>
+            <a:r>
+              <a:rPr lang="en-CA" b="1" i="0" dirty="0">
+                <a:solidFill>
+                  <a:srgbClr val="666666"/>
+                </a:solidFill>
+                <a:effectLst/>
+                <a:latin typeface="Consolas" panose="020B0609020204030204" pitchFamily="49" charset="0"/>
+              </a:rPr>
+              <a:t>\n</a:t>
+            </a:r>
+            <a:r>
+              <a:rPr lang="en-CA" b="0" i="0" dirty="0">
+                <a:solidFill>
+                  <a:srgbClr val="333333"/>
+                </a:solidFill>
+                <a:effectLst/>
+                <a:latin typeface="Consolas" panose="020B0609020204030204" pitchFamily="49" charset="0"/>
+              </a:rPr>
+              <a:t>'):</a:t>
+            </a:r>
+          </a:p>
+          <a:p>
+            <a:pPr algn="just">
+              <a:buNone/>
+            </a:pPr>
+            <a:r>
+              <a:rPr lang="en-CA" b="0" i="0" dirty="0">
+                <a:solidFill>
+                  <a:srgbClr val="333333"/>
+                </a:solidFill>
+                <a:effectLst/>
+                <a:latin typeface="Consolas" panose="020B0609020204030204" pitchFamily="49" charset="0"/>
+              </a:rPr>
+              <a:t>  buffer = ''</a:t>
+            </a:r>
+          </a:p>
+          <a:p>
+            <a:pPr algn="just">
+              <a:buNone/>
+            </a:pPr>
+            <a:r>
+              <a:rPr lang="en-CA" b="0" i="0" dirty="0">
+                <a:solidFill>
+                  <a:srgbClr val="333333"/>
+                </a:solidFill>
+                <a:effectLst/>
+                <a:latin typeface="Consolas" panose="020B0609020204030204" pitchFamily="49" charset="0"/>
+              </a:rPr>
+              <a:t>  </a:t>
+            </a:r>
+            <a:r>
+              <a:rPr lang="en-CA" b="1" i="0" dirty="0">
+                <a:solidFill>
+                  <a:srgbClr val="008800"/>
+                </a:solidFill>
+                <a:effectLst/>
+                <a:latin typeface="Consolas" panose="020B0609020204030204" pitchFamily="49" charset="0"/>
+              </a:rPr>
+              <a:t>for</a:t>
+            </a:r>
+            <a:r>
+              <a:rPr lang="en-CA" b="0" i="0" dirty="0">
+                <a:solidFill>
+                  <a:srgbClr val="333333"/>
+                </a:solidFill>
+                <a:effectLst/>
+                <a:latin typeface="Consolas" panose="020B0609020204030204" pitchFamily="49" charset="0"/>
+              </a:rPr>
+              <a:t> obj </a:t>
+            </a:r>
+            <a:r>
+              <a:rPr lang="en-CA" b="1" i="0" dirty="0">
+                <a:solidFill>
+                  <a:srgbClr val="000000"/>
+                </a:solidFill>
+                <a:effectLst/>
+                <a:latin typeface="Consolas" panose="020B0609020204030204" pitchFamily="49" charset="0"/>
+              </a:rPr>
+              <a:t>in</a:t>
+            </a:r>
+            <a:r>
+              <a:rPr lang="en-CA" b="0" i="0" dirty="0">
+                <a:solidFill>
+                  <a:srgbClr val="333333"/>
+                </a:solidFill>
+                <a:effectLst/>
+                <a:latin typeface="Consolas" panose="020B0609020204030204" pitchFamily="49" charset="0"/>
+              </a:rPr>
+              <a:t> </a:t>
+            </a:r>
+            <a:r>
+              <a:rPr lang="en-CA" b="0" i="0" dirty="0" err="1">
+                <a:solidFill>
+                  <a:srgbClr val="333333"/>
+                </a:solidFill>
+                <a:effectLst/>
+                <a:latin typeface="Consolas" panose="020B0609020204030204" pitchFamily="49" charset="0"/>
+              </a:rPr>
+              <a:t>objets</a:t>
+            </a:r>
+            <a:r>
+              <a:rPr lang="en-CA" b="0" i="0" dirty="0">
+                <a:solidFill>
+                  <a:srgbClr val="333333"/>
+                </a:solidFill>
+                <a:effectLst/>
+                <a:latin typeface="Consolas" panose="020B0609020204030204" pitchFamily="49" charset="0"/>
+              </a:rPr>
+              <a:t>[:-</a:t>
+            </a:r>
+            <a:r>
+              <a:rPr lang="en-CA" b="1" i="0" dirty="0">
+                <a:solidFill>
+                  <a:srgbClr val="0000DD"/>
+                </a:solidFill>
+                <a:effectLst/>
+                <a:latin typeface="Consolas" panose="020B0609020204030204" pitchFamily="49" charset="0"/>
+              </a:rPr>
+              <a:t>1</a:t>
+            </a:r>
+            <a:r>
+              <a:rPr lang="en-CA" b="0" i="0" dirty="0">
+                <a:solidFill>
+                  <a:srgbClr val="333333"/>
+                </a:solidFill>
+                <a:effectLst/>
+                <a:latin typeface="Consolas" panose="020B0609020204030204" pitchFamily="49" charset="0"/>
+              </a:rPr>
+              <a:t>]:</a:t>
+            </a:r>
+          </a:p>
+          <a:p>
+            <a:pPr algn="just">
+              <a:buNone/>
+            </a:pPr>
+            <a:r>
+              <a:rPr lang="en-CA" b="0" i="0" dirty="0">
+                <a:solidFill>
+                  <a:srgbClr val="333333"/>
+                </a:solidFill>
+                <a:effectLst/>
+                <a:latin typeface="Consolas" panose="020B0609020204030204" pitchFamily="49" charset="0"/>
+              </a:rPr>
+              <a:t>    buffer += </a:t>
+            </a:r>
+            <a:r>
+              <a:rPr lang="en-CA" b="0" i="0" dirty="0">
+                <a:solidFill>
+                  <a:srgbClr val="007020"/>
+                </a:solidFill>
+                <a:effectLst/>
+                <a:latin typeface="Consolas" panose="020B0609020204030204" pitchFamily="49" charset="0"/>
+              </a:rPr>
+              <a:t>str</a:t>
+            </a:r>
+            <a:r>
+              <a:rPr lang="en-CA" b="0" i="0" dirty="0">
+                <a:solidFill>
+                  <a:srgbClr val="333333"/>
+                </a:solidFill>
+                <a:effectLst/>
+                <a:latin typeface="Consolas" panose="020B0609020204030204" pitchFamily="49" charset="0"/>
+              </a:rPr>
+              <a:t>(obj) + </a:t>
+            </a:r>
+            <a:r>
+              <a:rPr lang="en-CA" b="0" i="0" dirty="0" err="1">
+                <a:solidFill>
+                  <a:srgbClr val="333333"/>
+                </a:solidFill>
+                <a:effectLst/>
+                <a:latin typeface="Consolas" panose="020B0609020204030204" pitchFamily="49" charset="0"/>
+              </a:rPr>
+              <a:t>sep</a:t>
+            </a:r>
+            <a:endParaRPr lang="en-CA" b="0" i="0" dirty="0">
+              <a:solidFill>
+                <a:srgbClr val="333333"/>
+              </a:solidFill>
+              <a:effectLst/>
+              <a:latin typeface="Consolas" panose="020B0609020204030204" pitchFamily="49" charset="0"/>
+            </a:endParaRPr>
+          </a:p>
+          <a:p>
+            <a:pPr algn="just">
+              <a:buNone/>
+            </a:pPr>
+            <a:r>
+              <a:rPr lang="en-CA" b="0" i="0" dirty="0">
+                <a:solidFill>
+                  <a:srgbClr val="333333"/>
+                </a:solidFill>
+                <a:effectLst/>
+                <a:latin typeface="Consolas" panose="020B0609020204030204" pitchFamily="49" charset="0"/>
+              </a:rPr>
+              <a:t>  buffer += </a:t>
+            </a:r>
+            <a:r>
+              <a:rPr lang="en-CA" b="0" i="0" dirty="0">
+                <a:solidFill>
+                  <a:srgbClr val="007020"/>
+                </a:solidFill>
+                <a:effectLst/>
+                <a:latin typeface="Consolas" panose="020B0609020204030204" pitchFamily="49" charset="0"/>
+              </a:rPr>
+              <a:t>str</a:t>
+            </a:r>
+            <a:r>
+              <a:rPr lang="en-CA" b="0" i="0" dirty="0">
+                <a:solidFill>
+                  <a:srgbClr val="333333"/>
+                </a:solidFill>
+                <a:effectLst/>
+                <a:latin typeface="Consolas" panose="020B0609020204030204" pitchFamily="49" charset="0"/>
+              </a:rPr>
+              <a:t>(</a:t>
+            </a:r>
+            <a:r>
+              <a:rPr lang="en-CA" b="0" i="0" dirty="0" err="1">
+                <a:solidFill>
+                  <a:srgbClr val="333333"/>
+                </a:solidFill>
+                <a:effectLst/>
+                <a:latin typeface="Consolas" panose="020B0609020204030204" pitchFamily="49" charset="0"/>
+              </a:rPr>
+              <a:t>objets</a:t>
+            </a:r>
+            <a:r>
+              <a:rPr lang="en-CA" b="0" i="0" dirty="0">
+                <a:solidFill>
+                  <a:srgbClr val="333333"/>
+                </a:solidFill>
+                <a:effectLst/>
+                <a:latin typeface="Consolas" panose="020B0609020204030204" pitchFamily="49" charset="0"/>
+              </a:rPr>
+              <a:t>[-</a:t>
+            </a:r>
+            <a:r>
+              <a:rPr lang="en-CA" b="1" i="0" dirty="0">
+                <a:solidFill>
+                  <a:srgbClr val="0000DD"/>
+                </a:solidFill>
+                <a:effectLst/>
+                <a:latin typeface="Consolas" panose="020B0609020204030204" pitchFamily="49" charset="0"/>
+              </a:rPr>
+              <a:t>1</a:t>
+            </a:r>
+            <a:r>
+              <a:rPr lang="en-CA" b="0" i="0" dirty="0">
+                <a:solidFill>
+                  <a:srgbClr val="333333"/>
+                </a:solidFill>
+                <a:effectLst/>
+                <a:latin typeface="Consolas" panose="020B0609020204030204" pitchFamily="49" charset="0"/>
+              </a:rPr>
+              <a:t>]) + end</a:t>
+            </a:r>
+          </a:p>
+          <a:p>
+            <a:pPr algn="just">
+              <a:buNone/>
+            </a:pPr>
+            <a:r>
+              <a:rPr lang="en-CA" b="0" i="0" dirty="0">
+                <a:solidFill>
+                  <a:srgbClr val="333333"/>
+                </a:solidFill>
+                <a:effectLst/>
+                <a:latin typeface="Consolas" panose="020B0609020204030204" pitchFamily="49" charset="0"/>
+              </a:rPr>
+              <a:t>  </a:t>
+            </a:r>
+            <a:r>
+              <a:rPr lang="en-CA" b="1" i="0" dirty="0">
+                <a:solidFill>
+                  <a:srgbClr val="008800"/>
+                </a:solidFill>
+                <a:effectLst/>
+                <a:latin typeface="Consolas" panose="020B0609020204030204" pitchFamily="49" charset="0"/>
+              </a:rPr>
+              <a:t>return</a:t>
+            </a:r>
+            <a:r>
+              <a:rPr lang="en-CA" b="0" i="0" dirty="0">
+                <a:solidFill>
+                  <a:srgbClr val="333333"/>
+                </a:solidFill>
+                <a:effectLst/>
+                <a:latin typeface="Consolas" panose="020B0609020204030204" pitchFamily="49" charset="0"/>
+              </a:rPr>
+              <a:t> buffer</a:t>
+            </a:r>
+          </a:p>
+        </p:txBody>
+      </p:sp>
+    </p:spTree>
+    <p:extLst>
+      <p:ext uri="{BB962C8B-B14F-4D97-AF65-F5344CB8AC3E}">
+        <p14:creationId xmlns:p14="http://schemas.microsoft.com/office/powerpoint/2010/main" val="2824829369"/>
+      </p:ext>
+    </p:extLst>
+  </p:cSld>
+  <p:clrMapOvr>
+    <a:masterClrMapping/>
+  </p:clrMapOvr>
+</p:sld>
+</file>
+
+<file path=ppt/slides/slide31.xml><?xml version="1.0" encoding="utf-8"?>
 <p:sld xmlns:a="http://schemas.openxmlformats.org/drawingml/2006/main" xmlns:r="http://schemas.openxmlformats.org/officeDocument/2006/relationships" xmlns:p="http://schemas.openxmlformats.org/presentationml/2006/main">
   <p:cSld>
     <p:bg>
@@ -27709,7 +28514,7 @@
           <a:p>
             <a:fld id="{846B06B1-1179-491F-A487-8E0C403F7C13}" type="slidenum">
               <a:rPr lang="fr-CA" smtClean="0"/>
-              <a:t>30</a:t>
+              <a:t>31</a:t>
             </a:fld>
             <a:endParaRPr lang="fr-CA"/>
           </a:p>
@@ -28271,7 +29076,7 @@
 </p:sld>
 </file>
 
-<file path=ppt/slides/slide31.xml><?xml version="1.0" encoding="utf-8"?>
+<file path=ppt/slides/slide32.xml><?xml version="1.0" encoding="utf-8"?>
 <p:sld xmlns:a="http://schemas.openxmlformats.org/drawingml/2006/main" xmlns:r="http://schemas.openxmlformats.org/officeDocument/2006/relationships" xmlns:p="http://schemas.openxmlformats.org/presentationml/2006/main">
   <p:cSld>
     <p:bg>
@@ -28715,7 +29520,7 @@
           <a:p>
             <a:fld id="{846B06B1-1179-491F-A487-8E0C403F7C13}" type="slidenum">
               <a:rPr lang="fr-CA" smtClean="0"/>
-              <a:t>31</a:t>
+              <a:t>32</a:t>
             </a:fld>
             <a:endParaRPr lang="fr-CA"/>
           </a:p>
@@ -28734,7 +29539,7 @@
 </p:sld>
 </file>
 
-<file path=ppt/slides/slide32.xml><?xml version="1.0" encoding="utf-8"?>
+<file path=ppt/slides/slide33.xml><?xml version="1.0" encoding="utf-8"?>
 <p:sld xmlns:a="http://schemas.openxmlformats.org/drawingml/2006/main" xmlns:r="http://schemas.openxmlformats.org/officeDocument/2006/relationships" xmlns:p="http://schemas.openxmlformats.org/presentationml/2006/main">
   <p:cSld>
     <p:bg>
@@ -29035,7 +29840,7 @@
           <a:p>
             <a:fld id="{846B06B1-1179-491F-A487-8E0C403F7C13}" type="slidenum">
               <a:rPr lang="fr-CA" smtClean="0"/>
-              <a:t>32</a:t>
+              <a:t>33</a:t>
             </a:fld>
             <a:endParaRPr lang="fr-CA"/>
           </a:p>
@@ -29807,7 +30612,7 @@
 </p:sld>
 </file>
 
-<file path=ppt/slides/slide33.xml><?xml version="1.0" encoding="utf-8"?>
+<file path=ppt/slides/slide34.xml><?xml version="1.0" encoding="utf-8"?>
 <p:sld xmlns:a="http://schemas.openxmlformats.org/drawingml/2006/main" xmlns:r="http://schemas.openxmlformats.org/officeDocument/2006/relationships" xmlns:p="http://schemas.openxmlformats.org/presentationml/2006/main">
   <p:cSld>
     <p:bg>
@@ -30377,7 +31182,7 @@
           <a:p>
             <a:fld id="{846B06B1-1179-491F-A487-8E0C403F7C13}" type="slidenum">
               <a:rPr lang="fr-CA" smtClean="0"/>
-              <a:t>33</a:t>
+              <a:t>34</a:t>
             </a:fld>
             <a:endParaRPr lang="fr-CA"/>
           </a:p>
@@ -32837,7 +33642,7 @@
 </p:sld>
 </file>
 
-<file path=ppt/slides/slide34.xml><?xml version="1.0" encoding="utf-8"?>
+<file path=ppt/slides/slide35.xml><?xml version="1.0" encoding="utf-8"?>
 <p:sld xmlns:a="http://schemas.openxmlformats.org/drawingml/2006/main" xmlns:r="http://schemas.openxmlformats.org/officeDocument/2006/relationships" xmlns:p="http://schemas.openxmlformats.org/presentationml/2006/main">
   <p:cSld>
     <p:bg>
@@ -33202,7 +34007,7 @@
           <a:p>
             <a:fld id="{846B06B1-1179-491F-A487-8E0C403F7C13}" type="slidenum">
               <a:rPr lang="fr-CA" smtClean="0"/>
-              <a:t>34</a:t>
+              <a:t>35</a:t>
             </a:fld>
             <a:endParaRPr lang="fr-CA"/>
           </a:p>
@@ -33221,7 +34026,7 @@
 </p:sld>
 </file>
 
-<file path=ppt/slides/slide35.xml><?xml version="1.0" encoding="utf-8"?>
+<file path=ppt/slides/slide36.xml><?xml version="1.0" encoding="utf-8"?>
 <p:sld xmlns:a="http://schemas.openxmlformats.org/drawingml/2006/main" xmlns:r="http://schemas.openxmlformats.org/officeDocument/2006/relationships" xmlns:p="http://schemas.openxmlformats.org/presentationml/2006/main">
   <p:cSld>
     <p:bg>
@@ -33320,7 +34125,7 @@
           <a:p>
             <a:fld id="{846B06B1-1179-491F-A487-8E0C403F7C13}" type="slidenum">
               <a:rPr lang="fr-CA" smtClean="0"/>
-              <a:t>35</a:t>
+              <a:t>36</a:t>
             </a:fld>
             <a:endParaRPr lang="fr-CA"/>
           </a:p>
@@ -35328,7 +36133,7 @@
 </p:sld>
 </file>
 
-<file path=ppt/slides/slide36.xml><?xml version="1.0" encoding="utf-8"?>
+<file path=ppt/slides/slide37.xml><?xml version="1.0" encoding="utf-8"?>
 <p:sld xmlns:a="http://schemas.openxmlformats.org/drawingml/2006/main" xmlns:r="http://schemas.openxmlformats.org/officeDocument/2006/relationships" xmlns:p="http://schemas.openxmlformats.org/presentationml/2006/main">
   <p:cSld>
     <p:bg>
@@ -35546,7 +36351,7 @@
           <a:p>
             <a:fld id="{846B06B1-1179-491F-A487-8E0C403F7C13}" type="slidenum">
               <a:rPr lang="fr-CA" smtClean="0"/>
-              <a:t>36</a:t>
+              <a:t>37</a:t>
             </a:fld>
             <a:endParaRPr lang="fr-CA"/>
           </a:p>
@@ -35822,7 +36627,7 @@
 </p:sld>
 </file>
 
-<file path=ppt/slides/slide37.xml><?xml version="1.0" encoding="utf-8"?>
+<file path=ppt/slides/slide38.xml><?xml version="1.0" encoding="utf-8"?>
 <p:sld xmlns:a="http://schemas.openxmlformats.org/drawingml/2006/main" xmlns:r="http://schemas.openxmlformats.org/officeDocument/2006/relationships" xmlns:p="http://schemas.openxmlformats.org/presentationml/2006/main">
   <p:cSld>
     <p:bg>
@@ -36268,7 +37073,7 @@
           <a:p>
             <a:fld id="{846B06B1-1179-491F-A487-8E0C403F7C13}" type="slidenum">
               <a:rPr lang="fr-CA" smtClean="0"/>
-              <a:t>37</a:t>
+              <a:t>38</a:t>
             </a:fld>
             <a:endParaRPr lang="fr-CA" dirty="0"/>
           </a:p>
@@ -37147,7 +37952,7 @@
 </p:sld>
 </file>
 
-<file path=ppt/slides/slide38.xml><?xml version="1.0" encoding="utf-8"?>
+<file path=ppt/slides/slide39.xml><?xml version="1.0" encoding="utf-8"?>
 <p:sld xmlns:a="http://schemas.openxmlformats.org/drawingml/2006/main" xmlns:r="http://schemas.openxmlformats.org/officeDocument/2006/relationships" xmlns:p="http://schemas.openxmlformats.org/presentationml/2006/main">
   <p:cSld>
     <p:bg>
@@ -37693,7 +38498,7 @@
           <a:p>
             <a:fld id="{846B06B1-1179-491F-A487-8E0C403F7C13}" type="slidenum">
               <a:rPr lang="fr-CA" smtClean="0"/>
-              <a:t>38</a:t>
+              <a:t>39</a:t>
             </a:fld>
             <a:endParaRPr lang="fr-CA"/>
           </a:p>
@@ -38715,466 +39520,6 @@
       <p:bldP spid="8" grpId="0" animBg="1"/>
     </p:bldLst>
   </p:timing>
-</p:sld>
-</file>
-
-<file path=ppt/slides/slide39.xml><?xml version="1.0" encoding="utf-8"?>
-<p:sld xmlns:a="http://schemas.openxmlformats.org/drawingml/2006/main" xmlns:r="http://schemas.openxmlformats.org/officeDocument/2006/relationships" xmlns:p="http://schemas.openxmlformats.org/presentationml/2006/main">
-  <p:cSld>
-    <p:bg>
-      <p:bgPr>
-        <a:solidFill>
-          <a:schemeClr val="accent6">
-            <a:lumMod val="20000"/>
-            <a:lumOff val="80000"/>
-          </a:schemeClr>
-        </a:solidFill>
-        <a:effectLst/>
-      </p:bgPr>
-    </p:bg>
-    <p:spTree>
-      <p:nvGrpSpPr>
-        <p:cNvPr id="1" name="">
-          <a:extLst>
-            <a:ext uri="{FF2B5EF4-FFF2-40B4-BE49-F238E27FC236}">
-              <a16:creationId xmlns:a16="http://schemas.microsoft.com/office/drawing/2014/main" id="{808E75C2-6E05-D4AE-5915-518C66CDFFB4}"/>
-            </a:ext>
-          </a:extLst>
-        </p:cNvPr>
-        <p:cNvGrpSpPr/>
-        <p:nvPr/>
-      </p:nvGrpSpPr>
-      <p:grpSpPr>
-        <a:xfrm>
-          <a:off x="0" y="0"/>
-          <a:ext cx="0" cy="0"/>
-          <a:chOff x="0" y="0"/>
-          <a:chExt cx="0" cy="0"/>
-        </a:xfrm>
-      </p:grpSpPr>
-      <p:sp>
-        <p:nvSpPr>
-          <p:cNvPr id="2" name="Title 1">
-            <a:extLst>
-              <a:ext uri="{FF2B5EF4-FFF2-40B4-BE49-F238E27FC236}">
-                <a16:creationId xmlns:a16="http://schemas.microsoft.com/office/drawing/2014/main" id="{DFCE78E3-6E2F-2513-0701-01EE22E72B4D}"/>
-              </a:ext>
-            </a:extLst>
-          </p:cNvPr>
-          <p:cNvSpPr>
-            <a:spLocks noGrp="1"/>
-          </p:cNvSpPr>
-          <p:nvPr>
-            <p:ph type="title"/>
-          </p:nvPr>
-        </p:nvSpPr>
-        <p:spPr/>
-        <p:txBody>
-          <a:bodyPr/>
-          <a:lstStyle/>
-          <a:p>
-            <a:r>
-              <a:rPr lang="en-US" dirty="0">
-                <a:latin typeface="Arial Rounded MT Bold" panose="020F0704030504030204" pitchFamily="34" charset="0"/>
-              </a:rPr>
-              <a:t>XR6 – Moyenne et </a:t>
-            </a:r>
-            <a:r>
-              <a:rPr lang="en-US" dirty="0" err="1">
-                <a:latin typeface="Arial Rounded MT Bold" panose="020F0704030504030204" pitchFamily="34" charset="0"/>
-              </a:rPr>
-              <a:t>écart</a:t>
-            </a:r>
-            <a:r>
-              <a:rPr lang="en-US" dirty="0">
-                <a:latin typeface="Arial Rounded MT Bold" panose="020F0704030504030204" pitchFamily="34" charset="0"/>
-              </a:rPr>
-              <a:t>-type</a:t>
-            </a:r>
-            <a:endParaRPr lang="fr-CA" dirty="0">
-              <a:latin typeface="Arial Rounded MT Bold" panose="020F0704030504030204" pitchFamily="34" charset="0"/>
-            </a:endParaRPr>
-          </a:p>
-        </p:txBody>
-      </p:sp>
-      <p:sp>
-        <p:nvSpPr>
-          <p:cNvPr id="3" name="Content Placeholder 2">
-            <a:extLst>
-              <a:ext uri="{FF2B5EF4-FFF2-40B4-BE49-F238E27FC236}">
-                <a16:creationId xmlns:a16="http://schemas.microsoft.com/office/drawing/2014/main" id="{E5BFA73A-5F16-C1DB-89AE-EB491A024297}"/>
-              </a:ext>
-            </a:extLst>
-          </p:cNvPr>
-          <p:cNvSpPr>
-            <a:spLocks noGrp="1"/>
-          </p:cNvSpPr>
-          <p:nvPr>
-            <p:ph idx="1"/>
-          </p:nvPr>
-        </p:nvSpPr>
-        <p:spPr/>
-        <p:txBody>
-          <a:bodyPr>
-            <a:normAutofit/>
-          </a:bodyPr>
-          <a:lstStyle/>
-          <a:p>
-            <a:pPr marL="0" indent="0" algn="just">
-              <a:lnSpc>
-                <a:spcPct val="100000"/>
-              </a:lnSpc>
-              <a:buNone/>
-            </a:pPr>
-            <a:r>
-              <a:rPr lang="en-US" sz="2200" dirty="0" err="1">
-                <a:latin typeface="Consolas" panose="020B0609020204030204" pitchFamily="49" charset="0"/>
-              </a:rPr>
-              <a:t>Implémentez</a:t>
-            </a:r>
-            <a:r>
-              <a:rPr lang="en-US" sz="2200" dirty="0">
-                <a:latin typeface="Consolas" panose="020B0609020204030204" pitchFamily="49" charset="0"/>
-              </a:rPr>
-              <a:t> la function </a:t>
-            </a:r>
-            <a:r>
-              <a:rPr lang="en-US" sz="2200" b="1" dirty="0" err="1">
-                <a:latin typeface="Consolas" panose="020B0609020204030204" pitchFamily="49" charset="0"/>
-              </a:rPr>
-              <a:t>afficher_moyenne_ecart_type</a:t>
-            </a:r>
-            <a:r>
-              <a:rPr lang="en-US" sz="2200" b="1" dirty="0">
-                <a:latin typeface="Consolas" panose="020B0609020204030204" pitchFamily="49" charset="0"/>
-              </a:rPr>
-              <a:t> </a:t>
-            </a:r>
-            <a:r>
-              <a:rPr lang="en-US" sz="2200" dirty="0">
-                <a:latin typeface="Consolas" panose="020B0609020204030204" pitchFamily="49" charset="0"/>
-              </a:rPr>
-              <a:t>qui suit:</a:t>
-            </a:r>
-          </a:p>
-          <a:p>
-            <a:pPr marL="0" indent="0" algn="just">
-              <a:lnSpc>
-                <a:spcPct val="100000"/>
-              </a:lnSpc>
-              <a:buNone/>
-            </a:pPr>
-            <a:endParaRPr lang="en-US" sz="200" dirty="0">
-              <a:latin typeface="Consolas" panose="020B0609020204030204" pitchFamily="49" charset="0"/>
-            </a:endParaRPr>
-          </a:p>
-          <a:p>
-            <a:pPr marL="457200" lvl="1" indent="0" algn="just">
-              <a:lnSpc>
-                <a:spcPct val="100000"/>
-              </a:lnSpc>
-              <a:buNone/>
-            </a:pPr>
-            <a:r>
-              <a:rPr lang="fr-CA" sz="2000" b="1" dirty="0">
-                <a:latin typeface="Consolas" panose="020B0609020204030204" pitchFamily="49" charset="0"/>
-              </a:rPr>
-              <a:t>&gt;&gt;&gt; </a:t>
-            </a:r>
-            <a:r>
-              <a:rPr lang="fr-CA" sz="2000" b="1" dirty="0" err="1">
-                <a:latin typeface="Consolas" panose="020B0609020204030204" pitchFamily="49" charset="0"/>
-              </a:rPr>
-              <a:t>afficher_moyenne_ecart_type</a:t>
-            </a:r>
-            <a:r>
-              <a:rPr lang="fr-CA" sz="2000" b="1">
-                <a:latin typeface="Consolas" panose="020B0609020204030204" pitchFamily="49" charset="0"/>
-              </a:rPr>
-              <a:t>()</a:t>
-            </a:r>
-            <a:endParaRPr lang="fr-CA" sz="2000" b="1" dirty="0">
-              <a:latin typeface="Consolas" panose="020B0609020204030204" pitchFamily="49" charset="0"/>
-            </a:endParaRPr>
-          </a:p>
-          <a:p>
-            <a:pPr marL="457200" lvl="1" indent="0" algn="just">
-              <a:lnSpc>
-                <a:spcPct val="100000"/>
-              </a:lnSpc>
-              <a:buNone/>
-            </a:pPr>
-            <a:r>
-              <a:rPr lang="fr-CA" sz="2000" dirty="0" err="1">
-                <a:solidFill>
-                  <a:schemeClr val="bg1">
-                    <a:lumMod val="50000"/>
-                  </a:schemeClr>
-                </a:solidFill>
-                <a:latin typeface="Consolas" panose="020B0609020204030204" pitchFamily="49" charset="0"/>
-              </a:rPr>
-              <a:t>Saissez</a:t>
-            </a:r>
-            <a:r>
-              <a:rPr lang="fr-CA" sz="2000" dirty="0">
-                <a:solidFill>
-                  <a:schemeClr val="bg1">
-                    <a:lumMod val="50000"/>
-                  </a:schemeClr>
-                </a:solidFill>
-                <a:latin typeface="Consolas" panose="020B0609020204030204" pitchFamily="49" charset="0"/>
-              </a:rPr>
-              <a:t> une valeur (rien pour quitter): 1</a:t>
-            </a:r>
-          </a:p>
-          <a:p>
-            <a:pPr marL="457200" lvl="1" indent="0" algn="just">
-              <a:lnSpc>
-                <a:spcPct val="100000"/>
-              </a:lnSpc>
-              <a:buNone/>
-            </a:pPr>
-            <a:r>
-              <a:rPr lang="fr-CA" sz="2000" dirty="0" err="1">
-                <a:solidFill>
-                  <a:schemeClr val="bg1">
-                    <a:lumMod val="50000"/>
-                  </a:schemeClr>
-                </a:solidFill>
-                <a:latin typeface="Consolas" panose="020B0609020204030204" pitchFamily="49" charset="0"/>
-              </a:rPr>
-              <a:t>Saissez</a:t>
-            </a:r>
-            <a:r>
-              <a:rPr lang="fr-CA" sz="2000" dirty="0">
-                <a:solidFill>
-                  <a:schemeClr val="bg1">
-                    <a:lumMod val="50000"/>
-                  </a:schemeClr>
-                </a:solidFill>
-                <a:latin typeface="Consolas" panose="020B0609020204030204" pitchFamily="49" charset="0"/>
-              </a:rPr>
-              <a:t> une valeur (rien pour quitter): 2</a:t>
-            </a:r>
-          </a:p>
-          <a:p>
-            <a:pPr marL="457200" lvl="1" indent="0" algn="just">
-              <a:lnSpc>
-                <a:spcPct val="100000"/>
-              </a:lnSpc>
-              <a:buNone/>
-            </a:pPr>
-            <a:r>
-              <a:rPr lang="fr-CA" sz="2000" dirty="0" err="1">
-                <a:solidFill>
-                  <a:schemeClr val="bg1">
-                    <a:lumMod val="50000"/>
-                  </a:schemeClr>
-                </a:solidFill>
-                <a:latin typeface="Consolas" panose="020B0609020204030204" pitchFamily="49" charset="0"/>
-              </a:rPr>
-              <a:t>Saissez</a:t>
-            </a:r>
-            <a:r>
-              <a:rPr lang="fr-CA" sz="2000" dirty="0">
-                <a:solidFill>
-                  <a:schemeClr val="bg1">
-                    <a:lumMod val="50000"/>
-                  </a:schemeClr>
-                </a:solidFill>
-                <a:latin typeface="Consolas" panose="020B0609020204030204" pitchFamily="49" charset="0"/>
-              </a:rPr>
-              <a:t> une valeur (rien pour quitter): 3</a:t>
-            </a:r>
-          </a:p>
-          <a:p>
-            <a:pPr marL="457200" lvl="1" indent="0" algn="just">
-              <a:lnSpc>
-                <a:spcPct val="100000"/>
-              </a:lnSpc>
-              <a:buNone/>
-            </a:pPr>
-            <a:r>
-              <a:rPr lang="fr-CA" sz="2000" dirty="0" err="1">
-                <a:solidFill>
-                  <a:schemeClr val="bg1">
-                    <a:lumMod val="50000"/>
-                  </a:schemeClr>
-                </a:solidFill>
-                <a:latin typeface="Consolas" panose="020B0609020204030204" pitchFamily="49" charset="0"/>
-              </a:rPr>
-              <a:t>Saissez</a:t>
-            </a:r>
-            <a:r>
-              <a:rPr lang="fr-CA" sz="2000" dirty="0">
-                <a:solidFill>
-                  <a:schemeClr val="bg1">
-                    <a:lumMod val="50000"/>
-                  </a:schemeClr>
-                </a:solidFill>
-                <a:latin typeface="Consolas" panose="020B0609020204030204" pitchFamily="49" charset="0"/>
-              </a:rPr>
-              <a:t> une valeur (rien pour quitter): 4</a:t>
-            </a:r>
-          </a:p>
-          <a:p>
-            <a:pPr marL="457200" lvl="1" indent="0" algn="just">
-              <a:lnSpc>
-                <a:spcPct val="100000"/>
-              </a:lnSpc>
-              <a:buNone/>
-            </a:pPr>
-            <a:r>
-              <a:rPr lang="fr-CA" sz="2000" dirty="0" err="1">
-                <a:solidFill>
-                  <a:schemeClr val="bg1">
-                    <a:lumMod val="50000"/>
-                  </a:schemeClr>
-                </a:solidFill>
-                <a:latin typeface="Consolas" panose="020B0609020204030204" pitchFamily="49" charset="0"/>
-              </a:rPr>
-              <a:t>Saissez</a:t>
-            </a:r>
-            <a:r>
-              <a:rPr lang="fr-CA" sz="2000" dirty="0">
-                <a:solidFill>
-                  <a:schemeClr val="bg1">
-                    <a:lumMod val="50000"/>
-                  </a:schemeClr>
-                </a:solidFill>
-                <a:latin typeface="Consolas" panose="020B0609020204030204" pitchFamily="49" charset="0"/>
-              </a:rPr>
-              <a:t> une valeur (rien pour quitter): 5</a:t>
-            </a:r>
-          </a:p>
-          <a:p>
-            <a:pPr marL="457200" lvl="1" indent="0" algn="just">
-              <a:lnSpc>
-                <a:spcPct val="100000"/>
-              </a:lnSpc>
-              <a:buNone/>
-            </a:pPr>
-            <a:r>
-              <a:rPr lang="fr-CA" sz="2000" dirty="0" err="1">
-                <a:solidFill>
-                  <a:schemeClr val="bg1">
-                    <a:lumMod val="50000"/>
-                  </a:schemeClr>
-                </a:solidFill>
-                <a:latin typeface="Consolas" panose="020B0609020204030204" pitchFamily="49" charset="0"/>
-              </a:rPr>
-              <a:t>Saissez</a:t>
-            </a:r>
-            <a:r>
-              <a:rPr lang="fr-CA" sz="2000" dirty="0">
-                <a:solidFill>
-                  <a:schemeClr val="bg1">
-                    <a:lumMod val="50000"/>
-                  </a:schemeClr>
-                </a:solidFill>
-                <a:latin typeface="Consolas" panose="020B0609020204030204" pitchFamily="49" charset="0"/>
-              </a:rPr>
-              <a:t> une valeur (rien pour quitter): </a:t>
-            </a:r>
-          </a:p>
-          <a:p>
-            <a:pPr marL="457200" lvl="1" indent="0" algn="just">
-              <a:lnSpc>
-                <a:spcPct val="100000"/>
-              </a:lnSpc>
-              <a:buNone/>
-            </a:pPr>
-            <a:r>
-              <a:rPr lang="fr-CA" sz="2000" dirty="0">
-                <a:solidFill>
-                  <a:schemeClr val="bg1">
-                    <a:lumMod val="50000"/>
-                  </a:schemeClr>
-                </a:solidFill>
-                <a:latin typeface="Consolas" panose="020B0609020204030204" pitchFamily="49" charset="0"/>
-              </a:rPr>
-              <a:t>Moyenne    : 3.0</a:t>
-            </a:r>
-          </a:p>
-          <a:p>
-            <a:pPr marL="457200" lvl="1" indent="0" algn="just">
-              <a:lnSpc>
-                <a:spcPct val="100000"/>
-              </a:lnSpc>
-              <a:buNone/>
-            </a:pPr>
-            <a:r>
-              <a:rPr lang="en-US" sz="2000" dirty="0" err="1">
-                <a:solidFill>
-                  <a:schemeClr val="bg1">
-                    <a:lumMod val="50000"/>
-                  </a:schemeClr>
-                </a:solidFill>
-                <a:latin typeface="Consolas" panose="020B0609020204030204" pitchFamily="49" charset="0"/>
-              </a:rPr>
-              <a:t>Écart</a:t>
-            </a:r>
-            <a:r>
-              <a:rPr lang="en-US" sz="2000" dirty="0">
-                <a:solidFill>
-                  <a:schemeClr val="bg1">
-                    <a:lumMod val="50000"/>
-                  </a:schemeClr>
-                </a:solidFill>
-                <a:latin typeface="Consolas" panose="020B0609020204030204" pitchFamily="49" charset="0"/>
-              </a:rPr>
-              <a:t>-type : 1.41420135623730951</a:t>
-            </a:r>
-            <a:endParaRPr lang="fr-CA" sz="2000" dirty="0">
-              <a:solidFill>
-                <a:schemeClr val="bg1">
-                  <a:lumMod val="50000"/>
-                </a:schemeClr>
-              </a:solidFill>
-              <a:latin typeface="Consolas" panose="020B0609020204030204" pitchFamily="49" charset="0"/>
-            </a:endParaRPr>
-          </a:p>
-        </p:txBody>
-      </p:sp>
-      <p:sp>
-        <p:nvSpPr>
-          <p:cNvPr id="4" name="Slide Number Placeholder 3">
-            <a:extLst>
-              <a:ext uri="{FF2B5EF4-FFF2-40B4-BE49-F238E27FC236}">
-                <a16:creationId xmlns:a16="http://schemas.microsoft.com/office/drawing/2014/main" id="{C73E7699-9260-2B26-4E4F-F82743E2161A}"/>
-              </a:ext>
-            </a:extLst>
-          </p:cNvPr>
-          <p:cNvSpPr>
-            <a:spLocks noGrp="1"/>
-          </p:cNvSpPr>
-          <p:nvPr>
-            <p:ph type="sldNum" sz="quarter" idx="12"/>
-          </p:nvPr>
-        </p:nvSpPr>
-        <p:spPr/>
-        <p:txBody>
-          <a:bodyPr/>
-          <a:lstStyle/>
-          <a:p>
-            <a:fld id="{846B06B1-1179-491F-A487-8E0C403F7C13}" type="slidenum">
-              <a:rPr lang="fr-CA" smtClean="0"/>
-              <a:t>39</a:t>
-            </a:fld>
-            <a:endParaRPr lang="fr-CA"/>
-          </a:p>
-        </p:txBody>
-      </p:sp>
-    </p:spTree>
-    <p:extLst>
-      <p:ext uri="{BB962C8B-B14F-4D97-AF65-F5344CB8AC3E}">
-        <p14:creationId xmlns:p14="http://schemas.microsoft.com/office/powerpoint/2010/main" val="1553947036"/>
-      </p:ext>
-    </p:extLst>
-  </p:cSld>
-  <p:clrMapOvr>
-    <a:masterClrMapping/>
-  </p:clrMapOvr>
 </p:sld>
 </file>
 
@@ -39698,6 +40043,466 @@
     <p:extLst>
       <p:ext uri="{BB962C8B-B14F-4D97-AF65-F5344CB8AC3E}">
         <p14:creationId xmlns:p14="http://schemas.microsoft.com/office/powerpoint/2010/main" val="947172890"/>
+      </p:ext>
+    </p:extLst>
+  </p:cSld>
+  <p:clrMapOvr>
+    <a:masterClrMapping/>
+  </p:clrMapOvr>
+</p:sld>
+</file>
+
+<file path=ppt/slides/slide40.xml><?xml version="1.0" encoding="utf-8"?>
+<p:sld xmlns:a="http://schemas.openxmlformats.org/drawingml/2006/main" xmlns:r="http://schemas.openxmlformats.org/officeDocument/2006/relationships" xmlns:p="http://schemas.openxmlformats.org/presentationml/2006/main">
+  <p:cSld>
+    <p:bg>
+      <p:bgPr>
+        <a:solidFill>
+          <a:schemeClr val="accent6">
+            <a:lumMod val="20000"/>
+            <a:lumOff val="80000"/>
+          </a:schemeClr>
+        </a:solidFill>
+        <a:effectLst/>
+      </p:bgPr>
+    </p:bg>
+    <p:spTree>
+      <p:nvGrpSpPr>
+        <p:cNvPr id="1" name="">
+          <a:extLst>
+            <a:ext uri="{FF2B5EF4-FFF2-40B4-BE49-F238E27FC236}">
+              <a16:creationId xmlns:a16="http://schemas.microsoft.com/office/drawing/2014/main" id="{808E75C2-6E05-D4AE-5915-518C66CDFFB4}"/>
+            </a:ext>
+          </a:extLst>
+        </p:cNvPr>
+        <p:cNvGrpSpPr/>
+        <p:nvPr/>
+      </p:nvGrpSpPr>
+      <p:grpSpPr>
+        <a:xfrm>
+          <a:off x="0" y="0"/>
+          <a:ext cx="0" cy="0"/>
+          <a:chOff x="0" y="0"/>
+          <a:chExt cx="0" cy="0"/>
+        </a:xfrm>
+      </p:grpSpPr>
+      <p:sp>
+        <p:nvSpPr>
+          <p:cNvPr id="2" name="Title 1">
+            <a:extLst>
+              <a:ext uri="{FF2B5EF4-FFF2-40B4-BE49-F238E27FC236}">
+                <a16:creationId xmlns:a16="http://schemas.microsoft.com/office/drawing/2014/main" id="{DFCE78E3-6E2F-2513-0701-01EE22E72B4D}"/>
+              </a:ext>
+            </a:extLst>
+          </p:cNvPr>
+          <p:cNvSpPr>
+            <a:spLocks noGrp="1"/>
+          </p:cNvSpPr>
+          <p:nvPr>
+            <p:ph type="title"/>
+          </p:nvPr>
+        </p:nvSpPr>
+        <p:spPr/>
+        <p:txBody>
+          <a:bodyPr/>
+          <a:lstStyle/>
+          <a:p>
+            <a:r>
+              <a:rPr lang="en-US" dirty="0">
+                <a:latin typeface="Arial Rounded MT Bold" panose="020F0704030504030204" pitchFamily="34" charset="0"/>
+              </a:rPr>
+              <a:t>XR6 – Moyenne et </a:t>
+            </a:r>
+            <a:r>
+              <a:rPr lang="en-US" dirty="0" err="1">
+                <a:latin typeface="Arial Rounded MT Bold" panose="020F0704030504030204" pitchFamily="34" charset="0"/>
+              </a:rPr>
+              <a:t>écart</a:t>
+            </a:r>
+            <a:r>
+              <a:rPr lang="en-US" dirty="0">
+                <a:latin typeface="Arial Rounded MT Bold" panose="020F0704030504030204" pitchFamily="34" charset="0"/>
+              </a:rPr>
+              <a:t>-type</a:t>
+            </a:r>
+            <a:endParaRPr lang="fr-CA" dirty="0">
+              <a:latin typeface="Arial Rounded MT Bold" panose="020F0704030504030204" pitchFamily="34" charset="0"/>
+            </a:endParaRPr>
+          </a:p>
+        </p:txBody>
+      </p:sp>
+      <p:sp>
+        <p:nvSpPr>
+          <p:cNvPr id="3" name="Content Placeholder 2">
+            <a:extLst>
+              <a:ext uri="{FF2B5EF4-FFF2-40B4-BE49-F238E27FC236}">
+                <a16:creationId xmlns:a16="http://schemas.microsoft.com/office/drawing/2014/main" id="{E5BFA73A-5F16-C1DB-89AE-EB491A024297}"/>
+              </a:ext>
+            </a:extLst>
+          </p:cNvPr>
+          <p:cNvSpPr>
+            <a:spLocks noGrp="1"/>
+          </p:cNvSpPr>
+          <p:nvPr>
+            <p:ph idx="1"/>
+          </p:nvPr>
+        </p:nvSpPr>
+        <p:spPr/>
+        <p:txBody>
+          <a:bodyPr>
+            <a:normAutofit/>
+          </a:bodyPr>
+          <a:lstStyle/>
+          <a:p>
+            <a:pPr marL="0" indent="0" algn="just">
+              <a:lnSpc>
+                <a:spcPct val="100000"/>
+              </a:lnSpc>
+              <a:buNone/>
+            </a:pPr>
+            <a:r>
+              <a:rPr lang="en-US" sz="2200" dirty="0" err="1">
+                <a:latin typeface="Consolas" panose="020B0609020204030204" pitchFamily="49" charset="0"/>
+              </a:rPr>
+              <a:t>Implémentez</a:t>
+            </a:r>
+            <a:r>
+              <a:rPr lang="en-US" sz="2200" dirty="0">
+                <a:latin typeface="Consolas" panose="020B0609020204030204" pitchFamily="49" charset="0"/>
+              </a:rPr>
+              <a:t> la function </a:t>
+            </a:r>
+            <a:r>
+              <a:rPr lang="en-US" sz="2200" b="1" dirty="0" err="1">
+                <a:latin typeface="Consolas" panose="020B0609020204030204" pitchFamily="49" charset="0"/>
+              </a:rPr>
+              <a:t>afficher_moyenne_ecart_type</a:t>
+            </a:r>
+            <a:r>
+              <a:rPr lang="en-US" sz="2200" b="1" dirty="0">
+                <a:latin typeface="Consolas" panose="020B0609020204030204" pitchFamily="49" charset="0"/>
+              </a:rPr>
+              <a:t> </a:t>
+            </a:r>
+            <a:r>
+              <a:rPr lang="en-US" sz="2200" dirty="0">
+                <a:latin typeface="Consolas" panose="020B0609020204030204" pitchFamily="49" charset="0"/>
+              </a:rPr>
+              <a:t>qui suit:</a:t>
+            </a:r>
+          </a:p>
+          <a:p>
+            <a:pPr marL="0" indent="0" algn="just">
+              <a:lnSpc>
+                <a:spcPct val="100000"/>
+              </a:lnSpc>
+              <a:buNone/>
+            </a:pPr>
+            <a:endParaRPr lang="en-US" sz="200" dirty="0">
+              <a:latin typeface="Consolas" panose="020B0609020204030204" pitchFamily="49" charset="0"/>
+            </a:endParaRPr>
+          </a:p>
+          <a:p>
+            <a:pPr marL="457200" lvl="1" indent="0" algn="just">
+              <a:lnSpc>
+                <a:spcPct val="100000"/>
+              </a:lnSpc>
+              <a:buNone/>
+            </a:pPr>
+            <a:r>
+              <a:rPr lang="fr-CA" sz="2000" b="1" dirty="0">
+                <a:latin typeface="Consolas" panose="020B0609020204030204" pitchFamily="49" charset="0"/>
+              </a:rPr>
+              <a:t>&gt;&gt;&gt; </a:t>
+            </a:r>
+            <a:r>
+              <a:rPr lang="fr-CA" sz="2000" b="1" dirty="0" err="1">
+                <a:latin typeface="Consolas" panose="020B0609020204030204" pitchFamily="49" charset="0"/>
+              </a:rPr>
+              <a:t>afficher_moyenne_ecart_type</a:t>
+            </a:r>
+            <a:r>
+              <a:rPr lang="fr-CA" sz="2000" b="1">
+                <a:latin typeface="Consolas" panose="020B0609020204030204" pitchFamily="49" charset="0"/>
+              </a:rPr>
+              <a:t>()</a:t>
+            </a:r>
+            <a:endParaRPr lang="fr-CA" sz="2000" b="1" dirty="0">
+              <a:latin typeface="Consolas" panose="020B0609020204030204" pitchFamily="49" charset="0"/>
+            </a:endParaRPr>
+          </a:p>
+          <a:p>
+            <a:pPr marL="457200" lvl="1" indent="0" algn="just">
+              <a:lnSpc>
+                <a:spcPct val="100000"/>
+              </a:lnSpc>
+              <a:buNone/>
+            </a:pPr>
+            <a:r>
+              <a:rPr lang="fr-CA" sz="2000" dirty="0" err="1">
+                <a:solidFill>
+                  <a:schemeClr val="bg1">
+                    <a:lumMod val="50000"/>
+                  </a:schemeClr>
+                </a:solidFill>
+                <a:latin typeface="Consolas" panose="020B0609020204030204" pitchFamily="49" charset="0"/>
+              </a:rPr>
+              <a:t>Saissez</a:t>
+            </a:r>
+            <a:r>
+              <a:rPr lang="fr-CA" sz="2000" dirty="0">
+                <a:solidFill>
+                  <a:schemeClr val="bg1">
+                    <a:lumMod val="50000"/>
+                  </a:schemeClr>
+                </a:solidFill>
+                <a:latin typeface="Consolas" panose="020B0609020204030204" pitchFamily="49" charset="0"/>
+              </a:rPr>
+              <a:t> une valeur (rien pour quitter): 1</a:t>
+            </a:r>
+          </a:p>
+          <a:p>
+            <a:pPr marL="457200" lvl="1" indent="0" algn="just">
+              <a:lnSpc>
+                <a:spcPct val="100000"/>
+              </a:lnSpc>
+              <a:buNone/>
+            </a:pPr>
+            <a:r>
+              <a:rPr lang="fr-CA" sz="2000" dirty="0" err="1">
+                <a:solidFill>
+                  <a:schemeClr val="bg1">
+                    <a:lumMod val="50000"/>
+                  </a:schemeClr>
+                </a:solidFill>
+                <a:latin typeface="Consolas" panose="020B0609020204030204" pitchFamily="49" charset="0"/>
+              </a:rPr>
+              <a:t>Saissez</a:t>
+            </a:r>
+            <a:r>
+              <a:rPr lang="fr-CA" sz="2000" dirty="0">
+                <a:solidFill>
+                  <a:schemeClr val="bg1">
+                    <a:lumMod val="50000"/>
+                  </a:schemeClr>
+                </a:solidFill>
+                <a:latin typeface="Consolas" panose="020B0609020204030204" pitchFamily="49" charset="0"/>
+              </a:rPr>
+              <a:t> une valeur (rien pour quitter): 2</a:t>
+            </a:r>
+          </a:p>
+          <a:p>
+            <a:pPr marL="457200" lvl="1" indent="0" algn="just">
+              <a:lnSpc>
+                <a:spcPct val="100000"/>
+              </a:lnSpc>
+              <a:buNone/>
+            </a:pPr>
+            <a:r>
+              <a:rPr lang="fr-CA" sz="2000" dirty="0" err="1">
+                <a:solidFill>
+                  <a:schemeClr val="bg1">
+                    <a:lumMod val="50000"/>
+                  </a:schemeClr>
+                </a:solidFill>
+                <a:latin typeface="Consolas" panose="020B0609020204030204" pitchFamily="49" charset="0"/>
+              </a:rPr>
+              <a:t>Saissez</a:t>
+            </a:r>
+            <a:r>
+              <a:rPr lang="fr-CA" sz="2000" dirty="0">
+                <a:solidFill>
+                  <a:schemeClr val="bg1">
+                    <a:lumMod val="50000"/>
+                  </a:schemeClr>
+                </a:solidFill>
+                <a:latin typeface="Consolas" panose="020B0609020204030204" pitchFamily="49" charset="0"/>
+              </a:rPr>
+              <a:t> une valeur (rien pour quitter): 3</a:t>
+            </a:r>
+          </a:p>
+          <a:p>
+            <a:pPr marL="457200" lvl="1" indent="0" algn="just">
+              <a:lnSpc>
+                <a:spcPct val="100000"/>
+              </a:lnSpc>
+              <a:buNone/>
+            </a:pPr>
+            <a:r>
+              <a:rPr lang="fr-CA" sz="2000" dirty="0" err="1">
+                <a:solidFill>
+                  <a:schemeClr val="bg1">
+                    <a:lumMod val="50000"/>
+                  </a:schemeClr>
+                </a:solidFill>
+                <a:latin typeface="Consolas" panose="020B0609020204030204" pitchFamily="49" charset="0"/>
+              </a:rPr>
+              <a:t>Saissez</a:t>
+            </a:r>
+            <a:r>
+              <a:rPr lang="fr-CA" sz="2000" dirty="0">
+                <a:solidFill>
+                  <a:schemeClr val="bg1">
+                    <a:lumMod val="50000"/>
+                  </a:schemeClr>
+                </a:solidFill>
+                <a:latin typeface="Consolas" panose="020B0609020204030204" pitchFamily="49" charset="0"/>
+              </a:rPr>
+              <a:t> une valeur (rien pour quitter): 4</a:t>
+            </a:r>
+          </a:p>
+          <a:p>
+            <a:pPr marL="457200" lvl="1" indent="0" algn="just">
+              <a:lnSpc>
+                <a:spcPct val="100000"/>
+              </a:lnSpc>
+              <a:buNone/>
+            </a:pPr>
+            <a:r>
+              <a:rPr lang="fr-CA" sz="2000" dirty="0" err="1">
+                <a:solidFill>
+                  <a:schemeClr val="bg1">
+                    <a:lumMod val="50000"/>
+                  </a:schemeClr>
+                </a:solidFill>
+                <a:latin typeface="Consolas" panose="020B0609020204030204" pitchFamily="49" charset="0"/>
+              </a:rPr>
+              <a:t>Saissez</a:t>
+            </a:r>
+            <a:r>
+              <a:rPr lang="fr-CA" sz="2000" dirty="0">
+                <a:solidFill>
+                  <a:schemeClr val="bg1">
+                    <a:lumMod val="50000"/>
+                  </a:schemeClr>
+                </a:solidFill>
+                <a:latin typeface="Consolas" panose="020B0609020204030204" pitchFamily="49" charset="0"/>
+              </a:rPr>
+              <a:t> une valeur (rien pour quitter): 5</a:t>
+            </a:r>
+          </a:p>
+          <a:p>
+            <a:pPr marL="457200" lvl="1" indent="0" algn="just">
+              <a:lnSpc>
+                <a:spcPct val="100000"/>
+              </a:lnSpc>
+              <a:buNone/>
+            </a:pPr>
+            <a:r>
+              <a:rPr lang="fr-CA" sz="2000" dirty="0" err="1">
+                <a:solidFill>
+                  <a:schemeClr val="bg1">
+                    <a:lumMod val="50000"/>
+                  </a:schemeClr>
+                </a:solidFill>
+                <a:latin typeface="Consolas" panose="020B0609020204030204" pitchFamily="49" charset="0"/>
+              </a:rPr>
+              <a:t>Saissez</a:t>
+            </a:r>
+            <a:r>
+              <a:rPr lang="fr-CA" sz="2000" dirty="0">
+                <a:solidFill>
+                  <a:schemeClr val="bg1">
+                    <a:lumMod val="50000"/>
+                  </a:schemeClr>
+                </a:solidFill>
+                <a:latin typeface="Consolas" panose="020B0609020204030204" pitchFamily="49" charset="0"/>
+              </a:rPr>
+              <a:t> une valeur (rien pour quitter): </a:t>
+            </a:r>
+          </a:p>
+          <a:p>
+            <a:pPr marL="457200" lvl="1" indent="0" algn="just">
+              <a:lnSpc>
+                <a:spcPct val="100000"/>
+              </a:lnSpc>
+              <a:buNone/>
+            </a:pPr>
+            <a:r>
+              <a:rPr lang="fr-CA" sz="2000" dirty="0">
+                <a:solidFill>
+                  <a:schemeClr val="bg1">
+                    <a:lumMod val="50000"/>
+                  </a:schemeClr>
+                </a:solidFill>
+                <a:latin typeface="Consolas" panose="020B0609020204030204" pitchFamily="49" charset="0"/>
+              </a:rPr>
+              <a:t>Moyenne    : 3.0</a:t>
+            </a:r>
+          </a:p>
+          <a:p>
+            <a:pPr marL="457200" lvl="1" indent="0" algn="just">
+              <a:lnSpc>
+                <a:spcPct val="100000"/>
+              </a:lnSpc>
+              <a:buNone/>
+            </a:pPr>
+            <a:r>
+              <a:rPr lang="en-US" sz="2000" dirty="0" err="1">
+                <a:solidFill>
+                  <a:schemeClr val="bg1">
+                    <a:lumMod val="50000"/>
+                  </a:schemeClr>
+                </a:solidFill>
+                <a:latin typeface="Consolas" panose="020B0609020204030204" pitchFamily="49" charset="0"/>
+              </a:rPr>
+              <a:t>Écart</a:t>
+            </a:r>
+            <a:r>
+              <a:rPr lang="en-US" sz="2000" dirty="0">
+                <a:solidFill>
+                  <a:schemeClr val="bg1">
+                    <a:lumMod val="50000"/>
+                  </a:schemeClr>
+                </a:solidFill>
+                <a:latin typeface="Consolas" panose="020B0609020204030204" pitchFamily="49" charset="0"/>
+              </a:rPr>
+              <a:t>-type : 1.41420135623730951</a:t>
+            </a:r>
+            <a:endParaRPr lang="fr-CA" sz="2000" dirty="0">
+              <a:solidFill>
+                <a:schemeClr val="bg1">
+                  <a:lumMod val="50000"/>
+                </a:schemeClr>
+              </a:solidFill>
+              <a:latin typeface="Consolas" panose="020B0609020204030204" pitchFamily="49" charset="0"/>
+            </a:endParaRPr>
+          </a:p>
+        </p:txBody>
+      </p:sp>
+      <p:sp>
+        <p:nvSpPr>
+          <p:cNvPr id="4" name="Slide Number Placeholder 3">
+            <a:extLst>
+              <a:ext uri="{FF2B5EF4-FFF2-40B4-BE49-F238E27FC236}">
+                <a16:creationId xmlns:a16="http://schemas.microsoft.com/office/drawing/2014/main" id="{C73E7699-9260-2B26-4E4F-F82743E2161A}"/>
+              </a:ext>
+            </a:extLst>
+          </p:cNvPr>
+          <p:cNvSpPr>
+            <a:spLocks noGrp="1"/>
+          </p:cNvSpPr>
+          <p:nvPr>
+            <p:ph type="sldNum" sz="quarter" idx="12"/>
+          </p:nvPr>
+        </p:nvSpPr>
+        <p:spPr/>
+        <p:txBody>
+          <a:bodyPr/>
+          <a:lstStyle/>
+          <a:p>
+            <a:fld id="{846B06B1-1179-491F-A487-8E0C403F7C13}" type="slidenum">
+              <a:rPr lang="fr-CA" smtClean="0"/>
+              <a:t>40</a:t>
+            </a:fld>
+            <a:endParaRPr lang="fr-CA"/>
+          </a:p>
+        </p:txBody>
+      </p:sp>
+    </p:spTree>
+    <p:extLst>
+      <p:ext uri="{BB962C8B-B14F-4D97-AF65-F5344CB8AC3E}">
+        <p14:creationId xmlns:p14="http://schemas.microsoft.com/office/powerpoint/2010/main" val="1553947036"/>
       </p:ext>
     </p:extLst>
   </p:cSld>
@@ -42544,8 +43349,8 @@
           </a:p>
         </p:txBody>
       </p:sp>
-      <mc:AlternateContent xmlns:mc="http://schemas.openxmlformats.org/markup-compatibility/2006" xmlns:a14="http://schemas.microsoft.com/office/drawing/2010/main">
-        <mc:Choice Requires="a14">
+      <mc:AlternateContent xmlns:mc="http://schemas.openxmlformats.org/markup-compatibility/2006">
+        <mc:Choice xmlns:a14="http://schemas.microsoft.com/office/drawing/2010/main" Requires="a14">
           <p:sp>
             <p:nvSpPr>
               <p:cNvPr id="3" name="Content Placeholder 2">
@@ -42571,7 +43376,7 @@
               <a:p>
                 <a:pPr algn="just">
                   <a:lnSpc>
-                    <a:spcPct val="100000"/>
+                    <a:spcPct val="150000"/>
                   </a:lnSpc>
                 </a:pPr>
                 <a:r>
@@ -42630,7 +43435,7 @@
               <a:p>
                 <a:pPr algn="just">
                   <a:lnSpc>
-                    <a:spcPct val="100000"/>
+                    <a:spcPct val="150000"/>
                   </a:lnSpc>
                 </a:pPr>
                 <a:r>
@@ -42707,7 +43512,7 @@
               <a:p>
                 <a:pPr lvl="1" algn="just">
                   <a:lnSpc>
-                    <a:spcPct val="100000"/>
+                    <a:spcPct val="150000"/>
                   </a:lnSpc>
                 </a:pPr>
                 <a:r>
@@ -42732,7 +43537,7 @@
               <a:p>
                 <a:pPr lvl="1" algn="just">
                   <a:lnSpc>
-                    <a:spcPct val="100000"/>
+                    <a:spcPct val="150000"/>
                   </a:lnSpc>
                 </a:pPr>
                 <a:r>
@@ -42745,7 +43550,7 @@
             </p:txBody>
           </p:sp>
         </mc:Choice>
-        <mc:Fallback xmlns="">
+        <mc:Fallback>
           <p:sp>
             <p:nvSpPr>
               <p:cNvPr id="3" name="Content Placeholder 2">
@@ -42766,7 +43571,7 @@
               <a:blipFill>
                 <a:blip r:embed="rId2"/>
                 <a:stretch>
-                  <a:fillRect l="-406" t="-700" r="-464"/>
+                  <a:fillRect l="-406" r="-464"/>
                 </a:stretch>
               </a:blipFill>
             </p:spPr>

</xml_diff>

<commit_message>
feat: Add python_2 presentation slide no.19
</commit_message>
<xml_diff>
--- a/python_2/presentation_python_2.pptx
+++ b/python_2/presentation_python_2.pptx
@@ -5,7 +5,7 @@
     <p:sldMasterId id="2147483648" r:id="rId1"/>
   </p:sldMasterIdLst>
   <p:notesMasterIdLst>
-    <p:notesMasterId r:id="rId20"/>
+    <p:notesMasterId r:id="rId21"/>
   </p:notesMasterIdLst>
   <p:sldIdLst>
     <p:sldId id="256" r:id="rId2"/>
@@ -25,7 +25,8 @@
     <p:sldId id="309" r:id="rId16"/>
     <p:sldId id="311" r:id="rId17"/>
     <p:sldId id="312" r:id="rId18"/>
-    <p:sldId id="297" r:id="rId19"/>
+    <p:sldId id="313" r:id="rId19"/>
+    <p:sldId id="297" r:id="rId20"/>
   </p:sldIdLst>
   <p:sldSz cx="12192000" cy="6858000"/>
   <p:notesSz cx="6858000" cy="9144000"/>
@@ -585,6 +586,114 @@
     <p:extLst>
       <p:ext uri="{BB962C8B-B14F-4D97-AF65-F5344CB8AC3E}">
         <p14:creationId xmlns:p14="http://schemas.microsoft.com/office/powerpoint/2010/main" val="506805993"/>
+      </p:ext>
+    </p:extLst>
+  </p:cSld>
+  <p:clrMapOvr>
+    <a:masterClrMapping/>
+  </p:clrMapOvr>
+</p:notes>
+</file>
+
+<file path=ppt/notesSlides/notesSlide10.xml><?xml version="1.0" encoding="utf-8"?>
+<p:notes xmlns:a="http://schemas.openxmlformats.org/drawingml/2006/main" xmlns:r="http://schemas.openxmlformats.org/officeDocument/2006/relationships" xmlns:p="http://schemas.openxmlformats.org/presentationml/2006/main">
+  <p:cSld>
+    <p:spTree>
+      <p:nvGrpSpPr>
+        <p:cNvPr id="1" name="">
+          <a:extLst>
+            <a:ext uri="{FF2B5EF4-FFF2-40B4-BE49-F238E27FC236}">
+              <a16:creationId xmlns:a16="http://schemas.microsoft.com/office/drawing/2014/main" id="{294D5604-FDBC-D681-9D03-26299CC1D5AD}"/>
+            </a:ext>
+          </a:extLst>
+        </p:cNvPr>
+        <p:cNvGrpSpPr/>
+        <p:nvPr/>
+      </p:nvGrpSpPr>
+      <p:grpSpPr>
+        <a:xfrm>
+          <a:off x="0" y="0"/>
+          <a:ext cx="0" cy="0"/>
+          <a:chOff x="0" y="0"/>
+          <a:chExt cx="0" cy="0"/>
+        </a:xfrm>
+      </p:grpSpPr>
+      <p:sp>
+        <p:nvSpPr>
+          <p:cNvPr id="2" name="Slide Image Placeholder 1">
+            <a:extLst>
+              <a:ext uri="{FF2B5EF4-FFF2-40B4-BE49-F238E27FC236}">
+                <a16:creationId xmlns:a16="http://schemas.microsoft.com/office/drawing/2014/main" id="{B958D57B-86F9-B4FC-58C0-36FB265AAC54}"/>
+              </a:ext>
+            </a:extLst>
+          </p:cNvPr>
+          <p:cNvSpPr>
+            <a:spLocks noGrp="1" noRot="1" noChangeAspect="1"/>
+          </p:cNvSpPr>
+          <p:nvPr>
+            <p:ph type="sldImg"/>
+          </p:nvPr>
+        </p:nvSpPr>
+        <p:spPr/>
+      </p:sp>
+      <p:sp>
+        <p:nvSpPr>
+          <p:cNvPr id="3" name="Notes Placeholder 2">
+            <a:extLst>
+              <a:ext uri="{FF2B5EF4-FFF2-40B4-BE49-F238E27FC236}">
+                <a16:creationId xmlns:a16="http://schemas.microsoft.com/office/drawing/2014/main" id="{2C797C78-4AE3-669F-6455-49774B313E08}"/>
+              </a:ext>
+            </a:extLst>
+          </p:cNvPr>
+          <p:cNvSpPr>
+            <a:spLocks noGrp="1"/>
+          </p:cNvSpPr>
+          <p:nvPr>
+            <p:ph type="body" idx="1"/>
+          </p:nvPr>
+        </p:nvSpPr>
+        <p:spPr/>
+        <p:txBody>
+          <a:bodyPr/>
+          <a:lstStyle/>
+          <a:p>
+            <a:endParaRPr lang="fr-CA" dirty="0"/>
+          </a:p>
+        </p:txBody>
+      </p:sp>
+      <p:sp>
+        <p:nvSpPr>
+          <p:cNvPr id="4" name="Slide Number Placeholder 3">
+            <a:extLst>
+              <a:ext uri="{FF2B5EF4-FFF2-40B4-BE49-F238E27FC236}">
+                <a16:creationId xmlns:a16="http://schemas.microsoft.com/office/drawing/2014/main" id="{64CA70F8-DE3F-87B6-731B-AA8031C2A88B}"/>
+              </a:ext>
+            </a:extLst>
+          </p:cNvPr>
+          <p:cNvSpPr>
+            <a:spLocks noGrp="1"/>
+          </p:cNvSpPr>
+          <p:nvPr>
+            <p:ph type="sldNum" sz="quarter" idx="5"/>
+          </p:nvPr>
+        </p:nvSpPr>
+        <p:spPr/>
+        <p:txBody>
+          <a:bodyPr/>
+          <a:lstStyle/>
+          <a:p>
+            <a:fld id="{D755565A-1FEC-4FFE-8425-B731D92946D0}" type="slidenum">
+              <a:rPr lang="fr-CA" smtClean="0"/>
+              <a:t>18</a:t>
+            </a:fld>
+            <a:endParaRPr lang="fr-CA"/>
+          </a:p>
+        </p:txBody>
+      </p:sp>
+    </p:spTree>
+    <p:extLst>
+      <p:ext uri="{BB962C8B-B14F-4D97-AF65-F5344CB8AC3E}">
+        <p14:creationId xmlns:p14="http://schemas.microsoft.com/office/powerpoint/2010/main" val="1204014661"/>
       </p:ext>
     </p:extLst>
   </p:cSld>
@@ -13438,6 +13547,16 @@
             </a:r>
           </a:p>
           <a:p>
+            <a:pPr algn="just">
+              <a:lnSpc>
+                <a:spcPct val="110000"/>
+              </a:lnSpc>
+            </a:pPr>
+            <a:endParaRPr lang="fr-CA" sz="100" dirty="0">
+              <a:latin typeface="Consolas" panose="020B0609020204030204" pitchFamily="49" charset="0"/>
+            </a:endParaRPr>
+          </a:p>
+          <a:p>
             <a:pPr lvl="1" algn="just">
               <a:lnSpc>
                 <a:spcPct val="110000"/>
@@ -13746,7 +13865,7 @@
                                         <p:tgtEl>
                                           <p:spTgt spid="3">
                                             <p:txEl>
-                                              <p:pRg st="1" end="1"/>
+                                              <p:pRg st="2" end="2"/>
                                             </p:txEl>
                                           </p:spTgt>
                                         </p:tgtEl>
@@ -13764,7 +13883,7 @@
                                         <p:tgtEl>
                                           <p:spTgt spid="3">
                                             <p:txEl>
-                                              <p:pRg st="1" end="1"/>
+                                              <p:pRg st="2" end="2"/>
                                             </p:txEl>
                                           </p:spTgt>
                                         </p:tgtEl>
@@ -13807,7 +13926,7 @@
                                         <p:tgtEl>
                                           <p:spTgt spid="3">
                                             <p:txEl>
-                                              <p:pRg st="2" end="2"/>
+                                              <p:pRg st="3" end="3"/>
                                             </p:txEl>
                                           </p:spTgt>
                                         </p:tgtEl>
@@ -13825,7 +13944,7 @@
                                         <p:tgtEl>
                                           <p:spTgt spid="3">
                                             <p:txEl>
-                                              <p:pRg st="2" end="2"/>
+                                              <p:pRg st="3" end="3"/>
                                             </p:txEl>
                                           </p:spTgt>
                                         </p:tgtEl>
@@ -13868,7 +13987,7 @@
                                         <p:tgtEl>
                                           <p:spTgt spid="3">
                                             <p:txEl>
-                                              <p:pRg st="3" end="3"/>
+                                              <p:pRg st="4" end="4"/>
                                             </p:txEl>
                                           </p:spTgt>
                                         </p:tgtEl>
@@ -13886,7 +14005,7 @@
                                         <p:tgtEl>
                                           <p:spTgt spid="3">
                                             <p:txEl>
-                                              <p:pRg st="3" end="3"/>
+                                              <p:pRg st="4" end="4"/>
                                             </p:txEl>
                                           </p:spTgt>
                                         </p:tgtEl>
@@ -13929,7 +14048,7 @@
                                         <p:tgtEl>
                                           <p:spTgt spid="3">
                                             <p:txEl>
-                                              <p:pRg st="4" end="4"/>
+                                              <p:pRg st="5" end="5"/>
                                             </p:txEl>
                                           </p:spTgt>
                                         </p:tgtEl>
@@ -13947,7 +14066,7 @@
                                         <p:tgtEl>
                                           <p:spTgt spid="3">
                                             <p:txEl>
-                                              <p:pRg st="4" end="4"/>
+                                              <p:pRg st="5" end="5"/>
                                             </p:txEl>
                                           </p:spTgt>
                                         </p:tgtEl>
@@ -13990,7 +14109,7 @@
                                         <p:tgtEl>
                                           <p:spTgt spid="3">
                                             <p:txEl>
-                                              <p:pRg st="5" end="5"/>
+                                              <p:pRg st="6" end="6"/>
                                             </p:txEl>
                                           </p:spTgt>
                                         </p:tgtEl>
@@ -14008,7 +14127,7 @@
                                         <p:tgtEl>
                                           <p:spTgt spid="3">
                                             <p:txEl>
-                                              <p:pRg st="5" end="5"/>
+                                              <p:pRg st="6" end="6"/>
                                             </p:txEl>
                                           </p:spTgt>
                                         </p:tgtEl>
@@ -14051,7 +14170,7 @@
                                         <p:tgtEl>
                                           <p:spTgt spid="3">
                                             <p:txEl>
-                                              <p:pRg st="7" end="7"/>
+                                              <p:pRg st="8" end="8"/>
                                             </p:txEl>
                                           </p:spTgt>
                                         </p:tgtEl>
@@ -14069,7 +14188,7 @@
                                         <p:tgtEl>
                                           <p:spTgt spid="3">
                                             <p:txEl>
-                                              <p:pRg st="7" end="7"/>
+                                              <p:pRg st="8" end="8"/>
                                             </p:txEl>
                                           </p:spTgt>
                                         </p:tgtEl>
@@ -14110,6 +14229,408 @@
 </file>
 
 <file path=ppt/slides/slide18.xml><?xml version="1.0" encoding="utf-8"?>
+<p:sld xmlns:a="http://schemas.openxmlformats.org/drawingml/2006/main" xmlns:r="http://schemas.openxmlformats.org/officeDocument/2006/relationships" xmlns:p="http://schemas.openxmlformats.org/presentationml/2006/main">
+  <p:cSld>
+    <p:bg>
+      <p:bgPr>
+        <a:solidFill>
+          <a:schemeClr val="bg1"/>
+        </a:solidFill>
+        <a:effectLst/>
+      </p:bgPr>
+    </p:bg>
+    <p:spTree>
+      <p:nvGrpSpPr>
+        <p:cNvPr id="1" name="">
+          <a:extLst>
+            <a:ext uri="{FF2B5EF4-FFF2-40B4-BE49-F238E27FC236}">
+              <a16:creationId xmlns:a16="http://schemas.microsoft.com/office/drawing/2014/main" id="{157999F6-E167-AC13-9C13-B4B6B300C870}"/>
+            </a:ext>
+          </a:extLst>
+        </p:cNvPr>
+        <p:cNvGrpSpPr/>
+        <p:nvPr/>
+      </p:nvGrpSpPr>
+      <p:grpSpPr>
+        <a:xfrm>
+          <a:off x="0" y="0"/>
+          <a:ext cx="0" cy="0"/>
+          <a:chOff x="0" y="0"/>
+          <a:chExt cx="0" cy="0"/>
+        </a:xfrm>
+      </p:grpSpPr>
+      <p:sp>
+        <p:nvSpPr>
+          <p:cNvPr id="5" name="Slide Number Placeholder 4">
+            <a:extLst>
+              <a:ext uri="{FF2B5EF4-FFF2-40B4-BE49-F238E27FC236}">
+                <a16:creationId xmlns:a16="http://schemas.microsoft.com/office/drawing/2014/main" id="{7D1EAE46-18C1-3274-151E-4580ADFDDAA6}"/>
+              </a:ext>
+            </a:extLst>
+          </p:cNvPr>
+          <p:cNvSpPr>
+            <a:spLocks noGrp="1"/>
+          </p:cNvSpPr>
+          <p:nvPr>
+            <p:ph type="sldNum" sz="quarter" idx="12"/>
+          </p:nvPr>
+        </p:nvSpPr>
+        <p:spPr/>
+        <p:txBody>
+          <a:bodyPr/>
+          <a:lstStyle/>
+          <a:p>
+            <a:fld id="{846B06B1-1179-491F-A487-8E0C403F7C13}" type="slidenum">
+              <a:rPr lang="fr-CA" smtClean="0"/>
+              <a:t>18</a:t>
+            </a:fld>
+            <a:endParaRPr lang="fr-CA" dirty="0"/>
+          </a:p>
+        </p:txBody>
+      </p:sp>
+      <p:pic>
+        <p:nvPicPr>
+          <p:cNvPr id="7" name="Graphique 16">
+            <a:extLst>
+              <a:ext uri="{FF2B5EF4-FFF2-40B4-BE49-F238E27FC236}">
+                <a16:creationId xmlns:a16="http://schemas.microsoft.com/office/drawing/2014/main" id="{DFCF3A4C-CEF0-9DDE-5CA4-335E5236FA5E}"/>
+              </a:ext>
+            </a:extLst>
+          </p:cNvPr>
+          <p:cNvPicPr>
+            <a:picLocks noChangeAspect="1"/>
+          </p:cNvPicPr>
+          <p:nvPr/>
+        </p:nvPicPr>
+        <p:blipFill>
+          <a:blip>
+            <a:extLst>
+              <a:ext uri="{28A0092B-C50C-407E-A947-70E740481C1C}">
+                <a14:useLocalDpi xmlns:a14="http://schemas.microsoft.com/office/drawing/2010/main" val="0"/>
+              </a:ext>
+              <a:ext uri="{96DAC541-7B7A-43D3-8B79-37D633B846F1}">
+                <asvg:svgBlip xmlns:asvg="http://schemas.microsoft.com/office/drawing/2016/SVG/main" r:embed="rId3"/>
+              </a:ext>
+            </a:extLst>
+          </a:blip>
+          <a:stretch>
+            <a:fillRect/>
+          </a:stretch>
+        </p:blipFill>
+        <p:spPr>
+          <a:xfrm>
+            <a:off x="3036000" y="372875"/>
+            <a:ext cx="6120000" cy="6120000"/>
+          </a:xfrm>
+          <a:prstGeom prst="rect">
+            <a:avLst/>
+          </a:prstGeom>
+        </p:spPr>
+      </p:pic>
+      <p:pic>
+        <p:nvPicPr>
+          <p:cNvPr id="1026" name="Picture 2" descr="Comic Book Woman Images – Browse 393,037 Stock Photos, Vectors, and Video |  Adobe Stock">
+            <a:extLst>
+              <a:ext uri="{FF2B5EF4-FFF2-40B4-BE49-F238E27FC236}">
+                <a16:creationId xmlns:a16="http://schemas.microsoft.com/office/drawing/2014/main" id="{E197B27B-9941-45BE-B66E-D5E071D6F8F3}"/>
+              </a:ext>
+            </a:extLst>
+          </p:cNvPr>
+          <p:cNvPicPr>
+            <a:picLocks noChangeAspect="1" noChangeArrowheads="1"/>
+          </p:cNvPicPr>
+          <p:nvPr/>
+        </p:nvPicPr>
+        <p:blipFill>
+          <a:blip r:embed="rId4">
+            <a:extLst>
+              <a:ext uri="{28A0092B-C50C-407E-A947-70E740481C1C}">
+                <a14:useLocalDpi xmlns:a14="http://schemas.microsoft.com/office/drawing/2010/main" val="0"/>
+              </a:ext>
+            </a:extLst>
+          </a:blip>
+          <a:srcRect/>
+          <a:stretch>
+            <a:fillRect/>
+          </a:stretch>
+        </p:blipFill>
+        <p:spPr bwMode="auto">
+          <a:xfrm>
+            <a:off x="457403" y="5058000"/>
+            <a:ext cx="2250000" cy="1800000"/>
+          </a:xfrm>
+          <a:prstGeom prst="rect">
+            <a:avLst/>
+          </a:prstGeom>
+          <a:noFill/>
+          <a:extLst>
+            <a:ext uri="{909E8E84-426E-40DD-AFC4-6F175D3DCCD1}">
+              <a14:hiddenFill xmlns:a14="http://schemas.microsoft.com/office/drawing/2010/main">
+                <a:solidFill>
+                  <a:srgbClr val="FFFFFF"/>
+                </a:solidFill>
+              </a14:hiddenFill>
+            </a:ext>
+          </a:extLst>
+        </p:spPr>
+      </p:pic>
+      <p:grpSp>
+        <p:nvGrpSpPr>
+          <p:cNvPr id="10" name="Group 9">
+            <a:extLst>
+              <a:ext uri="{FF2B5EF4-FFF2-40B4-BE49-F238E27FC236}">
+                <a16:creationId xmlns:a16="http://schemas.microsoft.com/office/drawing/2014/main" id="{988D3726-AAF0-638A-6969-5B2A7B82B318}"/>
+              </a:ext>
+            </a:extLst>
+          </p:cNvPr>
+          <p:cNvGrpSpPr/>
+          <p:nvPr/>
+        </p:nvGrpSpPr>
+        <p:grpSpPr>
+          <a:xfrm>
+            <a:off x="8610600" y="2967335"/>
+            <a:ext cx="3147499" cy="923330"/>
+            <a:chOff x="6485106" y="3637379"/>
+            <a:chExt cx="3147499" cy="923330"/>
+          </a:xfrm>
+        </p:grpSpPr>
+        <p:sp>
+          <p:nvSpPr>
+            <p:cNvPr id="11" name="TextBox 10">
+              <a:extLst>
+                <a:ext uri="{FF2B5EF4-FFF2-40B4-BE49-F238E27FC236}">
+                  <a16:creationId xmlns:a16="http://schemas.microsoft.com/office/drawing/2014/main" id="{F9FE82D0-EEE0-A2B1-3805-6163F4EEF85C}"/>
+                </a:ext>
+              </a:extLst>
+            </p:cNvPr>
+            <p:cNvSpPr txBox="1"/>
+            <p:nvPr/>
+          </p:nvSpPr>
+          <p:spPr>
+            <a:xfrm>
+              <a:off x="7295106" y="3637379"/>
+              <a:ext cx="2337499" cy="923330"/>
+            </a:xfrm>
+            <a:prstGeom prst="rect">
+              <a:avLst/>
+            </a:prstGeom>
+            <a:noFill/>
+          </p:spPr>
+          <p:txBody>
+            <a:bodyPr wrap="none" rtlCol="0">
+              <a:spAutoFit/>
+            </a:bodyPr>
+            <a:lstStyle/>
+            <a:p>
+              <a:r>
+                <a:rPr lang="en-US" dirty="0">
+                  <a:latin typeface="Consolas" panose="020B0609020204030204" pitchFamily="49" charset="0"/>
+                </a:rPr>
+                <a:t>Le </a:t>
+              </a:r>
+              <a:r>
+                <a:rPr lang="en-US" dirty="0" err="1">
+                  <a:latin typeface="Consolas" panose="020B0609020204030204" pitchFamily="49" charset="0"/>
+                </a:rPr>
+                <a:t>graphique</a:t>
+              </a:r>
+              <a:r>
+                <a:rPr lang="en-US" dirty="0">
+                  <a:latin typeface="Consolas" panose="020B0609020204030204" pitchFamily="49" charset="0"/>
+                </a:rPr>
+                <a:t> est </a:t>
+              </a:r>
+            </a:p>
+            <a:p>
+              <a:r>
+                <a:rPr lang="en-US" dirty="0">
+                  <a:latin typeface="Consolas" panose="020B0609020204030204" pitchFamily="49" charset="0"/>
+                </a:rPr>
+                <a:t>un </a:t>
+              </a:r>
+              <a:r>
+                <a:rPr lang="en-US" dirty="0" err="1">
+                  <a:latin typeface="Consolas" panose="020B0609020204030204" pitchFamily="49" charset="0"/>
+                </a:rPr>
+                <a:t>objet</a:t>
+              </a:r>
+              <a:r>
+                <a:rPr lang="en-US" dirty="0">
+                  <a:latin typeface="Consolas" panose="020B0609020204030204" pitchFamily="49" charset="0"/>
+                </a:rPr>
+                <a:t> </a:t>
+              </a:r>
+              <a:r>
+                <a:rPr lang="en-US" dirty="0" err="1">
+                  <a:latin typeface="Consolas" panose="020B0609020204030204" pitchFamily="49" charset="0"/>
+                </a:rPr>
+                <a:t>composé</a:t>
+              </a:r>
+              <a:r>
+                <a:rPr lang="en-US" dirty="0">
+                  <a:latin typeface="Consolas" panose="020B0609020204030204" pitchFamily="49" charset="0"/>
+                </a:rPr>
+                <a:t> </a:t>
+              </a:r>
+            </a:p>
+            <a:p>
+              <a:r>
+                <a:rPr lang="en-US" dirty="0" err="1">
+                  <a:latin typeface="Consolas" panose="020B0609020204030204" pitchFamily="49" charset="0"/>
+                </a:rPr>
+                <a:t>d'objets</a:t>
+              </a:r>
+              <a:r>
+                <a:rPr lang="en-US" dirty="0">
+                  <a:latin typeface="Consolas" panose="020B0609020204030204" pitchFamily="49" charset="0"/>
+                </a:rPr>
+                <a:t> ...</a:t>
+              </a:r>
+              <a:endParaRPr lang="fr-CA" dirty="0">
+                <a:latin typeface="Consolas" panose="020B0609020204030204" pitchFamily="49" charset="0"/>
+              </a:endParaRPr>
+            </a:p>
+          </p:txBody>
+        </p:sp>
+        <p:cxnSp>
+          <p:nvCxnSpPr>
+            <p:cNvPr id="12" name="Straight Arrow Connector 11">
+              <a:extLst>
+                <a:ext uri="{FF2B5EF4-FFF2-40B4-BE49-F238E27FC236}">
+                  <a16:creationId xmlns:a16="http://schemas.microsoft.com/office/drawing/2014/main" id="{4B239757-BB95-EC61-34EC-012AF76F984F}"/>
+                </a:ext>
+              </a:extLst>
+            </p:cNvPr>
+            <p:cNvCxnSpPr>
+              <a:cxnSpLocks/>
+            </p:cNvCxnSpPr>
+            <p:nvPr/>
+          </p:nvCxnSpPr>
+          <p:spPr>
+            <a:xfrm flipH="1">
+              <a:off x="6485106" y="4099044"/>
+              <a:ext cx="810000" cy="0"/>
+            </a:xfrm>
+            <a:prstGeom prst="straightConnector1">
+              <a:avLst/>
+            </a:prstGeom>
+            <a:ln>
+              <a:tailEnd type="triangle"/>
+            </a:ln>
+          </p:spPr>
+          <p:style>
+            <a:lnRef idx="2">
+              <a:schemeClr val="dk1"/>
+            </a:lnRef>
+            <a:fillRef idx="0">
+              <a:schemeClr val="dk1"/>
+            </a:fillRef>
+            <a:effectRef idx="1">
+              <a:schemeClr val="dk1"/>
+            </a:effectRef>
+            <a:fontRef idx="minor">
+              <a:schemeClr val="tx1"/>
+            </a:fontRef>
+          </p:style>
+        </p:cxnSp>
+      </p:grpSp>
+    </p:spTree>
+    <p:extLst>
+      <p:ext uri="{BB962C8B-B14F-4D97-AF65-F5344CB8AC3E}">
+        <p14:creationId xmlns:p14="http://schemas.microsoft.com/office/powerpoint/2010/main" val="4154210216"/>
+      </p:ext>
+    </p:extLst>
+  </p:cSld>
+  <p:clrMapOvr>
+    <a:masterClrMapping/>
+  </p:clrMapOvr>
+  <p:timing>
+    <p:tnLst>
+      <p:par>
+        <p:cTn id="1" dur="indefinite" restart="never" nodeType="tmRoot">
+          <p:childTnLst>
+            <p:seq concurrent="1" nextAc="seek">
+              <p:cTn id="2" dur="indefinite" nodeType="mainSeq">
+                <p:childTnLst>
+                  <p:par>
+                    <p:cTn id="3" fill="hold">
+                      <p:stCondLst>
+                        <p:cond delay="indefinite"/>
+                      </p:stCondLst>
+                      <p:childTnLst>
+                        <p:par>
+                          <p:cTn id="4" fill="hold">
+                            <p:stCondLst>
+                              <p:cond delay="0"/>
+                            </p:stCondLst>
+                            <p:childTnLst>
+                              <p:par>
+                                <p:cTn id="5" presetID="10" presetClass="entr" presetSubtype="0" fill="hold" nodeType="clickEffect">
+                                  <p:stCondLst>
+                                    <p:cond delay="0"/>
+                                  </p:stCondLst>
+                                  <p:childTnLst>
+                                    <p:set>
+                                      <p:cBhvr>
+                                        <p:cTn id="6" dur="1" fill="hold">
+                                          <p:stCondLst>
+                                            <p:cond delay="0"/>
+                                          </p:stCondLst>
+                                        </p:cTn>
+                                        <p:tgtEl>
+                                          <p:spTgt spid="10"/>
+                                        </p:tgtEl>
+                                        <p:attrNameLst>
+                                          <p:attrName>style.visibility</p:attrName>
+                                        </p:attrNameLst>
+                                      </p:cBhvr>
+                                      <p:to>
+                                        <p:strVal val="visible"/>
+                                      </p:to>
+                                    </p:set>
+                                    <p:animEffect transition="in" filter="fade">
+                                      <p:cBhvr>
+                                        <p:cTn id="7" dur="500"/>
+                                        <p:tgtEl>
+                                          <p:spTgt spid="10"/>
+                                        </p:tgtEl>
+                                      </p:cBhvr>
+                                    </p:animEffect>
+                                  </p:childTnLst>
+                                </p:cTn>
+                              </p:par>
+                            </p:childTnLst>
+                          </p:cTn>
+                        </p:par>
+                      </p:childTnLst>
+                    </p:cTn>
+                  </p:par>
+                </p:childTnLst>
+              </p:cTn>
+              <p:prevCondLst>
+                <p:cond evt="onPrev" delay="0">
+                  <p:tgtEl>
+                    <p:sldTgt/>
+                  </p:tgtEl>
+                </p:cond>
+              </p:prevCondLst>
+              <p:nextCondLst>
+                <p:cond evt="onNext" delay="0">
+                  <p:tgtEl>
+                    <p:sldTgt/>
+                  </p:tgtEl>
+                </p:cond>
+              </p:nextCondLst>
+            </p:seq>
+          </p:childTnLst>
+        </p:cTn>
+      </p:par>
+    </p:tnLst>
+  </p:timing>
+</p:sld>
+</file>
+
+<file path=ppt/slides/slide19.xml><?xml version="1.0" encoding="utf-8"?>
 <p:sld xmlns:a="http://schemas.openxmlformats.org/drawingml/2006/main" xmlns:r="http://schemas.openxmlformats.org/officeDocument/2006/relationships" xmlns:p="http://schemas.openxmlformats.org/presentationml/2006/main">
   <p:cSld>
     <p:bg>

</xml_diff>

<commit_message>
feat: Add python_2 presentation slides up to slide no.21
</commit_message>
<xml_diff>
--- a/python_2/presentation_python_2.pptx
+++ b/python_2/presentation_python_2.pptx
@@ -5,7 +5,7 @@
     <p:sldMasterId id="2147483648" r:id="rId1"/>
   </p:sldMasterIdLst>
   <p:notesMasterIdLst>
-    <p:notesMasterId r:id="rId21"/>
+    <p:notesMasterId r:id="rId24"/>
   </p:notesMasterIdLst>
   <p:sldIdLst>
     <p:sldId id="256" r:id="rId2"/>
@@ -22,11 +22,14 @@
     <p:sldId id="306" r:id="rId13"/>
     <p:sldId id="307" r:id="rId14"/>
     <p:sldId id="308" r:id="rId15"/>
-    <p:sldId id="309" r:id="rId16"/>
+    <p:sldId id="317" r:id="rId16"/>
     <p:sldId id="311" r:id="rId17"/>
     <p:sldId id="312" r:id="rId18"/>
     <p:sldId id="313" r:id="rId19"/>
-    <p:sldId id="297" r:id="rId20"/>
+    <p:sldId id="314" r:id="rId20"/>
+    <p:sldId id="315" r:id="rId21"/>
+    <p:sldId id="309" r:id="rId22"/>
+    <p:sldId id="297" r:id="rId23"/>
   </p:sldIdLst>
   <p:sldSz cx="12192000" cy="6858000"/>
   <p:notesSz cx="6858000" cy="9144000"/>
@@ -694,6 +697,330 @@
     <p:extLst>
       <p:ext uri="{BB962C8B-B14F-4D97-AF65-F5344CB8AC3E}">
         <p14:creationId xmlns:p14="http://schemas.microsoft.com/office/powerpoint/2010/main" val="1204014661"/>
+      </p:ext>
+    </p:extLst>
+  </p:cSld>
+  <p:clrMapOvr>
+    <a:masterClrMapping/>
+  </p:clrMapOvr>
+</p:notes>
+</file>
+
+<file path=ppt/notesSlides/notesSlide11.xml><?xml version="1.0" encoding="utf-8"?>
+<p:notes xmlns:a="http://schemas.openxmlformats.org/drawingml/2006/main" xmlns:r="http://schemas.openxmlformats.org/officeDocument/2006/relationships" xmlns:p="http://schemas.openxmlformats.org/presentationml/2006/main">
+  <p:cSld>
+    <p:spTree>
+      <p:nvGrpSpPr>
+        <p:cNvPr id="1" name="">
+          <a:extLst>
+            <a:ext uri="{FF2B5EF4-FFF2-40B4-BE49-F238E27FC236}">
+              <a16:creationId xmlns:a16="http://schemas.microsoft.com/office/drawing/2014/main" id="{E56A9BC3-6A7B-0C4A-710A-B2763BE81D11}"/>
+            </a:ext>
+          </a:extLst>
+        </p:cNvPr>
+        <p:cNvGrpSpPr/>
+        <p:nvPr/>
+      </p:nvGrpSpPr>
+      <p:grpSpPr>
+        <a:xfrm>
+          <a:off x="0" y="0"/>
+          <a:ext cx="0" cy="0"/>
+          <a:chOff x="0" y="0"/>
+          <a:chExt cx="0" cy="0"/>
+        </a:xfrm>
+      </p:grpSpPr>
+      <p:sp>
+        <p:nvSpPr>
+          <p:cNvPr id="2" name="Slide Image Placeholder 1">
+            <a:extLst>
+              <a:ext uri="{FF2B5EF4-FFF2-40B4-BE49-F238E27FC236}">
+                <a16:creationId xmlns:a16="http://schemas.microsoft.com/office/drawing/2014/main" id="{AD75CD3A-A9AB-2F05-78C0-6F07C8EEDFA2}"/>
+              </a:ext>
+            </a:extLst>
+          </p:cNvPr>
+          <p:cNvSpPr>
+            <a:spLocks noGrp="1" noRot="1" noChangeAspect="1"/>
+          </p:cNvSpPr>
+          <p:nvPr>
+            <p:ph type="sldImg"/>
+          </p:nvPr>
+        </p:nvSpPr>
+        <p:spPr/>
+      </p:sp>
+      <p:sp>
+        <p:nvSpPr>
+          <p:cNvPr id="3" name="Notes Placeholder 2">
+            <a:extLst>
+              <a:ext uri="{FF2B5EF4-FFF2-40B4-BE49-F238E27FC236}">
+                <a16:creationId xmlns:a16="http://schemas.microsoft.com/office/drawing/2014/main" id="{3E9C536A-70FD-B5D0-6452-DC57CDA73149}"/>
+              </a:ext>
+            </a:extLst>
+          </p:cNvPr>
+          <p:cNvSpPr>
+            <a:spLocks noGrp="1"/>
+          </p:cNvSpPr>
+          <p:nvPr>
+            <p:ph type="body" idx="1"/>
+          </p:nvPr>
+        </p:nvSpPr>
+        <p:spPr/>
+        <p:txBody>
+          <a:bodyPr/>
+          <a:lstStyle/>
+          <a:p>
+            <a:endParaRPr lang="fr-CA" dirty="0"/>
+          </a:p>
+        </p:txBody>
+      </p:sp>
+      <p:sp>
+        <p:nvSpPr>
+          <p:cNvPr id="4" name="Slide Number Placeholder 3">
+            <a:extLst>
+              <a:ext uri="{FF2B5EF4-FFF2-40B4-BE49-F238E27FC236}">
+                <a16:creationId xmlns:a16="http://schemas.microsoft.com/office/drawing/2014/main" id="{F38425FA-5FF2-2300-7796-CB3F147C0F7B}"/>
+              </a:ext>
+            </a:extLst>
+          </p:cNvPr>
+          <p:cNvSpPr>
+            <a:spLocks noGrp="1"/>
+          </p:cNvSpPr>
+          <p:nvPr>
+            <p:ph type="sldNum" sz="quarter" idx="5"/>
+          </p:nvPr>
+        </p:nvSpPr>
+        <p:spPr/>
+        <p:txBody>
+          <a:bodyPr/>
+          <a:lstStyle/>
+          <a:p>
+            <a:fld id="{D755565A-1FEC-4FFE-8425-B731D92946D0}" type="slidenum">
+              <a:rPr lang="fr-CA" smtClean="0"/>
+              <a:t>19</a:t>
+            </a:fld>
+            <a:endParaRPr lang="fr-CA"/>
+          </a:p>
+        </p:txBody>
+      </p:sp>
+    </p:spTree>
+    <p:extLst>
+      <p:ext uri="{BB962C8B-B14F-4D97-AF65-F5344CB8AC3E}">
+        <p14:creationId xmlns:p14="http://schemas.microsoft.com/office/powerpoint/2010/main" val="4027214688"/>
+      </p:ext>
+    </p:extLst>
+  </p:cSld>
+  <p:clrMapOvr>
+    <a:masterClrMapping/>
+  </p:clrMapOvr>
+</p:notes>
+</file>
+
+<file path=ppt/notesSlides/notesSlide12.xml><?xml version="1.0" encoding="utf-8"?>
+<p:notes xmlns:a="http://schemas.openxmlformats.org/drawingml/2006/main" xmlns:r="http://schemas.openxmlformats.org/officeDocument/2006/relationships" xmlns:p="http://schemas.openxmlformats.org/presentationml/2006/main">
+  <p:cSld>
+    <p:spTree>
+      <p:nvGrpSpPr>
+        <p:cNvPr id="1" name="">
+          <a:extLst>
+            <a:ext uri="{FF2B5EF4-FFF2-40B4-BE49-F238E27FC236}">
+              <a16:creationId xmlns:a16="http://schemas.microsoft.com/office/drawing/2014/main" id="{F16C23B7-3E11-AFE0-D01E-55DFEE75A999}"/>
+            </a:ext>
+          </a:extLst>
+        </p:cNvPr>
+        <p:cNvGrpSpPr/>
+        <p:nvPr/>
+      </p:nvGrpSpPr>
+      <p:grpSpPr>
+        <a:xfrm>
+          <a:off x="0" y="0"/>
+          <a:ext cx="0" cy="0"/>
+          <a:chOff x="0" y="0"/>
+          <a:chExt cx="0" cy="0"/>
+        </a:xfrm>
+      </p:grpSpPr>
+      <p:sp>
+        <p:nvSpPr>
+          <p:cNvPr id="2" name="Slide Image Placeholder 1">
+            <a:extLst>
+              <a:ext uri="{FF2B5EF4-FFF2-40B4-BE49-F238E27FC236}">
+                <a16:creationId xmlns:a16="http://schemas.microsoft.com/office/drawing/2014/main" id="{BE081753-A90E-A99E-15D9-4D4141A829B4}"/>
+              </a:ext>
+            </a:extLst>
+          </p:cNvPr>
+          <p:cNvSpPr>
+            <a:spLocks noGrp="1" noRot="1" noChangeAspect="1"/>
+          </p:cNvSpPr>
+          <p:nvPr>
+            <p:ph type="sldImg"/>
+          </p:nvPr>
+        </p:nvSpPr>
+        <p:spPr/>
+      </p:sp>
+      <p:sp>
+        <p:nvSpPr>
+          <p:cNvPr id="3" name="Notes Placeholder 2">
+            <a:extLst>
+              <a:ext uri="{FF2B5EF4-FFF2-40B4-BE49-F238E27FC236}">
+                <a16:creationId xmlns:a16="http://schemas.microsoft.com/office/drawing/2014/main" id="{736839BE-8798-7938-1440-40ED0144FC4F}"/>
+              </a:ext>
+            </a:extLst>
+          </p:cNvPr>
+          <p:cNvSpPr>
+            <a:spLocks noGrp="1"/>
+          </p:cNvSpPr>
+          <p:nvPr>
+            <p:ph type="body" idx="1"/>
+          </p:nvPr>
+        </p:nvSpPr>
+        <p:spPr/>
+        <p:txBody>
+          <a:bodyPr/>
+          <a:lstStyle/>
+          <a:p>
+            <a:endParaRPr lang="fr-CA" dirty="0"/>
+          </a:p>
+        </p:txBody>
+      </p:sp>
+      <p:sp>
+        <p:nvSpPr>
+          <p:cNvPr id="4" name="Slide Number Placeholder 3">
+            <a:extLst>
+              <a:ext uri="{FF2B5EF4-FFF2-40B4-BE49-F238E27FC236}">
+                <a16:creationId xmlns:a16="http://schemas.microsoft.com/office/drawing/2014/main" id="{4110DF33-330B-C07A-CBEC-0961FBA1A07A}"/>
+              </a:ext>
+            </a:extLst>
+          </p:cNvPr>
+          <p:cNvSpPr>
+            <a:spLocks noGrp="1"/>
+          </p:cNvSpPr>
+          <p:nvPr>
+            <p:ph type="sldNum" sz="quarter" idx="5"/>
+          </p:nvPr>
+        </p:nvSpPr>
+        <p:spPr/>
+        <p:txBody>
+          <a:bodyPr/>
+          <a:lstStyle/>
+          <a:p>
+            <a:fld id="{D755565A-1FEC-4FFE-8425-B731D92946D0}" type="slidenum">
+              <a:rPr lang="fr-CA" smtClean="0"/>
+              <a:t>20</a:t>
+            </a:fld>
+            <a:endParaRPr lang="fr-CA"/>
+          </a:p>
+        </p:txBody>
+      </p:sp>
+    </p:spTree>
+    <p:extLst>
+      <p:ext uri="{BB962C8B-B14F-4D97-AF65-F5344CB8AC3E}">
+        <p14:creationId xmlns:p14="http://schemas.microsoft.com/office/powerpoint/2010/main" val="1001525891"/>
+      </p:ext>
+    </p:extLst>
+  </p:cSld>
+  <p:clrMapOvr>
+    <a:masterClrMapping/>
+  </p:clrMapOvr>
+</p:notes>
+</file>
+
+<file path=ppt/notesSlides/notesSlide13.xml><?xml version="1.0" encoding="utf-8"?>
+<p:notes xmlns:a="http://schemas.openxmlformats.org/drawingml/2006/main" xmlns:r="http://schemas.openxmlformats.org/officeDocument/2006/relationships" xmlns:p="http://schemas.openxmlformats.org/presentationml/2006/main">
+  <p:cSld>
+    <p:spTree>
+      <p:nvGrpSpPr>
+        <p:cNvPr id="1" name="">
+          <a:extLst>
+            <a:ext uri="{FF2B5EF4-FFF2-40B4-BE49-F238E27FC236}">
+              <a16:creationId xmlns:a16="http://schemas.microsoft.com/office/drawing/2014/main" id="{E743B822-925C-566B-0957-2C896F3D4F51}"/>
+            </a:ext>
+          </a:extLst>
+        </p:cNvPr>
+        <p:cNvGrpSpPr/>
+        <p:nvPr/>
+      </p:nvGrpSpPr>
+      <p:grpSpPr>
+        <a:xfrm>
+          <a:off x="0" y="0"/>
+          <a:ext cx="0" cy="0"/>
+          <a:chOff x="0" y="0"/>
+          <a:chExt cx="0" cy="0"/>
+        </a:xfrm>
+      </p:grpSpPr>
+      <p:sp>
+        <p:nvSpPr>
+          <p:cNvPr id="2" name="Slide Image Placeholder 1">
+            <a:extLst>
+              <a:ext uri="{FF2B5EF4-FFF2-40B4-BE49-F238E27FC236}">
+                <a16:creationId xmlns:a16="http://schemas.microsoft.com/office/drawing/2014/main" id="{43C3F3D0-483A-9F6F-63B3-5E0BECDE09AA}"/>
+              </a:ext>
+            </a:extLst>
+          </p:cNvPr>
+          <p:cNvSpPr>
+            <a:spLocks noGrp="1" noRot="1" noChangeAspect="1"/>
+          </p:cNvSpPr>
+          <p:nvPr>
+            <p:ph type="sldImg"/>
+          </p:nvPr>
+        </p:nvSpPr>
+        <p:spPr/>
+      </p:sp>
+      <p:sp>
+        <p:nvSpPr>
+          <p:cNvPr id="3" name="Notes Placeholder 2">
+            <a:extLst>
+              <a:ext uri="{FF2B5EF4-FFF2-40B4-BE49-F238E27FC236}">
+                <a16:creationId xmlns:a16="http://schemas.microsoft.com/office/drawing/2014/main" id="{B6519F0A-F632-39D8-6EAE-7A38DB481D0F}"/>
+              </a:ext>
+            </a:extLst>
+          </p:cNvPr>
+          <p:cNvSpPr>
+            <a:spLocks noGrp="1"/>
+          </p:cNvSpPr>
+          <p:nvPr>
+            <p:ph type="body" idx="1"/>
+          </p:nvPr>
+        </p:nvSpPr>
+        <p:spPr/>
+        <p:txBody>
+          <a:bodyPr/>
+          <a:lstStyle/>
+          <a:p>
+            <a:endParaRPr lang="fr-CA" dirty="0"/>
+          </a:p>
+        </p:txBody>
+      </p:sp>
+      <p:sp>
+        <p:nvSpPr>
+          <p:cNvPr id="4" name="Slide Number Placeholder 3">
+            <a:extLst>
+              <a:ext uri="{FF2B5EF4-FFF2-40B4-BE49-F238E27FC236}">
+                <a16:creationId xmlns:a16="http://schemas.microsoft.com/office/drawing/2014/main" id="{C4AF9893-46BB-9232-3E05-47C984B70904}"/>
+              </a:ext>
+            </a:extLst>
+          </p:cNvPr>
+          <p:cNvSpPr>
+            <a:spLocks noGrp="1"/>
+          </p:cNvSpPr>
+          <p:nvPr>
+            <p:ph type="sldNum" sz="quarter" idx="5"/>
+          </p:nvPr>
+        </p:nvSpPr>
+        <p:spPr/>
+        <p:txBody>
+          <a:bodyPr/>
+          <a:lstStyle/>
+          <a:p>
+            <a:fld id="{D755565A-1FEC-4FFE-8425-B731D92946D0}" type="slidenum">
+              <a:rPr lang="fr-CA" smtClean="0"/>
+              <a:t>21</a:t>
+            </a:fld>
+            <a:endParaRPr lang="fr-CA"/>
+          </a:p>
+        </p:txBody>
+      </p:sp>
+    </p:spTree>
+    <p:extLst>
+      <p:ext uri="{BB962C8B-B14F-4D97-AF65-F5344CB8AC3E}">
+        <p14:creationId xmlns:p14="http://schemas.microsoft.com/office/powerpoint/2010/main" val="567433994"/>
       </p:ext>
     </p:extLst>
   </p:cSld>
@@ -10194,37 +10521,61 @@
           <a:p>
             <a:pPr algn="l"/>
             <a:r>
+              <a:rPr lang="en-US" sz="1800" b="0" dirty="0"/>
+              <a:t>  </a:t>
+            </a:r>
+            <a:r>
               <a:rPr lang="en-US" sz="1800" dirty="0"/>
-              <a:t>  with open(</a:t>
-            </a:r>
-            <a:r>
-              <a:rPr lang="en-US" sz="1800" dirty="0" err="1"/>
+              <a:t>with</a:t>
+            </a:r>
+            <a:r>
+              <a:rPr lang="en-US" sz="1800" b="0" dirty="0"/>
+              <a:t> </a:t>
+            </a:r>
+            <a:r>
+              <a:rPr lang="en-US" sz="1800" dirty="0"/>
+              <a:t>open</a:t>
+            </a:r>
+            <a:r>
+              <a:rPr lang="en-US" sz="1800" b="0" dirty="0"/>
+              <a:t>(</a:t>
+            </a:r>
+            <a:r>
+              <a:rPr lang="en-US" sz="1800" b="0" dirty="0" err="1"/>
               <a:t>nom_fichier</a:t>
             </a:r>
             <a:r>
-              <a:rPr lang="en-US" sz="1800" dirty="0"/>
+              <a:rPr lang="en-US" sz="1800" b="0" dirty="0"/>
               <a:t> </a:t>
             </a:r>
             <a:r>
+              <a:rPr lang="en-CA" sz="1800" b="0" dirty="0"/>
+              <a:t>[, mode='r']) </a:t>
+            </a:r>
+            <a:r>
               <a:rPr lang="en-CA" sz="1800" dirty="0"/>
-              <a:t>[, mode='r']) as </a:t>
-            </a:r>
-            <a:r>
-              <a:rPr lang="en-CA" sz="1800" dirty="0" err="1"/>
+              <a:t>as</a:t>
+            </a:r>
+            <a:r>
+              <a:rPr lang="en-CA" sz="1800" b="0" dirty="0"/>
+              <a:t> </a:t>
+            </a:r>
+            <a:r>
+              <a:rPr lang="en-CA" sz="1800" b="0" dirty="0" err="1"/>
               <a:t>fichier</a:t>
             </a:r>
             <a:r>
-              <a:rPr lang="en-CA" sz="1800" dirty="0"/>
+              <a:rPr lang="en-CA" sz="1800" b="0" dirty="0"/>
               <a:t>:</a:t>
             </a:r>
           </a:p>
           <a:p>
             <a:pPr algn="l"/>
             <a:r>
-              <a:rPr lang="en-CA" sz="1800" dirty="0"/>
+              <a:rPr lang="en-CA" sz="1800" b="0" dirty="0"/>
               <a:t>    ...</a:t>
             </a:r>
-            <a:endParaRPr lang="en-US" sz="1800" dirty="0"/>
+            <a:endParaRPr lang="en-US" sz="1800" b="0" dirty="0"/>
           </a:p>
         </p:txBody>
       </p:sp>
@@ -11845,7 +12196,9 @@
     <p:bg>
       <p:bgPr>
         <a:solidFill>
-          <a:srgbClr val="F5F5F5"/>
+          <a:schemeClr val="bg1">
+            <a:lumMod val="95000"/>
+          </a:schemeClr>
         </a:solidFill>
         <a:effectLst/>
       </p:bgPr>
@@ -13064,7 +13417,7 @@
     </p:spTree>
     <p:extLst>
       <p:ext uri="{BB962C8B-B14F-4D97-AF65-F5344CB8AC3E}">
-        <p14:creationId xmlns:p14="http://schemas.microsoft.com/office/powerpoint/2010/main" val="4472728"/>
+        <p14:creationId xmlns:p14="http://schemas.microsoft.com/office/powerpoint/2010/main" val="428461038"/>
       </p:ext>
     </p:extLst>
   </p:cSld>
@@ -14389,9 +14742,9 @@
         <p:grpSpPr>
           <a:xfrm>
             <a:off x="8610600" y="2967335"/>
-            <a:ext cx="3147499" cy="923330"/>
+            <a:ext cx="2882899" cy="923330"/>
             <a:chOff x="6485106" y="3637379"/>
-            <a:chExt cx="3147499" cy="923330"/>
+            <a:chExt cx="2882899" cy="923330"/>
           </a:xfrm>
         </p:grpSpPr>
         <p:sp>
@@ -14408,7 +14761,7 @@
           </p:nvSpPr>
           <p:spPr>
             <a:xfrm>
-              <a:off x="7295106" y="3637379"/>
+              <a:off x="7030506" y="3637379"/>
               <a:ext cx="2337499" cy="923330"/>
             </a:xfrm>
             <a:prstGeom prst="rect">
@@ -14426,7 +14779,7 @@
                 <a:rPr lang="en-US" dirty="0">
                   <a:latin typeface="Consolas" panose="020B0609020204030204" pitchFamily="49" charset="0"/>
                 </a:rPr>
-                <a:t>Le </a:t>
+                <a:t>Un </a:t>
               </a:r>
               <a:r>
                 <a:rPr lang="en-US" dirty="0" err="1">
@@ -14509,7 +14862,7 @@
           <p:spPr>
             <a:xfrm flipH="1">
               <a:off x="6485106" y="4099044"/>
-              <a:ext cx="810000" cy="0"/>
+              <a:ext cx="545400" cy="0"/>
             </a:xfrm>
             <a:prstGeom prst="straightConnector1">
               <a:avLst/>
@@ -14636,7 +14989,7 @@
     <p:bg>
       <p:bgPr>
         <a:solidFill>
-          <a:srgbClr val="FFFF00"/>
+          <a:srgbClr val="F5F5F5"/>
         </a:solidFill>
         <a:effectLst/>
       </p:bgPr>
@@ -14646,7 +14999,7 @@
         <p:cNvPr id="1" name="">
           <a:extLst>
             <a:ext uri="{FF2B5EF4-FFF2-40B4-BE49-F238E27FC236}">
-              <a16:creationId xmlns:a16="http://schemas.microsoft.com/office/drawing/2014/main" id="{A79EE80B-5617-3AC9-1D3D-FF9406939B6B}"/>
+              <a16:creationId xmlns:a16="http://schemas.microsoft.com/office/drawing/2014/main" id="{E1818D54-B850-2B08-EF83-0642E57872E5}"/>
             </a:ext>
           </a:extLst>
         </p:cNvPr>
@@ -14663,106 +15016,873 @@
       </p:grpSpPr>
       <p:sp>
         <p:nvSpPr>
-          <p:cNvPr id="15" name="Rectangle 14">
+          <p:cNvPr id="2" name="Title 1">
             <a:extLst>
               <a:ext uri="{FF2B5EF4-FFF2-40B4-BE49-F238E27FC236}">
-                <a16:creationId xmlns:a16="http://schemas.microsoft.com/office/drawing/2014/main" id="{AED2F8D1-AEB0-E659-5BE9-F91783BAB484}"/>
+                <a16:creationId xmlns:a16="http://schemas.microsoft.com/office/drawing/2014/main" id="{5B9237F8-B3FD-2D73-B1F8-B777BF3CB58C}"/>
               </a:ext>
             </a:extLst>
           </p:cNvPr>
-          <p:cNvSpPr/>
+          <p:cNvSpPr>
+            <a:spLocks noGrp="1"/>
+          </p:cNvSpPr>
+          <p:nvPr>
+            <p:ph type="title"/>
+          </p:nvPr>
+        </p:nvSpPr>
+        <p:spPr/>
+        <p:txBody>
+          <a:bodyPr/>
+          <a:lstStyle/>
+          <a:p>
+            <a:r>
+              <a:rPr lang="fr-CA" dirty="0">
+                <a:latin typeface="Arial Rounded MT Bold" panose="020F0704030504030204" pitchFamily="34" charset="0"/>
+              </a:rPr>
+              <a:t>Graphique point-ligne</a:t>
+            </a:r>
+          </a:p>
+        </p:txBody>
+      </p:sp>
+      <p:sp>
+        <p:nvSpPr>
+          <p:cNvPr id="3" name="Content Placeholder 2">
+            <a:extLst>
+              <a:ext uri="{FF2B5EF4-FFF2-40B4-BE49-F238E27FC236}">
+                <a16:creationId xmlns:a16="http://schemas.microsoft.com/office/drawing/2014/main" id="{8443651F-5C09-E884-282C-2593EC19E811}"/>
+              </a:ext>
+            </a:extLst>
+          </p:cNvPr>
+          <p:cNvSpPr>
+            <a:spLocks noGrp="1"/>
+          </p:cNvSpPr>
+          <p:nvPr>
+            <p:ph idx="1"/>
+          </p:nvPr>
+        </p:nvSpPr>
+        <p:spPr>
+          <a:xfrm>
+            <a:off x="838200" y="1818566"/>
+            <a:ext cx="10515600" cy="4351338"/>
+          </a:xfrm>
+        </p:spPr>
+        <p:txBody>
+          <a:bodyPr>
+            <a:normAutofit/>
+          </a:bodyPr>
+          <a:lstStyle/>
+          <a:p>
+            <a:pPr algn="just">
+              <a:lnSpc>
+                <a:spcPct val="110000"/>
+              </a:lnSpc>
+            </a:pPr>
+            <a:r>
+              <a:rPr lang="fr-CA" sz="1600" dirty="0">
+                <a:latin typeface="Consolas" panose="020B0609020204030204" pitchFamily="49" charset="0"/>
+              </a:rPr>
+              <a:t>Importer l'interface </a:t>
+            </a:r>
+            <a:r>
+              <a:rPr lang="fr-CA" sz="1600" b="1" dirty="0" err="1">
+                <a:latin typeface="Consolas" panose="020B0609020204030204" pitchFamily="49" charset="0"/>
+              </a:rPr>
+              <a:t>pyplot</a:t>
+            </a:r>
+            <a:r>
+              <a:rPr lang="fr-CA" sz="1600" dirty="0">
+                <a:latin typeface="Consolas" panose="020B0609020204030204" pitchFamily="49" charset="0"/>
+              </a:rPr>
+              <a:t> de </a:t>
+            </a:r>
+            <a:r>
+              <a:rPr lang="fr-CA" sz="1600" b="1" dirty="0" err="1">
+                <a:latin typeface="Consolas" panose="020B0609020204030204" pitchFamily="49" charset="0"/>
+              </a:rPr>
+              <a:t>matploblib</a:t>
+            </a:r>
+            <a:r>
+              <a:rPr lang="fr-CA" sz="1600" b="1" dirty="0">
+                <a:latin typeface="Consolas" panose="020B0609020204030204" pitchFamily="49" charset="0"/>
+              </a:rPr>
+              <a:t> </a:t>
+            </a:r>
+            <a:r>
+              <a:rPr lang="fr-CA" sz="1600" dirty="0">
+                <a:latin typeface="Consolas" panose="020B0609020204030204" pitchFamily="49" charset="0"/>
+              </a:rPr>
+              <a:t>(inspirée de MATLAB)</a:t>
+            </a:r>
+          </a:p>
+          <a:p>
+            <a:pPr algn="just">
+              <a:lnSpc>
+                <a:spcPct val="110000"/>
+              </a:lnSpc>
+            </a:pPr>
+            <a:endParaRPr lang="fr-CA" sz="1600" b="1" dirty="0">
+              <a:latin typeface="Consolas" panose="020B0609020204030204" pitchFamily="49" charset="0"/>
+            </a:endParaRPr>
+          </a:p>
+          <a:p>
+            <a:pPr algn="just">
+              <a:lnSpc>
+                <a:spcPct val="110000"/>
+              </a:lnSpc>
+            </a:pPr>
+            <a:endParaRPr lang="fr-CA" sz="1600" b="1" dirty="0">
+              <a:latin typeface="Consolas" panose="020B0609020204030204" pitchFamily="49" charset="0"/>
+            </a:endParaRPr>
+          </a:p>
+          <a:p>
+            <a:pPr algn="just">
+              <a:lnSpc>
+                <a:spcPct val="110000"/>
+              </a:lnSpc>
+            </a:pPr>
+            <a:r>
+              <a:rPr lang="fr-CA" sz="1600" dirty="0">
+                <a:latin typeface="Consolas" panose="020B0609020204030204" pitchFamily="49" charset="0"/>
+              </a:rPr>
+              <a:t>Tracer un graphique</a:t>
+            </a:r>
+          </a:p>
+          <a:p>
+            <a:pPr algn="just">
+              <a:lnSpc>
+                <a:spcPct val="110000"/>
+              </a:lnSpc>
+            </a:pPr>
+            <a:endParaRPr lang="fr-CA" sz="1600" b="1" dirty="0">
+              <a:latin typeface="Consolas" panose="020B0609020204030204" pitchFamily="49" charset="0"/>
+            </a:endParaRPr>
+          </a:p>
+          <a:p>
+            <a:pPr algn="just">
+              <a:lnSpc>
+                <a:spcPct val="110000"/>
+              </a:lnSpc>
+            </a:pPr>
+            <a:endParaRPr lang="fr-CA" sz="1600" b="1" dirty="0">
+              <a:latin typeface="Consolas" panose="020B0609020204030204" pitchFamily="49" charset="0"/>
+            </a:endParaRPr>
+          </a:p>
+          <a:p>
+            <a:pPr algn="just">
+              <a:lnSpc>
+                <a:spcPct val="110000"/>
+              </a:lnSpc>
+            </a:pPr>
+            <a:r>
+              <a:rPr lang="fr-CA" sz="1600" dirty="0">
+                <a:latin typeface="Consolas" panose="020B0609020204030204" pitchFamily="49" charset="0"/>
+              </a:rPr>
+              <a:t>Afficher le graphique en mode non-interactif</a:t>
+            </a:r>
+          </a:p>
+        </p:txBody>
+      </p:sp>
+      <p:sp>
+        <p:nvSpPr>
+          <p:cNvPr id="5" name="Slide Number Placeholder 4">
+            <a:extLst>
+              <a:ext uri="{FF2B5EF4-FFF2-40B4-BE49-F238E27FC236}">
+                <a16:creationId xmlns:a16="http://schemas.microsoft.com/office/drawing/2014/main" id="{41F3DE03-26F2-0534-91A6-9EA304DF0B80}"/>
+              </a:ext>
+            </a:extLst>
+          </p:cNvPr>
+          <p:cNvSpPr>
+            <a:spLocks noGrp="1"/>
+          </p:cNvSpPr>
+          <p:nvPr>
+            <p:ph type="sldNum" sz="quarter" idx="12"/>
+          </p:nvPr>
+        </p:nvSpPr>
+        <p:spPr/>
+        <p:txBody>
+          <a:bodyPr/>
+          <a:lstStyle/>
+          <a:p>
+            <a:fld id="{846B06B1-1179-491F-A487-8E0C403F7C13}" type="slidenum">
+              <a:rPr lang="fr-CA" smtClean="0"/>
+              <a:t>19</a:t>
+            </a:fld>
+            <a:endParaRPr lang="fr-CA" dirty="0"/>
+          </a:p>
+        </p:txBody>
+      </p:sp>
+      <p:sp>
+        <p:nvSpPr>
+          <p:cNvPr id="7" name="TextBox 6">
+            <a:extLst>
+              <a:ext uri="{FF2B5EF4-FFF2-40B4-BE49-F238E27FC236}">
+                <a16:creationId xmlns:a16="http://schemas.microsoft.com/office/drawing/2014/main" id="{9B3825A8-77E9-B87E-CCE8-4906B1D5318E}"/>
+              </a:ext>
+            </a:extLst>
+          </p:cNvPr>
+          <p:cNvSpPr txBox="1"/>
           <p:nvPr/>
         </p:nvSpPr>
         <p:spPr>
           <a:xfrm>
-            <a:off x="5732834" y="3357820"/>
-            <a:ext cx="726332" cy="142360"/>
+            <a:off x="2230874" y="3587358"/>
+            <a:ext cx="7730249" cy="408578"/>
           </a:xfrm>
-          <a:prstGeom prst="rect">
+          <a:prstGeom prst="roundRect">
             <a:avLst/>
           </a:prstGeom>
+          <a:solidFill>
+            <a:srgbClr val="FFF2CC">
+              <a:alpha val="49803"/>
+            </a:srgbClr>
+          </a:solidFill>
+          <a:ln w="9525" cap="flat" cmpd="sng">
+            <a:solidFill>
+              <a:schemeClr val="dk1"/>
+            </a:solidFill>
+            <a:prstDash val="solid"/>
+            <a:round/>
+            <a:headEnd type="none" w="sm" len="sm"/>
+            <a:tailEnd type="none" w="sm" len="sm"/>
+          </a:ln>
         </p:spPr>
-        <p:style>
-          <a:lnRef idx="2">
-            <a:schemeClr val="accent1">
-              <a:shade val="15000"/>
-            </a:schemeClr>
-          </a:lnRef>
-          <a:fillRef idx="1">
-            <a:schemeClr val="accent1"/>
-          </a:fillRef>
-          <a:effectRef idx="0">
-            <a:schemeClr val="accent1"/>
-          </a:effectRef>
-          <a:fontRef idx="minor">
-            <a:schemeClr val="lt1"/>
-          </a:fontRef>
-        </p:style>
         <p:txBody>
-          <a:bodyPr rtlCol="0" anchor="ctr"/>
-          <a:lstStyle/>
-          <a:p>
-            <a:pPr algn="ctr"/>
-            <a:endParaRPr lang="fr-CA"/>
+          <a:bodyPr spcFirstLastPara="1" wrap="square" lIns="91425" tIns="45700" rIns="91425" bIns="45700" anchor="t" anchorCtr="0">
+            <a:spAutoFit/>
+          </a:bodyPr>
+          <a:lstStyle>
+            <a:defPPr>
+              <a:defRPr lang="en-US"/>
+            </a:defPPr>
+            <a:lvl1pPr marR="0" lvl="0" indent="0" algn="ctr">
+              <a:lnSpc>
+                <a:spcPct val="100000"/>
+              </a:lnSpc>
+              <a:spcBef>
+                <a:spcPts val="0"/>
+              </a:spcBef>
+              <a:spcAft>
+                <a:spcPts val="0"/>
+              </a:spcAft>
+              <a:buClr>
+                <a:srgbClr val="000000"/>
+              </a:buClr>
+              <a:buSzPts val="1400"/>
+              <a:buFont typeface="Consolas"/>
+              <a:buNone/>
+              <a:defRPr sz="2800" b="1" i="0" u="none" strike="noStrike" cap="none">
+                <a:solidFill>
+                  <a:srgbClr val="000000"/>
+                </a:solidFill>
+                <a:latin typeface="Consolas"/>
+                <a:ea typeface="Consolas"/>
+                <a:cs typeface="Consolas"/>
+              </a:defRPr>
+            </a:lvl1pPr>
+          </a:lstStyle>
+          <a:p>
+            <a:pPr lvl="0">
+              <a:buClrTx/>
+              <a:buSzTx/>
+              <a:defRPr/>
+            </a:pPr>
+            <a:r>
+              <a:rPr lang="fr-CA" sz="1800" b="0" dirty="0">
+                <a:latin typeface="Consolas" panose="020B0609020204030204" pitchFamily="49" charset="0"/>
+              </a:rPr>
+              <a:t>[figure =] </a:t>
+            </a:r>
+            <a:r>
+              <a:rPr lang="fr-CA" sz="1800" dirty="0" err="1">
+                <a:latin typeface="Consolas" panose="020B0609020204030204" pitchFamily="49" charset="0"/>
+              </a:rPr>
+              <a:t>plt.plot</a:t>
+            </a:r>
+            <a:r>
+              <a:rPr lang="fr-CA" sz="1800" b="0" dirty="0">
+                <a:latin typeface="Consolas" panose="020B0609020204030204" pitchFamily="49" charset="0"/>
+              </a:rPr>
+              <a:t>(</a:t>
+            </a:r>
+            <a:r>
+              <a:rPr lang="fr-CA" sz="1800" b="0" i="1" dirty="0">
+                <a:latin typeface="Consolas" panose="020B0609020204030204" pitchFamily="49" charset="0"/>
+              </a:rPr>
+              <a:t>x</a:t>
+            </a:r>
+            <a:r>
+              <a:rPr lang="fr-CA" sz="1800" b="0" dirty="0">
+                <a:latin typeface="Consolas" panose="020B0609020204030204" pitchFamily="49" charset="0"/>
+              </a:rPr>
+              <a:t>, </a:t>
+            </a:r>
+            <a:r>
+              <a:rPr lang="fr-CA" sz="1800" b="0" i="1" dirty="0">
+                <a:latin typeface="Consolas" panose="020B0609020204030204" pitchFamily="49" charset="0"/>
+              </a:rPr>
+              <a:t>y</a:t>
+            </a:r>
+            <a:r>
+              <a:rPr lang="fr-CA" sz="1800" b="0" dirty="0">
+                <a:latin typeface="Consolas" panose="020B0609020204030204" pitchFamily="49" charset="0"/>
+              </a:rPr>
+              <a:t>, [</a:t>
+            </a:r>
+            <a:r>
+              <a:rPr lang="fr-CA" sz="1800" b="0" i="1" dirty="0">
+                <a:latin typeface="Consolas" panose="020B0609020204030204" pitchFamily="49" charset="0"/>
+              </a:rPr>
+              <a:t>format</a:t>
+            </a:r>
+            <a:r>
+              <a:rPr lang="fr-CA" sz="1800" b="0" dirty="0">
+                <a:latin typeface="Consolas" panose="020B0609020204030204" pitchFamily="49" charset="0"/>
+              </a:rPr>
+              <a:t>])</a:t>
+            </a:r>
           </a:p>
         </p:txBody>
       </p:sp>
       <p:sp>
         <p:nvSpPr>
-          <p:cNvPr id="2" name="Rectangle 1">
+          <p:cNvPr id="8" name="TextBox 7">
             <a:extLst>
               <a:ext uri="{FF2B5EF4-FFF2-40B4-BE49-F238E27FC236}">
-                <a16:creationId xmlns:a16="http://schemas.microsoft.com/office/drawing/2014/main" id="{DF179609-0D20-7919-F3E7-E44EC67D7DAF}"/>
+                <a16:creationId xmlns:a16="http://schemas.microsoft.com/office/drawing/2014/main" id="{5EF8B224-0CEC-D3FB-624E-C39CFC428A6F}"/>
               </a:ext>
             </a:extLst>
           </p:cNvPr>
-          <p:cNvSpPr/>
+          <p:cNvSpPr txBox="1"/>
           <p:nvPr/>
         </p:nvSpPr>
         <p:spPr>
           <a:xfrm>
-            <a:off x="5732834" y="3665863"/>
-            <a:ext cx="726332" cy="360000"/>
+            <a:off x="2230875" y="2427023"/>
+            <a:ext cx="7730249" cy="408578"/>
           </a:xfrm>
-          <a:prstGeom prst="rect">
+          <a:prstGeom prst="roundRect">
             <a:avLst/>
           </a:prstGeom>
+          <a:solidFill>
+            <a:srgbClr val="FFF2CC">
+              <a:alpha val="49803"/>
+            </a:srgbClr>
+          </a:solidFill>
+          <a:ln w="9525" cap="flat" cmpd="sng">
+            <a:solidFill>
+              <a:schemeClr val="dk1"/>
+            </a:solidFill>
+            <a:prstDash val="solid"/>
+            <a:round/>
+            <a:headEnd type="none" w="sm" len="sm"/>
+            <a:tailEnd type="none" w="sm" len="sm"/>
+          </a:ln>
         </p:spPr>
-        <p:style>
-          <a:lnRef idx="2">
-            <a:schemeClr val="accent1">
-              <a:shade val="15000"/>
-            </a:schemeClr>
-          </a:lnRef>
-          <a:fillRef idx="1">
-            <a:schemeClr val="accent1"/>
-          </a:fillRef>
-          <a:effectRef idx="0">
-            <a:schemeClr val="accent1"/>
-          </a:effectRef>
-          <a:fontRef idx="minor">
-            <a:schemeClr val="lt1"/>
-          </a:fontRef>
-        </p:style>
         <p:txBody>
-          <a:bodyPr rtlCol="0" anchor="ctr"/>
-          <a:lstStyle/>
-          <a:p>
-            <a:pPr algn="ctr"/>
-            <a:endParaRPr lang="fr-CA"/>
+          <a:bodyPr spcFirstLastPara="1" wrap="square" lIns="91425" tIns="45700" rIns="91425" bIns="45700" anchor="t" anchorCtr="0">
+            <a:spAutoFit/>
+          </a:bodyPr>
+          <a:lstStyle>
+            <a:defPPr>
+              <a:defRPr lang="en-US"/>
+            </a:defPPr>
+            <a:lvl1pPr marR="0" lvl="0" indent="0" algn="ctr">
+              <a:lnSpc>
+                <a:spcPct val="100000"/>
+              </a:lnSpc>
+              <a:spcBef>
+                <a:spcPts val="0"/>
+              </a:spcBef>
+              <a:spcAft>
+                <a:spcPts val="0"/>
+              </a:spcAft>
+              <a:buClr>
+                <a:srgbClr val="000000"/>
+              </a:buClr>
+              <a:buSzPts val="1400"/>
+              <a:buFont typeface="Consolas"/>
+              <a:buNone/>
+              <a:defRPr sz="2800" b="1" i="0" u="none" strike="noStrike" cap="none">
+                <a:solidFill>
+                  <a:srgbClr val="000000"/>
+                </a:solidFill>
+                <a:latin typeface="Consolas"/>
+                <a:ea typeface="Consolas"/>
+                <a:cs typeface="Consolas"/>
+              </a:defRPr>
+            </a:lvl1pPr>
+          </a:lstStyle>
+          <a:p>
+            <a:pPr lvl="0">
+              <a:buClrTx/>
+              <a:buSzTx/>
+              <a:defRPr/>
+            </a:pPr>
+            <a:r>
+              <a:rPr lang="fr-CA" sz="1800" dirty="0">
+                <a:latin typeface="Consolas" panose="020B0609020204030204" pitchFamily="49" charset="0"/>
+              </a:rPr>
+              <a:t>import </a:t>
+            </a:r>
+            <a:r>
+              <a:rPr lang="fr-CA" sz="1800" dirty="0" err="1">
+                <a:latin typeface="Consolas" panose="020B0609020204030204" pitchFamily="49" charset="0"/>
+              </a:rPr>
+              <a:t>matploblib.pyplot</a:t>
+            </a:r>
+            <a:r>
+              <a:rPr lang="fr-CA" sz="1800" dirty="0">
+                <a:latin typeface="Consolas" panose="020B0609020204030204" pitchFamily="49" charset="0"/>
+              </a:rPr>
+              <a:t> as </a:t>
+            </a:r>
+            <a:r>
+              <a:rPr lang="fr-CA" sz="1800" dirty="0" err="1">
+                <a:latin typeface="Consolas" panose="020B0609020204030204" pitchFamily="49" charset="0"/>
+              </a:rPr>
+              <a:t>plt</a:t>
+            </a:r>
+            <a:endParaRPr lang="fr-CA" sz="1800" b="0" dirty="0">
+              <a:latin typeface="Consolas" panose="020B0609020204030204" pitchFamily="49" charset="0"/>
+            </a:endParaRPr>
+          </a:p>
+        </p:txBody>
+      </p:sp>
+      <p:sp>
+        <p:nvSpPr>
+          <p:cNvPr id="9" name="TextBox 8">
+            <a:extLst>
+              <a:ext uri="{FF2B5EF4-FFF2-40B4-BE49-F238E27FC236}">
+                <a16:creationId xmlns:a16="http://schemas.microsoft.com/office/drawing/2014/main" id="{017A8126-F090-5C31-651B-61F48E46B957}"/>
+              </a:ext>
+            </a:extLst>
+          </p:cNvPr>
+          <p:cNvSpPr txBox="1"/>
+          <p:nvPr/>
+        </p:nvSpPr>
+        <p:spPr>
+          <a:xfrm>
+            <a:off x="2230873" y="4747693"/>
+            <a:ext cx="7730249" cy="408578"/>
+          </a:xfrm>
+          <a:prstGeom prst="roundRect">
+            <a:avLst/>
+          </a:prstGeom>
+          <a:solidFill>
+            <a:srgbClr val="FFF2CC">
+              <a:alpha val="49803"/>
+            </a:srgbClr>
+          </a:solidFill>
+          <a:ln w="9525" cap="flat" cmpd="sng">
+            <a:solidFill>
+              <a:schemeClr val="dk1"/>
+            </a:solidFill>
+            <a:prstDash val="solid"/>
+            <a:round/>
+            <a:headEnd type="none" w="sm" len="sm"/>
+            <a:tailEnd type="none" w="sm" len="sm"/>
+          </a:ln>
+        </p:spPr>
+        <p:txBody>
+          <a:bodyPr spcFirstLastPara="1" wrap="square" lIns="91425" tIns="45700" rIns="91425" bIns="45700" anchor="t" anchorCtr="0">
+            <a:spAutoFit/>
+          </a:bodyPr>
+          <a:lstStyle>
+            <a:defPPr>
+              <a:defRPr lang="en-US"/>
+            </a:defPPr>
+            <a:lvl1pPr marR="0" lvl="0" indent="0" algn="ctr">
+              <a:lnSpc>
+                <a:spcPct val="100000"/>
+              </a:lnSpc>
+              <a:spcBef>
+                <a:spcPts val="0"/>
+              </a:spcBef>
+              <a:spcAft>
+                <a:spcPts val="0"/>
+              </a:spcAft>
+              <a:buClr>
+                <a:srgbClr val="000000"/>
+              </a:buClr>
+              <a:buSzPts val="1400"/>
+              <a:buFont typeface="Consolas"/>
+              <a:buNone/>
+              <a:defRPr sz="2800" b="1" i="0" u="none" strike="noStrike" cap="none">
+                <a:solidFill>
+                  <a:srgbClr val="000000"/>
+                </a:solidFill>
+                <a:latin typeface="Consolas"/>
+                <a:ea typeface="Consolas"/>
+                <a:cs typeface="Consolas"/>
+              </a:defRPr>
+            </a:lvl1pPr>
+          </a:lstStyle>
+          <a:p>
+            <a:pPr lvl="0">
+              <a:buClrTx/>
+              <a:buSzTx/>
+              <a:defRPr/>
+            </a:pPr>
+            <a:r>
+              <a:rPr lang="fr-CA" sz="1800" dirty="0" err="1">
+                <a:latin typeface="Consolas" panose="020B0609020204030204" pitchFamily="49" charset="0"/>
+              </a:rPr>
+              <a:t>plt.show</a:t>
+            </a:r>
+            <a:r>
+              <a:rPr lang="fr-CA" sz="1800" b="0" dirty="0">
+                <a:latin typeface="Consolas" panose="020B0609020204030204" pitchFamily="49" charset="0"/>
+              </a:rPr>
+              <a:t>([</a:t>
+            </a:r>
+            <a:r>
+              <a:rPr lang="fr-CA" sz="1800" b="0" i="1" dirty="0">
+                <a:latin typeface="Consolas" panose="020B0609020204030204" pitchFamily="49" charset="0"/>
+              </a:rPr>
+              <a:t>figure</a:t>
+            </a:r>
+            <a:r>
+              <a:rPr lang="fr-CA" sz="1800" b="0" dirty="0">
+                <a:latin typeface="Consolas" panose="020B0609020204030204" pitchFamily="49" charset="0"/>
+              </a:rPr>
+              <a:t>])</a:t>
+            </a:r>
           </a:p>
         </p:txBody>
       </p:sp>
     </p:spTree>
     <p:extLst>
       <p:ext uri="{BB962C8B-B14F-4D97-AF65-F5344CB8AC3E}">
-        <p14:creationId xmlns:p14="http://schemas.microsoft.com/office/powerpoint/2010/main" val="2781789880"/>
+        <p14:creationId xmlns:p14="http://schemas.microsoft.com/office/powerpoint/2010/main" val="2101291111"/>
       </p:ext>
     </p:extLst>
   </p:cSld>
   <p:clrMapOvr>
     <a:masterClrMapping/>
   </p:clrMapOvr>
+  <p:timing>
+    <p:tnLst>
+      <p:par>
+        <p:cTn id="1" dur="indefinite" restart="never" nodeType="tmRoot">
+          <p:childTnLst>
+            <p:seq concurrent="1" nextAc="seek">
+              <p:cTn id="2" dur="indefinite" nodeType="mainSeq">
+                <p:childTnLst>
+                  <p:par>
+                    <p:cTn id="3" fill="hold">
+                      <p:stCondLst>
+                        <p:cond delay="indefinite"/>
+                      </p:stCondLst>
+                      <p:childTnLst>
+                        <p:par>
+                          <p:cTn id="4" fill="hold">
+                            <p:stCondLst>
+                              <p:cond delay="0"/>
+                            </p:stCondLst>
+                            <p:childTnLst>
+                              <p:par>
+                                <p:cTn id="5" presetID="10" presetClass="entr" presetSubtype="0" fill="hold" nodeType="clickEffect">
+                                  <p:stCondLst>
+                                    <p:cond delay="0"/>
+                                  </p:stCondLst>
+                                  <p:childTnLst>
+                                    <p:set>
+                                      <p:cBhvr>
+                                        <p:cTn id="6" dur="1" fill="hold">
+                                          <p:stCondLst>
+                                            <p:cond delay="0"/>
+                                          </p:stCondLst>
+                                        </p:cTn>
+                                        <p:tgtEl>
+                                          <p:spTgt spid="3">
+                                            <p:txEl>
+                                              <p:pRg st="0" end="0"/>
+                                            </p:txEl>
+                                          </p:spTgt>
+                                        </p:tgtEl>
+                                        <p:attrNameLst>
+                                          <p:attrName>style.visibility</p:attrName>
+                                        </p:attrNameLst>
+                                      </p:cBhvr>
+                                      <p:to>
+                                        <p:strVal val="visible"/>
+                                      </p:to>
+                                    </p:set>
+                                    <p:animEffect transition="in" filter="fade">
+                                      <p:cBhvr>
+                                        <p:cTn id="7" dur="500"/>
+                                        <p:tgtEl>
+                                          <p:spTgt spid="3">
+                                            <p:txEl>
+                                              <p:pRg st="0" end="0"/>
+                                            </p:txEl>
+                                          </p:spTgt>
+                                        </p:tgtEl>
+                                      </p:cBhvr>
+                                    </p:animEffect>
+                                  </p:childTnLst>
+                                </p:cTn>
+                              </p:par>
+                              <p:par>
+                                <p:cTn id="8" presetID="10" presetClass="entr" presetSubtype="0" fill="hold" grpId="0" nodeType="withEffect">
+                                  <p:stCondLst>
+                                    <p:cond delay="0"/>
+                                  </p:stCondLst>
+                                  <p:childTnLst>
+                                    <p:set>
+                                      <p:cBhvr>
+                                        <p:cTn id="9" dur="1" fill="hold">
+                                          <p:stCondLst>
+                                            <p:cond delay="0"/>
+                                          </p:stCondLst>
+                                        </p:cTn>
+                                        <p:tgtEl>
+                                          <p:spTgt spid="8"/>
+                                        </p:tgtEl>
+                                        <p:attrNameLst>
+                                          <p:attrName>style.visibility</p:attrName>
+                                        </p:attrNameLst>
+                                      </p:cBhvr>
+                                      <p:to>
+                                        <p:strVal val="visible"/>
+                                      </p:to>
+                                    </p:set>
+                                    <p:animEffect transition="in" filter="fade">
+                                      <p:cBhvr>
+                                        <p:cTn id="10" dur="500"/>
+                                        <p:tgtEl>
+                                          <p:spTgt spid="8"/>
+                                        </p:tgtEl>
+                                      </p:cBhvr>
+                                    </p:animEffect>
+                                  </p:childTnLst>
+                                </p:cTn>
+                              </p:par>
+                            </p:childTnLst>
+                          </p:cTn>
+                        </p:par>
+                      </p:childTnLst>
+                    </p:cTn>
+                  </p:par>
+                  <p:par>
+                    <p:cTn id="11" fill="hold">
+                      <p:stCondLst>
+                        <p:cond delay="indefinite"/>
+                      </p:stCondLst>
+                      <p:childTnLst>
+                        <p:par>
+                          <p:cTn id="12" fill="hold">
+                            <p:stCondLst>
+                              <p:cond delay="0"/>
+                            </p:stCondLst>
+                            <p:childTnLst>
+                              <p:par>
+                                <p:cTn id="13" presetID="10" presetClass="entr" presetSubtype="0" fill="hold" nodeType="clickEffect">
+                                  <p:stCondLst>
+                                    <p:cond delay="0"/>
+                                  </p:stCondLst>
+                                  <p:childTnLst>
+                                    <p:set>
+                                      <p:cBhvr>
+                                        <p:cTn id="14" dur="1" fill="hold">
+                                          <p:stCondLst>
+                                            <p:cond delay="0"/>
+                                          </p:stCondLst>
+                                        </p:cTn>
+                                        <p:tgtEl>
+                                          <p:spTgt spid="3">
+                                            <p:txEl>
+                                              <p:pRg st="3" end="3"/>
+                                            </p:txEl>
+                                          </p:spTgt>
+                                        </p:tgtEl>
+                                        <p:attrNameLst>
+                                          <p:attrName>style.visibility</p:attrName>
+                                        </p:attrNameLst>
+                                      </p:cBhvr>
+                                      <p:to>
+                                        <p:strVal val="visible"/>
+                                      </p:to>
+                                    </p:set>
+                                    <p:animEffect transition="in" filter="fade">
+                                      <p:cBhvr>
+                                        <p:cTn id="15" dur="500"/>
+                                        <p:tgtEl>
+                                          <p:spTgt spid="3">
+                                            <p:txEl>
+                                              <p:pRg st="3" end="3"/>
+                                            </p:txEl>
+                                          </p:spTgt>
+                                        </p:tgtEl>
+                                      </p:cBhvr>
+                                    </p:animEffect>
+                                  </p:childTnLst>
+                                </p:cTn>
+                              </p:par>
+                              <p:par>
+                                <p:cTn id="16" presetID="10" presetClass="entr" presetSubtype="0" fill="hold" grpId="0" nodeType="withEffect">
+                                  <p:stCondLst>
+                                    <p:cond delay="0"/>
+                                  </p:stCondLst>
+                                  <p:childTnLst>
+                                    <p:set>
+                                      <p:cBhvr>
+                                        <p:cTn id="17" dur="1" fill="hold">
+                                          <p:stCondLst>
+                                            <p:cond delay="0"/>
+                                          </p:stCondLst>
+                                        </p:cTn>
+                                        <p:tgtEl>
+                                          <p:spTgt spid="7"/>
+                                        </p:tgtEl>
+                                        <p:attrNameLst>
+                                          <p:attrName>style.visibility</p:attrName>
+                                        </p:attrNameLst>
+                                      </p:cBhvr>
+                                      <p:to>
+                                        <p:strVal val="visible"/>
+                                      </p:to>
+                                    </p:set>
+                                    <p:animEffect transition="in" filter="fade">
+                                      <p:cBhvr>
+                                        <p:cTn id="18" dur="500"/>
+                                        <p:tgtEl>
+                                          <p:spTgt spid="7"/>
+                                        </p:tgtEl>
+                                      </p:cBhvr>
+                                    </p:animEffect>
+                                  </p:childTnLst>
+                                </p:cTn>
+                              </p:par>
+                            </p:childTnLst>
+                          </p:cTn>
+                        </p:par>
+                      </p:childTnLst>
+                    </p:cTn>
+                  </p:par>
+                  <p:par>
+                    <p:cTn id="19" fill="hold">
+                      <p:stCondLst>
+                        <p:cond delay="indefinite"/>
+                      </p:stCondLst>
+                      <p:childTnLst>
+                        <p:par>
+                          <p:cTn id="20" fill="hold">
+                            <p:stCondLst>
+                              <p:cond delay="0"/>
+                            </p:stCondLst>
+                            <p:childTnLst>
+                              <p:par>
+                                <p:cTn id="21" presetID="10" presetClass="entr" presetSubtype="0" fill="hold" nodeType="clickEffect">
+                                  <p:stCondLst>
+                                    <p:cond delay="0"/>
+                                  </p:stCondLst>
+                                  <p:childTnLst>
+                                    <p:set>
+                                      <p:cBhvr>
+                                        <p:cTn id="22" dur="1" fill="hold">
+                                          <p:stCondLst>
+                                            <p:cond delay="0"/>
+                                          </p:stCondLst>
+                                        </p:cTn>
+                                        <p:tgtEl>
+                                          <p:spTgt spid="3">
+                                            <p:txEl>
+                                              <p:pRg st="6" end="6"/>
+                                            </p:txEl>
+                                          </p:spTgt>
+                                        </p:tgtEl>
+                                        <p:attrNameLst>
+                                          <p:attrName>style.visibility</p:attrName>
+                                        </p:attrNameLst>
+                                      </p:cBhvr>
+                                      <p:to>
+                                        <p:strVal val="visible"/>
+                                      </p:to>
+                                    </p:set>
+                                    <p:animEffect transition="in" filter="fade">
+                                      <p:cBhvr>
+                                        <p:cTn id="23" dur="500"/>
+                                        <p:tgtEl>
+                                          <p:spTgt spid="3">
+                                            <p:txEl>
+                                              <p:pRg st="6" end="6"/>
+                                            </p:txEl>
+                                          </p:spTgt>
+                                        </p:tgtEl>
+                                      </p:cBhvr>
+                                    </p:animEffect>
+                                  </p:childTnLst>
+                                </p:cTn>
+                              </p:par>
+                              <p:par>
+                                <p:cTn id="24" presetID="10" presetClass="entr" presetSubtype="0" fill="hold" grpId="0" nodeType="withEffect">
+                                  <p:stCondLst>
+                                    <p:cond delay="0"/>
+                                  </p:stCondLst>
+                                  <p:childTnLst>
+                                    <p:set>
+                                      <p:cBhvr>
+                                        <p:cTn id="25" dur="1" fill="hold">
+                                          <p:stCondLst>
+                                            <p:cond delay="0"/>
+                                          </p:stCondLst>
+                                        </p:cTn>
+                                        <p:tgtEl>
+                                          <p:spTgt spid="9"/>
+                                        </p:tgtEl>
+                                        <p:attrNameLst>
+                                          <p:attrName>style.visibility</p:attrName>
+                                        </p:attrNameLst>
+                                      </p:cBhvr>
+                                      <p:to>
+                                        <p:strVal val="visible"/>
+                                      </p:to>
+                                    </p:set>
+                                    <p:animEffect transition="in" filter="fade">
+                                      <p:cBhvr>
+                                        <p:cTn id="26" dur="500"/>
+                                        <p:tgtEl>
+                                          <p:spTgt spid="9"/>
+                                        </p:tgtEl>
+                                      </p:cBhvr>
+                                    </p:animEffect>
+                                  </p:childTnLst>
+                                </p:cTn>
+                              </p:par>
+                            </p:childTnLst>
+                          </p:cTn>
+                        </p:par>
+                      </p:childTnLst>
+                    </p:cTn>
+                  </p:par>
+                </p:childTnLst>
+              </p:cTn>
+              <p:prevCondLst>
+                <p:cond evt="onPrev" delay="0">
+                  <p:tgtEl>
+                    <p:sldTgt/>
+                  </p:tgtEl>
+                </p:cond>
+              </p:prevCondLst>
+              <p:nextCondLst>
+                <p:cond evt="onNext" delay="0">
+                  <p:tgtEl>
+                    <p:sldTgt/>
+                  </p:tgtEl>
+                </p:cond>
+              </p:nextCondLst>
+            </p:seq>
+          </p:childTnLst>
+        </p:cTn>
+      </p:par>
+    </p:tnLst>
+    <p:bldLst>
+      <p:bldP spid="7" grpId="0" animBg="1"/>
+      <p:bldP spid="8" grpId="0" animBg="1"/>
+      <p:bldP spid="9" grpId="0" animBg="1"/>
+    </p:bldLst>
+  </p:timing>
 </p:sld>
 </file>
 
@@ -15224,6 +16344,2673 @@
       <p188:commentRel xmlns:p188="http://schemas.microsoft.com/office/powerpoint/2018/8/main" r:id="rId2"/>
     </p:ext>
   </p:extLst>
+</p:sld>
+</file>
+
+<file path=ppt/slides/slide20.xml><?xml version="1.0" encoding="utf-8"?>
+<p:sld xmlns:a="http://schemas.openxmlformats.org/drawingml/2006/main" xmlns:r="http://schemas.openxmlformats.org/officeDocument/2006/relationships" xmlns:p="http://schemas.openxmlformats.org/presentationml/2006/main">
+  <p:cSld>
+    <p:bg>
+      <p:bgPr>
+        <a:solidFill>
+          <a:srgbClr val="F5F5F5"/>
+        </a:solidFill>
+        <a:effectLst/>
+      </p:bgPr>
+    </p:bg>
+    <p:spTree>
+      <p:nvGrpSpPr>
+        <p:cNvPr id="1" name="">
+          <a:extLst>
+            <a:ext uri="{FF2B5EF4-FFF2-40B4-BE49-F238E27FC236}">
+              <a16:creationId xmlns:a16="http://schemas.microsoft.com/office/drawing/2014/main" id="{884CAF91-7A77-4F86-A486-1761D3C626E8}"/>
+            </a:ext>
+          </a:extLst>
+        </p:cNvPr>
+        <p:cNvGrpSpPr/>
+        <p:nvPr/>
+      </p:nvGrpSpPr>
+      <p:grpSpPr>
+        <a:xfrm>
+          <a:off x="0" y="0"/>
+          <a:ext cx="0" cy="0"/>
+          <a:chOff x="0" y="0"/>
+          <a:chExt cx="0" cy="0"/>
+        </a:xfrm>
+      </p:grpSpPr>
+      <p:sp>
+        <p:nvSpPr>
+          <p:cNvPr id="2" name="Title 1">
+            <a:extLst>
+              <a:ext uri="{FF2B5EF4-FFF2-40B4-BE49-F238E27FC236}">
+                <a16:creationId xmlns:a16="http://schemas.microsoft.com/office/drawing/2014/main" id="{A652F66B-0182-A922-9599-58D470B11C40}"/>
+              </a:ext>
+            </a:extLst>
+          </p:cNvPr>
+          <p:cNvSpPr>
+            <a:spLocks noGrp="1"/>
+          </p:cNvSpPr>
+          <p:nvPr>
+            <p:ph type="title"/>
+          </p:nvPr>
+        </p:nvSpPr>
+        <p:spPr/>
+        <p:txBody>
+          <a:bodyPr/>
+          <a:lstStyle/>
+          <a:p>
+            <a:r>
+              <a:rPr lang="fr-CA" dirty="0">
+                <a:latin typeface="Arial Rounded MT Bold" panose="020F0704030504030204" pitchFamily="34" charset="0"/>
+              </a:rPr>
+              <a:t>Notation en compréhension</a:t>
+            </a:r>
+          </a:p>
+        </p:txBody>
+      </p:sp>
+      <mc:AlternateContent xmlns:mc="http://schemas.openxmlformats.org/markup-compatibility/2006">
+        <mc:Choice xmlns:a14="http://schemas.microsoft.com/office/drawing/2010/main" Requires="a14">
+          <p:sp>
+            <p:nvSpPr>
+              <p:cNvPr id="3" name="Content Placeholder 2">
+                <a:extLst>
+                  <a:ext uri="{FF2B5EF4-FFF2-40B4-BE49-F238E27FC236}">
+                    <a16:creationId xmlns:a16="http://schemas.microsoft.com/office/drawing/2014/main" id="{9B1FA108-C450-01DE-4435-AF0F17B0A919}"/>
+                  </a:ext>
+                </a:extLst>
+              </p:cNvPr>
+              <p:cNvSpPr>
+                <a:spLocks noGrp="1"/>
+              </p:cNvSpPr>
+              <p:nvPr>
+                <p:ph idx="1"/>
+              </p:nvPr>
+            </p:nvSpPr>
+            <p:spPr>
+              <a:xfrm>
+                <a:off x="838200" y="1818566"/>
+                <a:ext cx="10515600" cy="4351338"/>
+              </a:xfrm>
+            </p:spPr>
+            <p:txBody>
+              <a:bodyPr>
+                <a:normAutofit/>
+              </a:bodyPr>
+              <a:lstStyle/>
+              <a:p>
+                <a:pPr algn="just">
+                  <a:lnSpc>
+                    <a:spcPct val="150000"/>
+                  </a:lnSpc>
+                </a:pPr>
+                <a:r>
+                  <a:rPr lang="fr-CA" sz="1600" dirty="0">
+                    <a:latin typeface="Consolas" panose="020B0609020204030204" pitchFamily="49" charset="0"/>
+                  </a:rPr>
+                  <a:t>En maths </a:t>
+                </a:r>
+                <a:r>
+                  <a:rPr lang="fr-CA" sz="1600" i="1" dirty="0">
+                    <a:latin typeface="Consolas" panose="020B0609020204030204" pitchFamily="49" charset="0"/>
+                  </a:rPr>
+                  <a:t>(</a:t>
+                </a:r>
+                <a:r>
+                  <a:rPr lang="fr-CA" sz="1600" dirty="0">
+                    <a:latin typeface="Consolas" panose="020B0609020204030204" pitchFamily="49" charset="0"/>
+                  </a:rPr>
+                  <a:t>angl.</a:t>
+                </a:r>
+                <a:r>
+                  <a:rPr lang="fr-CA" sz="1600" i="1" dirty="0">
+                    <a:latin typeface="Consolas" panose="020B0609020204030204" pitchFamily="49" charset="0"/>
+                  </a:rPr>
+                  <a:t> </a:t>
+                </a:r>
+                <a:r>
+                  <a:rPr lang="fr-CA" sz="1600" b="1" i="1" dirty="0">
+                    <a:latin typeface="Consolas" panose="020B0609020204030204" pitchFamily="49" charset="0"/>
+                  </a:rPr>
+                  <a:t>set-</a:t>
+                </a:r>
+                <a:r>
+                  <a:rPr lang="fr-CA" sz="1600" b="1" i="1" dirty="0" err="1">
+                    <a:latin typeface="Consolas" panose="020B0609020204030204" pitchFamily="49" charset="0"/>
+                  </a:rPr>
+                  <a:t>builder</a:t>
+                </a:r>
+                <a:r>
+                  <a:rPr lang="fr-CA" sz="1600" b="1" i="1" dirty="0">
+                    <a:latin typeface="Consolas" panose="020B0609020204030204" pitchFamily="49" charset="0"/>
+                  </a:rPr>
+                  <a:t> notation</a:t>
+                </a:r>
+                <a:r>
+                  <a:rPr lang="fr-CA" sz="1600" i="1" dirty="0">
+                    <a:latin typeface="Consolas" panose="020B0609020204030204" pitchFamily="49" charset="0"/>
+                  </a:rPr>
+                  <a:t>):</a:t>
+                </a:r>
+              </a:p>
+              <a:p>
+                <a:pPr algn="just">
+                  <a:lnSpc>
+                    <a:spcPct val="150000"/>
+                  </a:lnSpc>
+                </a:pPr>
+                <a:endParaRPr lang="fr-CA" sz="100" i="1" dirty="0">
+                  <a:latin typeface="Consolas" panose="020B0609020204030204" pitchFamily="49" charset="0"/>
+                </a:endParaRPr>
+              </a:p>
+              <a:p>
+                <a:pPr marL="0" indent="0" algn="just">
+                  <a:lnSpc>
+                    <a:spcPct val="150000"/>
+                  </a:lnSpc>
+                  <a:buNone/>
+                </a:pPr>
+                <a14:m>
+                  <m:oMathPara xmlns:m="http://schemas.openxmlformats.org/officeDocument/2006/math">
+                    <m:oMathParaPr>
+                      <m:jc m:val="centerGroup"/>
+                    </m:oMathParaPr>
+                    <m:oMath xmlns:m="http://schemas.openxmlformats.org/officeDocument/2006/math">
+                      <m:d>
+                        <m:dPr>
+                          <m:begChr m:val="{"/>
+                          <m:endChr m:val="}"/>
+                          <m:ctrlPr>
+                            <a:rPr lang="en-CA" sz="1600" smtClean="0">
+                              <a:latin typeface="Cambria Math" panose="02040503050406030204" pitchFamily="18" charset="0"/>
+                            </a:rPr>
+                          </m:ctrlPr>
+                        </m:dPr>
+                        <m:e>
+                          <m:sSup>
+                            <m:sSupPr>
+                              <m:ctrlPr>
+                                <a:rPr lang="en-CA" sz="1600" smtClean="0">
+                                  <a:latin typeface="Cambria Math" panose="02040503050406030204" pitchFamily="18" charset="0"/>
+                                </a:rPr>
+                              </m:ctrlPr>
+                            </m:sSupPr>
+                            <m:e>
+                              <m:r>
+                                <a:rPr lang="en-CA" sz="1600" b="0" i="1" smtClean="0">
+                                  <a:latin typeface="Cambria Math" panose="02040503050406030204" pitchFamily="18" charset="0"/>
+                                </a:rPr>
+                                <m:t>𝑥</m:t>
+                              </m:r>
+                            </m:e>
+                            <m:sup>
+                              <m:r>
+                                <a:rPr lang="en-CA" sz="1600" b="0" i="0" smtClean="0">
+                                  <a:latin typeface="Cambria Math" panose="02040503050406030204" pitchFamily="18" charset="0"/>
+                                </a:rPr>
+                                <m:t>2</m:t>
+                              </m:r>
+                            </m:sup>
+                          </m:sSup>
+                          <m:r>
+                            <a:rPr lang="en-CA" sz="1600" b="0" i="0" smtClean="0">
+                              <a:latin typeface="Cambria Math" panose="02040503050406030204" pitchFamily="18" charset="0"/>
+                            </a:rPr>
+                            <m:t>|</m:t>
+                          </m:r>
+                          <m:r>
+                            <a:rPr lang="en-CA" sz="1600" b="0" i="1" smtClean="0">
+                              <a:latin typeface="Cambria Math" panose="02040503050406030204" pitchFamily="18" charset="0"/>
+                            </a:rPr>
+                            <m:t>𝑥</m:t>
+                          </m:r>
+                          <m:r>
+                            <a:rPr lang="en-CA" sz="1600" b="0" i="0" smtClean="0">
+                              <a:latin typeface="Cambria Math" panose="02040503050406030204" pitchFamily="18" charset="0"/>
+                              <a:ea typeface="Cambria Math" panose="02040503050406030204" pitchFamily="18" charset="0"/>
+                            </a:rPr>
+                            <m:t>∈</m:t>
+                          </m:r>
+                          <m:r>
+                            <a:rPr lang="en-CA" sz="1600" b="0" i="0" smtClean="0">
+                              <a:latin typeface="Cambria Math" panose="02040503050406030204" pitchFamily="18" charset="0"/>
+                              <a:ea typeface="Cambria Math" panose="02040503050406030204" pitchFamily="18" charset="0"/>
+                            </a:rPr>
+                            <m:t>ℕ</m:t>
+                          </m:r>
+                          <m:r>
+                            <a:rPr lang="en-CA" sz="1600" b="0" i="0" smtClean="0">
+                              <a:latin typeface="Cambria Math" panose="02040503050406030204" pitchFamily="18" charset="0"/>
+                              <a:ea typeface="Cambria Math" panose="02040503050406030204" pitchFamily="18" charset="0"/>
+                            </a:rPr>
+                            <m:t>, </m:t>
+                          </m:r>
+                          <m:r>
+                            <a:rPr lang="en-CA" sz="1600" b="0" i="1" smtClean="0">
+                              <a:latin typeface="Cambria Math" panose="02040503050406030204" pitchFamily="18" charset="0"/>
+                              <a:ea typeface="Cambria Math" panose="02040503050406030204" pitchFamily="18" charset="0"/>
+                            </a:rPr>
+                            <m:t>𝑥</m:t>
+                          </m:r>
+                          <m:r>
+                            <a:rPr lang="en-CA" sz="1600" b="0" i="0" smtClean="0">
+                              <a:latin typeface="Cambria Math" panose="02040503050406030204" pitchFamily="18" charset="0"/>
+                              <a:ea typeface="Cambria Math" panose="02040503050406030204" pitchFamily="18" charset="0"/>
+                            </a:rPr>
+                            <m:t> </m:t>
+                          </m:r>
+                          <m:r>
+                            <m:rPr>
+                              <m:sty m:val="p"/>
+                            </m:rPr>
+                            <a:rPr lang="en-CA" sz="1600" b="0" i="0" smtClean="0">
+                              <a:latin typeface="Cambria Math" panose="02040503050406030204" pitchFamily="18" charset="0"/>
+                              <a:ea typeface="Cambria Math" panose="02040503050406030204" pitchFamily="18" charset="0"/>
+                            </a:rPr>
+                            <m:t>est</m:t>
+                          </m:r>
+                          <m:r>
+                            <a:rPr lang="en-CA" sz="1600" b="0" i="0" smtClean="0">
+                              <a:latin typeface="Cambria Math" panose="02040503050406030204" pitchFamily="18" charset="0"/>
+                              <a:ea typeface="Cambria Math" panose="02040503050406030204" pitchFamily="18" charset="0"/>
+                            </a:rPr>
+                            <m:t> </m:t>
+                          </m:r>
+                          <m:r>
+                            <m:rPr>
+                              <m:sty m:val="p"/>
+                            </m:rPr>
+                            <a:rPr lang="en-CA" sz="1600" b="0" i="0" smtClean="0">
+                              <a:latin typeface="Cambria Math" panose="02040503050406030204" pitchFamily="18" charset="0"/>
+                              <a:ea typeface="Cambria Math" panose="02040503050406030204" pitchFamily="18" charset="0"/>
+                            </a:rPr>
+                            <m:t>pair</m:t>
+                          </m:r>
+                          <m:r>
+                            <a:rPr lang="en-CA" sz="1600" b="0" i="0" smtClean="0">
+                              <a:latin typeface="Cambria Math" panose="02040503050406030204" pitchFamily="18" charset="0"/>
+                              <a:ea typeface="Cambria Math" panose="02040503050406030204" pitchFamily="18" charset="0"/>
+                            </a:rPr>
+                            <m:t>, </m:t>
+                          </m:r>
+                          <m:r>
+                            <a:rPr lang="en-CA" sz="1600" b="0" i="1" smtClean="0">
+                              <a:latin typeface="Cambria Math" panose="02040503050406030204" pitchFamily="18" charset="0"/>
+                              <a:ea typeface="Cambria Math" panose="02040503050406030204" pitchFamily="18" charset="0"/>
+                            </a:rPr>
+                            <m:t>𝑥</m:t>
+                          </m:r>
+                          <m:r>
+                            <a:rPr lang="en-CA" sz="1600" b="0" i="0" smtClean="0">
+                              <a:latin typeface="Cambria Math" panose="02040503050406030204" pitchFamily="18" charset="0"/>
+                              <a:ea typeface="Cambria Math" panose="02040503050406030204" pitchFamily="18" charset="0"/>
+                            </a:rPr>
+                            <m:t>≤10</m:t>
+                          </m:r>
+                        </m:e>
+                      </m:d>
+                    </m:oMath>
+                  </m:oMathPara>
+                </a14:m>
+                <a:endParaRPr lang="fr-CA" sz="1600" dirty="0">
+                  <a:latin typeface="Consolas" panose="020B0609020204030204" pitchFamily="49" charset="0"/>
+                </a:endParaRPr>
+              </a:p>
+              <a:p>
+                <a:pPr marL="0" indent="0" algn="just">
+                  <a:lnSpc>
+                    <a:spcPct val="150000"/>
+                  </a:lnSpc>
+                  <a:buNone/>
+                </a:pPr>
+                <a14:m>
+                  <m:oMathPara xmlns:m="http://schemas.openxmlformats.org/officeDocument/2006/math">
+                    <m:oMathParaPr>
+                      <m:jc m:val="centerGroup"/>
+                    </m:oMathParaPr>
+                    <m:oMath xmlns:m="http://schemas.openxmlformats.org/officeDocument/2006/math">
+                      <m:r>
+                        <a:rPr lang="fr-CA" sz="1600" i="1" smtClean="0">
+                          <a:latin typeface="Cambria Math" panose="02040503050406030204" pitchFamily="18" charset="0"/>
+                          <a:ea typeface="Cambria Math" panose="02040503050406030204" pitchFamily="18" charset="0"/>
+                        </a:rPr>
+                        <m:t>↓</m:t>
+                      </m:r>
+                    </m:oMath>
+                  </m:oMathPara>
+                </a14:m>
+                <a:endParaRPr lang="fr-CA" sz="1600" dirty="0">
+                  <a:latin typeface="Consolas" panose="020B0609020204030204" pitchFamily="49" charset="0"/>
+                </a:endParaRPr>
+              </a:p>
+              <a:p>
+                <a:pPr marL="0" indent="0" algn="just">
+                  <a:lnSpc>
+                    <a:spcPct val="150000"/>
+                  </a:lnSpc>
+                  <a:buNone/>
+                </a:pPr>
+                <a14:m>
+                  <m:oMathPara xmlns:m="http://schemas.openxmlformats.org/officeDocument/2006/math">
+                    <m:oMathParaPr>
+                      <m:jc m:val="centerGroup"/>
+                    </m:oMathParaPr>
+                    <m:oMath xmlns:m="http://schemas.openxmlformats.org/officeDocument/2006/math">
+                      <m:r>
+                        <a:rPr lang="en-CA" sz="1600" b="0" i="1" smtClean="0">
+                          <a:latin typeface="Cambria Math" panose="02040503050406030204" pitchFamily="18" charset="0"/>
+                        </a:rPr>
+                        <m:t>{0, 2, 4, 6, 8, 10}</m:t>
+                      </m:r>
+                    </m:oMath>
+                  </m:oMathPara>
+                </a14:m>
+                <a:endParaRPr lang="fr-CA" sz="1600" dirty="0">
+                  <a:latin typeface="Consolas" panose="020B0609020204030204" pitchFamily="49" charset="0"/>
+                </a:endParaRPr>
+              </a:p>
+              <a:p>
+                <a:pPr marL="0" indent="0" algn="just">
+                  <a:lnSpc>
+                    <a:spcPct val="150000"/>
+                  </a:lnSpc>
+                  <a:buNone/>
+                </a:pPr>
+                <a:endParaRPr lang="fr-CA" sz="100" b="1" dirty="0">
+                  <a:latin typeface="Consolas" panose="020B0609020204030204" pitchFamily="49" charset="0"/>
+                </a:endParaRPr>
+              </a:p>
+              <a:p>
+                <a:pPr algn="just">
+                  <a:lnSpc>
+                    <a:spcPct val="110000"/>
+                  </a:lnSpc>
+                </a:pPr>
+                <a:r>
+                  <a:rPr lang="fr-CA" sz="1600" dirty="0">
+                    <a:latin typeface="Consolas" panose="020B0609020204030204" pitchFamily="49" charset="0"/>
+                  </a:rPr>
+                  <a:t>En Python:</a:t>
+                </a:r>
+              </a:p>
+              <a:p>
+                <a:pPr algn="just">
+                  <a:lnSpc>
+                    <a:spcPct val="110000"/>
+                  </a:lnSpc>
+                </a:pPr>
+                <a:endParaRPr lang="fr-CA" sz="100" dirty="0">
+                  <a:latin typeface="Consolas" panose="020B0609020204030204" pitchFamily="49" charset="0"/>
+                </a:endParaRPr>
+              </a:p>
+              <a:p>
+                <a:pPr marL="457200" lvl="1" indent="0" algn="just">
+                  <a:lnSpc>
+                    <a:spcPct val="110000"/>
+                  </a:lnSpc>
+                  <a:buNone/>
+                </a:pPr>
+                <a:r>
+                  <a:rPr lang="fr-CA" sz="1600" b="1" dirty="0">
+                    <a:latin typeface="Consolas" panose="020B0609020204030204" pitchFamily="49" charset="0"/>
+                  </a:rPr>
+                  <a:t>&gt;&gt;&gt; [x for x in range(11) if x % 2 == 0 and &lt;= 10]</a:t>
+                </a:r>
+              </a:p>
+              <a:p>
+                <a:pPr marL="457200" lvl="1" indent="0" algn="just">
+                  <a:lnSpc>
+                    <a:spcPct val="110000"/>
+                  </a:lnSpc>
+                  <a:buNone/>
+                </a:pPr>
+                <a:r>
+                  <a:rPr lang="fr-CA" sz="1600" dirty="0">
+                    <a:solidFill>
+                      <a:schemeClr val="bg1">
+                        <a:lumMod val="50000"/>
+                      </a:schemeClr>
+                    </a:solidFill>
+                    <a:latin typeface="Consolas" panose="020B0609020204030204" pitchFamily="49" charset="0"/>
+                  </a:rPr>
+                  <a:t>[0, 2, 4, 6, 8, 10]</a:t>
+                </a:r>
+              </a:p>
+              <a:p>
+                <a:pPr marL="0" indent="0" algn="just">
+                  <a:lnSpc>
+                    <a:spcPct val="110000"/>
+                  </a:lnSpc>
+                  <a:buNone/>
+                </a:pPr>
+                <a:endParaRPr lang="fr-CA" sz="100" dirty="0">
+                  <a:solidFill>
+                    <a:schemeClr val="bg1">
+                      <a:lumMod val="50000"/>
+                    </a:schemeClr>
+                  </a:solidFill>
+                  <a:latin typeface="Consolas" panose="020B0609020204030204" pitchFamily="49" charset="0"/>
+                </a:endParaRPr>
+              </a:p>
+              <a:p>
+                <a:pPr algn="just">
+                  <a:lnSpc>
+                    <a:spcPct val="110000"/>
+                  </a:lnSpc>
+                </a:pPr>
+                <a:r>
+                  <a:rPr lang="fr-CA" sz="1600" dirty="0">
+                    <a:latin typeface="Consolas" panose="020B0609020204030204" pitchFamily="49" charset="0"/>
+                  </a:rPr>
+                  <a:t>S'applique aux liste, tuples ... et même aux dictionnaires!</a:t>
+                </a:r>
+              </a:p>
+              <a:p>
+                <a:pPr marL="0" indent="0" algn="just">
+                  <a:lnSpc>
+                    <a:spcPct val="110000"/>
+                  </a:lnSpc>
+                  <a:buNone/>
+                </a:pPr>
+                <a:endParaRPr lang="fr-CA" sz="2000" dirty="0">
+                  <a:latin typeface="Consolas" panose="020B0609020204030204" pitchFamily="49" charset="0"/>
+                </a:endParaRPr>
+              </a:p>
+            </p:txBody>
+          </p:sp>
+        </mc:Choice>
+        <mc:Fallback>
+          <p:sp>
+            <p:nvSpPr>
+              <p:cNvPr id="3" name="Content Placeholder 2">
+                <a:extLst>
+                  <a:ext uri="{FF2B5EF4-FFF2-40B4-BE49-F238E27FC236}">
+                    <a16:creationId xmlns:a16="http://schemas.microsoft.com/office/drawing/2014/main" id="{9B1FA108-C450-01DE-4435-AF0F17B0A919}"/>
+                  </a:ext>
+                </a:extLst>
+              </p:cNvPr>
+              <p:cNvSpPr>
+                <a:spLocks noGrp="1" noRot="1" noChangeAspect="1" noMove="1" noResize="1" noEditPoints="1" noAdjustHandles="1" noChangeArrowheads="1" noChangeShapeType="1" noTextEdit="1"/>
+              </p:cNvSpPr>
+              <p:nvPr>
+                <p:ph idx="1"/>
+              </p:nvPr>
+            </p:nvSpPr>
+            <p:spPr>
+              <a:xfrm>
+                <a:off x="838200" y="1818566"/>
+                <a:ext cx="10515600" cy="4351338"/>
+              </a:xfrm>
+              <a:blipFill>
+                <a:blip r:embed="rId3"/>
+                <a:stretch>
+                  <a:fillRect l="-232"/>
+                </a:stretch>
+              </a:blipFill>
+            </p:spPr>
+            <p:txBody>
+              <a:bodyPr/>
+              <a:lstStyle/>
+              <a:p>
+                <a:r>
+                  <a:rPr lang="fr-CA">
+                    <a:noFill/>
+                  </a:rPr>
+                  <a:t> </a:t>
+                </a:r>
+              </a:p>
+            </p:txBody>
+          </p:sp>
+        </mc:Fallback>
+      </mc:AlternateContent>
+      <p:sp>
+        <p:nvSpPr>
+          <p:cNvPr id="5" name="Slide Number Placeholder 4">
+            <a:extLst>
+              <a:ext uri="{FF2B5EF4-FFF2-40B4-BE49-F238E27FC236}">
+                <a16:creationId xmlns:a16="http://schemas.microsoft.com/office/drawing/2014/main" id="{DCED0CA0-E074-C43C-9D26-75707CD290C7}"/>
+              </a:ext>
+            </a:extLst>
+          </p:cNvPr>
+          <p:cNvSpPr>
+            <a:spLocks noGrp="1"/>
+          </p:cNvSpPr>
+          <p:nvPr>
+            <p:ph type="sldNum" sz="quarter" idx="12"/>
+          </p:nvPr>
+        </p:nvSpPr>
+        <p:spPr/>
+        <p:txBody>
+          <a:bodyPr/>
+          <a:lstStyle/>
+          <a:p>
+            <a:fld id="{846B06B1-1179-491F-A487-8E0C403F7C13}" type="slidenum">
+              <a:rPr lang="fr-CA" smtClean="0"/>
+              <a:t>20</a:t>
+            </a:fld>
+            <a:endParaRPr lang="fr-CA" dirty="0"/>
+          </a:p>
+        </p:txBody>
+      </p:sp>
+    </p:spTree>
+    <p:extLst>
+      <p:ext uri="{BB962C8B-B14F-4D97-AF65-F5344CB8AC3E}">
+        <p14:creationId xmlns:p14="http://schemas.microsoft.com/office/powerpoint/2010/main" val="1119906317"/>
+      </p:ext>
+    </p:extLst>
+  </p:cSld>
+  <p:clrMapOvr>
+    <a:masterClrMapping/>
+  </p:clrMapOvr>
+  <p:timing>
+    <p:tnLst>
+      <p:par>
+        <p:cTn id="1" dur="indefinite" restart="never" nodeType="tmRoot">
+          <p:childTnLst>
+            <p:seq concurrent="1" nextAc="seek">
+              <p:cTn id="2" dur="indefinite" nodeType="mainSeq">
+                <p:childTnLst>
+                  <p:par>
+                    <p:cTn id="3" fill="hold">
+                      <p:stCondLst>
+                        <p:cond delay="indefinite"/>
+                      </p:stCondLst>
+                      <p:childTnLst>
+                        <p:par>
+                          <p:cTn id="4" fill="hold">
+                            <p:stCondLst>
+                              <p:cond delay="0"/>
+                            </p:stCondLst>
+                            <p:childTnLst>
+                              <p:par>
+                                <p:cTn id="5" presetID="10" presetClass="entr" presetSubtype="0" fill="hold" nodeType="clickEffect">
+                                  <p:stCondLst>
+                                    <p:cond delay="0"/>
+                                  </p:stCondLst>
+                                  <p:childTnLst>
+                                    <p:set>
+                                      <p:cBhvr>
+                                        <p:cTn id="6" dur="1" fill="hold">
+                                          <p:stCondLst>
+                                            <p:cond delay="0"/>
+                                          </p:stCondLst>
+                                        </p:cTn>
+                                        <p:tgtEl>
+                                          <p:spTgt spid="3">
+                                            <p:txEl>
+                                              <p:pRg st="0" end="0"/>
+                                            </p:txEl>
+                                          </p:spTgt>
+                                        </p:tgtEl>
+                                        <p:attrNameLst>
+                                          <p:attrName>style.visibility</p:attrName>
+                                        </p:attrNameLst>
+                                      </p:cBhvr>
+                                      <p:to>
+                                        <p:strVal val="visible"/>
+                                      </p:to>
+                                    </p:set>
+                                    <p:animEffect transition="in" filter="fade">
+                                      <p:cBhvr>
+                                        <p:cTn id="7" dur="500"/>
+                                        <p:tgtEl>
+                                          <p:spTgt spid="3">
+                                            <p:txEl>
+                                              <p:pRg st="0" end="0"/>
+                                            </p:txEl>
+                                          </p:spTgt>
+                                        </p:tgtEl>
+                                      </p:cBhvr>
+                                    </p:animEffect>
+                                  </p:childTnLst>
+                                </p:cTn>
+                              </p:par>
+                            </p:childTnLst>
+                          </p:cTn>
+                        </p:par>
+                      </p:childTnLst>
+                    </p:cTn>
+                  </p:par>
+                  <p:par>
+                    <p:cTn id="8" fill="hold">
+                      <p:stCondLst>
+                        <p:cond delay="indefinite"/>
+                      </p:stCondLst>
+                      <p:childTnLst>
+                        <p:par>
+                          <p:cTn id="9" fill="hold">
+                            <p:stCondLst>
+                              <p:cond delay="0"/>
+                            </p:stCondLst>
+                            <p:childTnLst>
+                              <p:par>
+                                <p:cTn id="10" presetID="10" presetClass="entr" presetSubtype="0" fill="hold" nodeType="clickEffect">
+                                  <p:stCondLst>
+                                    <p:cond delay="0"/>
+                                  </p:stCondLst>
+                                  <p:childTnLst>
+                                    <p:set>
+                                      <p:cBhvr>
+                                        <p:cTn id="11" dur="1" fill="hold">
+                                          <p:stCondLst>
+                                            <p:cond delay="0"/>
+                                          </p:stCondLst>
+                                        </p:cTn>
+                                        <p:tgtEl>
+                                          <p:spTgt spid="3">
+                                            <p:txEl>
+                                              <p:pRg st="2" end="2"/>
+                                            </p:txEl>
+                                          </p:spTgt>
+                                        </p:tgtEl>
+                                        <p:attrNameLst>
+                                          <p:attrName>style.visibility</p:attrName>
+                                        </p:attrNameLst>
+                                      </p:cBhvr>
+                                      <p:to>
+                                        <p:strVal val="visible"/>
+                                      </p:to>
+                                    </p:set>
+                                    <p:animEffect transition="in" filter="fade">
+                                      <p:cBhvr>
+                                        <p:cTn id="12" dur="500"/>
+                                        <p:tgtEl>
+                                          <p:spTgt spid="3">
+                                            <p:txEl>
+                                              <p:pRg st="2" end="2"/>
+                                            </p:txEl>
+                                          </p:spTgt>
+                                        </p:tgtEl>
+                                      </p:cBhvr>
+                                    </p:animEffect>
+                                  </p:childTnLst>
+                                </p:cTn>
+                              </p:par>
+                            </p:childTnLst>
+                          </p:cTn>
+                        </p:par>
+                      </p:childTnLst>
+                    </p:cTn>
+                  </p:par>
+                  <p:par>
+                    <p:cTn id="13" fill="hold">
+                      <p:stCondLst>
+                        <p:cond delay="indefinite"/>
+                      </p:stCondLst>
+                      <p:childTnLst>
+                        <p:par>
+                          <p:cTn id="14" fill="hold">
+                            <p:stCondLst>
+                              <p:cond delay="0"/>
+                            </p:stCondLst>
+                            <p:childTnLst>
+                              <p:par>
+                                <p:cTn id="15" presetID="10" presetClass="entr" presetSubtype="0" fill="hold" nodeType="clickEffect">
+                                  <p:stCondLst>
+                                    <p:cond delay="0"/>
+                                  </p:stCondLst>
+                                  <p:childTnLst>
+                                    <p:set>
+                                      <p:cBhvr>
+                                        <p:cTn id="16" dur="1" fill="hold">
+                                          <p:stCondLst>
+                                            <p:cond delay="0"/>
+                                          </p:stCondLst>
+                                        </p:cTn>
+                                        <p:tgtEl>
+                                          <p:spTgt spid="3">
+                                            <p:txEl>
+                                              <p:pRg st="3" end="3"/>
+                                            </p:txEl>
+                                          </p:spTgt>
+                                        </p:tgtEl>
+                                        <p:attrNameLst>
+                                          <p:attrName>style.visibility</p:attrName>
+                                        </p:attrNameLst>
+                                      </p:cBhvr>
+                                      <p:to>
+                                        <p:strVal val="visible"/>
+                                      </p:to>
+                                    </p:set>
+                                    <p:animEffect transition="in" filter="fade">
+                                      <p:cBhvr>
+                                        <p:cTn id="17" dur="500"/>
+                                        <p:tgtEl>
+                                          <p:spTgt spid="3">
+                                            <p:txEl>
+                                              <p:pRg st="3" end="3"/>
+                                            </p:txEl>
+                                          </p:spTgt>
+                                        </p:tgtEl>
+                                      </p:cBhvr>
+                                    </p:animEffect>
+                                  </p:childTnLst>
+                                </p:cTn>
+                              </p:par>
+                              <p:par>
+                                <p:cTn id="18" presetID="10" presetClass="entr" presetSubtype="0" fill="hold" nodeType="withEffect">
+                                  <p:stCondLst>
+                                    <p:cond delay="0"/>
+                                  </p:stCondLst>
+                                  <p:childTnLst>
+                                    <p:set>
+                                      <p:cBhvr>
+                                        <p:cTn id="19" dur="1" fill="hold">
+                                          <p:stCondLst>
+                                            <p:cond delay="0"/>
+                                          </p:stCondLst>
+                                        </p:cTn>
+                                        <p:tgtEl>
+                                          <p:spTgt spid="3">
+                                            <p:txEl>
+                                              <p:pRg st="4" end="4"/>
+                                            </p:txEl>
+                                          </p:spTgt>
+                                        </p:tgtEl>
+                                        <p:attrNameLst>
+                                          <p:attrName>style.visibility</p:attrName>
+                                        </p:attrNameLst>
+                                      </p:cBhvr>
+                                      <p:to>
+                                        <p:strVal val="visible"/>
+                                      </p:to>
+                                    </p:set>
+                                    <p:animEffect transition="in" filter="fade">
+                                      <p:cBhvr>
+                                        <p:cTn id="20" dur="500"/>
+                                        <p:tgtEl>
+                                          <p:spTgt spid="3">
+                                            <p:txEl>
+                                              <p:pRg st="4" end="4"/>
+                                            </p:txEl>
+                                          </p:spTgt>
+                                        </p:tgtEl>
+                                      </p:cBhvr>
+                                    </p:animEffect>
+                                  </p:childTnLst>
+                                </p:cTn>
+                              </p:par>
+                            </p:childTnLst>
+                          </p:cTn>
+                        </p:par>
+                      </p:childTnLst>
+                    </p:cTn>
+                  </p:par>
+                  <p:par>
+                    <p:cTn id="21" fill="hold">
+                      <p:stCondLst>
+                        <p:cond delay="indefinite"/>
+                      </p:stCondLst>
+                      <p:childTnLst>
+                        <p:par>
+                          <p:cTn id="22" fill="hold">
+                            <p:stCondLst>
+                              <p:cond delay="0"/>
+                            </p:stCondLst>
+                            <p:childTnLst>
+                              <p:par>
+                                <p:cTn id="23" presetID="10" presetClass="entr" presetSubtype="0" fill="hold" nodeType="clickEffect">
+                                  <p:stCondLst>
+                                    <p:cond delay="0"/>
+                                  </p:stCondLst>
+                                  <p:childTnLst>
+                                    <p:set>
+                                      <p:cBhvr>
+                                        <p:cTn id="24" dur="1" fill="hold">
+                                          <p:stCondLst>
+                                            <p:cond delay="0"/>
+                                          </p:stCondLst>
+                                        </p:cTn>
+                                        <p:tgtEl>
+                                          <p:spTgt spid="3">
+                                            <p:txEl>
+                                              <p:pRg st="6" end="6"/>
+                                            </p:txEl>
+                                          </p:spTgt>
+                                        </p:tgtEl>
+                                        <p:attrNameLst>
+                                          <p:attrName>style.visibility</p:attrName>
+                                        </p:attrNameLst>
+                                      </p:cBhvr>
+                                      <p:to>
+                                        <p:strVal val="visible"/>
+                                      </p:to>
+                                    </p:set>
+                                    <p:animEffect transition="in" filter="fade">
+                                      <p:cBhvr>
+                                        <p:cTn id="25" dur="500"/>
+                                        <p:tgtEl>
+                                          <p:spTgt spid="3">
+                                            <p:txEl>
+                                              <p:pRg st="6" end="6"/>
+                                            </p:txEl>
+                                          </p:spTgt>
+                                        </p:tgtEl>
+                                      </p:cBhvr>
+                                    </p:animEffect>
+                                  </p:childTnLst>
+                                </p:cTn>
+                              </p:par>
+                              <p:par>
+                                <p:cTn id="26" presetID="10" presetClass="entr" presetSubtype="0" fill="hold" nodeType="withEffect">
+                                  <p:stCondLst>
+                                    <p:cond delay="0"/>
+                                  </p:stCondLst>
+                                  <p:childTnLst>
+                                    <p:set>
+                                      <p:cBhvr>
+                                        <p:cTn id="27" dur="1" fill="hold">
+                                          <p:stCondLst>
+                                            <p:cond delay="0"/>
+                                          </p:stCondLst>
+                                        </p:cTn>
+                                        <p:tgtEl>
+                                          <p:spTgt spid="3">
+                                            <p:txEl>
+                                              <p:pRg st="8" end="8"/>
+                                            </p:txEl>
+                                          </p:spTgt>
+                                        </p:tgtEl>
+                                        <p:attrNameLst>
+                                          <p:attrName>style.visibility</p:attrName>
+                                        </p:attrNameLst>
+                                      </p:cBhvr>
+                                      <p:to>
+                                        <p:strVal val="visible"/>
+                                      </p:to>
+                                    </p:set>
+                                    <p:animEffect transition="in" filter="fade">
+                                      <p:cBhvr>
+                                        <p:cTn id="28" dur="500"/>
+                                        <p:tgtEl>
+                                          <p:spTgt spid="3">
+                                            <p:txEl>
+                                              <p:pRg st="8" end="8"/>
+                                            </p:txEl>
+                                          </p:spTgt>
+                                        </p:tgtEl>
+                                      </p:cBhvr>
+                                    </p:animEffect>
+                                  </p:childTnLst>
+                                </p:cTn>
+                              </p:par>
+                            </p:childTnLst>
+                          </p:cTn>
+                        </p:par>
+                      </p:childTnLst>
+                    </p:cTn>
+                  </p:par>
+                  <p:par>
+                    <p:cTn id="29" fill="hold">
+                      <p:stCondLst>
+                        <p:cond delay="indefinite"/>
+                      </p:stCondLst>
+                      <p:childTnLst>
+                        <p:par>
+                          <p:cTn id="30" fill="hold">
+                            <p:stCondLst>
+                              <p:cond delay="0"/>
+                            </p:stCondLst>
+                            <p:childTnLst>
+                              <p:par>
+                                <p:cTn id="31" presetID="10" presetClass="entr" presetSubtype="0" fill="hold" nodeType="clickEffect">
+                                  <p:stCondLst>
+                                    <p:cond delay="0"/>
+                                  </p:stCondLst>
+                                  <p:childTnLst>
+                                    <p:set>
+                                      <p:cBhvr>
+                                        <p:cTn id="32" dur="1" fill="hold">
+                                          <p:stCondLst>
+                                            <p:cond delay="0"/>
+                                          </p:stCondLst>
+                                        </p:cTn>
+                                        <p:tgtEl>
+                                          <p:spTgt spid="3">
+                                            <p:txEl>
+                                              <p:pRg st="9" end="9"/>
+                                            </p:txEl>
+                                          </p:spTgt>
+                                        </p:tgtEl>
+                                        <p:attrNameLst>
+                                          <p:attrName>style.visibility</p:attrName>
+                                        </p:attrNameLst>
+                                      </p:cBhvr>
+                                      <p:to>
+                                        <p:strVal val="visible"/>
+                                      </p:to>
+                                    </p:set>
+                                    <p:animEffect transition="in" filter="fade">
+                                      <p:cBhvr>
+                                        <p:cTn id="33" dur="500"/>
+                                        <p:tgtEl>
+                                          <p:spTgt spid="3">
+                                            <p:txEl>
+                                              <p:pRg st="9" end="9"/>
+                                            </p:txEl>
+                                          </p:spTgt>
+                                        </p:tgtEl>
+                                      </p:cBhvr>
+                                    </p:animEffect>
+                                  </p:childTnLst>
+                                </p:cTn>
+                              </p:par>
+                            </p:childTnLst>
+                          </p:cTn>
+                        </p:par>
+                      </p:childTnLst>
+                    </p:cTn>
+                  </p:par>
+                  <p:par>
+                    <p:cTn id="34" fill="hold">
+                      <p:stCondLst>
+                        <p:cond delay="indefinite"/>
+                      </p:stCondLst>
+                      <p:childTnLst>
+                        <p:par>
+                          <p:cTn id="35" fill="hold">
+                            <p:stCondLst>
+                              <p:cond delay="0"/>
+                            </p:stCondLst>
+                            <p:childTnLst>
+                              <p:par>
+                                <p:cTn id="36" presetID="10" presetClass="entr" presetSubtype="0" fill="hold" nodeType="clickEffect">
+                                  <p:stCondLst>
+                                    <p:cond delay="0"/>
+                                  </p:stCondLst>
+                                  <p:childTnLst>
+                                    <p:set>
+                                      <p:cBhvr>
+                                        <p:cTn id="37" dur="1" fill="hold">
+                                          <p:stCondLst>
+                                            <p:cond delay="0"/>
+                                          </p:stCondLst>
+                                        </p:cTn>
+                                        <p:tgtEl>
+                                          <p:spTgt spid="3">
+                                            <p:txEl>
+                                              <p:pRg st="11" end="11"/>
+                                            </p:txEl>
+                                          </p:spTgt>
+                                        </p:tgtEl>
+                                        <p:attrNameLst>
+                                          <p:attrName>style.visibility</p:attrName>
+                                        </p:attrNameLst>
+                                      </p:cBhvr>
+                                      <p:to>
+                                        <p:strVal val="visible"/>
+                                      </p:to>
+                                    </p:set>
+                                    <p:animEffect transition="in" filter="fade">
+                                      <p:cBhvr>
+                                        <p:cTn id="38" dur="500"/>
+                                        <p:tgtEl>
+                                          <p:spTgt spid="3">
+                                            <p:txEl>
+                                              <p:pRg st="11" end="11"/>
+                                            </p:txEl>
+                                          </p:spTgt>
+                                        </p:tgtEl>
+                                      </p:cBhvr>
+                                    </p:animEffect>
+                                  </p:childTnLst>
+                                </p:cTn>
+                              </p:par>
+                            </p:childTnLst>
+                          </p:cTn>
+                        </p:par>
+                      </p:childTnLst>
+                    </p:cTn>
+                  </p:par>
+                </p:childTnLst>
+              </p:cTn>
+              <p:prevCondLst>
+                <p:cond evt="onPrev" delay="0">
+                  <p:tgtEl>
+                    <p:sldTgt/>
+                  </p:tgtEl>
+                </p:cond>
+              </p:prevCondLst>
+              <p:nextCondLst>
+                <p:cond evt="onNext" delay="0">
+                  <p:tgtEl>
+                    <p:sldTgt/>
+                  </p:tgtEl>
+                </p:cond>
+              </p:nextCondLst>
+            </p:seq>
+          </p:childTnLst>
+        </p:cTn>
+      </p:par>
+    </p:tnLst>
+  </p:timing>
+</p:sld>
+</file>
+
+<file path=ppt/slides/slide21.xml><?xml version="1.0" encoding="utf-8"?>
+<p:sld xmlns:a="http://schemas.openxmlformats.org/drawingml/2006/main" xmlns:r="http://schemas.openxmlformats.org/officeDocument/2006/relationships" xmlns:p="http://schemas.openxmlformats.org/presentationml/2006/main">
+  <p:cSld>
+    <p:bg>
+      <p:bgPr>
+        <a:solidFill>
+          <a:srgbClr val="F5F5F5"/>
+        </a:solidFill>
+        <a:effectLst/>
+      </p:bgPr>
+    </p:bg>
+    <p:spTree>
+      <p:nvGrpSpPr>
+        <p:cNvPr id="1" name="">
+          <a:extLst>
+            <a:ext uri="{FF2B5EF4-FFF2-40B4-BE49-F238E27FC236}">
+              <a16:creationId xmlns:a16="http://schemas.microsoft.com/office/drawing/2014/main" id="{BD475687-C77D-9BC1-3EE8-0643FE733560}"/>
+            </a:ext>
+          </a:extLst>
+        </p:cNvPr>
+        <p:cNvGrpSpPr/>
+        <p:nvPr/>
+      </p:nvGrpSpPr>
+      <p:grpSpPr>
+        <a:xfrm>
+          <a:off x="0" y="0"/>
+          <a:ext cx="0" cy="0"/>
+          <a:chOff x="0" y="0"/>
+          <a:chExt cx="0" cy="0"/>
+        </a:xfrm>
+      </p:grpSpPr>
+      <p:sp>
+        <p:nvSpPr>
+          <p:cNvPr id="24" name="Title 1">
+            <a:extLst>
+              <a:ext uri="{FF2B5EF4-FFF2-40B4-BE49-F238E27FC236}">
+                <a16:creationId xmlns:a16="http://schemas.microsoft.com/office/drawing/2014/main" id="{31858485-360D-9BCF-CCDE-22ABAF6439C8}"/>
+              </a:ext>
+            </a:extLst>
+          </p:cNvPr>
+          <p:cNvSpPr>
+            <a:spLocks noGrp="1"/>
+          </p:cNvSpPr>
+          <p:nvPr>
+            <p:ph type="title"/>
+          </p:nvPr>
+        </p:nvSpPr>
+        <p:spPr>
+          <a:xfrm>
+            <a:off x="838200" y="365125"/>
+            <a:ext cx="10515600" cy="1325563"/>
+          </a:xfrm>
+        </p:spPr>
+        <p:txBody>
+          <a:bodyPr/>
+          <a:lstStyle/>
+          <a:p>
+            <a:r>
+              <a:rPr lang="fr-CA" dirty="0">
+                <a:latin typeface="Arial Rounded MT Bold" panose="020F0704030504030204" pitchFamily="34" charset="0"/>
+              </a:rPr>
+              <a:t>Exemple</a:t>
+            </a:r>
+          </a:p>
+        </p:txBody>
+      </p:sp>
+      <p:sp>
+        <p:nvSpPr>
+          <p:cNvPr id="25" name="Content Placeholder 2">
+            <a:extLst>
+              <a:ext uri="{FF2B5EF4-FFF2-40B4-BE49-F238E27FC236}">
+                <a16:creationId xmlns:a16="http://schemas.microsoft.com/office/drawing/2014/main" id="{90C38B7A-DA25-55D2-5B22-583FD211581E}"/>
+              </a:ext>
+            </a:extLst>
+          </p:cNvPr>
+          <p:cNvSpPr>
+            <a:spLocks noGrp="1"/>
+          </p:cNvSpPr>
+          <p:nvPr>
+            <p:ph idx="1"/>
+          </p:nvPr>
+        </p:nvSpPr>
+        <p:spPr>
+          <a:xfrm>
+            <a:off x="838200" y="1818566"/>
+            <a:ext cx="10515600" cy="4351338"/>
+          </a:xfrm>
+        </p:spPr>
+        <p:txBody>
+          <a:bodyPr>
+            <a:normAutofit/>
+          </a:bodyPr>
+          <a:lstStyle/>
+          <a:p>
+            <a:pPr marL="0" indent="0" algn="just">
+              <a:lnSpc>
+                <a:spcPct val="110000"/>
+              </a:lnSpc>
+              <a:buNone/>
+            </a:pPr>
+            <a:endParaRPr lang="fr-CA" sz="1600" dirty="0">
+              <a:latin typeface="Consolas" panose="020B0609020204030204" pitchFamily="49" charset="0"/>
+            </a:endParaRPr>
+          </a:p>
+          <a:p>
+            <a:pPr algn="just">
+              <a:lnSpc>
+                <a:spcPct val="110000"/>
+              </a:lnSpc>
+            </a:pPr>
+            <a:endParaRPr lang="fr-CA" sz="1600" dirty="0">
+              <a:latin typeface="Consolas" panose="020B0609020204030204" pitchFamily="49" charset="0"/>
+            </a:endParaRPr>
+          </a:p>
+          <a:p>
+            <a:pPr algn="just">
+              <a:lnSpc>
+                <a:spcPct val="110000"/>
+              </a:lnSpc>
+            </a:pPr>
+            <a:endParaRPr lang="fr-CA" sz="1600" dirty="0">
+              <a:latin typeface="Consolas" panose="020B0609020204030204" pitchFamily="49" charset="0"/>
+            </a:endParaRPr>
+          </a:p>
+          <a:p>
+            <a:pPr marL="0" indent="0" algn="just">
+              <a:lnSpc>
+                <a:spcPct val="110000"/>
+              </a:lnSpc>
+              <a:buNone/>
+            </a:pPr>
+            <a:endParaRPr lang="fr-CA" sz="1600" dirty="0">
+              <a:latin typeface="Consolas" panose="020B0609020204030204" pitchFamily="49" charset="0"/>
+            </a:endParaRPr>
+          </a:p>
+          <a:p>
+            <a:pPr marL="0" indent="0" algn="just">
+              <a:lnSpc>
+                <a:spcPct val="110000"/>
+              </a:lnSpc>
+              <a:buNone/>
+            </a:pPr>
+            <a:endParaRPr lang="fr-CA" sz="1600" dirty="0">
+              <a:latin typeface="Consolas" panose="020B0609020204030204" pitchFamily="49" charset="0"/>
+            </a:endParaRPr>
+          </a:p>
+        </p:txBody>
+      </p:sp>
+      <p:sp>
+        <p:nvSpPr>
+          <p:cNvPr id="26" name="Slide Number Placeholder 4">
+            <a:extLst>
+              <a:ext uri="{FF2B5EF4-FFF2-40B4-BE49-F238E27FC236}">
+                <a16:creationId xmlns:a16="http://schemas.microsoft.com/office/drawing/2014/main" id="{CFD92060-FD02-4B49-2EDE-70AB65A8DD19}"/>
+              </a:ext>
+            </a:extLst>
+          </p:cNvPr>
+          <p:cNvSpPr>
+            <a:spLocks noGrp="1"/>
+          </p:cNvSpPr>
+          <p:nvPr>
+            <p:ph type="sldNum" sz="quarter" idx="12"/>
+          </p:nvPr>
+        </p:nvSpPr>
+        <p:spPr>
+          <a:xfrm>
+            <a:off x="8610600" y="6356350"/>
+            <a:ext cx="2743200" cy="365125"/>
+          </a:xfrm>
+        </p:spPr>
+        <p:txBody>
+          <a:bodyPr/>
+          <a:lstStyle/>
+          <a:p>
+            <a:fld id="{846B06B1-1179-491F-A487-8E0C403F7C13}" type="slidenum">
+              <a:rPr lang="fr-CA" smtClean="0"/>
+              <a:t>21</a:t>
+            </a:fld>
+            <a:endParaRPr lang="fr-CA" dirty="0"/>
+          </a:p>
+        </p:txBody>
+      </p:sp>
+      <p:grpSp>
+        <p:nvGrpSpPr>
+          <p:cNvPr id="27" name="Google Shape;368;p19">
+            <a:extLst>
+              <a:ext uri="{FF2B5EF4-FFF2-40B4-BE49-F238E27FC236}">
+                <a16:creationId xmlns:a16="http://schemas.microsoft.com/office/drawing/2014/main" id="{3AD048B7-F697-2F0D-73EF-2FC8438DF40E}"/>
+              </a:ext>
+            </a:extLst>
+          </p:cNvPr>
+          <p:cNvGrpSpPr/>
+          <p:nvPr/>
+        </p:nvGrpSpPr>
+        <p:grpSpPr>
+          <a:xfrm>
+            <a:off x="907409" y="2131235"/>
+            <a:ext cx="5588641" cy="3726000"/>
+            <a:chOff x="6413585" y="3766183"/>
+            <a:chExt cx="6102299" cy="3000002"/>
+          </a:xfrm>
+        </p:grpSpPr>
+        <p:sp>
+          <p:nvSpPr>
+            <p:cNvPr id="28" name="Google Shape;369;p19">
+              <a:extLst>
+                <a:ext uri="{FF2B5EF4-FFF2-40B4-BE49-F238E27FC236}">
+                  <a16:creationId xmlns:a16="http://schemas.microsoft.com/office/drawing/2014/main" id="{D86DB69A-8151-95AD-8D51-9917C0ADA8AF}"/>
+                </a:ext>
+              </a:extLst>
+            </p:cNvPr>
+            <p:cNvSpPr/>
+            <p:nvPr/>
+          </p:nvSpPr>
+          <p:spPr>
+            <a:xfrm>
+              <a:off x="6413585" y="3766183"/>
+              <a:ext cx="432397" cy="3000002"/>
+            </a:xfrm>
+            <a:prstGeom prst="rect">
+              <a:avLst/>
+            </a:prstGeom>
+            <a:solidFill>
+              <a:srgbClr val="7F7F7F"/>
+            </a:solidFill>
+            <a:ln w="12700" cap="flat" cmpd="sng">
+              <a:solidFill>
+                <a:srgbClr val="7F7F7F"/>
+              </a:solidFill>
+              <a:prstDash val="solid"/>
+              <a:miter lim="800000"/>
+              <a:headEnd type="none" w="sm" len="sm"/>
+              <a:tailEnd type="none" w="sm" len="sm"/>
+            </a:ln>
+          </p:spPr>
+          <p:txBody>
+            <a:bodyPr spcFirstLastPara="1" wrap="square" lIns="91425" tIns="45700" rIns="91425" bIns="45700" anchor="ctr" anchorCtr="0">
+              <a:noAutofit/>
+            </a:bodyPr>
+            <a:lstStyle/>
+            <a:p>
+              <a:pPr marL="0" marR="0" lvl="0" indent="0" algn="ctr" rtl="0">
+                <a:spcBef>
+                  <a:spcPts val="0"/>
+                </a:spcBef>
+                <a:spcAft>
+                  <a:spcPts val="0"/>
+                </a:spcAft>
+                <a:buNone/>
+              </a:pPr>
+              <a:r>
+                <a:rPr lang="fr-CA" sz="1400" dirty="0">
+                  <a:solidFill>
+                    <a:schemeClr val="lt1"/>
+                  </a:solidFill>
+                  <a:latin typeface="Calibri"/>
+                  <a:ea typeface="Calibri"/>
+                  <a:cs typeface="Calibri"/>
+                  <a:sym typeface="Calibri"/>
+                </a:rPr>
+                <a:t>1</a:t>
+              </a:r>
+              <a:endParaRPr sz="1400" dirty="0">
+                <a:solidFill>
+                  <a:schemeClr val="lt1"/>
+                </a:solidFill>
+                <a:latin typeface="Calibri"/>
+                <a:ea typeface="Calibri"/>
+                <a:cs typeface="Calibri"/>
+                <a:sym typeface="Calibri"/>
+              </a:endParaRPr>
+            </a:p>
+            <a:p>
+              <a:pPr marL="0" marR="0" lvl="0" indent="0" algn="ctr" rtl="0">
+                <a:spcBef>
+                  <a:spcPts val="0"/>
+                </a:spcBef>
+                <a:spcAft>
+                  <a:spcPts val="0"/>
+                </a:spcAft>
+                <a:buNone/>
+              </a:pPr>
+              <a:r>
+                <a:rPr lang="fr-CA" sz="1400" dirty="0">
+                  <a:solidFill>
+                    <a:schemeClr val="lt1"/>
+                  </a:solidFill>
+                  <a:latin typeface="Calibri"/>
+                  <a:ea typeface="Calibri"/>
+                  <a:cs typeface="Calibri"/>
+                  <a:sym typeface="Calibri"/>
+                </a:rPr>
+                <a:t>2</a:t>
+              </a:r>
+              <a:endParaRPr sz="1400" dirty="0"/>
+            </a:p>
+            <a:p>
+              <a:pPr marL="0" marR="0" lvl="0" indent="0" algn="ctr" rtl="0">
+                <a:spcBef>
+                  <a:spcPts val="0"/>
+                </a:spcBef>
+                <a:spcAft>
+                  <a:spcPts val="0"/>
+                </a:spcAft>
+                <a:buNone/>
+              </a:pPr>
+              <a:r>
+                <a:rPr lang="fr-CA" sz="1400" dirty="0">
+                  <a:solidFill>
+                    <a:schemeClr val="lt1"/>
+                  </a:solidFill>
+                  <a:latin typeface="Calibri"/>
+                  <a:ea typeface="Calibri"/>
+                  <a:cs typeface="Calibri"/>
+                  <a:sym typeface="Calibri"/>
+                </a:rPr>
+                <a:t>3</a:t>
+              </a:r>
+            </a:p>
+            <a:p>
+              <a:pPr marL="0" marR="0" lvl="0" indent="0" algn="ctr" rtl="0">
+                <a:spcBef>
+                  <a:spcPts val="0"/>
+                </a:spcBef>
+                <a:spcAft>
+                  <a:spcPts val="0"/>
+                </a:spcAft>
+                <a:buNone/>
+              </a:pPr>
+              <a:r>
+                <a:rPr lang="fr-CA" sz="1400" dirty="0">
+                  <a:solidFill>
+                    <a:schemeClr val="lt1"/>
+                  </a:solidFill>
+                  <a:latin typeface="Calibri"/>
+                  <a:ea typeface="Calibri"/>
+                  <a:cs typeface="Calibri"/>
+                  <a:sym typeface="Calibri"/>
+                </a:rPr>
+                <a:t>4</a:t>
+              </a:r>
+            </a:p>
+            <a:p>
+              <a:pPr marL="0" marR="0" lvl="0" indent="0" algn="ctr" rtl="0">
+                <a:spcBef>
+                  <a:spcPts val="0"/>
+                </a:spcBef>
+                <a:spcAft>
+                  <a:spcPts val="0"/>
+                </a:spcAft>
+                <a:buNone/>
+              </a:pPr>
+              <a:r>
+                <a:rPr lang="fr-CA" sz="1400" dirty="0">
+                  <a:solidFill>
+                    <a:schemeClr val="lt1"/>
+                  </a:solidFill>
+                  <a:latin typeface="Calibri"/>
+                  <a:ea typeface="Calibri"/>
+                  <a:cs typeface="Calibri"/>
+                  <a:sym typeface="Calibri"/>
+                </a:rPr>
+                <a:t>5</a:t>
+              </a:r>
+            </a:p>
+            <a:p>
+              <a:pPr marL="0" marR="0" lvl="0" indent="0" algn="ctr" rtl="0">
+                <a:spcBef>
+                  <a:spcPts val="0"/>
+                </a:spcBef>
+                <a:spcAft>
+                  <a:spcPts val="0"/>
+                </a:spcAft>
+                <a:buNone/>
+              </a:pPr>
+              <a:r>
+                <a:rPr lang="fr-CA" sz="1400" dirty="0">
+                  <a:solidFill>
+                    <a:schemeClr val="lt1"/>
+                  </a:solidFill>
+                  <a:latin typeface="Calibri"/>
+                  <a:ea typeface="Calibri"/>
+                  <a:cs typeface="Calibri"/>
+                  <a:sym typeface="Calibri"/>
+                </a:rPr>
+                <a:t>6</a:t>
+              </a:r>
+            </a:p>
+            <a:p>
+              <a:pPr marL="0" marR="0" lvl="0" indent="0" algn="ctr" rtl="0">
+                <a:spcBef>
+                  <a:spcPts val="0"/>
+                </a:spcBef>
+                <a:spcAft>
+                  <a:spcPts val="0"/>
+                </a:spcAft>
+                <a:buNone/>
+              </a:pPr>
+              <a:r>
+                <a:rPr lang="fr-CA" sz="1400" dirty="0">
+                  <a:solidFill>
+                    <a:schemeClr val="lt1"/>
+                  </a:solidFill>
+                  <a:latin typeface="Calibri"/>
+                  <a:ea typeface="Calibri"/>
+                  <a:cs typeface="Calibri"/>
+                  <a:sym typeface="Calibri"/>
+                </a:rPr>
+                <a:t>7</a:t>
+              </a:r>
+            </a:p>
+            <a:p>
+              <a:pPr marL="0" marR="0" lvl="0" indent="0" algn="ctr" rtl="0">
+                <a:spcBef>
+                  <a:spcPts val="0"/>
+                </a:spcBef>
+                <a:spcAft>
+                  <a:spcPts val="0"/>
+                </a:spcAft>
+                <a:buNone/>
+              </a:pPr>
+              <a:r>
+                <a:rPr lang="fr-CA" sz="1400" dirty="0">
+                  <a:solidFill>
+                    <a:schemeClr val="lt1"/>
+                  </a:solidFill>
+                  <a:latin typeface="Calibri"/>
+                  <a:ea typeface="Calibri"/>
+                  <a:cs typeface="Calibri"/>
+                  <a:sym typeface="Calibri"/>
+                </a:rPr>
+                <a:t>8</a:t>
+              </a:r>
+            </a:p>
+            <a:p>
+              <a:pPr marL="0" marR="0" lvl="0" indent="0" algn="ctr" rtl="0">
+                <a:spcBef>
+                  <a:spcPts val="0"/>
+                </a:spcBef>
+                <a:spcAft>
+                  <a:spcPts val="0"/>
+                </a:spcAft>
+                <a:buNone/>
+              </a:pPr>
+              <a:r>
+                <a:rPr lang="fr-CA" sz="1400" dirty="0">
+                  <a:solidFill>
+                    <a:schemeClr val="lt1"/>
+                  </a:solidFill>
+                  <a:latin typeface="Calibri"/>
+                  <a:ea typeface="Calibri"/>
+                  <a:cs typeface="Calibri"/>
+                  <a:sym typeface="Calibri"/>
+                </a:rPr>
+                <a:t>9</a:t>
+              </a:r>
+            </a:p>
+            <a:p>
+              <a:pPr marL="0" marR="0" lvl="0" indent="0" algn="ctr" rtl="0">
+                <a:spcBef>
+                  <a:spcPts val="0"/>
+                </a:spcBef>
+                <a:spcAft>
+                  <a:spcPts val="0"/>
+                </a:spcAft>
+                <a:buNone/>
+              </a:pPr>
+              <a:r>
+                <a:rPr lang="fr-CA" sz="1400" dirty="0">
+                  <a:solidFill>
+                    <a:schemeClr val="lt1"/>
+                  </a:solidFill>
+                  <a:latin typeface="Calibri"/>
+                  <a:ea typeface="Calibri"/>
+                  <a:cs typeface="Calibri"/>
+                  <a:sym typeface="Calibri"/>
+                </a:rPr>
+                <a:t>10</a:t>
+              </a:r>
+            </a:p>
+            <a:p>
+              <a:pPr marL="0" marR="0" lvl="0" indent="0" algn="ctr" rtl="0">
+                <a:spcBef>
+                  <a:spcPts val="0"/>
+                </a:spcBef>
+                <a:spcAft>
+                  <a:spcPts val="0"/>
+                </a:spcAft>
+                <a:buNone/>
+              </a:pPr>
+              <a:r>
+                <a:rPr lang="fr-CA" sz="1400" dirty="0">
+                  <a:solidFill>
+                    <a:schemeClr val="lt1"/>
+                  </a:solidFill>
+                  <a:latin typeface="Calibri"/>
+                  <a:ea typeface="Calibri"/>
+                  <a:cs typeface="Calibri"/>
+                  <a:sym typeface="Calibri"/>
+                </a:rPr>
+                <a:t>11</a:t>
+              </a:r>
+            </a:p>
+            <a:p>
+              <a:pPr marL="0" marR="0" lvl="0" indent="0" algn="ctr" rtl="0">
+                <a:spcBef>
+                  <a:spcPts val="0"/>
+                </a:spcBef>
+                <a:spcAft>
+                  <a:spcPts val="0"/>
+                </a:spcAft>
+                <a:buNone/>
+              </a:pPr>
+              <a:r>
+                <a:rPr lang="fr-CA" sz="1400" dirty="0">
+                  <a:solidFill>
+                    <a:schemeClr val="lt1"/>
+                  </a:solidFill>
+                  <a:latin typeface="Calibri"/>
+                  <a:ea typeface="Calibri"/>
+                  <a:cs typeface="Calibri"/>
+                  <a:sym typeface="Calibri"/>
+                </a:rPr>
+                <a:t>12</a:t>
+              </a:r>
+            </a:p>
+            <a:p>
+              <a:pPr marL="0" marR="0" lvl="0" indent="0" algn="ctr" rtl="0">
+                <a:spcBef>
+                  <a:spcPts val="0"/>
+                </a:spcBef>
+                <a:spcAft>
+                  <a:spcPts val="0"/>
+                </a:spcAft>
+                <a:buNone/>
+              </a:pPr>
+              <a:r>
+                <a:rPr lang="fr-CA" sz="1400" dirty="0">
+                  <a:solidFill>
+                    <a:schemeClr val="lt1"/>
+                  </a:solidFill>
+                  <a:latin typeface="Calibri"/>
+                  <a:ea typeface="Calibri"/>
+                  <a:cs typeface="Calibri"/>
+                  <a:sym typeface="Calibri"/>
+                </a:rPr>
+                <a:t>13</a:t>
+              </a:r>
+            </a:p>
+            <a:p>
+              <a:pPr marL="0" marR="0" lvl="0" indent="0" algn="ctr" rtl="0">
+                <a:spcBef>
+                  <a:spcPts val="0"/>
+                </a:spcBef>
+                <a:spcAft>
+                  <a:spcPts val="0"/>
+                </a:spcAft>
+                <a:buNone/>
+              </a:pPr>
+              <a:r>
+                <a:rPr lang="fr-CA" sz="1400" dirty="0">
+                  <a:solidFill>
+                    <a:schemeClr val="lt1"/>
+                  </a:solidFill>
+                  <a:latin typeface="Calibri"/>
+                  <a:ea typeface="Calibri"/>
+                  <a:cs typeface="Calibri"/>
+                  <a:sym typeface="Calibri"/>
+                </a:rPr>
+                <a:t>14</a:t>
+              </a:r>
+            </a:p>
+            <a:p>
+              <a:pPr marL="0" marR="0" lvl="0" indent="0" algn="ctr" rtl="0">
+                <a:spcBef>
+                  <a:spcPts val="0"/>
+                </a:spcBef>
+                <a:spcAft>
+                  <a:spcPts val="0"/>
+                </a:spcAft>
+                <a:buNone/>
+              </a:pPr>
+              <a:r>
+                <a:rPr lang="fr-CA" sz="1400" dirty="0">
+                  <a:solidFill>
+                    <a:schemeClr val="lt1"/>
+                  </a:solidFill>
+                  <a:latin typeface="Calibri"/>
+                  <a:ea typeface="Calibri"/>
+                  <a:cs typeface="Calibri"/>
+                  <a:sym typeface="Calibri"/>
+                </a:rPr>
+                <a:t>15</a:t>
+              </a:r>
+            </a:p>
+          </p:txBody>
+        </p:sp>
+        <p:sp>
+          <p:nvSpPr>
+            <p:cNvPr id="29" name="Google Shape;370;p19">
+              <a:extLst>
+                <a:ext uri="{FF2B5EF4-FFF2-40B4-BE49-F238E27FC236}">
+                  <a16:creationId xmlns:a16="http://schemas.microsoft.com/office/drawing/2014/main" id="{7A5CFC99-25C0-1DD8-7E21-16740BF68268}"/>
+                </a:ext>
+              </a:extLst>
+            </p:cNvPr>
+            <p:cNvSpPr/>
+            <p:nvPr/>
+          </p:nvSpPr>
+          <p:spPr>
+            <a:xfrm>
+              <a:off x="6845982" y="3766183"/>
+              <a:ext cx="5669902" cy="3000002"/>
+            </a:xfrm>
+            <a:prstGeom prst="rect">
+              <a:avLst/>
+            </a:prstGeom>
+            <a:solidFill>
+              <a:srgbClr val="F2F2F2"/>
+            </a:solidFill>
+            <a:ln w="12700" cap="flat" cmpd="sng">
+              <a:solidFill>
+                <a:srgbClr val="7F7F7F"/>
+              </a:solidFill>
+              <a:prstDash val="solid"/>
+              <a:miter lim="800000"/>
+              <a:headEnd type="none" w="sm" len="sm"/>
+              <a:tailEnd type="none" w="sm" len="sm"/>
+            </a:ln>
+          </p:spPr>
+          <p:txBody>
+            <a:bodyPr spcFirstLastPara="1" wrap="square" lIns="91425" tIns="45700" rIns="91425" bIns="45700" anchor="ctr" anchorCtr="0">
+              <a:noAutofit/>
+            </a:bodyPr>
+            <a:lstStyle/>
+            <a:p>
+              <a:r>
+                <a:rPr lang="en-CA" sz="1400" dirty="0">
+                  <a:solidFill>
+                    <a:srgbClr val="888888"/>
+                  </a:solidFill>
+                  <a:latin typeface="Consolas" panose="020B0609020204030204" pitchFamily="49" charset="0"/>
+                </a:rPr>
+                <a:t># Importer </a:t>
+              </a:r>
+              <a:r>
+                <a:rPr lang="en-CA" sz="1400" dirty="0" err="1">
+                  <a:solidFill>
+                    <a:srgbClr val="888888"/>
+                  </a:solidFill>
+                  <a:latin typeface="Consolas" panose="020B0609020204030204" pitchFamily="49" charset="0"/>
+                </a:rPr>
+                <a:t>l'interface</a:t>
+              </a:r>
+              <a:r>
+                <a:rPr lang="en-CA" sz="1400" dirty="0">
+                  <a:solidFill>
+                    <a:srgbClr val="888888"/>
+                  </a:solidFill>
+                  <a:latin typeface="Consolas" panose="020B0609020204030204" pitchFamily="49" charset="0"/>
+                </a:rPr>
+                <a:t> </a:t>
+              </a:r>
+              <a:r>
+                <a:rPr lang="en-CA" sz="1400" dirty="0" err="1">
+                  <a:solidFill>
+                    <a:srgbClr val="888888"/>
+                  </a:solidFill>
+                  <a:latin typeface="Consolas" panose="020B0609020204030204" pitchFamily="49" charset="0"/>
+                </a:rPr>
+                <a:t>pyplot</a:t>
+              </a:r>
+              <a:r>
+                <a:rPr lang="en-CA" sz="1400" dirty="0">
+                  <a:solidFill>
+                    <a:srgbClr val="888888"/>
+                  </a:solidFill>
+                  <a:latin typeface="Consolas" panose="020B0609020204030204" pitchFamily="49" charset="0"/>
+                </a:rPr>
+                <a:t> de matplotlib</a:t>
+              </a:r>
+              <a:endParaRPr lang="en-CA" sz="1400" dirty="0">
+                <a:solidFill>
+                  <a:srgbClr val="333333"/>
+                </a:solidFill>
+                <a:latin typeface="Consolas" panose="020B0609020204030204" pitchFamily="49" charset="0"/>
+              </a:endParaRPr>
+            </a:p>
+            <a:p>
+              <a:r>
+                <a:rPr lang="en-CA" sz="1400" b="1" dirty="0">
+                  <a:solidFill>
+                    <a:srgbClr val="008800"/>
+                  </a:solidFill>
+                  <a:latin typeface="Consolas" panose="020B0609020204030204" pitchFamily="49" charset="0"/>
+                </a:rPr>
+                <a:t>import</a:t>
+              </a:r>
+              <a:r>
+                <a:rPr lang="en-CA" sz="1400" dirty="0">
+                  <a:solidFill>
+                    <a:srgbClr val="BBBBBB"/>
+                  </a:solidFill>
+                  <a:latin typeface="Consolas" panose="020B0609020204030204" pitchFamily="49" charset="0"/>
+                </a:rPr>
+                <a:t> </a:t>
+              </a:r>
+              <a:r>
+                <a:rPr lang="en-CA" sz="1400" b="1" dirty="0" err="1">
+                  <a:solidFill>
+                    <a:srgbClr val="0E84B5"/>
+                  </a:solidFill>
+                  <a:latin typeface="Consolas" panose="020B0609020204030204" pitchFamily="49" charset="0"/>
+                </a:rPr>
+                <a:t>matplotlib.pyplot</a:t>
+              </a:r>
+              <a:r>
+                <a:rPr lang="en-CA" sz="1400" dirty="0">
+                  <a:solidFill>
+                    <a:srgbClr val="BBBBBB"/>
+                  </a:solidFill>
+                  <a:latin typeface="Consolas" panose="020B0609020204030204" pitchFamily="49" charset="0"/>
+                </a:rPr>
+                <a:t> </a:t>
+              </a:r>
+              <a:r>
+                <a:rPr lang="en-CA" sz="1400" b="1" dirty="0">
+                  <a:solidFill>
+                    <a:srgbClr val="008800"/>
+                  </a:solidFill>
+                  <a:latin typeface="Consolas" panose="020B0609020204030204" pitchFamily="49" charset="0"/>
+                </a:rPr>
+                <a:t>as</a:t>
+              </a:r>
+              <a:r>
+                <a:rPr lang="en-CA" sz="1400" dirty="0">
+                  <a:solidFill>
+                    <a:srgbClr val="BBBBBB"/>
+                  </a:solidFill>
+                  <a:latin typeface="Consolas" panose="020B0609020204030204" pitchFamily="49" charset="0"/>
+                </a:rPr>
+                <a:t> </a:t>
+              </a:r>
+              <a:r>
+                <a:rPr lang="en-CA" sz="1400" b="1" dirty="0" err="1">
+                  <a:solidFill>
+                    <a:srgbClr val="0E84B5"/>
+                  </a:solidFill>
+                  <a:latin typeface="Consolas" panose="020B0609020204030204" pitchFamily="49" charset="0"/>
+                </a:rPr>
+                <a:t>plt</a:t>
+              </a:r>
+              <a:endParaRPr lang="en-CA" sz="1400" dirty="0">
+                <a:solidFill>
+                  <a:srgbClr val="333333"/>
+                </a:solidFill>
+                <a:latin typeface="Consolas" panose="020B0609020204030204" pitchFamily="49" charset="0"/>
+              </a:endParaRPr>
+            </a:p>
+            <a:p>
+              <a:endParaRPr lang="en-CA" sz="1400" dirty="0">
+                <a:solidFill>
+                  <a:srgbClr val="333333"/>
+                </a:solidFill>
+                <a:latin typeface="Consolas" panose="020B0609020204030204" pitchFamily="49" charset="0"/>
+              </a:endParaRPr>
+            </a:p>
+            <a:p>
+              <a:r>
+                <a:rPr lang="en-CA" sz="1400" dirty="0">
+                  <a:solidFill>
+                    <a:srgbClr val="888888"/>
+                  </a:solidFill>
+                  <a:latin typeface="Consolas" panose="020B0609020204030204" pitchFamily="49" charset="0"/>
+                </a:rPr>
+                <a:t># </a:t>
+              </a:r>
+              <a:r>
+                <a:rPr lang="en-CA" sz="1400" dirty="0" err="1">
+                  <a:solidFill>
+                    <a:srgbClr val="888888"/>
+                  </a:solidFill>
+                  <a:latin typeface="Consolas" panose="020B0609020204030204" pitchFamily="49" charset="0"/>
+                </a:rPr>
+                <a:t>Fonction</a:t>
+              </a:r>
+              <a:r>
+                <a:rPr lang="en-CA" sz="1400" dirty="0">
+                  <a:solidFill>
+                    <a:srgbClr val="888888"/>
+                  </a:solidFill>
+                  <a:latin typeface="Consolas" panose="020B0609020204030204" pitchFamily="49" charset="0"/>
+                </a:rPr>
+                <a:t> </a:t>
+              </a:r>
+              <a:r>
+                <a:rPr lang="en-CA" sz="1400" dirty="0" err="1">
+                  <a:solidFill>
+                    <a:srgbClr val="888888"/>
+                  </a:solidFill>
+                  <a:latin typeface="Consolas" panose="020B0609020204030204" pitchFamily="49" charset="0"/>
+                </a:rPr>
+                <a:t>cosinus</a:t>
+              </a:r>
+              <a:endParaRPr lang="en-CA" sz="1400" dirty="0">
+                <a:solidFill>
+                  <a:srgbClr val="333333"/>
+                </a:solidFill>
+                <a:latin typeface="Consolas" panose="020B0609020204030204" pitchFamily="49" charset="0"/>
+              </a:endParaRPr>
+            </a:p>
+            <a:p>
+              <a:r>
+                <a:rPr lang="en-CA" sz="1400" b="1" dirty="0">
+                  <a:solidFill>
+                    <a:srgbClr val="008800"/>
+                  </a:solidFill>
+                  <a:latin typeface="Consolas" panose="020B0609020204030204" pitchFamily="49" charset="0"/>
+                </a:rPr>
+                <a:t>from</a:t>
+              </a:r>
+              <a:r>
+                <a:rPr lang="en-CA" sz="1400" dirty="0">
+                  <a:solidFill>
+                    <a:srgbClr val="BBBBBB"/>
+                  </a:solidFill>
+                  <a:latin typeface="Consolas" panose="020B0609020204030204" pitchFamily="49" charset="0"/>
+                </a:rPr>
+                <a:t> </a:t>
+              </a:r>
+              <a:r>
+                <a:rPr lang="en-CA" sz="1400" b="1" dirty="0">
+                  <a:solidFill>
+                    <a:srgbClr val="0E84B5"/>
+                  </a:solidFill>
+                  <a:latin typeface="Consolas" panose="020B0609020204030204" pitchFamily="49" charset="0"/>
+                </a:rPr>
+                <a:t>math</a:t>
+              </a:r>
+              <a:r>
+                <a:rPr lang="en-CA" sz="1400" dirty="0">
+                  <a:solidFill>
+                    <a:srgbClr val="BBBBBB"/>
+                  </a:solidFill>
+                  <a:latin typeface="Consolas" panose="020B0609020204030204" pitchFamily="49" charset="0"/>
+                </a:rPr>
+                <a:t> </a:t>
+              </a:r>
+              <a:r>
+                <a:rPr lang="en-CA" sz="1400" b="1" dirty="0">
+                  <a:solidFill>
+                    <a:srgbClr val="008800"/>
+                  </a:solidFill>
+                  <a:latin typeface="Consolas" panose="020B0609020204030204" pitchFamily="49" charset="0"/>
+                </a:rPr>
+                <a:t>import</a:t>
+              </a:r>
+              <a:r>
+                <a:rPr lang="en-CA" sz="1400" dirty="0">
+                  <a:solidFill>
+                    <a:srgbClr val="333333"/>
+                  </a:solidFill>
+                  <a:latin typeface="Consolas" panose="020B0609020204030204" pitchFamily="49" charset="0"/>
+                </a:rPr>
+                <a:t> cos</a:t>
+              </a:r>
+            </a:p>
+            <a:p>
+              <a:endParaRPr lang="en-CA" sz="1400" dirty="0">
+                <a:solidFill>
+                  <a:srgbClr val="333333"/>
+                </a:solidFill>
+                <a:latin typeface="Consolas" panose="020B0609020204030204" pitchFamily="49" charset="0"/>
+              </a:endParaRPr>
+            </a:p>
+            <a:p>
+              <a:r>
+                <a:rPr lang="en-CA" sz="1400" dirty="0">
+                  <a:solidFill>
+                    <a:srgbClr val="888888"/>
+                  </a:solidFill>
+                  <a:latin typeface="Consolas" panose="020B0609020204030204" pitchFamily="49" charset="0"/>
+                </a:rPr>
+                <a:t># </a:t>
+              </a:r>
+              <a:r>
+                <a:rPr lang="en-CA" sz="1400" dirty="0" err="1">
+                  <a:solidFill>
+                    <a:srgbClr val="888888"/>
+                  </a:solidFill>
+                  <a:latin typeface="Consolas" panose="020B0609020204030204" pitchFamily="49" charset="0"/>
+                </a:rPr>
+                <a:t>Créer</a:t>
+              </a:r>
+              <a:r>
+                <a:rPr lang="en-CA" sz="1400" dirty="0">
+                  <a:solidFill>
+                    <a:srgbClr val="888888"/>
+                  </a:solidFill>
+                  <a:latin typeface="Consolas" panose="020B0609020204030204" pitchFamily="49" charset="0"/>
+                </a:rPr>
+                <a:t> les données à tracer</a:t>
+              </a:r>
+              <a:endParaRPr lang="en-CA" sz="1400" dirty="0">
+                <a:solidFill>
+                  <a:srgbClr val="333333"/>
+                </a:solidFill>
+                <a:latin typeface="Consolas" panose="020B0609020204030204" pitchFamily="49" charset="0"/>
+              </a:endParaRPr>
+            </a:p>
+            <a:p>
+              <a:r>
+                <a:rPr lang="en-CA" sz="1400" dirty="0">
+                  <a:solidFill>
+                    <a:srgbClr val="333333"/>
+                  </a:solidFill>
+                  <a:latin typeface="Consolas" panose="020B0609020204030204" pitchFamily="49" charset="0"/>
+                </a:rPr>
+                <a:t>x: </a:t>
+              </a:r>
+              <a:r>
+                <a:rPr lang="en-CA" sz="1400" dirty="0">
+                  <a:solidFill>
+                    <a:srgbClr val="007020"/>
+                  </a:solidFill>
+                  <a:latin typeface="Consolas" panose="020B0609020204030204" pitchFamily="49" charset="0"/>
+                </a:rPr>
+                <a:t>list</a:t>
+              </a:r>
+              <a:r>
+                <a:rPr lang="en-CA" sz="1400" dirty="0">
+                  <a:solidFill>
+                    <a:srgbClr val="333333"/>
+                  </a:solidFill>
+                  <a:latin typeface="Consolas" panose="020B0609020204030204" pitchFamily="49" charset="0"/>
+                </a:rPr>
+                <a:t>[</a:t>
+              </a:r>
+              <a:r>
+                <a:rPr lang="en-CA" sz="1400" dirty="0">
+                  <a:solidFill>
+                    <a:srgbClr val="007020"/>
+                  </a:solidFill>
+                  <a:latin typeface="Consolas" panose="020B0609020204030204" pitchFamily="49" charset="0"/>
+                </a:rPr>
+                <a:t>float</a:t>
+              </a:r>
+              <a:r>
+                <a:rPr lang="en-CA" sz="1400" dirty="0">
+                  <a:solidFill>
+                    <a:srgbClr val="333333"/>
+                  </a:solidFill>
+                  <a:latin typeface="Consolas" panose="020B0609020204030204" pitchFamily="49" charset="0"/>
+                </a:rPr>
+                <a:t>] = [</a:t>
+              </a:r>
+              <a:r>
+                <a:rPr lang="en-CA" sz="1400" b="1" dirty="0">
+                  <a:solidFill>
+                    <a:srgbClr val="6600EE"/>
+                  </a:solidFill>
+                  <a:latin typeface="Consolas" panose="020B0609020204030204" pitchFamily="49" charset="0"/>
+                </a:rPr>
+                <a:t>0.1</a:t>
+              </a:r>
+              <a:r>
+                <a:rPr lang="en-CA" sz="1400" dirty="0">
+                  <a:solidFill>
+                    <a:srgbClr val="333333"/>
+                  </a:solidFill>
+                  <a:latin typeface="Consolas" panose="020B0609020204030204" pitchFamily="49" charset="0"/>
+                </a:rPr>
+                <a:t> * </a:t>
+              </a:r>
+              <a:r>
+                <a:rPr lang="en-CA" sz="1400" dirty="0" err="1">
+                  <a:solidFill>
+                    <a:srgbClr val="333333"/>
+                  </a:solidFill>
+                  <a:latin typeface="Consolas" panose="020B0609020204030204" pitchFamily="49" charset="0"/>
+                </a:rPr>
+                <a:t>i</a:t>
+              </a:r>
+              <a:r>
+                <a:rPr lang="en-CA" sz="1400" dirty="0">
+                  <a:solidFill>
+                    <a:srgbClr val="333333"/>
+                  </a:solidFill>
+                  <a:latin typeface="Consolas" panose="020B0609020204030204" pitchFamily="49" charset="0"/>
+                </a:rPr>
+                <a:t> </a:t>
+              </a:r>
+              <a:r>
+                <a:rPr lang="en-CA" sz="1400" b="1" dirty="0">
+                  <a:solidFill>
+                    <a:srgbClr val="008800"/>
+                  </a:solidFill>
+                  <a:latin typeface="Consolas" panose="020B0609020204030204" pitchFamily="49" charset="0"/>
+                </a:rPr>
+                <a:t>for</a:t>
+              </a:r>
+              <a:r>
+                <a:rPr lang="en-CA" sz="1400" dirty="0">
+                  <a:solidFill>
+                    <a:srgbClr val="333333"/>
+                  </a:solidFill>
+                  <a:latin typeface="Consolas" panose="020B0609020204030204" pitchFamily="49" charset="0"/>
+                </a:rPr>
+                <a:t> </a:t>
+              </a:r>
+              <a:r>
+                <a:rPr lang="en-CA" sz="1400" dirty="0" err="1">
+                  <a:solidFill>
+                    <a:srgbClr val="333333"/>
+                  </a:solidFill>
+                  <a:latin typeface="Consolas" panose="020B0609020204030204" pitchFamily="49" charset="0"/>
+                </a:rPr>
+                <a:t>i</a:t>
+              </a:r>
+              <a:r>
+                <a:rPr lang="en-CA" sz="1400" dirty="0">
+                  <a:solidFill>
+                    <a:srgbClr val="333333"/>
+                  </a:solidFill>
+                  <a:latin typeface="Consolas" panose="020B0609020204030204" pitchFamily="49" charset="0"/>
+                </a:rPr>
+                <a:t> </a:t>
+              </a:r>
+              <a:r>
+                <a:rPr lang="en-CA" sz="1400" b="1" dirty="0">
+                  <a:solidFill>
+                    <a:srgbClr val="000000"/>
+                  </a:solidFill>
+                  <a:latin typeface="Consolas" panose="020B0609020204030204" pitchFamily="49" charset="0"/>
+                </a:rPr>
+                <a:t>in</a:t>
+              </a:r>
+              <a:r>
+                <a:rPr lang="en-CA" sz="1400" dirty="0">
+                  <a:solidFill>
+                    <a:srgbClr val="333333"/>
+                  </a:solidFill>
+                  <a:latin typeface="Consolas" panose="020B0609020204030204" pitchFamily="49" charset="0"/>
+                </a:rPr>
+                <a:t> </a:t>
+              </a:r>
+              <a:r>
+                <a:rPr lang="en-CA" sz="1400" dirty="0">
+                  <a:solidFill>
+                    <a:srgbClr val="007020"/>
+                  </a:solidFill>
+                  <a:latin typeface="Consolas" panose="020B0609020204030204" pitchFamily="49" charset="0"/>
+                </a:rPr>
+                <a:t>range</a:t>
+              </a:r>
+              <a:r>
+                <a:rPr lang="en-CA" sz="1400" dirty="0">
+                  <a:solidFill>
+                    <a:srgbClr val="333333"/>
+                  </a:solidFill>
+                  <a:latin typeface="Consolas" panose="020B0609020204030204" pitchFamily="49" charset="0"/>
+                </a:rPr>
+                <a:t>(</a:t>
+              </a:r>
+              <a:r>
+                <a:rPr lang="en-CA" sz="1400" b="1" dirty="0">
+                  <a:solidFill>
+                    <a:srgbClr val="0000DD"/>
+                  </a:solidFill>
+                  <a:latin typeface="Consolas" panose="020B0609020204030204" pitchFamily="49" charset="0"/>
+                </a:rPr>
+                <a:t>65</a:t>
+              </a:r>
+              <a:r>
+                <a:rPr lang="en-CA" sz="1400" dirty="0">
+                  <a:solidFill>
+                    <a:srgbClr val="333333"/>
+                  </a:solidFill>
+                  <a:latin typeface="Consolas" panose="020B0609020204030204" pitchFamily="49" charset="0"/>
+                </a:rPr>
+                <a:t>)]</a:t>
+              </a:r>
+            </a:p>
+            <a:p>
+              <a:r>
+                <a:rPr lang="en-CA" sz="1400" dirty="0">
+                  <a:solidFill>
+                    <a:srgbClr val="333333"/>
+                  </a:solidFill>
+                  <a:latin typeface="Consolas" panose="020B0609020204030204" pitchFamily="49" charset="0"/>
+                </a:rPr>
+                <a:t>y: </a:t>
+              </a:r>
+              <a:r>
+                <a:rPr lang="en-CA" sz="1400" dirty="0">
+                  <a:solidFill>
+                    <a:srgbClr val="007020"/>
+                  </a:solidFill>
+                  <a:latin typeface="Consolas" panose="020B0609020204030204" pitchFamily="49" charset="0"/>
+                </a:rPr>
+                <a:t>list</a:t>
+              </a:r>
+              <a:r>
+                <a:rPr lang="en-CA" sz="1400" dirty="0">
+                  <a:solidFill>
+                    <a:srgbClr val="333333"/>
+                  </a:solidFill>
+                  <a:latin typeface="Consolas" panose="020B0609020204030204" pitchFamily="49" charset="0"/>
+                </a:rPr>
+                <a:t>[</a:t>
+              </a:r>
+              <a:r>
+                <a:rPr lang="en-CA" sz="1400" dirty="0">
+                  <a:solidFill>
+                    <a:srgbClr val="007020"/>
+                  </a:solidFill>
+                  <a:latin typeface="Consolas" panose="020B0609020204030204" pitchFamily="49" charset="0"/>
+                </a:rPr>
+                <a:t>float</a:t>
+              </a:r>
+              <a:r>
+                <a:rPr lang="en-CA" sz="1400" dirty="0">
+                  <a:solidFill>
+                    <a:srgbClr val="333333"/>
+                  </a:solidFill>
+                  <a:latin typeface="Consolas" panose="020B0609020204030204" pitchFamily="49" charset="0"/>
+                </a:rPr>
+                <a:t>] = [cos(</a:t>
+              </a:r>
+              <a:r>
+                <a:rPr lang="en-CA" sz="1400" b="1" dirty="0">
+                  <a:solidFill>
+                    <a:srgbClr val="6600EE"/>
+                  </a:solidFill>
+                  <a:latin typeface="Consolas" panose="020B0609020204030204" pitchFamily="49" charset="0"/>
+                </a:rPr>
+                <a:t>5</a:t>
+              </a:r>
+              <a:r>
+                <a:rPr lang="en-CA" sz="1400" dirty="0">
+                  <a:solidFill>
+                    <a:srgbClr val="333333"/>
+                  </a:solidFill>
+                  <a:latin typeface="Consolas" panose="020B0609020204030204" pitchFamily="49" charset="0"/>
+                </a:rPr>
+                <a:t> * </a:t>
+              </a:r>
+              <a:r>
+                <a:rPr lang="en-CA" sz="1400" dirty="0" err="1">
+                  <a:solidFill>
+                    <a:srgbClr val="333333"/>
+                  </a:solidFill>
+                  <a:latin typeface="Consolas" panose="020B0609020204030204" pitchFamily="49" charset="0"/>
+                </a:rPr>
+                <a:t>valeur</a:t>
+              </a:r>
+              <a:r>
+                <a:rPr lang="en-CA" sz="1400" dirty="0">
+                  <a:solidFill>
+                    <a:srgbClr val="333333"/>
+                  </a:solidFill>
+                  <a:latin typeface="Consolas" panose="020B0609020204030204" pitchFamily="49" charset="0"/>
+                </a:rPr>
+                <a:t>) </a:t>
+              </a:r>
+              <a:r>
+                <a:rPr lang="en-CA" sz="1400" b="1" dirty="0">
+                  <a:solidFill>
+                    <a:srgbClr val="008800"/>
+                  </a:solidFill>
+                  <a:latin typeface="Consolas" panose="020B0609020204030204" pitchFamily="49" charset="0"/>
+                </a:rPr>
+                <a:t>for</a:t>
+              </a:r>
+              <a:r>
+                <a:rPr lang="en-CA" sz="1400" dirty="0">
+                  <a:solidFill>
+                    <a:srgbClr val="333333"/>
+                  </a:solidFill>
+                  <a:latin typeface="Consolas" panose="020B0609020204030204" pitchFamily="49" charset="0"/>
+                </a:rPr>
+                <a:t> </a:t>
+              </a:r>
+              <a:r>
+                <a:rPr lang="en-CA" sz="1400" dirty="0" err="1">
+                  <a:solidFill>
+                    <a:srgbClr val="333333"/>
+                  </a:solidFill>
+                  <a:latin typeface="Consolas" panose="020B0609020204030204" pitchFamily="49" charset="0"/>
+                </a:rPr>
+                <a:t>valeur</a:t>
+              </a:r>
+              <a:r>
+                <a:rPr lang="en-CA" sz="1400" dirty="0">
+                  <a:solidFill>
+                    <a:srgbClr val="333333"/>
+                  </a:solidFill>
+                  <a:latin typeface="Consolas" panose="020B0609020204030204" pitchFamily="49" charset="0"/>
+                </a:rPr>
+                <a:t> </a:t>
+              </a:r>
+              <a:r>
+                <a:rPr lang="en-CA" sz="1400" b="1" dirty="0">
+                  <a:solidFill>
+                    <a:srgbClr val="000000"/>
+                  </a:solidFill>
+                  <a:latin typeface="Consolas" panose="020B0609020204030204" pitchFamily="49" charset="0"/>
+                </a:rPr>
+                <a:t>in</a:t>
+              </a:r>
+              <a:r>
+                <a:rPr lang="en-CA" sz="1400" dirty="0">
+                  <a:solidFill>
+                    <a:srgbClr val="333333"/>
+                  </a:solidFill>
+                  <a:latin typeface="Consolas" panose="020B0609020204030204" pitchFamily="49" charset="0"/>
+                </a:rPr>
+                <a:t> x]</a:t>
+              </a:r>
+            </a:p>
+            <a:p>
+              <a:endParaRPr lang="en-CA" sz="1400" dirty="0">
+                <a:solidFill>
+                  <a:srgbClr val="333333"/>
+                </a:solidFill>
+                <a:latin typeface="Consolas" panose="020B0609020204030204" pitchFamily="49" charset="0"/>
+              </a:endParaRPr>
+            </a:p>
+            <a:p>
+              <a:r>
+                <a:rPr lang="en-CA" sz="1400" dirty="0">
+                  <a:solidFill>
+                    <a:srgbClr val="888888"/>
+                  </a:solidFill>
+                  <a:latin typeface="Consolas" panose="020B0609020204030204" pitchFamily="49" charset="0"/>
+                </a:rPr>
+                <a:t># </a:t>
+              </a:r>
+              <a:r>
+                <a:rPr lang="en-CA" sz="1400" dirty="0" err="1">
+                  <a:solidFill>
+                    <a:srgbClr val="888888"/>
+                  </a:solidFill>
+                  <a:latin typeface="Consolas" panose="020B0609020204030204" pitchFamily="49" charset="0"/>
+                </a:rPr>
+                <a:t>Créer</a:t>
+              </a:r>
+              <a:r>
+                <a:rPr lang="en-CA" sz="1400" dirty="0">
+                  <a:solidFill>
+                    <a:srgbClr val="888888"/>
+                  </a:solidFill>
+                  <a:latin typeface="Consolas" panose="020B0609020204030204" pitchFamily="49" charset="0"/>
+                </a:rPr>
+                <a:t> le </a:t>
+              </a:r>
+              <a:r>
+                <a:rPr lang="en-CA" sz="1400" dirty="0" err="1">
+                  <a:solidFill>
+                    <a:srgbClr val="888888"/>
+                  </a:solidFill>
+                  <a:latin typeface="Consolas" panose="020B0609020204030204" pitchFamily="49" charset="0"/>
+                </a:rPr>
+                <a:t>graphique</a:t>
+              </a:r>
+              <a:endParaRPr lang="en-CA" sz="1400" dirty="0">
+                <a:solidFill>
+                  <a:srgbClr val="333333"/>
+                </a:solidFill>
+                <a:latin typeface="Consolas" panose="020B0609020204030204" pitchFamily="49" charset="0"/>
+              </a:endParaRPr>
+            </a:p>
+            <a:p>
+              <a:r>
+                <a:rPr lang="en-CA" sz="1400" dirty="0" err="1">
+                  <a:solidFill>
+                    <a:srgbClr val="333333"/>
+                  </a:solidFill>
+                  <a:latin typeface="Consolas" panose="020B0609020204030204" pitchFamily="49" charset="0"/>
+                </a:rPr>
+                <a:t>plt.plot</a:t>
+              </a:r>
+              <a:r>
+                <a:rPr lang="en-CA" sz="1400" dirty="0">
+                  <a:solidFill>
+                    <a:srgbClr val="333333"/>
+                  </a:solidFill>
+                  <a:latin typeface="Consolas" panose="020B0609020204030204" pitchFamily="49" charset="0"/>
+                </a:rPr>
+                <a:t>(x, y)</a:t>
+              </a:r>
+            </a:p>
+            <a:p>
+              <a:endParaRPr lang="en-CA" sz="1400" dirty="0">
+                <a:solidFill>
+                  <a:srgbClr val="333333"/>
+                </a:solidFill>
+                <a:latin typeface="Consolas" panose="020B0609020204030204" pitchFamily="49" charset="0"/>
+              </a:endParaRPr>
+            </a:p>
+            <a:p>
+              <a:r>
+                <a:rPr lang="en-CA" sz="1400" dirty="0">
+                  <a:solidFill>
+                    <a:srgbClr val="888888"/>
+                  </a:solidFill>
+                  <a:latin typeface="Consolas" panose="020B0609020204030204" pitchFamily="49" charset="0"/>
+                </a:rPr>
+                <a:t># </a:t>
+              </a:r>
+              <a:r>
+                <a:rPr lang="en-CA" sz="1400" dirty="0" err="1">
+                  <a:solidFill>
+                    <a:srgbClr val="888888"/>
+                  </a:solidFill>
+                  <a:latin typeface="Consolas" panose="020B0609020204030204" pitchFamily="49" charset="0"/>
+                </a:rPr>
+                <a:t>L'afficher</a:t>
+              </a:r>
+              <a:endParaRPr lang="en-CA" sz="1400" dirty="0">
+                <a:solidFill>
+                  <a:srgbClr val="333333"/>
+                </a:solidFill>
+                <a:latin typeface="Consolas" panose="020B0609020204030204" pitchFamily="49" charset="0"/>
+              </a:endParaRPr>
+            </a:p>
+            <a:p>
+              <a:r>
+                <a:rPr lang="en-CA" sz="1400" dirty="0" err="1">
+                  <a:solidFill>
+                    <a:srgbClr val="333333"/>
+                  </a:solidFill>
+                  <a:latin typeface="Consolas" panose="020B0609020204030204" pitchFamily="49" charset="0"/>
+                </a:rPr>
+                <a:t>plt.show</a:t>
+              </a:r>
+              <a:r>
+                <a:rPr lang="en-CA" sz="1400" dirty="0">
+                  <a:solidFill>
+                    <a:srgbClr val="333333"/>
+                  </a:solidFill>
+                  <a:latin typeface="Consolas" panose="020B0609020204030204" pitchFamily="49" charset="0"/>
+                </a:rPr>
+                <a:t>()</a:t>
+              </a:r>
+            </a:p>
+          </p:txBody>
+        </p:sp>
+      </p:grpSp>
+      <p:pic>
+        <p:nvPicPr>
+          <p:cNvPr id="30" name="Picture 4">
+            <a:extLst>
+              <a:ext uri="{FF2B5EF4-FFF2-40B4-BE49-F238E27FC236}">
+                <a16:creationId xmlns:a16="http://schemas.microsoft.com/office/drawing/2014/main" id="{F0E3D763-0952-C0A8-649D-BDE32AB9391C}"/>
+              </a:ext>
+            </a:extLst>
+          </p:cNvPr>
+          <p:cNvPicPr>
+            <a:picLocks noChangeAspect="1" noChangeArrowheads="1"/>
+          </p:cNvPicPr>
+          <p:nvPr/>
+        </p:nvPicPr>
+        <p:blipFill>
+          <a:blip r:embed="rId3">
+            <a:extLst>
+              <a:ext uri="{28A0092B-C50C-407E-A947-70E740481C1C}">
+                <a14:useLocalDpi xmlns:a14="http://schemas.microsoft.com/office/drawing/2010/main" val="0"/>
+              </a:ext>
+            </a:extLst>
+          </a:blip>
+          <a:srcRect/>
+          <a:stretch>
+            <a:fillRect/>
+          </a:stretch>
+        </p:blipFill>
+        <p:spPr bwMode="auto">
+          <a:xfrm>
+            <a:off x="6696934" y="2374235"/>
+            <a:ext cx="4455981" cy="3240000"/>
+          </a:xfrm>
+          <a:prstGeom prst="rect">
+            <a:avLst/>
+          </a:prstGeom>
+          <a:noFill/>
+          <a:extLst>
+            <a:ext uri="{909E8E84-426E-40DD-AFC4-6F175D3DCCD1}">
+              <a14:hiddenFill xmlns:a14="http://schemas.microsoft.com/office/drawing/2010/main">
+                <a:solidFill>
+                  <a:srgbClr val="FFFFFF"/>
+                </a:solidFill>
+              </a14:hiddenFill>
+            </a:ext>
+          </a:extLst>
+        </p:spPr>
+      </p:pic>
+    </p:spTree>
+    <p:extLst>
+      <p:ext uri="{BB962C8B-B14F-4D97-AF65-F5344CB8AC3E}">
+        <p14:creationId xmlns:p14="http://schemas.microsoft.com/office/powerpoint/2010/main" val="4472728"/>
+      </p:ext>
+    </p:extLst>
+  </p:cSld>
+  <p:clrMapOvr>
+    <a:masterClrMapping/>
+  </p:clrMapOvr>
+  <p:timing>
+    <p:tnLst>
+      <p:par>
+        <p:cTn id="1" dur="indefinite" restart="never" nodeType="tmRoot">
+          <p:childTnLst>
+            <p:seq concurrent="1" nextAc="seek">
+              <p:cTn id="2" dur="indefinite" nodeType="mainSeq">
+                <p:childTnLst>
+                  <p:par>
+                    <p:cTn id="3" fill="hold">
+                      <p:stCondLst>
+                        <p:cond delay="indefinite"/>
+                      </p:stCondLst>
+                      <p:childTnLst>
+                        <p:par>
+                          <p:cTn id="4" fill="hold">
+                            <p:stCondLst>
+                              <p:cond delay="0"/>
+                            </p:stCondLst>
+                            <p:childTnLst>
+                              <p:par>
+                                <p:cTn id="5" presetID="10" presetClass="entr" presetSubtype="0" fill="hold" nodeType="clickEffect">
+                                  <p:stCondLst>
+                                    <p:cond delay="0"/>
+                                  </p:stCondLst>
+                                  <p:childTnLst>
+                                    <p:set>
+                                      <p:cBhvr>
+                                        <p:cTn id="6" dur="1" fill="hold">
+                                          <p:stCondLst>
+                                            <p:cond delay="0"/>
+                                          </p:stCondLst>
+                                        </p:cTn>
+                                        <p:tgtEl>
+                                          <p:spTgt spid="30"/>
+                                        </p:tgtEl>
+                                        <p:attrNameLst>
+                                          <p:attrName>style.visibility</p:attrName>
+                                        </p:attrNameLst>
+                                      </p:cBhvr>
+                                      <p:to>
+                                        <p:strVal val="visible"/>
+                                      </p:to>
+                                    </p:set>
+                                    <p:animEffect transition="in" filter="fade">
+                                      <p:cBhvr>
+                                        <p:cTn id="7" dur="500"/>
+                                        <p:tgtEl>
+                                          <p:spTgt spid="30"/>
+                                        </p:tgtEl>
+                                      </p:cBhvr>
+                                    </p:animEffect>
+                                  </p:childTnLst>
+                                </p:cTn>
+                              </p:par>
+                            </p:childTnLst>
+                          </p:cTn>
+                        </p:par>
+                      </p:childTnLst>
+                    </p:cTn>
+                  </p:par>
+                </p:childTnLst>
+              </p:cTn>
+              <p:prevCondLst>
+                <p:cond evt="onPrev" delay="0">
+                  <p:tgtEl>
+                    <p:sldTgt/>
+                  </p:tgtEl>
+                </p:cond>
+              </p:prevCondLst>
+              <p:nextCondLst>
+                <p:cond evt="onNext" delay="0">
+                  <p:tgtEl>
+                    <p:sldTgt/>
+                  </p:tgtEl>
+                </p:cond>
+              </p:nextCondLst>
+            </p:seq>
+          </p:childTnLst>
+        </p:cTn>
+      </p:par>
+    </p:tnLst>
+  </p:timing>
+</p:sld>
+</file>
+
+<file path=ppt/slides/slide22.xml><?xml version="1.0" encoding="utf-8"?>
+<p:sld xmlns:a="http://schemas.openxmlformats.org/drawingml/2006/main" xmlns:r="http://schemas.openxmlformats.org/officeDocument/2006/relationships" xmlns:p="http://schemas.openxmlformats.org/presentationml/2006/main">
+  <p:cSld>
+    <p:bg>
+      <p:bgPr>
+        <a:solidFill>
+          <a:srgbClr val="FFFF00"/>
+        </a:solidFill>
+        <a:effectLst/>
+      </p:bgPr>
+    </p:bg>
+    <p:spTree>
+      <p:nvGrpSpPr>
+        <p:cNvPr id="1" name="">
+          <a:extLst>
+            <a:ext uri="{FF2B5EF4-FFF2-40B4-BE49-F238E27FC236}">
+              <a16:creationId xmlns:a16="http://schemas.microsoft.com/office/drawing/2014/main" id="{A79EE80B-5617-3AC9-1D3D-FF9406939B6B}"/>
+            </a:ext>
+          </a:extLst>
+        </p:cNvPr>
+        <p:cNvGrpSpPr/>
+        <p:nvPr/>
+      </p:nvGrpSpPr>
+      <p:grpSpPr>
+        <a:xfrm>
+          <a:off x="0" y="0"/>
+          <a:ext cx="0" cy="0"/>
+          <a:chOff x="0" y="0"/>
+          <a:chExt cx="0" cy="0"/>
+        </a:xfrm>
+      </p:grpSpPr>
+      <p:sp>
+        <p:nvSpPr>
+          <p:cNvPr id="15" name="Rectangle 14">
+            <a:extLst>
+              <a:ext uri="{FF2B5EF4-FFF2-40B4-BE49-F238E27FC236}">
+                <a16:creationId xmlns:a16="http://schemas.microsoft.com/office/drawing/2014/main" id="{AED2F8D1-AEB0-E659-5BE9-F91783BAB484}"/>
+              </a:ext>
+            </a:extLst>
+          </p:cNvPr>
+          <p:cNvSpPr/>
+          <p:nvPr/>
+        </p:nvSpPr>
+        <p:spPr>
+          <a:xfrm>
+            <a:off x="5732834" y="3357820"/>
+            <a:ext cx="726332" cy="142360"/>
+          </a:xfrm>
+          <a:prstGeom prst="rect">
+            <a:avLst/>
+          </a:prstGeom>
+        </p:spPr>
+        <p:style>
+          <a:lnRef idx="2">
+            <a:schemeClr val="accent1">
+              <a:shade val="15000"/>
+            </a:schemeClr>
+          </a:lnRef>
+          <a:fillRef idx="1">
+            <a:schemeClr val="accent1"/>
+          </a:fillRef>
+          <a:effectRef idx="0">
+            <a:schemeClr val="accent1"/>
+          </a:effectRef>
+          <a:fontRef idx="minor">
+            <a:schemeClr val="lt1"/>
+          </a:fontRef>
+        </p:style>
+        <p:txBody>
+          <a:bodyPr rtlCol="0" anchor="ctr"/>
+          <a:lstStyle/>
+          <a:p>
+            <a:pPr algn="ctr"/>
+            <a:endParaRPr lang="fr-CA"/>
+          </a:p>
+        </p:txBody>
+      </p:sp>
+      <p:sp>
+        <p:nvSpPr>
+          <p:cNvPr id="2" name="Rectangle 1">
+            <a:extLst>
+              <a:ext uri="{FF2B5EF4-FFF2-40B4-BE49-F238E27FC236}">
+                <a16:creationId xmlns:a16="http://schemas.microsoft.com/office/drawing/2014/main" id="{DF179609-0D20-7919-F3E7-E44EC67D7DAF}"/>
+              </a:ext>
+            </a:extLst>
+          </p:cNvPr>
+          <p:cNvSpPr/>
+          <p:nvPr/>
+        </p:nvSpPr>
+        <p:spPr>
+          <a:xfrm>
+            <a:off x="5732834" y="3665863"/>
+            <a:ext cx="726332" cy="360000"/>
+          </a:xfrm>
+          <a:prstGeom prst="rect">
+            <a:avLst/>
+          </a:prstGeom>
+        </p:spPr>
+        <p:style>
+          <a:lnRef idx="2">
+            <a:schemeClr val="accent1">
+              <a:shade val="15000"/>
+            </a:schemeClr>
+          </a:lnRef>
+          <a:fillRef idx="1">
+            <a:schemeClr val="accent1"/>
+          </a:fillRef>
+          <a:effectRef idx="0">
+            <a:schemeClr val="accent1"/>
+          </a:effectRef>
+          <a:fontRef idx="minor">
+            <a:schemeClr val="lt1"/>
+          </a:fontRef>
+        </p:style>
+        <p:txBody>
+          <a:bodyPr rtlCol="0" anchor="ctr"/>
+          <a:lstStyle/>
+          <a:p>
+            <a:pPr algn="ctr"/>
+            <a:endParaRPr lang="fr-CA"/>
+          </a:p>
+        </p:txBody>
+      </p:sp>
+    </p:spTree>
+    <p:extLst>
+      <p:ext uri="{BB962C8B-B14F-4D97-AF65-F5344CB8AC3E}">
+        <p14:creationId xmlns:p14="http://schemas.microsoft.com/office/powerpoint/2010/main" val="2781789880"/>
+      </p:ext>
+    </p:extLst>
+  </p:cSld>
+  <p:clrMapOvr>
+    <a:masterClrMapping/>
+  </p:clrMapOvr>
 </p:sld>
 </file>
 

</xml_diff>

<commit_message>
feat: Add python_2 presentation slides up to slide no.22
</commit_message>
<xml_diff>
--- a/python_2/presentation_python_2.pptx
+++ b/python_2/presentation_python_2.pptx
@@ -5,7 +5,7 @@
     <p:sldMasterId id="2147483648" r:id="rId1"/>
   </p:sldMasterIdLst>
   <p:notesMasterIdLst>
-    <p:notesMasterId r:id="rId24"/>
+    <p:notesMasterId r:id="rId25"/>
   </p:notesMasterIdLst>
   <p:sldIdLst>
     <p:sldId id="256" r:id="rId2"/>
@@ -29,7 +29,8 @@
     <p:sldId id="314" r:id="rId20"/>
     <p:sldId id="315" r:id="rId21"/>
     <p:sldId id="309" r:id="rId22"/>
-    <p:sldId id="297" r:id="rId23"/>
+    <p:sldId id="318" r:id="rId23"/>
+    <p:sldId id="297" r:id="rId24"/>
   </p:sldIdLst>
   <p:sldSz cx="12192000" cy="6858000"/>
   <p:notesSz cx="6858000" cy="9144000"/>
@@ -1021,6 +1022,114 @@
     <p:extLst>
       <p:ext uri="{BB962C8B-B14F-4D97-AF65-F5344CB8AC3E}">
         <p14:creationId xmlns:p14="http://schemas.microsoft.com/office/powerpoint/2010/main" val="567433994"/>
+      </p:ext>
+    </p:extLst>
+  </p:cSld>
+  <p:clrMapOvr>
+    <a:masterClrMapping/>
+  </p:clrMapOvr>
+</p:notes>
+</file>
+
+<file path=ppt/notesSlides/notesSlide14.xml><?xml version="1.0" encoding="utf-8"?>
+<p:notes xmlns:a="http://schemas.openxmlformats.org/drawingml/2006/main" xmlns:r="http://schemas.openxmlformats.org/officeDocument/2006/relationships" xmlns:p="http://schemas.openxmlformats.org/presentationml/2006/main">
+  <p:cSld>
+    <p:spTree>
+      <p:nvGrpSpPr>
+        <p:cNvPr id="1" name="">
+          <a:extLst>
+            <a:ext uri="{FF2B5EF4-FFF2-40B4-BE49-F238E27FC236}">
+              <a16:creationId xmlns:a16="http://schemas.microsoft.com/office/drawing/2014/main" id="{B0469248-D0F7-326A-1443-337A8B9BB1B6}"/>
+            </a:ext>
+          </a:extLst>
+        </p:cNvPr>
+        <p:cNvGrpSpPr/>
+        <p:nvPr/>
+      </p:nvGrpSpPr>
+      <p:grpSpPr>
+        <a:xfrm>
+          <a:off x="0" y="0"/>
+          <a:ext cx="0" cy="0"/>
+          <a:chOff x="0" y="0"/>
+          <a:chExt cx="0" cy="0"/>
+        </a:xfrm>
+      </p:grpSpPr>
+      <p:sp>
+        <p:nvSpPr>
+          <p:cNvPr id="2" name="Slide Image Placeholder 1">
+            <a:extLst>
+              <a:ext uri="{FF2B5EF4-FFF2-40B4-BE49-F238E27FC236}">
+                <a16:creationId xmlns:a16="http://schemas.microsoft.com/office/drawing/2014/main" id="{C4047F07-D2D2-E448-3037-6B83BC5EF015}"/>
+              </a:ext>
+            </a:extLst>
+          </p:cNvPr>
+          <p:cNvSpPr>
+            <a:spLocks noGrp="1" noRot="1" noChangeAspect="1"/>
+          </p:cNvSpPr>
+          <p:nvPr>
+            <p:ph type="sldImg"/>
+          </p:nvPr>
+        </p:nvSpPr>
+        <p:spPr/>
+      </p:sp>
+      <p:sp>
+        <p:nvSpPr>
+          <p:cNvPr id="3" name="Notes Placeholder 2">
+            <a:extLst>
+              <a:ext uri="{FF2B5EF4-FFF2-40B4-BE49-F238E27FC236}">
+                <a16:creationId xmlns:a16="http://schemas.microsoft.com/office/drawing/2014/main" id="{FE070510-E143-B449-C11B-461F7DD00800}"/>
+              </a:ext>
+            </a:extLst>
+          </p:cNvPr>
+          <p:cNvSpPr>
+            <a:spLocks noGrp="1"/>
+          </p:cNvSpPr>
+          <p:nvPr>
+            <p:ph type="body" idx="1"/>
+          </p:nvPr>
+        </p:nvSpPr>
+        <p:spPr/>
+        <p:txBody>
+          <a:bodyPr/>
+          <a:lstStyle/>
+          <a:p>
+            <a:endParaRPr lang="fr-CA"/>
+          </a:p>
+        </p:txBody>
+      </p:sp>
+      <p:sp>
+        <p:nvSpPr>
+          <p:cNvPr id="4" name="Slide Number Placeholder 3">
+            <a:extLst>
+              <a:ext uri="{FF2B5EF4-FFF2-40B4-BE49-F238E27FC236}">
+                <a16:creationId xmlns:a16="http://schemas.microsoft.com/office/drawing/2014/main" id="{14D21115-92DD-1129-231C-01C042CB1991}"/>
+              </a:ext>
+            </a:extLst>
+          </p:cNvPr>
+          <p:cNvSpPr>
+            <a:spLocks noGrp="1"/>
+          </p:cNvSpPr>
+          <p:nvPr>
+            <p:ph type="sldNum" sz="quarter" idx="5"/>
+          </p:nvPr>
+        </p:nvSpPr>
+        <p:spPr/>
+        <p:txBody>
+          <a:bodyPr/>
+          <a:lstStyle/>
+          <a:p>
+            <a:fld id="{D755565A-1FEC-4FFE-8425-B731D92946D0}" type="slidenum">
+              <a:rPr lang="fr-CA" smtClean="0"/>
+              <a:t>22</a:t>
+            </a:fld>
+            <a:endParaRPr lang="fr-CA"/>
+          </a:p>
+        </p:txBody>
+      </p:sp>
+    </p:spTree>
+    <p:extLst>
+      <p:ext uri="{BB962C8B-B14F-4D97-AF65-F5344CB8AC3E}">
+        <p14:creationId xmlns:p14="http://schemas.microsoft.com/office/powerpoint/2010/main" val="3515874851"/>
       </p:ext>
     </p:extLst>
   </p:cSld>
@@ -16408,8 +16517,8 @@
           </a:p>
         </p:txBody>
       </p:sp>
-      <mc:AlternateContent xmlns:mc="http://schemas.openxmlformats.org/markup-compatibility/2006">
-        <mc:Choice xmlns:a14="http://schemas.microsoft.com/office/drawing/2010/main" Requires="a14">
+      <mc:AlternateContent xmlns:mc="http://schemas.openxmlformats.org/markup-compatibility/2006" xmlns:a14="http://schemas.microsoft.com/office/drawing/2010/main">
+        <mc:Choice Requires="a14">
           <p:sp>
             <p:nvSpPr>
               <p:cNvPr id="3" name="Content Placeholder 2">
@@ -16520,7 +16629,7 @@
                           <m:begChr m:val="{"/>
                           <m:endChr m:val="}"/>
                           <m:ctrlPr>
-                            <a:rPr lang="en-CA" sz="1600" smtClean="0">
+                            <a:rPr lang="en-CA" sz="1600" i="1" smtClean="0">
                               <a:latin typeface="Cambria Math" panose="02040503050406030204" pitchFamily="18" charset="0"/>
                             </a:rPr>
                           </m:ctrlPr>
@@ -16529,7 +16638,7 @@
                           <m:sSup>
                             <m:sSupPr>
                               <m:ctrlPr>
-                                <a:rPr lang="en-CA" sz="1600" smtClean="0">
+                                <a:rPr lang="en-CA" sz="1600" i="1" smtClean="0">
                                   <a:latin typeface="Cambria Math" panose="02040503050406030204" pitchFamily="18" charset="0"/>
                                 </a:rPr>
                               </m:ctrlPr>
@@ -16818,7 +16927,7 @@
             </p:txBody>
           </p:sp>
         </mc:Choice>
-        <mc:Fallback>
+        <mc:Fallback xmlns="">
           <p:sp>
             <p:nvSpPr>
               <p:cNvPr id="3" name="Content Placeholder 2">
@@ -18879,6 +18988,542 @@
 </file>
 
 <file path=ppt/slides/slide22.xml><?xml version="1.0" encoding="utf-8"?>
+<p:sld xmlns:a="http://schemas.openxmlformats.org/drawingml/2006/main" xmlns:r="http://schemas.openxmlformats.org/officeDocument/2006/relationships" xmlns:p="http://schemas.openxmlformats.org/presentationml/2006/main">
+  <p:cSld>
+    <p:bg>
+      <p:bgPr>
+        <a:solidFill>
+          <a:schemeClr val="accent6">
+            <a:lumMod val="20000"/>
+            <a:lumOff val="80000"/>
+          </a:schemeClr>
+        </a:solidFill>
+        <a:effectLst/>
+      </p:bgPr>
+    </p:bg>
+    <p:spTree>
+      <p:nvGrpSpPr>
+        <p:cNvPr id="1" name="">
+          <a:extLst>
+            <a:ext uri="{FF2B5EF4-FFF2-40B4-BE49-F238E27FC236}">
+              <a16:creationId xmlns:a16="http://schemas.microsoft.com/office/drawing/2014/main" id="{95F328E5-EED5-E5C8-6124-5C05AF5B4621}"/>
+            </a:ext>
+          </a:extLst>
+        </p:cNvPr>
+        <p:cNvGrpSpPr/>
+        <p:nvPr/>
+      </p:nvGrpSpPr>
+      <p:grpSpPr>
+        <a:xfrm>
+          <a:off x="0" y="0"/>
+          <a:ext cx="0" cy="0"/>
+          <a:chOff x="0" y="0"/>
+          <a:chExt cx="0" cy="0"/>
+        </a:xfrm>
+      </p:grpSpPr>
+      <p:sp>
+        <p:nvSpPr>
+          <p:cNvPr id="2" name="Title 1">
+            <a:extLst>
+              <a:ext uri="{FF2B5EF4-FFF2-40B4-BE49-F238E27FC236}">
+                <a16:creationId xmlns:a16="http://schemas.microsoft.com/office/drawing/2014/main" id="{9793B006-77C6-9080-17FB-8AD76EC2AEA6}"/>
+              </a:ext>
+            </a:extLst>
+          </p:cNvPr>
+          <p:cNvSpPr>
+            <a:spLocks noGrp="1"/>
+          </p:cNvSpPr>
+          <p:nvPr>
+            <p:ph type="title"/>
+          </p:nvPr>
+        </p:nvSpPr>
+        <p:spPr/>
+        <p:txBody>
+          <a:bodyPr/>
+          <a:lstStyle/>
+          <a:p>
+            <a:r>
+              <a:rPr lang="en-US" dirty="0">
+                <a:latin typeface="Arial Rounded MT Bold" panose="020F0704030504030204" pitchFamily="34" charset="0"/>
+              </a:rPr>
+              <a:t>XR6 – </a:t>
+            </a:r>
+            <a:r>
+              <a:rPr lang="en-CA" dirty="0">
+                <a:latin typeface="Arial Rounded MT Bold" panose="020F0704030504030204" pitchFamily="34" charset="0"/>
+              </a:rPr>
+              <a:t>Tracer des </a:t>
+            </a:r>
+            <a:r>
+              <a:rPr lang="en-CA" dirty="0" err="1">
+                <a:latin typeface="Arial Rounded MT Bold" panose="020F0704030504030204" pitchFamily="34" charset="0"/>
+              </a:rPr>
+              <a:t>vecteurs</a:t>
+            </a:r>
+            <a:endParaRPr lang="fr-CA" dirty="0">
+              <a:latin typeface="Arial Rounded MT Bold" panose="020F0704030504030204" pitchFamily="34" charset="0"/>
+            </a:endParaRPr>
+          </a:p>
+        </p:txBody>
+      </p:sp>
+      <p:sp>
+        <p:nvSpPr>
+          <p:cNvPr id="4" name="Slide Number Placeholder 3">
+            <a:extLst>
+              <a:ext uri="{FF2B5EF4-FFF2-40B4-BE49-F238E27FC236}">
+                <a16:creationId xmlns:a16="http://schemas.microsoft.com/office/drawing/2014/main" id="{3EF5A7CC-14D6-EC1B-5BE7-FDFE088415A9}"/>
+              </a:ext>
+            </a:extLst>
+          </p:cNvPr>
+          <p:cNvSpPr>
+            <a:spLocks noGrp="1"/>
+          </p:cNvSpPr>
+          <p:nvPr>
+            <p:ph type="sldNum" sz="quarter" idx="12"/>
+          </p:nvPr>
+        </p:nvSpPr>
+        <p:spPr/>
+        <p:txBody>
+          <a:bodyPr/>
+          <a:lstStyle/>
+          <a:p>
+            <a:fld id="{846B06B1-1179-491F-A487-8E0C403F7C13}" type="slidenum">
+              <a:rPr lang="fr-CA" smtClean="0"/>
+              <a:t>22</a:t>
+            </a:fld>
+            <a:endParaRPr lang="fr-CA"/>
+          </a:p>
+        </p:txBody>
+      </p:sp>
+      <p:pic>
+        <p:nvPicPr>
+          <p:cNvPr id="35" name="Graphic 34">
+            <a:extLst>
+              <a:ext uri="{FF2B5EF4-FFF2-40B4-BE49-F238E27FC236}">
+                <a16:creationId xmlns:a16="http://schemas.microsoft.com/office/drawing/2014/main" id="{429C3405-5FD7-A561-95BD-8E85CAFE9815}"/>
+              </a:ext>
+            </a:extLst>
+          </p:cNvPr>
+          <p:cNvPicPr>
+            <a:picLocks noChangeAspect="1"/>
+          </p:cNvPicPr>
+          <p:nvPr/>
+        </p:nvPicPr>
+        <p:blipFill>
+          <a:blip>
+            <a:extLst>
+              <a:ext uri="{96DAC541-7B7A-43D3-8B79-37D633B846F1}">
+                <asvg:svgBlip xmlns:asvg="http://schemas.microsoft.com/office/drawing/2016/SVG/main" r:embed="rId3"/>
+              </a:ext>
+            </a:extLst>
+          </a:blip>
+          <a:stretch>
+            <a:fillRect/>
+          </a:stretch>
+        </p:blipFill>
+        <p:spPr>
+          <a:xfrm>
+            <a:off x="2627091" y="3494643"/>
+            <a:ext cx="3057525" cy="2857500"/>
+          </a:xfrm>
+          <a:prstGeom prst="rect">
+            <a:avLst/>
+          </a:prstGeom>
+        </p:spPr>
+      </p:pic>
+      <mc:AlternateContent xmlns:mc="http://schemas.openxmlformats.org/markup-compatibility/2006">
+        <mc:Choice xmlns:a14="http://schemas.microsoft.com/office/drawing/2010/main" Requires="a14">
+          <p:sp>
+            <p:nvSpPr>
+              <p:cNvPr id="37" name="Content Placeholder 36">
+                <a:extLst>
+                  <a:ext uri="{FF2B5EF4-FFF2-40B4-BE49-F238E27FC236}">
+                    <a16:creationId xmlns:a16="http://schemas.microsoft.com/office/drawing/2014/main" id="{28B9F5AA-AE60-0726-04F2-1E301C17C836}"/>
+                  </a:ext>
+                </a:extLst>
+              </p:cNvPr>
+              <p:cNvSpPr>
+                <a:spLocks noGrp="1"/>
+              </p:cNvSpPr>
+              <p:nvPr>
+                <p:ph idx="1"/>
+              </p:nvPr>
+            </p:nvSpPr>
+            <p:spPr/>
+            <p:txBody>
+              <a:bodyPr>
+                <a:normAutofit/>
+              </a:bodyPr>
+              <a:lstStyle/>
+              <a:p>
+                <a:pPr marL="0" indent="0" algn="just">
+                  <a:lnSpc>
+                    <a:spcPct val="150000"/>
+                  </a:lnSpc>
+                  <a:buNone/>
+                </a:pPr>
+                <a:r>
+                  <a:rPr lang="fr-CA" sz="2000" dirty="0"/>
+                  <a:t>Complétez la méthode </a:t>
+                </a:r>
+                <a:r>
+                  <a:rPr lang="fr-CA" sz="2000" dirty="0">
+                    <a:latin typeface="Consolas" panose="020B0609020204030204" pitchFamily="49" charset="0"/>
+                  </a:rPr>
+                  <a:t>tracer()</a:t>
+                </a:r>
+                <a:r>
+                  <a:rPr lang="fr-CA" sz="2000" dirty="0"/>
+                  <a:t> dans le carnet du cours. Cette dernière récupère les coordonnées </a:t>
+                </a:r>
+                <a14:m>
+                  <m:oMath xmlns:m="http://schemas.openxmlformats.org/officeDocument/2006/math">
+                    <m:d>
+                      <m:dPr>
+                        <m:ctrlPr>
+                          <a:rPr lang="fr-CA" sz="2000" b="0" i="1" smtClean="0">
+                            <a:latin typeface="Cambria Math" panose="02040503050406030204" pitchFamily="18" charset="0"/>
+                          </a:rPr>
+                        </m:ctrlPr>
+                      </m:dPr>
+                      <m:e>
+                        <m:sSub>
+                          <m:sSubPr>
+                            <m:ctrlPr>
+                              <a:rPr lang="fr-CA" sz="2000" b="0" i="1" smtClean="0">
+                                <a:latin typeface="Cambria Math" panose="02040503050406030204" pitchFamily="18" charset="0"/>
+                              </a:rPr>
+                            </m:ctrlPr>
+                          </m:sSubPr>
+                          <m:e>
+                            <m:r>
+                              <a:rPr lang="fr-CA" sz="2000" b="0" i="1" smtClean="0">
+                                <a:latin typeface="Cambria Math" panose="02040503050406030204" pitchFamily="18" charset="0"/>
+                              </a:rPr>
+                              <m:t>𝑥</m:t>
+                            </m:r>
+                          </m:e>
+                          <m:sub>
+                            <m:r>
+                              <a:rPr lang="fr-CA" sz="2000" b="0" i="1" smtClean="0">
+                                <a:latin typeface="Cambria Math" panose="02040503050406030204" pitchFamily="18" charset="0"/>
+                              </a:rPr>
+                              <m:t>𝑏</m:t>
+                            </m:r>
+                          </m:sub>
+                        </m:sSub>
+                        <m:r>
+                          <a:rPr lang="fr-CA" sz="2000" b="0" i="1" smtClean="0">
+                            <a:latin typeface="Cambria Math" panose="02040503050406030204" pitchFamily="18" charset="0"/>
+                          </a:rPr>
+                          <m:t>,</m:t>
+                        </m:r>
+                        <m:sSub>
+                          <m:sSubPr>
+                            <m:ctrlPr>
+                              <a:rPr lang="fr-CA" sz="2000" b="0" i="1" smtClean="0">
+                                <a:latin typeface="Cambria Math" panose="02040503050406030204" pitchFamily="18" charset="0"/>
+                              </a:rPr>
+                            </m:ctrlPr>
+                          </m:sSubPr>
+                          <m:e>
+                            <m:r>
+                              <a:rPr lang="fr-CA" sz="2000" b="0" i="1" smtClean="0">
+                                <a:latin typeface="Cambria Math" panose="02040503050406030204" pitchFamily="18" charset="0"/>
+                              </a:rPr>
+                              <m:t>𝑦</m:t>
+                            </m:r>
+                          </m:e>
+                          <m:sub>
+                            <m:r>
+                              <a:rPr lang="fr-CA" sz="2000" b="0" i="1" smtClean="0">
+                                <a:latin typeface="Cambria Math" panose="02040503050406030204" pitchFamily="18" charset="0"/>
+                              </a:rPr>
+                              <m:t>𝑏</m:t>
+                            </m:r>
+                          </m:sub>
+                        </m:sSub>
+                      </m:e>
+                    </m:d>
+                  </m:oMath>
+                </a14:m>
+                <a:r>
+                  <a:rPr lang="fr-CA" sz="2000" dirty="0"/>
+                  <a:t> et </a:t>
+                </a:r>
+                <a14:m>
+                  <m:oMath xmlns:m="http://schemas.openxmlformats.org/officeDocument/2006/math">
+                    <m:d>
+                      <m:dPr>
+                        <m:ctrlPr>
+                          <a:rPr lang="fr-CA" sz="2000" b="0" i="1" smtClean="0">
+                            <a:latin typeface="Cambria Math" panose="02040503050406030204" pitchFamily="18" charset="0"/>
+                          </a:rPr>
+                        </m:ctrlPr>
+                      </m:dPr>
+                      <m:e>
+                        <m:sSub>
+                          <m:sSubPr>
+                            <m:ctrlPr>
+                              <a:rPr lang="fr-CA" sz="2000" b="0" i="1" smtClean="0">
+                                <a:latin typeface="Cambria Math" panose="02040503050406030204" pitchFamily="18" charset="0"/>
+                              </a:rPr>
+                            </m:ctrlPr>
+                          </m:sSubPr>
+                          <m:e>
+                            <m:r>
+                              <a:rPr lang="fr-CA" sz="2000" b="0" i="1" smtClean="0">
+                                <a:latin typeface="Cambria Math" panose="02040503050406030204" pitchFamily="18" charset="0"/>
+                              </a:rPr>
+                              <m:t>𝑥</m:t>
+                            </m:r>
+                          </m:e>
+                          <m:sub>
+                            <m:r>
+                              <a:rPr lang="fr-CA" sz="2000" b="0" i="1" smtClean="0">
+                                <a:latin typeface="Cambria Math" panose="02040503050406030204" pitchFamily="18" charset="0"/>
+                              </a:rPr>
+                              <m:t>𝑐</m:t>
+                            </m:r>
+                          </m:sub>
+                        </m:sSub>
+                        <m:r>
+                          <a:rPr lang="fr-CA" sz="2000" b="0" i="1" smtClean="0">
+                            <a:latin typeface="Cambria Math" panose="02040503050406030204" pitchFamily="18" charset="0"/>
+                          </a:rPr>
+                          <m:t>,</m:t>
+                        </m:r>
+                        <m:sSub>
+                          <m:sSubPr>
+                            <m:ctrlPr>
+                              <a:rPr lang="fr-CA" sz="2000" b="0" i="1" smtClean="0">
+                                <a:latin typeface="Cambria Math" panose="02040503050406030204" pitchFamily="18" charset="0"/>
+                              </a:rPr>
+                            </m:ctrlPr>
+                          </m:sSubPr>
+                          <m:e>
+                            <m:r>
+                              <a:rPr lang="fr-CA" sz="2000" b="0" i="1" smtClean="0">
+                                <a:latin typeface="Cambria Math" panose="02040503050406030204" pitchFamily="18" charset="0"/>
+                              </a:rPr>
+                              <m:t>𝑦</m:t>
+                            </m:r>
+                          </m:e>
+                          <m:sub>
+                            <m:r>
+                              <a:rPr lang="fr-CA" sz="2000" b="0" i="1" smtClean="0">
+                                <a:latin typeface="Cambria Math" panose="02040503050406030204" pitchFamily="18" charset="0"/>
+                              </a:rPr>
+                              <m:t>𝑐</m:t>
+                            </m:r>
+                          </m:sub>
+                        </m:sSub>
+                      </m:e>
+                    </m:d>
+                  </m:oMath>
+                </a14:m>
+                <a:r>
+                  <a:rPr lang="fr-CA" sz="2000" dirty="0"/>
+                  <a:t> avec la méthode </a:t>
+                </a:r>
+                <a:r>
+                  <a:rPr lang="fr-CA" sz="2000" dirty="0">
+                    <a:latin typeface="Consolas" panose="020B0609020204030204" pitchFamily="49" charset="0"/>
+                  </a:rPr>
+                  <a:t>_</a:t>
+                </a:r>
+                <a:r>
+                  <a:rPr lang="fr-CA" sz="2000" dirty="0" err="1">
+                    <a:latin typeface="Consolas" panose="020B0609020204030204" pitchFamily="49" charset="0"/>
+                  </a:rPr>
+                  <a:t>calculer_coordonnees_fleche</a:t>
+                </a:r>
+                <a:r>
+                  <a:rPr lang="fr-CA" sz="2000" dirty="0">
+                    <a:latin typeface="Consolas" panose="020B0609020204030204" pitchFamily="49" charset="0"/>
+                  </a:rPr>
+                  <a:t>()</a:t>
+                </a:r>
+                <a:r>
+                  <a:rPr lang="fr-CA" sz="2000" dirty="0"/>
+                  <a:t> puis s'en sert pour afficher un graphique qui schématise le vecteur avec une tête en flèche.</a:t>
+                </a:r>
+              </a:p>
+            </p:txBody>
+          </p:sp>
+        </mc:Choice>
+        <mc:Fallback>
+          <p:sp>
+            <p:nvSpPr>
+              <p:cNvPr id="37" name="Content Placeholder 36">
+                <a:extLst>
+                  <a:ext uri="{FF2B5EF4-FFF2-40B4-BE49-F238E27FC236}">
+                    <a16:creationId xmlns:a16="http://schemas.microsoft.com/office/drawing/2014/main" id="{28B9F5AA-AE60-0726-04F2-1E301C17C836}"/>
+                  </a:ext>
+                </a:extLst>
+              </p:cNvPr>
+              <p:cNvSpPr>
+                <a:spLocks noGrp="1" noRot="1" noChangeAspect="1" noMove="1" noResize="1" noEditPoints="1" noAdjustHandles="1" noChangeArrowheads="1" noChangeShapeType="1" noTextEdit="1"/>
+              </p:cNvSpPr>
+              <p:nvPr>
+                <p:ph idx="1"/>
+              </p:nvPr>
+            </p:nvSpPr>
+            <p:spPr>
+              <a:blipFill>
+                <a:blip r:embed="rId4"/>
+                <a:stretch>
+                  <a:fillRect l="-638" r="-580"/>
+                </a:stretch>
+              </a:blipFill>
+            </p:spPr>
+            <p:txBody>
+              <a:bodyPr/>
+              <a:lstStyle/>
+              <a:p>
+                <a:r>
+                  <a:rPr lang="fr-CA">
+                    <a:noFill/>
+                  </a:rPr>
+                  <a:t> </a:t>
+                </a:r>
+              </a:p>
+            </p:txBody>
+          </p:sp>
+        </mc:Fallback>
+      </mc:AlternateContent>
+      <p:pic>
+        <p:nvPicPr>
+          <p:cNvPr id="1026" name="Picture 2">
+            <a:extLst>
+              <a:ext uri="{FF2B5EF4-FFF2-40B4-BE49-F238E27FC236}">
+                <a16:creationId xmlns:a16="http://schemas.microsoft.com/office/drawing/2014/main" id="{24786791-BFA3-FC8A-46C2-6141C62A3B53}"/>
+              </a:ext>
+            </a:extLst>
+          </p:cNvPr>
+          <p:cNvPicPr>
+            <a:picLocks noChangeAspect="1" noChangeArrowheads="1"/>
+          </p:cNvPicPr>
+          <p:nvPr/>
+        </p:nvPicPr>
+        <p:blipFill>
+          <a:blip r:embed="rId5">
+            <a:extLst>
+              <a:ext uri="{28A0092B-C50C-407E-A947-70E740481C1C}">
+                <a14:useLocalDpi xmlns:a14="http://schemas.microsoft.com/office/drawing/2010/main" val="0"/>
+              </a:ext>
+            </a:extLst>
+          </a:blip>
+          <a:srcRect/>
+          <a:stretch>
+            <a:fillRect/>
+          </a:stretch>
+        </p:blipFill>
+        <p:spPr bwMode="auto">
+          <a:xfrm>
+            <a:off x="6096000" y="3494643"/>
+            <a:ext cx="3785823" cy="2858400"/>
+          </a:xfrm>
+          <a:prstGeom prst="rect">
+            <a:avLst/>
+          </a:prstGeom>
+          <a:noFill/>
+          <a:extLst>
+            <a:ext uri="{909E8E84-426E-40DD-AFC4-6F175D3DCCD1}">
+              <a14:hiddenFill xmlns:a14="http://schemas.microsoft.com/office/drawing/2010/main">
+                <a:solidFill>
+                  <a:srgbClr val="FFFFFF"/>
+                </a:solidFill>
+              </a14:hiddenFill>
+            </a:ext>
+          </a:extLst>
+        </p:spPr>
+      </p:pic>
+      <p:sp>
+        <p:nvSpPr>
+          <p:cNvPr id="3" name="TextBox 2">
+            <a:extLst>
+              <a:ext uri="{FF2B5EF4-FFF2-40B4-BE49-F238E27FC236}">
+                <a16:creationId xmlns:a16="http://schemas.microsoft.com/office/drawing/2014/main" id="{FA39DC8A-A930-5CCB-BC4B-9CF27F4B7761}"/>
+              </a:ext>
+            </a:extLst>
+          </p:cNvPr>
+          <p:cNvSpPr txBox="1"/>
+          <p:nvPr/>
+        </p:nvSpPr>
+        <p:spPr>
+          <a:xfrm>
+            <a:off x="3268879" y="6352143"/>
+            <a:ext cx="1773947" cy="369332"/>
+          </a:xfrm>
+          <a:prstGeom prst="rect">
+            <a:avLst/>
+          </a:prstGeom>
+          <a:noFill/>
+        </p:spPr>
+        <p:txBody>
+          <a:bodyPr wrap="none" rtlCol="0">
+            <a:spAutoFit/>
+          </a:bodyPr>
+          <a:lstStyle/>
+          <a:p>
+            <a:r>
+              <a:rPr lang="fr-CA" dirty="0"/>
+              <a:t>paramétrisation</a:t>
+            </a:r>
+          </a:p>
+        </p:txBody>
+      </p:sp>
+      <p:sp>
+        <p:nvSpPr>
+          <p:cNvPr id="5" name="TextBox 4">
+            <a:extLst>
+              <a:ext uri="{FF2B5EF4-FFF2-40B4-BE49-F238E27FC236}">
+                <a16:creationId xmlns:a16="http://schemas.microsoft.com/office/drawing/2014/main" id="{E12814E2-9EDA-2487-6C9A-B3384037FF97}"/>
+              </a:ext>
+            </a:extLst>
+          </p:cNvPr>
+          <p:cNvSpPr txBox="1"/>
+          <p:nvPr/>
+        </p:nvSpPr>
+        <p:spPr>
+          <a:xfrm>
+            <a:off x="6096001" y="6353043"/>
+            <a:ext cx="3785822" cy="369332"/>
+          </a:xfrm>
+          <a:prstGeom prst="rect">
+            <a:avLst/>
+          </a:prstGeom>
+          <a:noFill/>
+        </p:spPr>
+        <p:txBody>
+          <a:bodyPr wrap="square" rtlCol="0">
+            <a:spAutoFit/>
+          </a:bodyPr>
+          <a:lstStyle/>
+          <a:p>
+            <a:pPr algn="ctr"/>
+            <a:r>
+              <a:rPr lang="fr-CA" dirty="0"/>
+              <a:t>graphique</a:t>
+            </a:r>
+          </a:p>
+        </p:txBody>
+      </p:sp>
+    </p:spTree>
+    <p:extLst>
+      <p:ext uri="{BB962C8B-B14F-4D97-AF65-F5344CB8AC3E}">
+        <p14:creationId xmlns:p14="http://schemas.microsoft.com/office/powerpoint/2010/main" val="2170581157"/>
+      </p:ext>
+    </p:extLst>
+  </p:cSld>
+  <p:clrMapOvr>
+    <a:masterClrMapping/>
+  </p:clrMapOvr>
+</p:sld>
+</file>
+
+<file path=ppt/slides/slide23.xml><?xml version="1.0" encoding="utf-8"?>
 <p:sld xmlns:a="http://schemas.openxmlformats.org/drawingml/2006/main" xmlns:r="http://schemas.openxmlformats.org/officeDocument/2006/relationships" xmlns:p="http://schemas.openxmlformats.org/presentationml/2006/main">
   <p:cSld>
     <p:bg>

</xml_diff>

<commit_message>
feat: Add python_2 presentation slides no.27-28
</commit_message>
<xml_diff>
--- a/python_2/presentation_python_2.pptx
+++ b/python_2/presentation_python_2.pptx
@@ -5,7 +5,7 @@
     <p:sldMasterId id="2147483648" r:id="rId1"/>
   </p:sldMasterIdLst>
   <p:notesMasterIdLst>
-    <p:notesMasterId r:id="rId29"/>
+    <p:notesMasterId r:id="rId30"/>
   </p:notesMasterIdLst>
   <p:sldIdLst>
     <p:sldId id="256" r:id="rId2"/>
@@ -34,7 +34,8 @@
     <p:sldId id="320" r:id="rId25"/>
     <p:sldId id="321" r:id="rId26"/>
     <p:sldId id="322" r:id="rId27"/>
-    <p:sldId id="297" r:id="rId28"/>
+    <p:sldId id="323" r:id="rId28"/>
+    <p:sldId id="324" r:id="rId29"/>
   </p:sldIdLst>
   <p:sldSz cx="12192000" cy="6858000"/>
   <p:notesSz cx="6858000" cy="9144000"/>
@@ -1566,6 +1567,114 @@
     <p:extLst>
       <p:ext uri="{BB962C8B-B14F-4D97-AF65-F5344CB8AC3E}">
         <p14:creationId xmlns:p14="http://schemas.microsoft.com/office/powerpoint/2010/main" val="639735978"/>
+      </p:ext>
+    </p:extLst>
+  </p:cSld>
+  <p:clrMapOvr>
+    <a:masterClrMapping/>
+  </p:clrMapOvr>
+</p:notes>
+</file>
+
+<file path=ppt/notesSlides/notesSlide19.xml><?xml version="1.0" encoding="utf-8"?>
+<p:notes xmlns:a="http://schemas.openxmlformats.org/drawingml/2006/main" xmlns:r="http://schemas.openxmlformats.org/officeDocument/2006/relationships" xmlns:p="http://schemas.openxmlformats.org/presentationml/2006/main">
+  <p:cSld>
+    <p:spTree>
+      <p:nvGrpSpPr>
+        <p:cNvPr id="1" name="">
+          <a:extLst>
+            <a:ext uri="{FF2B5EF4-FFF2-40B4-BE49-F238E27FC236}">
+              <a16:creationId xmlns:a16="http://schemas.microsoft.com/office/drawing/2014/main" id="{B608921F-6E61-68E5-1F6F-4E0C3CED41AB}"/>
+            </a:ext>
+          </a:extLst>
+        </p:cNvPr>
+        <p:cNvGrpSpPr/>
+        <p:nvPr/>
+      </p:nvGrpSpPr>
+      <p:grpSpPr>
+        <a:xfrm>
+          <a:off x="0" y="0"/>
+          <a:ext cx="0" cy="0"/>
+          <a:chOff x="0" y="0"/>
+          <a:chExt cx="0" cy="0"/>
+        </a:xfrm>
+      </p:grpSpPr>
+      <p:sp>
+        <p:nvSpPr>
+          <p:cNvPr id="2" name="Slide Image Placeholder 1">
+            <a:extLst>
+              <a:ext uri="{FF2B5EF4-FFF2-40B4-BE49-F238E27FC236}">
+                <a16:creationId xmlns:a16="http://schemas.microsoft.com/office/drawing/2014/main" id="{A3A3C3DE-E9FD-7203-974E-A3CC8A854036}"/>
+              </a:ext>
+            </a:extLst>
+          </p:cNvPr>
+          <p:cNvSpPr>
+            <a:spLocks noGrp="1" noRot="1" noChangeAspect="1"/>
+          </p:cNvSpPr>
+          <p:nvPr>
+            <p:ph type="sldImg"/>
+          </p:nvPr>
+        </p:nvSpPr>
+        <p:spPr/>
+      </p:sp>
+      <p:sp>
+        <p:nvSpPr>
+          <p:cNvPr id="3" name="Notes Placeholder 2">
+            <a:extLst>
+              <a:ext uri="{FF2B5EF4-FFF2-40B4-BE49-F238E27FC236}">
+                <a16:creationId xmlns:a16="http://schemas.microsoft.com/office/drawing/2014/main" id="{0004CE56-9F4D-E9BB-5AC3-6594CD2872EC}"/>
+              </a:ext>
+            </a:extLst>
+          </p:cNvPr>
+          <p:cNvSpPr>
+            <a:spLocks noGrp="1"/>
+          </p:cNvSpPr>
+          <p:nvPr>
+            <p:ph type="body" idx="1"/>
+          </p:nvPr>
+        </p:nvSpPr>
+        <p:spPr/>
+        <p:txBody>
+          <a:bodyPr/>
+          <a:lstStyle/>
+          <a:p>
+            <a:endParaRPr lang="fr-CA" dirty="0"/>
+          </a:p>
+        </p:txBody>
+      </p:sp>
+      <p:sp>
+        <p:nvSpPr>
+          <p:cNvPr id="4" name="Slide Number Placeholder 3">
+            <a:extLst>
+              <a:ext uri="{FF2B5EF4-FFF2-40B4-BE49-F238E27FC236}">
+                <a16:creationId xmlns:a16="http://schemas.microsoft.com/office/drawing/2014/main" id="{3D222D96-619A-4763-8780-0F24BFF4E4B8}"/>
+              </a:ext>
+            </a:extLst>
+          </p:cNvPr>
+          <p:cNvSpPr>
+            <a:spLocks noGrp="1"/>
+          </p:cNvSpPr>
+          <p:nvPr>
+            <p:ph type="sldNum" sz="quarter" idx="5"/>
+          </p:nvPr>
+        </p:nvSpPr>
+        <p:spPr/>
+        <p:txBody>
+          <a:bodyPr/>
+          <a:lstStyle/>
+          <a:p>
+            <a:fld id="{D755565A-1FEC-4FFE-8425-B731D92946D0}" type="slidenum">
+              <a:rPr lang="fr-CA" smtClean="0"/>
+              <a:t>28</a:t>
+            </a:fld>
+            <a:endParaRPr lang="fr-CA"/>
+          </a:p>
+        </p:txBody>
+      </p:sp>
+    </p:spTree>
+    <p:extLst>
+      <p:ext uri="{BB962C8B-B14F-4D97-AF65-F5344CB8AC3E}">
+        <p14:creationId xmlns:p14="http://schemas.microsoft.com/office/powerpoint/2010/main" val="3714194022"/>
       </p:ext>
     </p:extLst>
   </p:cSld>
@@ -21763,20 +21872,12 @@
 <file path=ppt/slides/slide27.xml><?xml version="1.0" encoding="utf-8"?>
 <p:sld xmlns:a="http://schemas.openxmlformats.org/drawingml/2006/main" xmlns:r="http://schemas.openxmlformats.org/officeDocument/2006/relationships" xmlns:p="http://schemas.openxmlformats.org/presentationml/2006/main">
   <p:cSld>
-    <p:bg>
-      <p:bgPr>
-        <a:solidFill>
-          <a:srgbClr val="FFFF00"/>
-        </a:solidFill>
-        <a:effectLst/>
-      </p:bgPr>
-    </p:bg>
     <p:spTree>
       <p:nvGrpSpPr>
         <p:cNvPr id="1" name="">
           <a:extLst>
             <a:ext uri="{FF2B5EF4-FFF2-40B4-BE49-F238E27FC236}">
-              <a16:creationId xmlns:a16="http://schemas.microsoft.com/office/drawing/2014/main" id="{A79EE80B-5617-3AC9-1D3D-FF9406939B6B}"/>
+              <a16:creationId xmlns:a16="http://schemas.microsoft.com/office/drawing/2014/main" id="{556803D2-DF33-7CD7-D453-FE57FF51E788}"/>
             </a:ext>
           </a:extLst>
         </p:cNvPr>
@@ -21793,100 +21894,814 @@
       </p:grpSpPr>
       <p:sp>
         <p:nvSpPr>
-          <p:cNvPr id="15" name="Rectangle 14">
+          <p:cNvPr id="3" name="Subtitle 2">
             <a:extLst>
               <a:ext uri="{FF2B5EF4-FFF2-40B4-BE49-F238E27FC236}">
-                <a16:creationId xmlns:a16="http://schemas.microsoft.com/office/drawing/2014/main" id="{AED2F8D1-AEB0-E659-5BE9-F91783BAB484}"/>
+                <a16:creationId xmlns:a16="http://schemas.microsoft.com/office/drawing/2014/main" id="{FDD2C54F-40A5-18AC-E2DA-3126D8540F2C}"/>
               </a:ext>
             </a:extLst>
           </p:cNvPr>
-          <p:cNvSpPr/>
-          <p:nvPr/>
+          <p:cNvSpPr>
+            <a:spLocks noGrp="1"/>
+          </p:cNvSpPr>
+          <p:nvPr>
+            <p:ph type="subTitle" idx="1"/>
+          </p:nvPr>
         </p:nvSpPr>
         <p:spPr>
           <a:xfrm>
-            <a:off x="5732834" y="3357820"/>
-            <a:ext cx="726332" cy="142360"/>
+            <a:off x="1524000" y="2202362"/>
+            <a:ext cx="9144000" cy="2181569"/>
           </a:xfrm>
-          <a:prstGeom prst="rect">
-            <a:avLst/>
-          </a:prstGeom>
         </p:spPr>
-        <p:style>
-          <a:lnRef idx="2">
-            <a:schemeClr val="accent1">
-              <a:shade val="15000"/>
-            </a:schemeClr>
-          </a:lnRef>
-          <a:fillRef idx="1">
-            <a:schemeClr val="accent1"/>
-          </a:fillRef>
-          <a:effectRef idx="0">
-            <a:schemeClr val="accent1"/>
-          </a:effectRef>
-          <a:fontRef idx="minor">
-            <a:schemeClr val="lt1"/>
-          </a:fontRef>
-        </p:style>
         <p:txBody>
-          <a:bodyPr rtlCol="0" anchor="ctr"/>
+          <a:bodyPr anchor="ctr">
+            <a:normAutofit/>
+          </a:bodyPr>
           <a:lstStyle/>
           <a:p>
-            <a:pPr algn="ctr"/>
-            <a:endParaRPr lang="fr-CA"/>
-          </a:p>
-        </p:txBody>
-      </p:sp>
-      <p:sp>
-        <p:nvSpPr>
-          <p:cNvPr id="2" name="Rectangle 1">
-            <a:extLst>
-              <a:ext uri="{FF2B5EF4-FFF2-40B4-BE49-F238E27FC236}">
-                <a16:creationId xmlns:a16="http://schemas.microsoft.com/office/drawing/2014/main" id="{DF179609-0D20-7919-F3E7-E44EC67D7DAF}"/>
-              </a:ext>
-            </a:extLst>
-          </p:cNvPr>
-          <p:cNvSpPr/>
-          <p:nvPr/>
-        </p:nvSpPr>
-        <p:spPr>
-          <a:xfrm>
-            <a:off x="5732834" y="3665863"/>
-            <a:ext cx="726332" cy="360000"/>
-          </a:xfrm>
-          <a:prstGeom prst="rect">
-            <a:avLst/>
-          </a:prstGeom>
-        </p:spPr>
-        <p:style>
-          <a:lnRef idx="2">
-            <a:schemeClr val="accent1">
-              <a:shade val="15000"/>
-            </a:schemeClr>
-          </a:lnRef>
-          <a:fillRef idx="1">
-            <a:schemeClr val="accent1"/>
-          </a:fillRef>
-          <a:effectRef idx="0">
-            <a:schemeClr val="accent1"/>
-          </a:effectRef>
-          <a:fontRef idx="minor">
-            <a:schemeClr val="lt1"/>
-          </a:fontRef>
-        </p:style>
-        <p:txBody>
-          <a:bodyPr rtlCol="0" anchor="ctr"/>
-          <a:lstStyle/>
-          <a:p>
-            <a:pPr algn="ctr"/>
-            <a:endParaRPr lang="fr-CA"/>
+            <a:r>
+              <a:rPr lang="fr-CA" sz="2800" b="1" dirty="0">
+                <a:latin typeface="Consolas" panose="020B0609020204030204" pitchFamily="49" charset="0"/>
+              </a:rPr>
+              <a:t>Si le temps le permet ...</a:t>
+            </a:r>
           </a:p>
         </p:txBody>
       </p:sp>
     </p:spTree>
     <p:extLst>
       <p:ext uri="{BB962C8B-B14F-4D97-AF65-F5344CB8AC3E}">
-        <p14:creationId xmlns:p14="http://schemas.microsoft.com/office/powerpoint/2010/main" val="2781789880"/>
+        <p14:creationId xmlns:p14="http://schemas.microsoft.com/office/powerpoint/2010/main" val="1519317609"/>
+      </p:ext>
+    </p:extLst>
+  </p:cSld>
+  <p:clrMapOvr>
+    <a:masterClrMapping/>
+  </p:clrMapOvr>
+</p:sld>
+</file>
+
+<file path=ppt/slides/slide28.xml><?xml version="1.0" encoding="utf-8"?>
+<p:sld xmlns:a="http://schemas.openxmlformats.org/drawingml/2006/main" xmlns:r="http://schemas.openxmlformats.org/officeDocument/2006/relationships" xmlns:p="http://schemas.openxmlformats.org/presentationml/2006/main">
+  <p:cSld>
+    <p:bg>
+      <p:bgPr>
+        <a:solidFill>
+          <a:srgbClr val="F5F5F5"/>
+        </a:solidFill>
+        <a:effectLst/>
+      </p:bgPr>
+    </p:bg>
+    <p:spTree>
+      <p:nvGrpSpPr>
+        <p:cNvPr id="1" name="">
+          <a:extLst>
+            <a:ext uri="{FF2B5EF4-FFF2-40B4-BE49-F238E27FC236}">
+              <a16:creationId xmlns:a16="http://schemas.microsoft.com/office/drawing/2014/main" id="{023C7187-7C2C-2CDD-7F80-80A102FE9EAE}"/>
+            </a:ext>
+          </a:extLst>
+        </p:cNvPr>
+        <p:cNvGrpSpPr/>
+        <p:nvPr/>
+      </p:nvGrpSpPr>
+      <p:grpSpPr>
+        <a:xfrm>
+          <a:off x="0" y="0"/>
+          <a:ext cx="0" cy="0"/>
+          <a:chOff x="0" y="0"/>
+          <a:chExt cx="0" cy="0"/>
+        </a:xfrm>
+      </p:grpSpPr>
+      <p:sp>
+        <p:nvSpPr>
+          <p:cNvPr id="24" name="Title 1">
+            <a:extLst>
+              <a:ext uri="{FF2B5EF4-FFF2-40B4-BE49-F238E27FC236}">
+                <a16:creationId xmlns:a16="http://schemas.microsoft.com/office/drawing/2014/main" id="{0F82D228-3393-7B87-8871-18EFB2162AA5}"/>
+              </a:ext>
+            </a:extLst>
+          </p:cNvPr>
+          <p:cNvSpPr>
+            <a:spLocks noGrp="1"/>
+          </p:cNvSpPr>
+          <p:nvPr>
+            <p:ph type="title"/>
+          </p:nvPr>
+        </p:nvSpPr>
+        <p:spPr>
+          <a:xfrm>
+            <a:off x="838200" y="365125"/>
+            <a:ext cx="10515600" cy="1325563"/>
+          </a:xfrm>
+        </p:spPr>
+        <p:txBody>
+          <a:bodyPr/>
+          <a:lstStyle/>
+          <a:p>
+            <a:r>
+              <a:rPr lang="fr-CA" dirty="0">
+                <a:latin typeface="Arial Rounded MT Bold" panose="020F0704030504030204" pitchFamily="34" charset="0"/>
+              </a:rPr>
+              <a:t>CSV, JSON et YAML</a:t>
+            </a:r>
+          </a:p>
+        </p:txBody>
+      </p:sp>
+      <p:sp>
+        <p:nvSpPr>
+          <p:cNvPr id="26" name="Slide Number Placeholder 4">
+            <a:extLst>
+              <a:ext uri="{FF2B5EF4-FFF2-40B4-BE49-F238E27FC236}">
+                <a16:creationId xmlns:a16="http://schemas.microsoft.com/office/drawing/2014/main" id="{A6E00FC1-A70D-913C-646B-45268C820CBE}"/>
+              </a:ext>
+            </a:extLst>
+          </p:cNvPr>
+          <p:cNvSpPr>
+            <a:spLocks noGrp="1"/>
+          </p:cNvSpPr>
+          <p:nvPr>
+            <p:ph type="sldNum" sz="quarter" idx="12"/>
+          </p:nvPr>
+        </p:nvSpPr>
+        <p:spPr>
+          <a:xfrm>
+            <a:off x="8610600" y="6356350"/>
+            <a:ext cx="2743200" cy="365125"/>
+          </a:xfrm>
+        </p:spPr>
+        <p:txBody>
+          <a:bodyPr/>
+          <a:lstStyle/>
+          <a:p>
+            <a:fld id="{846B06B1-1179-491F-A487-8E0C403F7C13}" type="slidenum">
+              <a:rPr lang="fr-CA" smtClean="0"/>
+              <a:t>28</a:t>
+            </a:fld>
+            <a:endParaRPr lang="fr-CA" dirty="0"/>
+          </a:p>
+        </p:txBody>
+      </p:sp>
+      <mc:AlternateContent xmlns:mc="http://schemas.openxmlformats.org/markup-compatibility/2006">
+        <mc:Choice xmlns:a14="http://schemas.microsoft.com/office/drawing/2010/main" Requires="a14">
+          <p:sp>
+            <p:nvSpPr>
+              <p:cNvPr id="6" name="Content Placeholder 1">
+                <a:extLst>
+                  <a:ext uri="{FF2B5EF4-FFF2-40B4-BE49-F238E27FC236}">
+                    <a16:creationId xmlns:a16="http://schemas.microsoft.com/office/drawing/2014/main" id="{816AD0E0-E4E4-E7E6-4B10-28490E874796}"/>
+                  </a:ext>
+                </a:extLst>
+              </p:cNvPr>
+              <p:cNvSpPr>
+                <a:spLocks noGrp="1"/>
+              </p:cNvSpPr>
+              <p:nvPr>
+                <p:ph idx="1"/>
+              </p:nvPr>
+            </p:nvSpPr>
+            <p:spPr>
+              <a:xfrm>
+                <a:off x="838200" y="1825625"/>
+                <a:ext cx="10515600" cy="4351338"/>
+              </a:xfrm>
+            </p:spPr>
+            <p:txBody>
+              <a:bodyPr/>
+              <a:lstStyle/>
+              <a:p>
+                <a:pPr>
+                  <a:lnSpc>
+                    <a:spcPct val="100000"/>
+                  </a:lnSpc>
+                </a:pPr>
+                <a:r>
+                  <a:rPr lang="fr-CA" dirty="0"/>
+                  <a:t>Formats optimisés selon les usages:</a:t>
+                </a:r>
+              </a:p>
+              <a:p>
+                <a:pPr lvl="1">
+                  <a:lnSpc>
+                    <a:spcPct val="100000"/>
+                  </a:lnSpc>
+                </a:pPr>
+                <a:r>
+                  <a:rPr lang="fr-CA" b="1" dirty="0"/>
+                  <a:t>CSV</a:t>
+                </a:r>
+                <a:r>
+                  <a:rPr lang="fr-CA" dirty="0"/>
+                  <a:t>: Données tabulaires (ex: Excel) </a:t>
+                </a:r>
+                <a14:m>
+                  <m:oMath xmlns:m="http://schemas.openxmlformats.org/officeDocument/2006/math">
+                    <m:r>
+                      <a:rPr lang="fr-CA" i="1" smtClean="0">
+                        <a:latin typeface="Cambria Math" panose="02040503050406030204" pitchFamily="18" charset="0"/>
+                        <a:ea typeface="Cambria Math" panose="02040503050406030204" pitchFamily="18" charset="0"/>
+                      </a:rPr>
+                      <m:t>→</m:t>
+                    </m:r>
+                  </m:oMath>
+                </a14:m>
+                <a:r>
+                  <a:rPr lang="fr-CA" dirty="0"/>
+                  <a:t> </a:t>
+                </a:r>
+                <a:r>
+                  <a:rPr lang="fr-CA" b="1" dirty="0">
+                    <a:latin typeface="Consolas" panose="020B0609020204030204" pitchFamily="49" charset="0"/>
+                  </a:rPr>
+                  <a:t>import csv</a:t>
+                </a:r>
+              </a:p>
+              <a:p>
+                <a:pPr lvl="1">
+                  <a:lnSpc>
+                    <a:spcPct val="100000"/>
+                  </a:lnSpc>
+                </a:pPr>
+                <a:r>
+                  <a:rPr lang="fr-CA" b="1" dirty="0"/>
+                  <a:t>JSON</a:t>
+                </a:r>
+                <a:r>
+                  <a:rPr lang="fr-CA" dirty="0"/>
+                  <a:t>: Données structurées (ex: dictionnaires) </a:t>
+                </a:r>
+                <a14:m>
+                  <m:oMath xmlns:m="http://schemas.openxmlformats.org/officeDocument/2006/math">
+                    <m:r>
+                      <a:rPr lang="fr-CA" i="1">
+                        <a:latin typeface="Cambria Math" panose="02040503050406030204" pitchFamily="18" charset="0"/>
+                        <a:ea typeface="Cambria Math" panose="02040503050406030204" pitchFamily="18" charset="0"/>
+                      </a:rPr>
+                      <m:t>→</m:t>
+                    </m:r>
+                  </m:oMath>
+                </a14:m>
+                <a:r>
+                  <a:rPr lang="fr-CA" dirty="0"/>
+                  <a:t> </a:t>
+                </a:r>
+                <a:r>
+                  <a:rPr lang="fr-CA" b="1" dirty="0">
+                    <a:latin typeface="Consolas" panose="020B0609020204030204" pitchFamily="49" charset="0"/>
+                  </a:rPr>
+                  <a:t>import </a:t>
+                </a:r>
+                <a:r>
+                  <a:rPr lang="fr-CA" b="1" dirty="0" err="1">
+                    <a:latin typeface="Consolas" panose="020B0609020204030204" pitchFamily="49" charset="0"/>
+                  </a:rPr>
+                  <a:t>json</a:t>
+                </a:r>
+                <a:endParaRPr lang="fr-CA" b="1" dirty="0"/>
+              </a:p>
+              <a:p>
+                <a:pPr lvl="1">
+                  <a:lnSpc>
+                    <a:spcPct val="100000"/>
+                  </a:lnSpc>
+                </a:pPr>
+                <a:r>
+                  <a:rPr lang="fr-CA" b="1" dirty="0"/>
+                  <a:t>YAML</a:t>
+                </a:r>
+                <a:r>
+                  <a:rPr lang="fr-CA" dirty="0"/>
+                  <a:t>: Souvent utilisé pour des configurations </a:t>
+                </a:r>
+                <a14:m>
+                  <m:oMath xmlns:m="http://schemas.openxmlformats.org/officeDocument/2006/math">
+                    <m:r>
+                      <a:rPr lang="fr-CA" i="1">
+                        <a:latin typeface="Cambria Math" panose="02040503050406030204" pitchFamily="18" charset="0"/>
+                        <a:ea typeface="Cambria Math" panose="02040503050406030204" pitchFamily="18" charset="0"/>
+                      </a:rPr>
+                      <m:t>→</m:t>
+                    </m:r>
+                  </m:oMath>
+                </a14:m>
+                <a:r>
+                  <a:rPr lang="fr-CA" dirty="0"/>
+                  <a:t> </a:t>
+                </a:r>
+                <a:r>
+                  <a:rPr lang="fr-CA" b="1" dirty="0">
+                    <a:latin typeface="Consolas" panose="020B0609020204030204" pitchFamily="49" charset="0"/>
+                  </a:rPr>
+                  <a:t>import </a:t>
+                </a:r>
+                <a:r>
+                  <a:rPr lang="fr-CA" b="1" dirty="0" err="1">
+                    <a:latin typeface="Consolas" panose="020B0609020204030204" pitchFamily="49" charset="0"/>
+                  </a:rPr>
+                  <a:t>yaml</a:t>
+                </a:r>
+                <a:endParaRPr lang="fr-CA" b="1" dirty="0">
+                  <a:latin typeface="Consolas" panose="020B0609020204030204" pitchFamily="49" charset="0"/>
+                </a:endParaRPr>
+              </a:p>
+            </p:txBody>
+          </p:sp>
+        </mc:Choice>
+        <mc:Fallback>
+          <p:sp>
+            <p:nvSpPr>
+              <p:cNvPr id="6" name="Content Placeholder 1">
+                <a:extLst>
+                  <a:ext uri="{FF2B5EF4-FFF2-40B4-BE49-F238E27FC236}">
+                    <a16:creationId xmlns:a16="http://schemas.microsoft.com/office/drawing/2014/main" id="{816AD0E0-E4E4-E7E6-4B10-28490E874796}"/>
+                  </a:ext>
+                </a:extLst>
+              </p:cNvPr>
+              <p:cNvSpPr>
+                <a:spLocks noGrp="1" noRot="1" noChangeAspect="1" noMove="1" noResize="1" noEditPoints="1" noAdjustHandles="1" noChangeArrowheads="1" noChangeShapeType="1" noTextEdit="1"/>
+              </p:cNvSpPr>
+              <p:nvPr>
+                <p:ph idx="1"/>
+              </p:nvPr>
+            </p:nvSpPr>
+            <p:spPr>
+              <a:xfrm>
+                <a:off x="838200" y="1825625"/>
+                <a:ext cx="10515600" cy="4351338"/>
+              </a:xfrm>
+              <a:blipFill>
+                <a:blip r:embed="rId3"/>
+                <a:stretch>
+                  <a:fillRect l="-1043" t="-1401"/>
+                </a:stretch>
+              </a:blipFill>
+            </p:spPr>
+            <p:txBody>
+              <a:bodyPr/>
+              <a:lstStyle/>
+              <a:p>
+                <a:r>
+                  <a:rPr lang="fr-CA">
+                    <a:noFill/>
+                  </a:rPr>
+                  <a:t> </a:t>
+                </a:r>
+              </a:p>
+            </p:txBody>
+          </p:sp>
+        </mc:Fallback>
+      </mc:AlternateContent>
+      <p:grpSp>
+        <p:nvGrpSpPr>
+          <p:cNvPr id="12" name="Group 11">
+            <a:extLst>
+              <a:ext uri="{FF2B5EF4-FFF2-40B4-BE49-F238E27FC236}">
+                <a16:creationId xmlns:a16="http://schemas.microsoft.com/office/drawing/2014/main" id="{7E02F405-3002-144D-0333-3F4F827B3B78}"/>
+              </a:ext>
+            </a:extLst>
+          </p:cNvPr>
+          <p:cNvGrpSpPr/>
+          <p:nvPr/>
+        </p:nvGrpSpPr>
+        <p:grpSpPr>
+          <a:xfrm>
+            <a:off x="3025806" y="4001294"/>
+            <a:ext cx="6140388" cy="2175668"/>
+            <a:chOff x="1755612" y="4001294"/>
+            <a:chExt cx="6140388" cy="2175668"/>
+          </a:xfrm>
+        </p:grpSpPr>
+        <p:sp>
+          <p:nvSpPr>
+            <p:cNvPr id="2" name="Google Shape;370;p19">
+              <a:extLst>
+                <a:ext uri="{FF2B5EF4-FFF2-40B4-BE49-F238E27FC236}">
+                  <a16:creationId xmlns:a16="http://schemas.microsoft.com/office/drawing/2014/main" id="{DC8366B3-8EFC-5475-934C-734DA6D0F31C}"/>
+                </a:ext>
+              </a:extLst>
+            </p:cNvPr>
+            <p:cNvSpPr/>
+            <p:nvPr/>
+          </p:nvSpPr>
+          <p:spPr>
+            <a:xfrm>
+              <a:off x="1755612" y="4376655"/>
+              <a:ext cx="1800000" cy="1800306"/>
+            </a:xfrm>
+            <a:prstGeom prst="rect">
+              <a:avLst/>
+            </a:prstGeom>
+            <a:solidFill>
+              <a:schemeClr val="bg1"/>
+            </a:solidFill>
+            <a:ln w="12700" cap="flat" cmpd="sng">
+              <a:solidFill>
+                <a:srgbClr val="7F7F7F"/>
+              </a:solidFill>
+              <a:prstDash val="solid"/>
+              <a:miter lim="800000"/>
+              <a:headEnd type="none" w="sm" len="sm"/>
+              <a:tailEnd type="none" w="sm" len="sm"/>
+            </a:ln>
+          </p:spPr>
+          <p:txBody>
+            <a:bodyPr spcFirstLastPara="1" wrap="square" lIns="91425" tIns="45700" rIns="91425" bIns="45700" anchor="ctr" anchorCtr="0">
+              <a:noAutofit/>
+            </a:bodyPr>
+            <a:lstStyle/>
+            <a:p>
+              <a:r>
+                <a:rPr lang="fr-FR" sz="1400" dirty="0">
+                  <a:latin typeface="Consolas" panose="020B0609020204030204" pitchFamily="49" charset="0"/>
+                </a:rPr>
+                <a:t>1,2,3,4,5</a:t>
+              </a:r>
+            </a:p>
+            <a:p>
+              <a:endParaRPr lang="fr-FR" sz="1400" dirty="0">
+                <a:latin typeface="Consolas" panose="020B0609020204030204" pitchFamily="49" charset="0"/>
+              </a:endParaRPr>
+            </a:p>
+            <a:p>
+              <a:endParaRPr lang="fr-FR" sz="1400" dirty="0">
+                <a:latin typeface="Consolas" panose="020B0609020204030204" pitchFamily="49" charset="0"/>
+              </a:endParaRPr>
+            </a:p>
+            <a:p>
+              <a:endParaRPr lang="fr-FR" sz="1400" dirty="0">
+                <a:latin typeface="Consolas" panose="020B0609020204030204" pitchFamily="49" charset="0"/>
+              </a:endParaRPr>
+            </a:p>
+            <a:p>
+              <a:endParaRPr lang="fr-FR" sz="1400" dirty="0">
+                <a:latin typeface="Consolas" panose="020B0609020204030204" pitchFamily="49" charset="0"/>
+              </a:endParaRPr>
+            </a:p>
+            <a:p>
+              <a:endParaRPr lang="fr-FR" sz="1400" dirty="0">
+                <a:latin typeface="Consolas" panose="020B0609020204030204" pitchFamily="49" charset="0"/>
+              </a:endParaRPr>
+            </a:p>
+            <a:p>
+              <a:endParaRPr lang="fr-FR" sz="1400" dirty="0">
+                <a:latin typeface="Consolas" panose="020B0609020204030204" pitchFamily="49" charset="0"/>
+              </a:endParaRPr>
+            </a:p>
+          </p:txBody>
+        </p:sp>
+        <p:sp>
+          <p:nvSpPr>
+            <p:cNvPr id="3" name="Google Shape;370;p19">
+              <a:extLst>
+                <a:ext uri="{FF2B5EF4-FFF2-40B4-BE49-F238E27FC236}">
+                  <a16:creationId xmlns:a16="http://schemas.microsoft.com/office/drawing/2014/main" id="{DCFF5B87-465C-5AB0-C0F8-438037314AA9}"/>
+                </a:ext>
+              </a:extLst>
+            </p:cNvPr>
+            <p:cNvSpPr/>
+            <p:nvPr/>
+          </p:nvSpPr>
+          <p:spPr>
+            <a:xfrm>
+              <a:off x="3917323" y="4376656"/>
+              <a:ext cx="1800000" cy="1800306"/>
+            </a:xfrm>
+            <a:prstGeom prst="rect">
+              <a:avLst/>
+            </a:prstGeom>
+            <a:solidFill>
+              <a:schemeClr val="bg1"/>
+            </a:solidFill>
+            <a:ln w="12700" cap="flat" cmpd="sng">
+              <a:solidFill>
+                <a:srgbClr val="7F7F7F"/>
+              </a:solidFill>
+              <a:prstDash val="solid"/>
+              <a:miter lim="800000"/>
+              <a:headEnd type="none" w="sm" len="sm"/>
+              <a:tailEnd type="none" w="sm" len="sm"/>
+            </a:ln>
+          </p:spPr>
+          <p:txBody>
+            <a:bodyPr spcFirstLastPara="1" wrap="square" lIns="91425" tIns="45700" rIns="91425" bIns="45700" anchor="ctr" anchorCtr="0">
+              <a:noAutofit/>
+            </a:bodyPr>
+            <a:lstStyle/>
+            <a:p>
+              <a:r>
+                <a:rPr lang="en-CA" sz="1400" dirty="0">
+                  <a:latin typeface="Consolas" panose="020B0609020204030204" pitchFamily="49" charset="0"/>
+                </a:rPr>
+                <a:t>{  </a:t>
+              </a:r>
+            </a:p>
+            <a:p>
+              <a:r>
+                <a:rPr lang="en-CA" sz="1400" dirty="0">
+                  <a:latin typeface="Consolas" panose="020B0609020204030204" pitchFamily="49" charset="0"/>
+                </a:rPr>
+                <a:t>  "</a:t>
+              </a:r>
+              <a:r>
+                <a:rPr lang="en-CA" sz="1400" dirty="0" err="1">
+                  <a:latin typeface="Consolas" panose="020B0609020204030204" pitchFamily="49" charset="0"/>
+                </a:rPr>
+                <a:t>vecteur</a:t>
+              </a:r>
+              <a:r>
+                <a:rPr lang="en-CA" sz="1400" dirty="0">
+                  <a:latin typeface="Consolas" panose="020B0609020204030204" pitchFamily="49" charset="0"/>
+                </a:rPr>
+                <a:t>": {    </a:t>
+              </a:r>
+            </a:p>
+            <a:p>
+              <a:r>
+                <a:rPr lang="en-CA" sz="1400" dirty="0">
+                  <a:latin typeface="Consolas" panose="020B0609020204030204" pitchFamily="49" charset="0"/>
+                </a:rPr>
+                <a:t>    "dx": 3,    </a:t>
+              </a:r>
+            </a:p>
+            <a:p>
+              <a:r>
+                <a:rPr lang="en-CA" sz="1400" dirty="0">
+                  <a:latin typeface="Consolas" panose="020B0609020204030204" pitchFamily="49" charset="0"/>
+                </a:rPr>
+                <a:t>    "</a:t>
+              </a:r>
+              <a:r>
+                <a:rPr lang="en-CA" sz="1400" dirty="0" err="1">
+                  <a:latin typeface="Consolas" panose="020B0609020204030204" pitchFamily="49" charset="0"/>
+                </a:rPr>
+                <a:t>dy</a:t>
+              </a:r>
+              <a:r>
+                <a:rPr lang="en-CA" sz="1400" dirty="0">
+                  <a:latin typeface="Consolas" panose="020B0609020204030204" pitchFamily="49" charset="0"/>
+                </a:rPr>
+                <a:t>": 4,    </a:t>
+              </a:r>
+            </a:p>
+            <a:p>
+              <a:r>
+                <a:rPr lang="en-CA" sz="1400" dirty="0">
+                  <a:latin typeface="Consolas" panose="020B0609020204030204" pitchFamily="49" charset="0"/>
+                </a:rPr>
+                <a:t>    "</a:t>
+              </a:r>
+              <a:r>
+                <a:rPr lang="en-CA" sz="1400" dirty="0" err="1">
+                  <a:latin typeface="Consolas" panose="020B0609020204030204" pitchFamily="49" charset="0"/>
+                </a:rPr>
+                <a:t>norme</a:t>
+              </a:r>
+              <a:r>
+                <a:rPr lang="en-CA" sz="1400" dirty="0">
+                  <a:latin typeface="Consolas" panose="020B0609020204030204" pitchFamily="49" charset="0"/>
+                </a:rPr>
+                <a:t>": 5  </a:t>
+              </a:r>
+            </a:p>
+            <a:p>
+              <a:r>
+                <a:rPr lang="en-CA" sz="1400" dirty="0">
+                  <a:latin typeface="Consolas" panose="020B0609020204030204" pitchFamily="49" charset="0"/>
+                </a:rPr>
+                <a:t>  }</a:t>
+              </a:r>
+            </a:p>
+            <a:p>
+              <a:r>
+                <a:rPr lang="en-CA" sz="1400" dirty="0">
+                  <a:latin typeface="Consolas" panose="020B0609020204030204" pitchFamily="49" charset="0"/>
+                </a:rPr>
+                <a:t>}</a:t>
+              </a:r>
+              <a:endParaRPr lang="fr-FR" sz="1400" dirty="0">
+                <a:latin typeface="Consolas" panose="020B0609020204030204" pitchFamily="49" charset="0"/>
+              </a:endParaRPr>
+            </a:p>
+          </p:txBody>
+        </p:sp>
+        <p:sp>
+          <p:nvSpPr>
+            <p:cNvPr id="4" name="Google Shape;370;p19">
+              <a:extLst>
+                <a:ext uri="{FF2B5EF4-FFF2-40B4-BE49-F238E27FC236}">
+                  <a16:creationId xmlns:a16="http://schemas.microsoft.com/office/drawing/2014/main" id="{0C5F38F3-85E4-B19B-02F9-229B4B664D3D}"/>
+                </a:ext>
+              </a:extLst>
+            </p:cNvPr>
+            <p:cNvSpPr/>
+            <p:nvPr/>
+          </p:nvSpPr>
+          <p:spPr>
+            <a:xfrm>
+              <a:off x="6096000" y="4376655"/>
+              <a:ext cx="1800000" cy="1800305"/>
+            </a:xfrm>
+            <a:prstGeom prst="rect">
+              <a:avLst/>
+            </a:prstGeom>
+            <a:solidFill>
+              <a:schemeClr val="bg1"/>
+            </a:solidFill>
+            <a:ln w="12700" cap="flat" cmpd="sng">
+              <a:solidFill>
+                <a:srgbClr val="7F7F7F"/>
+              </a:solidFill>
+              <a:prstDash val="solid"/>
+              <a:miter lim="800000"/>
+              <a:headEnd type="none" w="sm" len="sm"/>
+              <a:tailEnd type="none" w="sm" len="sm"/>
+            </a:ln>
+          </p:spPr>
+          <p:txBody>
+            <a:bodyPr spcFirstLastPara="1" wrap="square" lIns="91425" tIns="45700" rIns="91425" bIns="45700" anchor="ctr" anchorCtr="0">
+              <a:noAutofit/>
+            </a:bodyPr>
+            <a:lstStyle/>
+            <a:p>
+              <a:r>
+                <a:rPr lang="en-CA" sz="1400" dirty="0">
+                  <a:latin typeface="Consolas" panose="020B0609020204030204" pitchFamily="49" charset="0"/>
+                </a:rPr>
+                <a:t>options:</a:t>
+              </a:r>
+            </a:p>
+            <a:p>
+              <a:r>
+                <a:rPr lang="en-CA" sz="1400" dirty="0">
+                  <a:latin typeface="Consolas" panose="020B0609020204030204" pitchFamily="49" charset="0"/>
+                </a:rPr>
+                <a:t>  number: 1</a:t>
+              </a:r>
+            </a:p>
+            <a:p>
+              <a:r>
+                <a:rPr lang="en-CA" sz="1400" dirty="0">
+                  <a:latin typeface="Consolas" panose="020B0609020204030204" pitchFamily="49" charset="0"/>
+                </a:rPr>
+                <a:t>  repeat: 3</a:t>
+              </a:r>
+            </a:p>
+            <a:p>
+              <a:endParaRPr lang="en-CA" sz="1400" dirty="0">
+                <a:latin typeface="Consolas" panose="020B0609020204030204" pitchFamily="49" charset="0"/>
+              </a:endParaRPr>
+            </a:p>
+            <a:p>
+              <a:endParaRPr lang="en-CA" sz="1400" dirty="0">
+                <a:latin typeface="Consolas" panose="020B0609020204030204" pitchFamily="49" charset="0"/>
+              </a:endParaRPr>
+            </a:p>
+            <a:p>
+              <a:endParaRPr lang="en-CA" sz="1400" dirty="0">
+                <a:latin typeface="Consolas" panose="020B0609020204030204" pitchFamily="49" charset="0"/>
+              </a:endParaRPr>
+            </a:p>
+            <a:p>
+              <a:endParaRPr lang="en-CA" sz="1400" dirty="0">
+                <a:latin typeface="Consolas" panose="020B0609020204030204" pitchFamily="49" charset="0"/>
+              </a:endParaRPr>
+            </a:p>
+          </p:txBody>
+        </p:sp>
+        <p:sp>
+          <p:nvSpPr>
+            <p:cNvPr id="7" name="TextBox 6">
+              <a:extLst>
+                <a:ext uri="{FF2B5EF4-FFF2-40B4-BE49-F238E27FC236}">
+                  <a16:creationId xmlns:a16="http://schemas.microsoft.com/office/drawing/2014/main" id="{E1D767B7-CBCB-1863-A815-BF994DFBA364}"/>
+                </a:ext>
+              </a:extLst>
+            </p:cNvPr>
+            <p:cNvSpPr txBox="1"/>
+            <p:nvPr/>
+          </p:nvSpPr>
+          <p:spPr>
+            <a:xfrm>
+              <a:off x="1755612" y="4001294"/>
+              <a:ext cx="1800000" cy="369332"/>
+            </a:xfrm>
+            <a:prstGeom prst="rect">
+              <a:avLst/>
+            </a:prstGeom>
+            <a:noFill/>
+          </p:spPr>
+          <p:txBody>
+            <a:bodyPr wrap="square">
+              <a:spAutoFit/>
+            </a:bodyPr>
+            <a:lstStyle/>
+            <a:p>
+              <a:pPr algn="ctr"/>
+              <a:r>
+                <a:rPr lang="fr-CA" dirty="0">
+                  <a:latin typeface="Consolas" panose="020B0609020204030204" pitchFamily="49" charset="0"/>
+                </a:rPr>
+                <a:t>fichier</a:t>
+              </a:r>
+              <a:r>
+                <a:rPr lang="fr-CA" sz="1800" dirty="0">
+                  <a:latin typeface="Consolas" panose="020B0609020204030204" pitchFamily="49" charset="0"/>
+                </a:rPr>
+                <a:t>.csv</a:t>
+              </a:r>
+              <a:endParaRPr lang="fr-CA" dirty="0">
+                <a:latin typeface="Consolas" panose="020B0609020204030204" pitchFamily="49" charset="0"/>
+              </a:endParaRPr>
+            </a:p>
+          </p:txBody>
+        </p:sp>
+        <p:sp>
+          <p:nvSpPr>
+            <p:cNvPr id="9" name="TextBox 8">
+              <a:extLst>
+                <a:ext uri="{FF2B5EF4-FFF2-40B4-BE49-F238E27FC236}">
+                  <a16:creationId xmlns:a16="http://schemas.microsoft.com/office/drawing/2014/main" id="{1FA6F5F6-2190-959B-4AA0-9D619AC2F90C}"/>
+                </a:ext>
+              </a:extLst>
+            </p:cNvPr>
+            <p:cNvSpPr txBox="1"/>
+            <p:nvPr/>
+          </p:nvSpPr>
+          <p:spPr>
+            <a:xfrm>
+              <a:off x="3917323" y="4001294"/>
+              <a:ext cx="1800000" cy="369332"/>
+            </a:xfrm>
+            <a:prstGeom prst="rect">
+              <a:avLst/>
+            </a:prstGeom>
+            <a:noFill/>
+          </p:spPr>
+          <p:txBody>
+            <a:bodyPr wrap="square">
+              <a:spAutoFit/>
+            </a:bodyPr>
+            <a:lstStyle/>
+            <a:p>
+              <a:pPr algn="ctr"/>
+              <a:r>
+                <a:rPr lang="fr-CA" dirty="0" err="1">
+                  <a:latin typeface="Consolas" panose="020B0609020204030204" pitchFamily="49" charset="0"/>
+                </a:rPr>
+                <a:t>fichier.json</a:t>
+              </a:r>
+              <a:endParaRPr lang="fr-CA" dirty="0">
+                <a:latin typeface="Consolas" panose="020B0609020204030204" pitchFamily="49" charset="0"/>
+              </a:endParaRPr>
+            </a:p>
+          </p:txBody>
+        </p:sp>
+        <p:sp>
+          <p:nvSpPr>
+            <p:cNvPr id="11" name="TextBox 10">
+              <a:extLst>
+                <a:ext uri="{FF2B5EF4-FFF2-40B4-BE49-F238E27FC236}">
+                  <a16:creationId xmlns:a16="http://schemas.microsoft.com/office/drawing/2014/main" id="{33FC9DF0-4604-27D2-C8DD-4B613D25267B}"/>
+                </a:ext>
+              </a:extLst>
+            </p:cNvPr>
+            <p:cNvSpPr txBox="1"/>
+            <p:nvPr/>
+          </p:nvSpPr>
+          <p:spPr>
+            <a:xfrm>
+              <a:off x="6096000" y="4012602"/>
+              <a:ext cx="1800000" cy="369332"/>
+            </a:xfrm>
+            <a:prstGeom prst="rect">
+              <a:avLst/>
+            </a:prstGeom>
+            <a:noFill/>
+          </p:spPr>
+          <p:txBody>
+            <a:bodyPr wrap="square">
+              <a:spAutoFit/>
+            </a:bodyPr>
+            <a:lstStyle/>
+            <a:p>
+              <a:pPr algn="ctr"/>
+              <a:r>
+                <a:rPr lang="fr-CA" dirty="0" err="1">
+                  <a:latin typeface="Consolas" panose="020B0609020204030204" pitchFamily="49" charset="0"/>
+                </a:rPr>
+                <a:t>fichier.yaml</a:t>
+              </a:r>
+              <a:endParaRPr lang="fr-CA" dirty="0">
+                <a:latin typeface="Consolas" panose="020B0609020204030204" pitchFamily="49" charset="0"/>
+              </a:endParaRPr>
+            </a:p>
+          </p:txBody>
+        </p:sp>
+      </p:grpSp>
+    </p:spTree>
+    <p:extLst>
+      <p:ext uri="{BB962C8B-B14F-4D97-AF65-F5344CB8AC3E}">
+        <p14:creationId xmlns:p14="http://schemas.microsoft.com/office/powerpoint/2010/main" val="3890797491"/>
       </p:ext>
     </p:extLst>
   </p:cSld>
@@ -26647,8 +27462,8 @@
           </a:p>
         </p:txBody>
       </p:sp>
-      <mc:AlternateContent xmlns:mc="http://schemas.openxmlformats.org/markup-compatibility/2006" xmlns:a14="http://schemas.microsoft.com/office/drawing/2010/main">
-        <mc:Choice Requires="a14">
+      <mc:AlternateContent xmlns:mc="http://schemas.openxmlformats.org/markup-compatibility/2006">
+        <mc:Choice xmlns:a14="http://schemas.microsoft.com/office/drawing/2010/main" Requires="a14">
           <p:sp>
             <p:nvSpPr>
               <p:cNvPr id="3" name="Content Placeholder 2">
@@ -26702,7 +27517,7 @@
                   <a:t>, levez une exception de type </a:t>
                 </a:r>
                 <a:r>
-                  <a:rPr lang="fr-CA" sz="1800" dirty="0" err="1">
+                  <a:rPr lang="fr-CA" sz="1800" b="1" dirty="0" err="1">
                     <a:latin typeface="Consolas" panose="020B0609020204030204" pitchFamily="49" charset="0"/>
                   </a:rPr>
                   <a:t>ValueError</a:t>
@@ -26727,7 +27542,19 @@
                   <a:rPr lang="fr-CA" sz="1800" dirty="0">
                     <a:latin typeface="Consolas" panose="020B0609020204030204" pitchFamily="49" charset="0"/>
                   </a:rPr>
-                  <a:t> est nul.</a:t>
+                  <a:t> est </a:t>
+                </a:r>
+                <a:r>
+                  <a:rPr lang="fr-CA" sz="1800" b="1" dirty="0">
+                    <a:latin typeface="Consolas" panose="020B0609020204030204" pitchFamily="49" charset="0"/>
+                  </a:rPr>
+                  <a:t>nul</a:t>
+                </a:r>
+                <a:r>
+                  <a:rPr lang="fr-CA" sz="1800" dirty="0">
+                    <a:latin typeface="Consolas" panose="020B0609020204030204" pitchFamily="49" charset="0"/>
+                  </a:rPr>
+                  <a:t>.</a:t>
                 </a:r>
               </a:p>
               <a:p>
@@ -26848,7 +27675,7 @@
             </p:txBody>
           </p:sp>
         </mc:Choice>
-        <mc:Fallback xmlns="">
+        <mc:Fallback>
           <p:sp>
             <p:nvSpPr>
               <p:cNvPr id="3" name="Content Placeholder 2">

</xml_diff>

<commit_message>
feat: Add final version of python_2 presentation
</commit_message>
<xml_diff>
--- a/python_2/presentation_python_2.pptx
+++ b/python_2/presentation_python_2.pptx
@@ -20275,6 +20275,183 @@
   <p:clrMapOvr>
     <a:masterClrMapping/>
   </p:clrMapOvr>
+  <p:timing>
+    <p:tnLst>
+      <p:par>
+        <p:cTn id="1" dur="indefinite" restart="never" nodeType="tmRoot">
+          <p:childTnLst>
+            <p:seq concurrent="1" nextAc="seek">
+              <p:cTn id="2" dur="indefinite" nodeType="mainSeq">
+                <p:childTnLst>
+                  <p:par>
+                    <p:cTn id="3" fill="hold">
+                      <p:stCondLst>
+                        <p:cond delay="indefinite"/>
+                      </p:stCondLst>
+                      <p:childTnLst>
+                        <p:par>
+                          <p:cTn id="4" fill="hold">
+                            <p:stCondLst>
+                              <p:cond delay="0"/>
+                            </p:stCondLst>
+                            <p:childTnLst>
+                              <p:par>
+                                <p:cTn id="5" presetID="10" presetClass="entr" presetSubtype="0" fill="hold" nodeType="clickEffect">
+                                  <p:stCondLst>
+                                    <p:cond delay="0"/>
+                                  </p:stCondLst>
+                                  <p:childTnLst>
+                                    <p:set>
+                                      <p:cBhvr>
+                                        <p:cTn id="6" dur="1" fill="hold">
+                                          <p:stCondLst>
+                                            <p:cond delay="0"/>
+                                          </p:stCondLst>
+                                        </p:cTn>
+                                        <p:tgtEl>
+                                          <p:spTgt spid="2">
+                                            <p:txEl>
+                                              <p:pRg st="0" end="0"/>
+                                            </p:txEl>
+                                          </p:spTgt>
+                                        </p:tgtEl>
+                                        <p:attrNameLst>
+                                          <p:attrName>style.visibility</p:attrName>
+                                        </p:attrNameLst>
+                                      </p:cBhvr>
+                                      <p:to>
+                                        <p:strVal val="visible"/>
+                                      </p:to>
+                                    </p:set>
+                                    <p:animEffect transition="in" filter="fade">
+                                      <p:cBhvr>
+                                        <p:cTn id="7" dur="500"/>
+                                        <p:tgtEl>
+                                          <p:spTgt spid="2">
+                                            <p:txEl>
+                                              <p:pRg st="0" end="0"/>
+                                            </p:txEl>
+                                          </p:spTgt>
+                                        </p:tgtEl>
+                                      </p:cBhvr>
+                                    </p:animEffect>
+                                  </p:childTnLst>
+                                </p:cTn>
+                              </p:par>
+                              <p:par>
+                                <p:cTn id="8" presetID="10" presetClass="entr" presetSubtype="0" fill="hold" nodeType="withEffect">
+                                  <p:stCondLst>
+                                    <p:cond delay="0"/>
+                                  </p:stCondLst>
+                                  <p:childTnLst>
+                                    <p:set>
+                                      <p:cBhvr>
+                                        <p:cTn id="9" dur="1" fill="hold">
+                                          <p:stCondLst>
+                                            <p:cond delay="0"/>
+                                          </p:stCondLst>
+                                        </p:cTn>
+                                        <p:tgtEl>
+                                          <p:spTgt spid="2">
+                                            <p:txEl>
+                                              <p:pRg st="2" end="2"/>
+                                            </p:txEl>
+                                          </p:spTgt>
+                                        </p:tgtEl>
+                                        <p:attrNameLst>
+                                          <p:attrName>style.visibility</p:attrName>
+                                        </p:attrNameLst>
+                                      </p:cBhvr>
+                                      <p:to>
+                                        <p:strVal val="visible"/>
+                                      </p:to>
+                                    </p:set>
+                                    <p:animEffect transition="in" filter="fade">
+                                      <p:cBhvr>
+                                        <p:cTn id="10" dur="500"/>
+                                        <p:tgtEl>
+                                          <p:spTgt spid="2">
+                                            <p:txEl>
+                                              <p:pRg st="2" end="2"/>
+                                            </p:txEl>
+                                          </p:spTgt>
+                                        </p:tgtEl>
+                                      </p:cBhvr>
+                                    </p:animEffect>
+                                  </p:childTnLst>
+                                </p:cTn>
+                              </p:par>
+                              <p:par>
+                                <p:cTn id="11" presetID="10" presetClass="entr" presetSubtype="0" fill="hold" nodeType="withEffect">
+                                  <p:stCondLst>
+                                    <p:cond delay="0"/>
+                                  </p:stCondLst>
+                                  <p:childTnLst>
+                                    <p:set>
+                                      <p:cBhvr>
+                                        <p:cTn id="12" dur="1" fill="hold">
+                                          <p:stCondLst>
+                                            <p:cond delay="0"/>
+                                          </p:stCondLst>
+                                        </p:cTn>
+                                        <p:tgtEl>
+                                          <p:spTgt spid="2">
+                                            <p:txEl>
+                                              <p:pRg st="4" end="4"/>
+                                            </p:txEl>
+                                          </p:spTgt>
+                                        </p:tgtEl>
+                                        <p:attrNameLst>
+                                          <p:attrName>style.visibility</p:attrName>
+                                        </p:attrNameLst>
+                                      </p:cBhvr>
+                                      <p:to>
+                                        <p:strVal val="visible"/>
+                                      </p:to>
+                                    </p:set>
+                                    <p:animEffect transition="in" filter="fade">
+                                      <p:cBhvr>
+                                        <p:cTn id="13" dur="500"/>
+                                        <p:tgtEl>
+                                          <p:spTgt spid="2">
+                                            <p:txEl>
+                                              <p:pRg st="4" end="4"/>
+                                            </p:txEl>
+                                          </p:spTgt>
+                                        </p:tgtEl>
+                                      </p:cBhvr>
+                                    </p:animEffect>
+                                  </p:childTnLst>
+                                </p:cTn>
+                              </p:par>
+                            </p:childTnLst>
+                          </p:cTn>
+                        </p:par>
+                      </p:childTnLst>
+                    </p:cTn>
+                  </p:par>
+                </p:childTnLst>
+              </p:cTn>
+              <p:prevCondLst>
+                <p:cond evt="onPrev" delay="0">
+                  <p:tgtEl>
+                    <p:sldTgt/>
+                  </p:tgtEl>
+                </p:cond>
+              </p:prevCondLst>
+              <p:nextCondLst>
+                <p:cond evt="onNext" delay="0">
+                  <p:tgtEl>
+                    <p:sldTgt/>
+                  </p:tgtEl>
+                </p:cond>
+              </p:nextCondLst>
+            </p:seq>
+          </p:childTnLst>
+        </p:cTn>
+      </p:par>
+    </p:tnLst>
+  </p:timing>
 </p:sld>
 </file>
 
@@ -21537,9 +21714,6 @@
                     <p:cTn id="3" fill="hold">
                       <p:stCondLst>
                         <p:cond delay="indefinite"/>
-                        <p:cond evt="onBegin" delay="0">
-                          <p:tn val="2"/>
-                        </p:cond>
                       </p:stCondLst>
                       <p:childTnLst>
                         <p:par>
@@ -21549,7 +21723,7 @@
                             </p:stCondLst>
                             <p:childTnLst>
                               <p:par>
-                                <p:cTn id="5" presetID="10" presetClass="entr" presetSubtype="0" fill="hold" grpId="0" nodeType="withEffect">
+                                <p:cTn id="5" presetID="10" presetClass="entr" presetSubtype="0" fill="hold" nodeType="clickEffect">
                                   <p:stCondLst>
                                     <p:cond delay="0"/>
                                   </p:stCondLst>
@@ -21557,6 +21731,128 @@
                                     <p:set>
                                       <p:cBhvr>
                                         <p:cTn id="6" dur="1" fill="hold">
+                                          <p:stCondLst>
+                                            <p:cond delay="0"/>
+                                          </p:stCondLst>
+                                        </p:cTn>
+                                        <p:tgtEl>
+                                          <p:spTgt spid="6">
+                                            <p:txEl>
+                                              <p:pRg st="0" end="0"/>
+                                            </p:txEl>
+                                          </p:spTgt>
+                                        </p:tgtEl>
+                                        <p:attrNameLst>
+                                          <p:attrName>style.visibility</p:attrName>
+                                        </p:attrNameLst>
+                                      </p:cBhvr>
+                                      <p:to>
+                                        <p:strVal val="visible"/>
+                                      </p:to>
+                                    </p:set>
+                                    <p:animEffect transition="in" filter="fade">
+                                      <p:cBhvr>
+                                        <p:cTn id="7" dur="500"/>
+                                        <p:tgtEl>
+                                          <p:spTgt spid="6">
+                                            <p:txEl>
+                                              <p:pRg st="0" end="0"/>
+                                            </p:txEl>
+                                          </p:spTgt>
+                                        </p:tgtEl>
+                                      </p:cBhvr>
+                                    </p:animEffect>
+                                  </p:childTnLst>
+                                </p:cTn>
+                              </p:par>
+                            </p:childTnLst>
+                          </p:cTn>
+                        </p:par>
+                      </p:childTnLst>
+                    </p:cTn>
+                  </p:par>
+                  <p:par>
+                    <p:cTn id="8" fill="hold">
+                      <p:stCondLst>
+                        <p:cond delay="indefinite"/>
+                      </p:stCondLst>
+                      <p:childTnLst>
+                        <p:par>
+                          <p:cTn id="9" fill="hold">
+                            <p:stCondLst>
+                              <p:cond delay="0"/>
+                            </p:stCondLst>
+                            <p:childTnLst>
+                              <p:par>
+                                <p:cTn id="10" presetID="10" presetClass="entr" presetSubtype="0" fill="hold" nodeType="clickEffect">
+                                  <p:stCondLst>
+                                    <p:cond delay="0"/>
+                                  </p:stCondLst>
+                                  <p:childTnLst>
+                                    <p:set>
+                                      <p:cBhvr>
+                                        <p:cTn id="11" dur="1" fill="hold">
+                                          <p:stCondLst>
+                                            <p:cond delay="0"/>
+                                          </p:stCondLst>
+                                        </p:cTn>
+                                        <p:tgtEl>
+                                          <p:spTgt spid="6">
+                                            <p:txEl>
+                                              <p:pRg st="1" end="1"/>
+                                            </p:txEl>
+                                          </p:spTgt>
+                                        </p:tgtEl>
+                                        <p:attrNameLst>
+                                          <p:attrName>style.visibility</p:attrName>
+                                        </p:attrNameLst>
+                                      </p:cBhvr>
+                                      <p:to>
+                                        <p:strVal val="visible"/>
+                                      </p:to>
+                                    </p:set>
+                                    <p:animEffect transition="in" filter="fade">
+                                      <p:cBhvr>
+                                        <p:cTn id="12" dur="500"/>
+                                        <p:tgtEl>
+                                          <p:spTgt spid="6">
+                                            <p:txEl>
+                                              <p:pRg st="1" end="1"/>
+                                            </p:txEl>
+                                          </p:spTgt>
+                                        </p:tgtEl>
+                                      </p:cBhvr>
+                                    </p:animEffect>
+                                  </p:childTnLst>
+                                </p:cTn>
+                              </p:par>
+                            </p:childTnLst>
+                          </p:cTn>
+                        </p:par>
+                      </p:childTnLst>
+                    </p:cTn>
+                  </p:par>
+                  <p:par>
+                    <p:cTn id="13" fill="hold">
+                      <p:stCondLst>
+                        <p:cond delay="indefinite"/>
+                      </p:stCondLst>
+                      <p:childTnLst>
+                        <p:par>
+                          <p:cTn id="14" fill="hold">
+                            <p:stCondLst>
+                              <p:cond delay="0"/>
+                            </p:stCondLst>
+                            <p:childTnLst>
+                              <p:par>
+                                <p:cTn id="15" presetID="10" presetClass="entr" presetSubtype="0" fill="hold" grpId="0" nodeType="clickEffect">
+                                  <p:stCondLst>
+                                    <p:cond delay="0"/>
+                                  </p:stCondLst>
+                                  <p:childTnLst>
+                                    <p:set>
+                                      <p:cBhvr>
+                                        <p:cTn id="16" dur="1" fill="hold">
                                           <p:stCondLst>
                                             <p:cond delay="0"/>
                                           </p:stCondLst>
@@ -21574,9 +21870,115 @@
                                     </p:set>
                                     <p:animEffect transition="in" filter="fade">
                                       <p:cBhvr>
-                                        <p:cTn id="7" dur="500"/>
+                                        <p:cTn id="17" dur="500"/>
                                         <p:tgtEl>
                                           <p:spTgt spid="2"/>
+                                        </p:tgtEl>
+                                      </p:cBhvr>
+                                    </p:animEffect>
+                                  </p:childTnLst>
+                                </p:cTn>
+                              </p:par>
+                            </p:childTnLst>
+                          </p:cTn>
+                        </p:par>
+                      </p:childTnLst>
+                    </p:cTn>
+                  </p:par>
+                  <p:par>
+                    <p:cTn id="18" fill="hold">
+                      <p:stCondLst>
+                        <p:cond delay="indefinite"/>
+                      </p:stCondLst>
+                      <p:childTnLst>
+                        <p:par>
+                          <p:cTn id="19" fill="hold">
+                            <p:stCondLst>
+                              <p:cond delay="0"/>
+                            </p:stCondLst>
+                            <p:childTnLst>
+                              <p:par>
+                                <p:cTn id="20" presetID="10" presetClass="entr" presetSubtype="0" fill="hold" nodeType="clickEffect">
+                                  <p:stCondLst>
+                                    <p:cond delay="0"/>
+                                  </p:stCondLst>
+                                  <p:childTnLst>
+                                    <p:set>
+                                      <p:cBhvr>
+                                        <p:cTn id="21" dur="1" fill="hold">
+                                          <p:stCondLst>
+                                            <p:cond delay="0"/>
+                                          </p:stCondLst>
+                                        </p:cTn>
+                                        <p:tgtEl>
+                                          <p:spTgt spid="3"/>
+                                        </p:tgtEl>
+                                        <p:attrNameLst>
+                                          <p:attrName>style.visibility</p:attrName>
+                                        </p:attrNameLst>
+                                      </p:cBhvr>
+                                      <p:to>
+                                        <p:strVal val="visible"/>
+                                      </p:to>
+                                    </p:set>
+                                    <p:animEffect transition="in" filter="fade">
+                                      <p:cBhvr>
+                                        <p:cTn id="22" dur="500"/>
+                                        <p:tgtEl>
+                                          <p:spTgt spid="3"/>
+                                        </p:tgtEl>
+                                      </p:cBhvr>
+                                    </p:animEffect>
+                                  </p:childTnLst>
+                                </p:cTn>
+                              </p:par>
+                            </p:childTnLst>
+                          </p:cTn>
+                        </p:par>
+                      </p:childTnLst>
+                    </p:cTn>
+                  </p:par>
+                  <p:par>
+                    <p:cTn id="23" fill="hold">
+                      <p:stCondLst>
+                        <p:cond delay="indefinite"/>
+                      </p:stCondLst>
+                      <p:childTnLst>
+                        <p:par>
+                          <p:cTn id="24" fill="hold">
+                            <p:stCondLst>
+                              <p:cond delay="0"/>
+                            </p:stCondLst>
+                            <p:childTnLst>
+                              <p:par>
+                                <p:cTn id="25" presetID="10" presetClass="entr" presetSubtype="0" fill="hold" grpId="0" nodeType="clickEffect">
+                                  <p:stCondLst>
+                                    <p:cond delay="0"/>
+                                  </p:stCondLst>
+                                  <p:childTnLst>
+                                    <p:set>
+                                      <p:cBhvr>
+                                        <p:cTn id="26" dur="1" fill="hold">
+                                          <p:stCondLst>
+                                            <p:cond delay="0"/>
+                                          </p:stCondLst>
+                                        </p:cTn>
+                                        <p:tgtEl>
+                                          <p:spTgt spid="10"/>
+                                        </p:tgtEl>
+                                        <p:attrNameLst>
+                                          <p:attrName>style.visibility</p:attrName>
+                                        </p:attrNameLst>
+                                      </p:cBhvr>
+                                      <p:to>
+                                        <p:strVal val="visible"/>
+                                      </p:to>
+                                    </p:set>
+                                    <p:animEffect transition="in" filter="fade">
+                                      <p:cBhvr>
+                                        <p:cTn id="27" dur="500"/>
+                                        <p:tgtEl>
+                                          <p:spTgt spid="10"/>
                                         </p:tgtEl>
                                       </p:cBhvr>
                                     </p:animEffect>
@@ -21612,6 +22014,7 @@
     </p:tnLst>
     <p:bldLst>
       <p:bldP spid="2" grpId="0" animBg="1"/>
+      <p:bldP spid="10" grpId="0"/>
     </p:bldLst>
   </p:timing>
 </p:sld>
@@ -22067,7 +22470,9 @@
               </a:xfrm>
             </p:spPr>
             <p:txBody>
-              <a:bodyPr/>
+              <a:bodyPr>
+                <a:normAutofit/>
+              </a:bodyPr>
               <a:lstStyle/>
               <a:p>
                 <a:pPr>
@@ -22076,7 +22481,7 @@
                   </a:lnSpc>
                 </a:pPr>
                 <a:r>
-                  <a:rPr lang="fr-CA" dirty="0"/>
+                  <a:rPr lang="fr-CA" sz="2000" dirty="0"/>
                   <a:t>Formats optimisés selon les usages:</a:t>
                 </a:r>
               </a:p>
@@ -22087,17 +22492,17 @@
                   </a:lnSpc>
                 </a:pPr>
                 <a:r>
-                  <a:rPr lang="fr-CA" b="1" dirty="0"/>
+                  <a:rPr lang="fr-CA" sz="2000" b="1" dirty="0"/>
                   <a:t>CSV</a:t>
                 </a:r>
                 <a:r>
-                  <a:rPr lang="fr-CA" dirty="0"/>
+                  <a:rPr lang="fr-CA" sz="2000" dirty="0"/>
                   <a:t>: Données tabulaires (ex: Excel) </a:t>
                 </a:r>
                 <a14:m>
                   <m:oMath xmlns:m="http://schemas.openxmlformats.org/officeDocument/2006/math">
                     <m:r>
-                      <a:rPr lang="fr-CA" i="1" smtClean="0">
+                      <a:rPr lang="fr-CA" sz="2000" i="1" smtClean="0">
                         <a:latin typeface="Cambria Math" panose="02040503050406030204" pitchFamily="18" charset="0"/>
                         <a:ea typeface="Cambria Math" panose="02040503050406030204" pitchFamily="18" charset="0"/>
                       </a:rPr>
@@ -22106,11 +22511,11 @@
                   </m:oMath>
                 </a14:m>
                 <a:r>
-                  <a:rPr lang="fr-CA" dirty="0"/>
+                  <a:rPr lang="fr-CA" sz="2000" dirty="0"/>
                   <a:t> </a:t>
                 </a:r>
                 <a:r>
-                  <a:rPr lang="fr-CA" b="1" dirty="0">
+                  <a:rPr lang="fr-CA" sz="2000" b="1" dirty="0">
                     <a:latin typeface="Consolas" panose="020B0609020204030204" pitchFamily="49" charset="0"/>
                   </a:rPr>
                   <a:t>import csv</a:t>
@@ -22123,17 +22528,17 @@
                   </a:lnSpc>
                 </a:pPr>
                 <a:r>
-                  <a:rPr lang="fr-CA" b="1" dirty="0"/>
+                  <a:rPr lang="fr-CA" sz="2000" b="1" dirty="0"/>
                   <a:t>JSON</a:t>
                 </a:r>
                 <a:r>
-                  <a:rPr lang="fr-CA" dirty="0"/>
+                  <a:rPr lang="fr-CA" sz="2000" dirty="0"/>
                   <a:t>: Données structurées (ex: dictionnaires) </a:t>
                 </a:r>
                 <a14:m>
                   <m:oMath xmlns:m="http://schemas.openxmlformats.org/officeDocument/2006/math">
                     <m:r>
-                      <a:rPr lang="fr-CA" i="1">
+                      <a:rPr lang="fr-CA" sz="2000" i="1">
                         <a:latin typeface="Cambria Math" panose="02040503050406030204" pitchFamily="18" charset="0"/>
                         <a:ea typeface="Cambria Math" panose="02040503050406030204" pitchFamily="18" charset="0"/>
                       </a:rPr>
@@ -22142,22 +22547,22 @@
                   </m:oMath>
                 </a14:m>
                 <a:r>
-                  <a:rPr lang="fr-CA" dirty="0"/>
+                  <a:rPr lang="fr-CA" sz="2000" dirty="0"/>
                   <a:t> </a:t>
                 </a:r>
                 <a:r>
-                  <a:rPr lang="fr-CA" b="1" dirty="0">
+                  <a:rPr lang="fr-CA" sz="2000" b="1" dirty="0">
                     <a:latin typeface="Consolas" panose="020B0609020204030204" pitchFamily="49" charset="0"/>
                   </a:rPr>
                   <a:t>import </a:t>
                 </a:r>
                 <a:r>
-                  <a:rPr lang="fr-CA" b="1" dirty="0" err="1">
+                  <a:rPr lang="fr-CA" sz="2000" b="1" dirty="0" err="1">
                     <a:latin typeface="Consolas" panose="020B0609020204030204" pitchFamily="49" charset="0"/>
                   </a:rPr>
                   <a:t>json</a:t>
                 </a:r>
-                <a:endParaRPr lang="fr-CA" b="1" dirty="0"/>
+                <a:endParaRPr lang="fr-CA" sz="2000" b="1" dirty="0"/>
               </a:p>
               <a:p>
                 <a:pPr lvl="1">
@@ -22166,17 +22571,17 @@
                   </a:lnSpc>
                 </a:pPr>
                 <a:r>
-                  <a:rPr lang="fr-CA" b="1" dirty="0"/>
+                  <a:rPr lang="fr-CA" sz="2000" b="1" dirty="0"/>
                   <a:t>YAML</a:t>
                 </a:r>
                 <a:r>
-                  <a:rPr lang="fr-CA" dirty="0"/>
+                  <a:rPr lang="fr-CA" sz="2000" dirty="0"/>
                   <a:t>: Souvent utilisé pour des configurations </a:t>
                 </a:r>
                 <a14:m>
                   <m:oMath xmlns:m="http://schemas.openxmlformats.org/officeDocument/2006/math">
                     <m:r>
-                      <a:rPr lang="fr-CA" i="1">
+                      <a:rPr lang="fr-CA" sz="2000" i="1">
                         <a:latin typeface="Cambria Math" panose="02040503050406030204" pitchFamily="18" charset="0"/>
                         <a:ea typeface="Cambria Math" panose="02040503050406030204" pitchFamily="18" charset="0"/>
                       </a:rPr>
@@ -22185,22 +22590,22 @@
                   </m:oMath>
                 </a14:m>
                 <a:r>
-                  <a:rPr lang="fr-CA" dirty="0"/>
+                  <a:rPr lang="fr-CA" sz="2000" dirty="0"/>
                   <a:t> </a:t>
                 </a:r>
                 <a:r>
-                  <a:rPr lang="fr-CA" b="1" dirty="0">
+                  <a:rPr lang="fr-CA" sz="2000" b="1" dirty="0">
                     <a:latin typeface="Consolas" panose="020B0609020204030204" pitchFamily="49" charset="0"/>
                   </a:rPr>
                   <a:t>import </a:t>
                 </a:r>
                 <a:r>
-                  <a:rPr lang="fr-CA" b="1" dirty="0" err="1">
+                  <a:rPr lang="fr-CA" sz="2000" b="1" dirty="0" err="1">
                     <a:latin typeface="Consolas" panose="020B0609020204030204" pitchFamily="49" charset="0"/>
                   </a:rPr>
                   <a:t>yaml</a:t>
                 </a:r>
-                <a:endParaRPr lang="fr-CA" b="1" dirty="0">
+                <a:endParaRPr lang="fr-CA" sz="2000" b="1" dirty="0">
                   <a:latin typeface="Consolas" panose="020B0609020204030204" pitchFamily="49" charset="0"/>
                 </a:endParaRPr>
               </a:p>
@@ -22232,7 +22637,7 @@
               <a:blipFill>
                 <a:blip r:embed="rId3"/>
                 <a:stretch>
-                  <a:fillRect l="-1043" t="-1401"/>
+                  <a:fillRect l="-522" t="-700"/>
                 </a:stretch>
               </a:blipFill>
             </p:spPr>
@@ -22265,7 +22670,7 @@
         </p:nvGrpSpPr>
         <p:grpSpPr>
           <a:xfrm>
-            <a:off x="3025806" y="4001294"/>
+            <a:off x="3090657" y="3399778"/>
             <a:ext cx="6140388" cy="2175668"/>
             <a:chOff x="1755612" y="4001294"/>
             <a:chExt cx="6140388" cy="2175668"/>
@@ -22698,6 +23103,49 @@
           </p:txBody>
         </p:sp>
       </p:grpSp>
+      <p:sp>
+        <p:nvSpPr>
+          <p:cNvPr id="13" name="TextBox 12">
+            <a:extLst>
+              <a:ext uri="{FF2B5EF4-FFF2-40B4-BE49-F238E27FC236}">
+                <a16:creationId xmlns:a16="http://schemas.microsoft.com/office/drawing/2014/main" id="{8CC1382E-88CC-4344-639B-A58ABF23E4D6}"/>
+              </a:ext>
+            </a:extLst>
+          </p:cNvPr>
+          <p:cNvSpPr txBox="1"/>
+          <p:nvPr/>
+        </p:nvSpPr>
+        <p:spPr>
+          <a:xfrm>
+            <a:off x="3112851" y="5754833"/>
+            <a:ext cx="6096000" cy="380232"/>
+          </a:xfrm>
+          <a:prstGeom prst="rect">
+            <a:avLst/>
+          </a:prstGeom>
+          <a:noFill/>
+        </p:spPr>
+        <p:txBody>
+          <a:bodyPr wrap="square">
+            <a:spAutoFit/>
+          </a:bodyPr>
+          <a:lstStyle/>
+          <a:p>
+            <a:pPr marL="0" indent="0" algn="ctr">
+              <a:lnSpc>
+                <a:spcPct val="110000"/>
+              </a:lnSpc>
+              <a:buNone/>
+            </a:pPr>
+            <a:r>
+              <a:rPr lang="fr-CA" sz="1800" b="1" dirty="0">
+                <a:latin typeface="Consolas" panose="020B0609020204030204" pitchFamily="49" charset="0"/>
+              </a:rPr>
+              <a:t>VOIR L'EXEMPLE DANS LE CARNET</a:t>
+            </a:r>
+          </a:p>
+        </p:txBody>
+      </p:sp>
     </p:spTree>
     <p:extLst>
       <p:ext uri="{BB962C8B-B14F-4D97-AF65-F5344CB8AC3E}">

</xml_diff>